<commit_message>
Swap report + deck figures to publication-quality Chinese pub versions (9 core figures), merge two-domain significance into one compact figure
报告gen + PPT build 加 PUB 映射:9张核心图自动优先用 pub/ 顶会中文版(despine/色盲配色/矢量重绘)。两域显著性合并为单张紧凑图(替代原直方图×2)。三处(论文/报告/PPT)图风格统一顶会级。

Co-Authored-By: Claude Opus 4.8 (1M context) <noreply@anthropic.com>
</commit_message>
<xml_diff>
--- a/autoresearch/energy_m100/experiments/midterm_defense.pptx
+++ b/autoresearch/energy_m100/experiments/midterm_defense.pptx
@@ -4325,7 +4325,7 @@
       </p:sp>
       <p:pic>
         <p:nvPicPr>
-          <p:cNvPr id="5" name="Picture 4" descr="framework_ablation.png"/>
+          <p:cNvPr id="5" name="Picture 4" descr="框架消融_局部最优.png"/>
           <p:cNvPicPr>
             <a:picLocks noChangeAspect="1"/>
           </p:cNvPicPr>
@@ -4339,8 +4339,8 @@
         </p:blipFill>
         <p:spPr>
           <a:xfrm>
-            <a:off x="457200" y="2220163"/>
-            <a:ext cx="6583680" cy="3423513"/>
+            <a:off x="457200" y="2243900"/>
+            <a:ext cx="6583680" cy="3376040"/>
           </a:xfrm>
           <a:prstGeom prst="rect">
             <a:avLst/>
@@ -4739,7 +4739,7 @@
       </p:sp>
       <p:pic>
         <p:nvPicPr>
-          <p:cNvPr id="5" name="Picture 4" descr="domain_value.png"/>
+          <p:cNvPr id="5" name="Picture 4" descr="噪声地板.png"/>
           <p:cNvPicPr>
             <a:picLocks noChangeAspect="1"/>
           </p:cNvPicPr>
@@ -4753,8 +4753,8 @@
         </p:blipFill>
         <p:spPr>
           <a:xfrm>
-            <a:off x="502920" y="2481943"/>
-            <a:ext cx="7863840" cy="2808514"/>
+            <a:off x="1906341" y="1828800"/>
+            <a:ext cx="5056998" cy="4114800"/>
           </a:xfrm>
           <a:prstGeom prst="rect">
             <a:avLst/>
@@ -5081,7 +5081,7 @@
       </p:sp>
       <p:pic>
         <p:nvPicPr>
-          <p:cNvPr id="5" name="Picture 4" descr="significance_test.png"/>
+          <p:cNvPr id="5" name="Picture 4" descr="两域显著性.png"/>
           <p:cNvPicPr>
             <a:picLocks noChangeAspect="1"/>
           </p:cNvPicPr>
@@ -5095,41 +5095,17 @@
         </p:blipFill>
         <p:spPr>
           <a:xfrm>
-            <a:off x="457200" y="1916870"/>
-            <a:ext cx="5623560" cy="2841377"/>
+            <a:off x="457200" y="2527503"/>
+            <a:ext cx="5760720" cy="2991714"/>
           </a:xfrm>
           <a:prstGeom prst="rect">
             <a:avLst/>
           </a:prstGeom>
         </p:spPr>
       </p:pic>
-      <p:pic>
-        <p:nvPicPr>
-          <p:cNvPr id="6" name="Picture 5" descr="planner_significance.png"/>
-          <p:cNvPicPr>
-            <a:picLocks noChangeAspect="1"/>
-          </p:cNvPicPr>
-          <p:nvPr/>
-        </p:nvPicPr>
-        <p:blipFill>
-          <a:blip r:embed="rId3"/>
-          <a:stretch>
-            <a:fillRect/>
-          </a:stretch>
-        </p:blipFill>
-        <p:spPr>
-          <a:xfrm>
-            <a:off x="1549717" y="4846320"/>
-            <a:ext cx="3438525" cy="1737360"/>
-          </a:xfrm>
-          <a:prstGeom prst="rect">
-            <a:avLst/>
-          </a:prstGeom>
-        </p:spPr>
-      </p:pic>
-      <p:sp>
-        <p:nvSpPr>
-          <p:cNvPr id="7" name="TextBox 6"/>
+      <p:sp>
+        <p:nvSpPr>
+          <p:cNvPr id="6" name="TextBox 5"/>
           <p:cNvSpPr txBox="1"/>
           <p:nvPr/>
         </p:nvSpPr>
@@ -5278,7 +5254,7 @@
       </p:sp>
       <p:sp>
         <p:nvSpPr>
-          <p:cNvPr id="8" name="TextBox 7"/>
+          <p:cNvPr id="7" name="TextBox 6"/>
           <p:cNvSpPr txBox="1"/>
           <p:nvPr/>
         </p:nvSpPr>
@@ -5843,7 +5819,7 @@
       </p:sp>
       <p:pic>
         <p:nvPicPr>
-          <p:cNvPr id="5" name="Picture 4" descr="large_scale_savings.png"/>
+          <p:cNvPr id="5" name="Picture 4" descr="省能分布_n250.png"/>
           <p:cNvPicPr>
             <a:picLocks noChangeAspect="1"/>
           </p:cNvPicPr>
@@ -5857,8 +5833,8 @@
         </p:blipFill>
         <p:spPr>
           <a:xfrm>
-            <a:off x="502920" y="2110232"/>
-            <a:ext cx="6949440" cy="3551936"/>
+            <a:off x="562672" y="1828800"/>
+            <a:ext cx="6829936" cy="4114800"/>
           </a:xfrm>
           <a:prstGeom prst="rect">
             <a:avLst/>
@@ -6775,7 +6751,7 @@
       </p:sp>
       <p:pic>
         <p:nvPicPr>
-          <p:cNvPr id="4" name="Picture 3" descr="tradeoff.png"/>
+          <p:cNvPr id="4" name="Picture 3" descr="翻越绕行权衡.png"/>
           <p:cNvPicPr>
             <a:picLocks noChangeAspect="1"/>
           </p:cNvPicPr>
@@ -6789,8 +6765,8 @@
         </p:blipFill>
         <p:spPr>
           <a:xfrm>
-            <a:off x="1932093" y="1737360"/>
-            <a:ext cx="8297333" cy="4480560"/>
+            <a:off x="2576732" y="1737360"/>
+            <a:ext cx="7008055" cy="4480560"/>
           </a:xfrm>
           <a:prstGeom prst="rect">
             <a:avLst/>
@@ -6950,7 +6926,7 @@
       </p:sp>
       <p:pic>
         <p:nvPicPr>
-          <p:cNvPr id="4" name="Picture 3" descr="phase_diagram.png"/>
+          <p:cNvPr id="4" name="Picture 3" descr="操作包络相图.png"/>
           <p:cNvPicPr>
             <a:picLocks noChangeAspect="1"/>
           </p:cNvPicPr>
@@ -6964,8 +6940,8 @@
         </p:blipFill>
         <p:spPr>
           <a:xfrm>
-            <a:off x="1320165" y="1737360"/>
-            <a:ext cx="9521190" cy="4480560"/>
+            <a:off x="2589562" y="1737360"/>
+            <a:ext cx="6982395" cy="4480560"/>
           </a:xfrm>
           <a:prstGeom prst="rect">
             <a:avLst/>
@@ -11081,7 +11057,7 @@
       </p:sp>
       <p:pic>
         <p:nvPicPr>
-          <p:cNvPr id="5" name="Picture 4" descr="hero_figure.png"/>
+          <p:cNvPr id="5" name="Picture 4" descr="真机代价改变决策.png"/>
           <p:cNvPicPr>
             <a:picLocks noChangeAspect="1"/>
           </p:cNvPicPr>
@@ -11095,8 +11071,8 @@
         </p:blipFill>
         <p:spPr>
           <a:xfrm>
-            <a:off x="502920" y="2338864"/>
-            <a:ext cx="7772400" cy="2088832"/>
+            <a:off x="1070146" y="1828800"/>
+            <a:ext cx="6637948" cy="3108960"/>
           </a:xfrm>
           <a:prstGeom prst="rect">
             <a:avLst/>
@@ -11465,7 +11441,7 @@
       </p:sp>
       <p:pic>
         <p:nvPicPr>
-          <p:cNvPr id="5" name="Picture 4" descr="px4_ab_comparison.png"/>
+          <p:cNvPr id="5" name="Picture 4" descr="PX4真飞控_AB对比.png"/>
           <p:cNvPicPr>
             <a:picLocks noChangeAspect="1"/>
           </p:cNvPicPr>
@@ -11479,8 +11455,8 @@
         </p:blipFill>
         <p:spPr>
           <a:xfrm>
-            <a:off x="502920" y="2327148"/>
-            <a:ext cx="7680960" cy="2112264"/>
+            <a:off x="876487" y="1828800"/>
+            <a:ext cx="6933825" cy="3108960"/>
           </a:xfrm>
           <a:prstGeom prst="rect">
             <a:avLst/>

</xml_diff>

<commit_message>
Fix 3 figure text-overlaps (framework-ablation basin label, cross-domain loop labels) + add cumulative ablation ladder (naive->full framework, false-discoveries 3->0)
subagent视觉QA找出3处错位全修:框架消融盆地标注压数值→移空白+白底;两域显著性loop文字被竖线穿→挪线旁+白底;外搜逃逸文字重叠→合并。消融升级:ablation_ladder.py累加消融阶梯(顶会标准)——从朴素loop逐步加安全机制,假发现3→0、报告数字诚实不虚低。织进报告§5+PPT附录A。

Co-Authored-By: Claude Opus 4.8 (1M context) <noreply@anthropic.com>
</commit_message>
<xml_diff>
--- a/autoresearch/energy_m100/experiments/midterm_defense.pptx
+++ b/autoresearch/energy_m100/experiments/midterm_defense.pptx
@@ -27,6 +27,7 @@
     <p:sldId id="275" r:id="rId26"/>
     <p:sldId id="276" r:id="rId27"/>
     <p:sldId id="277" r:id="rId28"/>
+    <p:sldId id="278" r:id="rId29"/>
   </p:sldIdLst>
   <p:sldSz cx="12191695" cy="6858000" type="screen4x3"/>
   <p:notesSz cx="6858000" cy="9144000"/>
@@ -4339,8 +4340,8 @@
         </p:blipFill>
         <p:spPr>
           <a:xfrm>
-            <a:off x="457200" y="2243900"/>
-            <a:ext cx="6583680" cy="3376040"/>
+            <a:off x="457200" y="2230429"/>
+            <a:ext cx="6583680" cy="3402982"/>
           </a:xfrm>
           <a:prstGeom prst="rect">
             <a:avLst/>
@@ -6744,14 +6745,14 @@
                 <a:ea typeface="微软雅黑"/>
                 <a:cs typeface="微软雅黑"/>
               </a:rPr>
-              <a:t>附录 A:翻越/绕行能量权衡分解</a:t>
+              <a:t>附录 A:累加消融阶梯(框架每步都承重)</a:t>
             </a:r>
           </a:p>
         </p:txBody>
       </p:sp>
       <p:pic>
         <p:nvPicPr>
-          <p:cNvPr id="4" name="Picture 3" descr="翻越绕行权衡.png"/>
+          <p:cNvPr id="4" name="Picture 3" descr="消融阶梯.png"/>
           <p:cNvPicPr>
             <a:picLocks noChangeAspect="1"/>
           </p:cNvPicPr>
@@ -6765,8 +6766,8 @@
         </p:blipFill>
         <p:spPr>
           <a:xfrm>
-            <a:off x="2576732" y="1737360"/>
-            <a:ext cx="7008055" cy="4480560"/>
+            <a:off x="1914202" y="1737360"/>
+            <a:ext cx="8333116" cy="4480560"/>
           </a:xfrm>
           <a:prstGeom prst="rect">
             <a:avLst/>
@@ -6809,7 +6810,7 @@
                 <a:ea typeface="微软雅黑"/>
                 <a:cs typeface="微软雅黑"/>
               </a:rPr>
-              <a:t>翻越=固定爬升罚+少走距离,绕行=无爬升+多走距离,交叉≈半宽24m=相图边界物理解释</a:t>
+              <a:t>逐步加回安全机制:假发现 3→0(左),报告数字保持诚实不虚低(右)</a:t>
             </a:r>
           </a:p>
         </p:txBody>
@@ -6919,14 +6920,14 @@
                 <a:ea typeface="微软雅黑"/>
                 <a:cs typeface="微软雅黑"/>
               </a:rPr>
-              <a:t>附录 B:操作包络相图</a:t>
+              <a:t>附录 A2:翻越/绕行能量权衡分解</a:t>
             </a:r>
           </a:p>
         </p:txBody>
       </p:sp>
       <p:pic>
         <p:nvPicPr>
-          <p:cNvPr id="4" name="Picture 3" descr="操作包络相图.png"/>
+          <p:cNvPr id="4" name="Picture 3" descr="翻越绕行权衡.png"/>
           <p:cNvPicPr>
             <a:picLocks noChangeAspect="1"/>
           </p:cNvPicPr>
@@ -6940,8 +6941,8 @@
         </p:blipFill>
         <p:spPr>
           <a:xfrm>
-            <a:off x="2589562" y="1737360"/>
-            <a:ext cx="6982395" cy="4480560"/>
+            <a:off x="2576732" y="1737360"/>
+            <a:ext cx="7008055" cy="4480560"/>
           </a:xfrm>
           <a:prstGeom prst="rect">
             <a:avLst/>
@@ -6984,7 +6985,7 @@
                 <a:ea typeface="微软雅黑"/>
                 <a:cs typeface="微软雅黑"/>
               </a:rPr>
-              <a:t>高速+窄障省 22%,低速/宽障归零</a:t>
+              <a:t>翻越=固定爬升罚+少走距离,绕行=无爬升+多走距离,交叉≈半宽24m=相图边界物理解释</a:t>
             </a:r>
           </a:p>
         </p:txBody>
@@ -7471,14 +7472,14 @@
                 <a:ea typeface="微软雅黑"/>
                 <a:cs typeface="微软雅黑"/>
               </a:rPr>
-              <a:t>附录 C:安全机制消融(评测器抗 gaming)</a:t>
+              <a:t>附录 B:操作包络相图</a:t>
             </a:r>
           </a:p>
         </p:txBody>
       </p:sp>
       <p:pic>
         <p:nvPicPr>
-          <p:cNvPr id="4" name="Picture 3" descr="safeguard_ablation.png"/>
+          <p:cNvPr id="4" name="Picture 3" descr="操作包络相图.png"/>
           <p:cNvPicPr>
             <a:picLocks noChangeAspect="1"/>
           </p:cNvPicPr>
@@ -7492,8 +7493,8 @@
         </p:blipFill>
         <p:spPr>
           <a:xfrm>
-            <a:off x="731520" y="2506599"/>
-            <a:ext cx="10698480" cy="2942082"/>
+            <a:off x="2589562" y="1737360"/>
+            <a:ext cx="6982395" cy="4480560"/>
           </a:xfrm>
           <a:prstGeom prst="rect">
             <a:avLst/>
@@ -7536,7 +7537,7 @@
                 <a:ea typeface="微软雅黑"/>
                 <a:cs typeface="微软雅黑"/>
               </a:rPr>
-              <a:t>过拟合探针刷不动;查新门降级 2/3</a:t>
+              <a:t>高速+窄障省 22%,低速/宽障归零</a:t>
             </a:r>
           </a:p>
         </p:txBody>
@@ -7646,14 +7647,14 @@
                 <a:ea typeface="微软雅黑"/>
                 <a:cs typeface="微软雅黑"/>
               </a:rPr>
-              <a:t>附录 D:动力学实飞功率剖面</a:t>
+              <a:t>附录 C:安全机制消融(评测器抗 gaming)</a:t>
             </a:r>
           </a:p>
         </p:txBody>
       </p:sp>
       <p:pic>
         <p:nvPicPr>
-          <p:cNvPr id="4" name="Picture 3" descr="sim_flight.png"/>
+          <p:cNvPr id="4" name="Picture 3" descr="safeguard_ablation.png"/>
           <p:cNvPicPr>
             <a:picLocks noChangeAspect="1"/>
           </p:cNvPicPr>
@@ -7667,8 +7668,8 @@
         </p:blipFill>
         <p:spPr>
           <a:xfrm>
-            <a:off x="731520" y="2573464"/>
-            <a:ext cx="10698480" cy="2808351"/>
+            <a:off x="731520" y="2506599"/>
+            <a:ext cx="10698480" cy="2942082"/>
           </a:xfrm>
           <a:prstGeom prst="rect">
             <a:avLst/>
@@ -7711,7 +7712,7 @@
                 <a:ea typeface="微软雅黑"/>
                 <a:cs typeface="微软雅黑"/>
               </a:rPr>
-              <a:t>翻墙爬升段飙 870W,绕行平稳</a:t>
+              <a:t>过拟合探针刷不动;查新门降级 2/3</a:t>
             </a:r>
           </a:p>
         </p:txBody>
@@ -7725,6 +7726,181 @@
 </file>
 
 <file path=ppt/slides/slide22.xml><?xml version="1.0" encoding="utf-8"?>
+<p:sld xmlns:a="http://schemas.openxmlformats.org/drawingml/2006/main" xmlns:p="http://schemas.openxmlformats.org/presentationml/2006/main" xmlns:r="http://schemas.openxmlformats.org/officeDocument/2006/relationships">
+  <p:cSld>
+    <p:bg>
+      <p:bgPr>
+        <a:solidFill>
+          <a:srgbClr val="FFFFFF"/>
+        </a:solidFill>
+        <a:effectLst/>
+      </p:bgPr>
+    </p:bg>
+    <p:spTree>
+      <p:nvGrpSpPr>
+        <p:cNvPr id="1" name=""/>
+        <p:cNvGrpSpPr/>
+        <p:nvPr/>
+      </p:nvGrpSpPr>
+      <p:grpSpPr/>
+      <p:sp>
+        <p:nvSpPr>
+          <p:cNvPr id="2" name="Rectangle 1"/>
+          <p:cNvSpPr/>
+          <p:nvPr/>
+        </p:nvSpPr>
+        <p:spPr>
+          <a:xfrm>
+            <a:off x="0" y="0"/>
+            <a:ext cx="109728" cy="6858000"/>
+          </a:xfrm>
+          <a:prstGeom prst="rect">
+            <a:avLst/>
+          </a:prstGeom>
+          <a:solidFill>
+            <a:srgbClr val="028090"/>
+          </a:solidFill>
+          <a:ln>
+            <a:noFill/>
+          </a:ln>
+        </p:spPr>
+        <p:style>
+          <a:lnRef idx="1">
+            <a:schemeClr val="accent1"/>
+          </a:lnRef>
+          <a:fillRef idx="3">
+            <a:schemeClr val="accent1"/>
+          </a:fillRef>
+          <a:effectRef idx="2">
+            <a:schemeClr val="accent1"/>
+          </a:effectRef>
+          <a:fontRef idx="minor">
+            <a:schemeClr val="lt1"/>
+          </a:fontRef>
+        </p:style>
+        <p:txBody>
+          <a:bodyPr rtlCol="0" anchor="ctr"/>
+          <a:lstStyle/>
+          <a:p>
+            <a:pPr algn="ctr"/>
+          </a:p>
+        </p:txBody>
+      </p:sp>
+      <p:sp>
+        <p:nvSpPr>
+          <p:cNvPr id="3" name="TextBox 2"/>
+          <p:cNvSpPr txBox="1"/>
+          <p:nvPr/>
+        </p:nvSpPr>
+        <p:spPr>
+          <a:xfrm>
+            <a:off x="1143000" y="347472"/>
+            <a:ext cx="10607040" cy="914400"/>
+          </a:xfrm>
+          <a:prstGeom prst="rect">
+            <a:avLst/>
+          </a:prstGeom>
+          <a:noFill/>
+        </p:spPr>
+        <p:txBody>
+          <a:bodyPr wrap="square" anchor="t" lIns="25400" rIns="25400" tIns="25400" bIns="25400">
+            <a:spAutoFit/>
+          </a:bodyPr>
+          <a:lstStyle/>
+          <a:p>
+            <a:pPr algn="l">
+              <a:spcAft>
+                <a:spcPts val="400"/>
+              </a:spcAft>
+            </a:pPr>
+            <a:r>
+              <a:rPr sz="2600" b="1">
+                <a:solidFill>
+                  <a:srgbClr val="065A82"/>
+                </a:solidFill>
+                <a:latin typeface="微软雅黑"/>
+                <a:ea typeface="微软雅黑"/>
+                <a:cs typeface="微软雅黑"/>
+              </a:rPr>
+              <a:t>附录 D:动力学实飞功率剖面</a:t>
+            </a:r>
+          </a:p>
+        </p:txBody>
+      </p:sp>
+      <p:pic>
+        <p:nvPicPr>
+          <p:cNvPr id="4" name="Picture 3" descr="sim_flight.png"/>
+          <p:cNvPicPr>
+            <a:picLocks noChangeAspect="1"/>
+          </p:cNvPicPr>
+          <p:nvPr/>
+        </p:nvPicPr>
+        <p:blipFill>
+          <a:blip r:embed="rId2"/>
+          <a:stretch>
+            <a:fillRect/>
+          </a:stretch>
+        </p:blipFill>
+        <p:spPr>
+          <a:xfrm>
+            <a:off x="731520" y="2573464"/>
+            <a:ext cx="10698480" cy="2808351"/>
+          </a:xfrm>
+          <a:prstGeom prst="rect">
+            <a:avLst/>
+          </a:prstGeom>
+        </p:spPr>
+      </p:pic>
+      <p:sp>
+        <p:nvSpPr>
+          <p:cNvPr id="5" name="TextBox 4"/>
+          <p:cNvSpPr txBox="1"/>
+          <p:nvPr/>
+        </p:nvSpPr>
+        <p:spPr>
+          <a:xfrm>
+            <a:off x="502920" y="6400800"/>
+            <a:ext cx="11155680" cy="320040"/>
+          </a:xfrm>
+          <a:prstGeom prst="rect">
+            <a:avLst/>
+          </a:prstGeom>
+          <a:noFill/>
+        </p:spPr>
+        <p:txBody>
+          <a:bodyPr wrap="square" anchor="t" lIns="25400" rIns="25400" tIns="25400" bIns="25400">
+            <a:spAutoFit/>
+          </a:bodyPr>
+          <a:lstStyle/>
+          <a:p>
+            <a:pPr algn="l">
+              <a:spcAft>
+                <a:spcPts val="400"/>
+              </a:spcAft>
+            </a:pPr>
+            <a:r>
+              <a:rPr sz="1100" b="0">
+                <a:solidFill>
+                  <a:srgbClr val="6B7A8D"/>
+                </a:solidFill>
+                <a:latin typeface="微软雅黑"/>
+                <a:ea typeface="微软雅黑"/>
+                <a:cs typeface="微软雅黑"/>
+              </a:rPr>
+              <a:t>翻墙爬升段飙 870W,绕行平稳</a:t>
+            </a:r>
+          </a:p>
+        </p:txBody>
+      </p:sp>
+    </p:spTree>
+  </p:cSld>
+  <p:clrMapOvr>
+    <a:masterClrMapping/>
+  </p:clrMapOvr>
+</p:sld>
+</file>
+
+<file path=ppt/slides/slide23.xml><?xml version="1.0" encoding="utf-8"?>
 <p:sld xmlns:a="http://schemas.openxmlformats.org/drawingml/2006/main" xmlns:p="http://schemas.openxmlformats.org/presentationml/2006/main" xmlns:r="http://schemas.openxmlformats.org/officeDocument/2006/relationships">
   <p:cSld>
     <p:bg>

</xml_diff>

<commit_message>
Recolor deck+slides to XJTU (Xi'an Jiaotong) blue palette to match university template; add convergence-speed experiment (honest: random converges faster in this small space = further edge-case evidence) + value-dimension precedents from deep-research
配色改西交蓝(#0563C1/#4472C4,匹配2022西安交通大学创新港模板)。收敛速度实验:能耗域随机4次到地板、loop~17次——诚实负结果,进一步坐实小空间/数据封顶域结构搜索无益(不是收敛更快)。AI4S_POSITIONING补价值维度先例(Bergstra&Bengio2012样本效率/Li&Talwalkar2019/FunSearch可解释)。ARCH_AND_VALUE_RESEARCH.md存调研全文。

Co-Authored-By: Claude Opus 4.8 (1M context) <noreply@anthropic.com>
</commit_message>
<xml_diff>
--- a/autoresearch/energy_m100/experiments/midterm_defense.pptx
+++ b/autoresearch/energy_m100/experiments/midterm_defense.pptx
@@ -3108,7 +3108,7 @@
     <p:bg>
       <p:bgPr>
         <a:solidFill>
-          <a:srgbClr val="1E2961"/>
+          <a:srgbClr val="0A2A66"/>
         </a:solidFill>
         <a:effectLst/>
       </p:bgPr>
@@ -3135,7 +3135,7 @@
             <a:avLst/>
           </a:prstGeom>
           <a:solidFill>
-            <a:srgbClr val="02C39A"/>
+            <a:srgbClr val="5B9BD5"/>
           </a:solidFill>
           <a:ln>
             <a:noFill/>
@@ -3211,7 +3211,7 @@
             <a:r>
               <a:rPr sz="4000" b="1">
                 <a:solidFill>
-                  <a:srgbClr val="02C39A"/>
+                  <a:srgbClr val="5B9BD5"/>
                 </a:solidFill>
                 <a:latin typeface="微软雅黑"/>
                 <a:ea typeface="微软雅黑"/>
@@ -3252,7 +3252,7 @@
             <a:r>
               <a:rPr sz="1500" b="0">
                 <a:solidFill>
-                  <a:srgbClr val="CADCFC"/>
+                  <a:srgbClr val="D6E4F7"/>
                 </a:solidFill>
                 <a:latin typeface="微软雅黑"/>
                 <a:ea typeface="微软雅黑"/>
@@ -3270,7 +3270,7 @@
             <a:r>
               <a:rPr sz="1500" b="0">
                 <a:solidFill>
-                  <a:srgbClr val="CADCFC"/>
+                  <a:srgbClr val="D6E4F7"/>
                 </a:solidFill>
                 <a:latin typeface="微软雅黑"/>
                 <a:ea typeface="微软雅黑"/>
@@ -3363,7 +3363,7 @@
             <a:avLst/>
           </a:prstGeom>
           <a:solidFill>
-            <a:srgbClr val="028090"/>
+            <a:srgbClr val="4472C4"/>
           </a:solidFill>
           <a:ln>
             <a:noFill/>
@@ -3406,7 +3406,7 @@
             <a:avLst/>
           </a:prstGeom>
           <a:solidFill>
-            <a:srgbClr val="028090"/>
+            <a:srgbClr val="4472C4"/>
           </a:solidFill>
           <a:ln>
             <a:noFill/>
@@ -3475,7 +3475,7 @@
             <a:r>
               <a:rPr sz="2600" b="1">
                 <a:solidFill>
-                  <a:srgbClr val="065A82"/>
+                  <a:srgbClr val="0563C1"/>
                 </a:solidFill>
                 <a:latin typeface="微软雅黑"/>
                 <a:ea typeface="微软雅黑"/>
@@ -3582,7 +3582,7 @@
             <a:r>
               <a:rPr sz="1600" b="1">
                 <a:solidFill>
-                  <a:srgbClr val="02C39A"/>
+                  <a:srgbClr val="5B9BD5"/>
                 </a:solidFill>
                 <a:latin typeface="微软雅黑"/>
                 <a:ea typeface="微软雅黑"/>
@@ -3747,7 +3747,7 @@
             <a:avLst/>
           </a:prstGeom>
           <a:solidFill>
-            <a:srgbClr val="028090"/>
+            <a:srgbClr val="4472C4"/>
           </a:solidFill>
           <a:ln>
             <a:noFill/>
@@ -3790,7 +3790,7 @@
             <a:avLst/>
           </a:prstGeom>
           <a:solidFill>
-            <a:srgbClr val="028090"/>
+            <a:srgbClr val="4472C4"/>
           </a:solidFill>
           <a:ln>
             <a:noFill/>
@@ -3859,7 +3859,7 @@
             <a:r>
               <a:rPr sz="2600" b="1">
                 <a:solidFill>
-                  <a:srgbClr val="065A82"/>
+                  <a:srgbClr val="0563C1"/>
                 </a:solidFill>
                 <a:latin typeface="微软雅黑"/>
                 <a:ea typeface="微软雅黑"/>
@@ -4002,7 +4002,7 @@
             <a:r>
               <a:rPr sz="1800" b="1">
                 <a:solidFill>
-                  <a:srgbClr val="065A82"/>
+                  <a:srgbClr val="0563C1"/>
                 </a:solidFill>
                 <a:latin typeface="微软雅黑"/>
                 <a:ea typeface="微软雅黑"/>
@@ -4131,7 +4131,7 @@
             <a:avLst/>
           </a:prstGeom>
           <a:solidFill>
-            <a:srgbClr val="028090"/>
+            <a:srgbClr val="4472C4"/>
           </a:solidFill>
           <a:ln>
             <a:noFill/>
@@ -4174,7 +4174,7 @@
             <a:avLst/>
           </a:prstGeom>
           <a:solidFill>
-            <a:srgbClr val="028090"/>
+            <a:srgbClr val="4472C4"/>
           </a:solidFill>
           <a:ln>
             <a:noFill/>
@@ -4243,7 +4243,7 @@
             <a:r>
               <a:rPr sz="2600" b="1">
                 <a:solidFill>
-                  <a:srgbClr val="065A82"/>
+                  <a:srgbClr val="0563C1"/>
                 </a:solidFill>
                 <a:latin typeface="微软雅黑"/>
                 <a:ea typeface="微软雅黑"/>
@@ -4370,7 +4370,7 @@
             <a:r>
               <a:rPr sz="1500" b="1">
                 <a:solidFill>
-                  <a:srgbClr val="065A82"/>
+                  <a:srgbClr val="0563C1"/>
                 </a:solidFill>
                 <a:latin typeface="微软雅黑"/>
                 <a:ea typeface="微软雅黑"/>
@@ -4497,7 +4497,7 @@
             <a:r>
               <a:rPr sz="1500" b="1">
                 <a:solidFill>
-                  <a:srgbClr val="065A82"/>
+                  <a:srgbClr val="0563C1"/>
                 </a:solidFill>
                 <a:latin typeface="微软雅黑"/>
                 <a:ea typeface="微软雅黑"/>
@@ -4624,7 +4624,7 @@
             <a:r>
               <a:rPr sz="1500" b="1">
                 <a:solidFill>
-                  <a:srgbClr val="065A82"/>
+                  <a:srgbClr val="0563C1"/>
                 </a:solidFill>
                 <a:latin typeface="微软雅黑"/>
                 <a:ea typeface="微软雅黑"/>
@@ -4751,7 +4751,7 @@
             <a:r>
               <a:rPr sz="1500" b="1">
                 <a:solidFill>
-                  <a:srgbClr val="065A82"/>
+                  <a:srgbClr val="0563C1"/>
                 </a:solidFill>
                 <a:latin typeface="微软雅黑"/>
                 <a:ea typeface="微软雅黑"/>
@@ -4878,7 +4878,7 @@
             <a:r>
               <a:rPr sz="1500" b="1">
                 <a:solidFill>
-                  <a:srgbClr val="065A82"/>
+                  <a:srgbClr val="0563C1"/>
                 </a:solidFill>
                 <a:latin typeface="微软雅黑"/>
                 <a:ea typeface="微软雅黑"/>
@@ -4919,7 +4919,7 @@
             <a:r>
               <a:rPr sz="1600" b="1">
                 <a:solidFill>
-                  <a:srgbClr val="B83A3A"/>
+                  <a:srgbClr val="C0502D"/>
                 </a:solidFill>
                 <a:latin typeface="微软雅黑"/>
                 <a:ea typeface="微软雅黑"/>
@@ -4971,7 +4971,7 @@
             <a:avLst/>
           </a:prstGeom>
           <a:solidFill>
-            <a:srgbClr val="028090"/>
+            <a:srgbClr val="4472C4"/>
           </a:solidFill>
           <a:ln>
             <a:noFill/>
@@ -5014,7 +5014,7 @@
             <a:avLst/>
           </a:prstGeom>
           <a:solidFill>
-            <a:srgbClr val="028090"/>
+            <a:srgbClr val="4472C4"/>
           </a:solidFill>
           <a:ln>
             <a:noFill/>
@@ -5083,7 +5083,7 @@
             <a:r>
               <a:rPr sz="2600" b="1">
                 <a:solidFill>
-                  <a:srgbClr val="065A82"/>
+                  <a:srgbClr val="0563C1"/>
                 </a:solidFill>
                 <a:latin typeface="微软雅黑"/>
                 <a:ea typeface="微软雅黑"/>
@@ -5184,7 +5184,7 @@
             <a:r>
               <a:rPr sz="1400" b="1">
                 <a:solidFill>
-                  <a:srgbClr val="B83A3A"/>
+                  <a:srgbClr val="C0502D"/>
                 </a:solidFill>
                 <a:latin typeface="微软雅黑"/>
                 <a:ea typeface="微软雅黑"/>
@@ -5385,7 +5385,7 @@
             <a:avLst/>
           </a:prstGeom>
           <a:solidFill>
-            <a:srgbClr val="028090"/>
+            <a:srgbClr val="4472C4"/>
           </a:solidFill>
           <a:ln>
             <a:noFill/>
@@ -5428,7 +5428,7 @@
             <a:avLst/>
           </a:prstGeom>
           <a:solidFill>
-            <a:srgbClr val="028090"/>
+            <a:srgbClr val="4472C4"/>
           </a:solidFill>
           <a:ln>
             <a:noFill/>
@@ -5497,7 +5497,7 @@
             <a:r>
               <a:rPr sz="2600" b="1">
                 <a:solidFill>
-                  <a:srgbClr val="065A82"/>
+                  <a:srgbClr val="0563C1"/>
                 </a:solidFill>
                 <a:latin typeface="微软雅黑"/>
                 <a:ea typeface="微软雅黑"/>
@@ -5598,7 +5598,7 @@
             <a:r>
               <a:rPr sz="1600" b="1">
                 <a:solidFill>
-                  <a:srgbClr val="02C39A"/>
+                  <a:srgbClr val="5B9BD5"/>
                 </a:solidFill>
                 <a:latin typeface="微软雅黑"/>
                 <a:ea typeface="微软雅黑"/>
@@ -5634,7 +5634,7 @@
             <a:r>
               <a:rPr sz="1600" b="1">
                 <a:solidFill>
-                  <a:srgbClr val="065A82"/>
+                  <a:srgbClr val="0563C1"/>
                 </a:solidFill>
                 <a:latin typeface="微软雅黑"/>
                 <a:ea typeface="微软雅黑"/>
@@ -5727,7 +5727,7 @@
             <a:avLst/>
           </a:prstGeom>
           <a:solidFill>
-            <a:srgbClr val="028090"/>
+            <a:srgbClr val="4472C4"/>
           </a:solidFill>
           <a:ln>
             <a:noFill/>
@@ -5770,7 +5770,7 @@
             <a:avLst/>
           </a:prstGeom>
           <a:solidFill>
-            <a:srgbClr val="028090"/>
+            <a:srgbClr val="4472C4"/>
           </a:solidFill>
           <a:ln>
             <a:noFill/>
@@ -5839,7 +5839,7 @@
             <a:r>
               <a:rPr sz="2600" b="1">
                 <a:solidFill>
-                  <a:srgbClr val="065A82"/>
+                  <a:srgbClr val="0563C1"/>
                 </a:solidFill>
                 <a:latin typeface="微软雅黑"/>
                 <a:ea typeface="微软雅黑"/>
@@ -5976,7 +5976,7 @@
             <a:r>
               <a:rPr sz="1600" b="1">
                 <a:solidFill>
-                  <a:srgbClr val="02C39A"/>
+                  <a:srgbClr val="5B9BD5"/>
                 </a:solidFill>
                 <a:latin typeface="微软雅黑"/>
                 <a:ea typeface="微软雅黑"/>
@@ -6012,7 +6012,7 @@
             <a:r>
               <a:rPr sz="1700" b="1">
                 <a:solidFill>
-                  <a:srgbClr val="065A82"/>
+                  <a:srgbClr val="0563C1"/>
                 </a:solidFill>
                 <a:latin typeface="微软雅黑"/>
                 <a:ea typeface="微软雅黑"/>
@@ -6105,7 +6105,7 @@
             <a:avLst/>
           </a:prstGeom>
           <a:solidFill>
-            <a:srgbClr val="028090"/>
+            <a:srgbClr val="4472C4"/>
           </a:solidFill>
           <a:ln>
             <a:noFill/>
@@ -6148,7 +6148,7 @@
             <a:avLst/>
           </a:prstGeom>
           <a:solidFill>
-            <a:srgbClr val="028090"/>
+            <a:srgbClr val="4472C4"/>
           </a:solidFill>
           <a:ln>
             <a:noFill/>
@@ -6217,7 +6217,7 @@
             <a:r>
               <a:rPr sz="2600" b="1">
                 <a:solidFill>
-                  <a:srgbClr val="065A82"/>
+                  <a:srgbClr val="0563C1"/>
                 </a:solidFill>
                 <a:latin typeface="微软雅黑"/>
                 <a:ea typeface="微软雅黑"/>
@@ -6282,7 +6282,7 @@
             <a:r>
               <a:rPr sz="1600" b="1">
                 <a:solidFill>
-                  <a:srgbClr val="B83A3A"/>
+                  <a:srgbClr val="C0502D"/>
                 </a:solidFill>
                 <a:latin typeface="微软雅黑"/>
                 <a:ea typeface="微软雅黑"/>
@@ -6318,7 +6318,7 @@
             <a:r>
               <a:rPr sz="1600" b="1">
                 <a:solidFill>
-                  <a:srgbClr val="02C39A"/>
+                  <a:srgbClr val="5B9BD5"/>
                 </a:solidFill>
                 <a:latin typeface="微软雅黑"/>
                 <a:ea typeface="微软雅黑"/>
@@ -6465,7 +6465,7 @@
             <a:avLst/>
           </a:prstGeom>
           <a:solidFill>
-            <a:srgbClr val="028090"/>
+            <a:srgbClr val="4472C4"/>
           </a:solidFill>
           <a:ln>
             <a:noFill/>
@@ -6508,7 +6508,7 @@
             <a:avLst/>
           </a:prstGeom>
           <a:solidFill>
-            <a:srgbClr val="028090"/>
+            <a:srgbClr val="4472C4"/>
           </a:solidFill>
           <a:ln>
             <a:noFill/>
@@ -6577,7 +6577,7 @@
             <a:r>
               <a:rPr sz="2600" b="1">
                 <a:solidFill>
-                  <a:srgbClr val="065A82"/>
+                  <a:srgbClr val="0563C1"/>
                 </a:solidFill>
                 <a:latin typeface="微软雅黑"/>
                 <a:ea typeface="微软雅黑"/>
@@ -6732,7 +6732,7 @@
             <a:r>
               <a:rPr sz="1600" b="1">
                 <a:solidFill>
-                  <a:srgbClr val="065A82"/>
+                  <a:srgbClr val="0563C1"/>
                 </a:solidFill>
                 <a:latin typeface="微软雅黑"/>
                 <a:ea typeface="微软雅黑"/>
@@ -6798,7 +6798,7 @@
     <p:bg>
       <p:bgPr>
         <a:solidFill>
-          <a:srgbClr val="1E2961"/>
+          <a:srgbClr val="0A2A66"/>
         </a:solidFill>
         <a:effectLst/>
       </p:bgPr>
@@ -6825,7 +6825,7 @@
             <a:avLst/>
           </a:prstGeom>
           <a:solidFill>
-            <a:srgbClr val="02C39A"/>
+            <a:srgbClr val="5B9BD5"/>
           </a:solidFill>
           <a:ln>
             <a:noFill/>
@@ -6868,7 +6868,7 @@
             <a:avLst/>
           </a:prstGeom>
           <a:solidFill>
-            <a:srgbClr val="02C39A"/>
+            <a:srgbClr val="5B9BD5"/>
           </a:solidFill>
           <a:ln>
             <a:noFill/>
@@ -6937,7 +6937,7 @@
             <a:r>
               <a:rPr sz="2400" b="1">
                 <a:solidFill>
-                  <a:srgbClr val="02C39A"/>
+                  <a:srgbClr val="5B9BD5"/>
                 </a:solidFill>
                 <a:latin typeface="微软雅黑"/>
                 <a:ea typeface="微软雅黑"/>
@@ -6996,7 +6996,7 @@
             <a:r>
               <a:rPr sz="2100" b="1">
                 <a:solidFill>
-                  <a:srgbClr val="02C39A"/>
+                  <a:srgbClr val="5B9BD5"/>
                 </a:solidFill>
                 <a:latin typeface="微软雅黑"/>
                 <a:ea typeface="微软雅黑"/>
@@ -7102,7 +7102,7 @@
             <a:avLst/>
           </a:prstGeom>
           <a:solidFill>
-            <a:srgbClr val="028090"/>
+            <a:srgbClr val="4472C4"/>
           </a:solidFill>
           <a:ln>
             <a:noFill/>
@@ -7145,7 +7145,7 @@
             <a:avLst/>
           </a:prstGeom>
           <a:solidFill>
-            <a:srgbClr val="028090"/>
+            <a:srgbClr val="4472C4"/>
           </a:solidFill>
           <a:ln>
             <a:noFill/>
@@ -7214,7 +7214,7 @@
             <a:r>
               <a:rPr sz="2600" b="1">
                 <a:solidFill>
-                  <a:srgbClr val="065A82"/>
+                  <a:srgbClr val="0563C1"/>
                 </a:solidFill>
                 <a:latin typeface="微软雅黑"/>
                 <a:ea typeface="微软雅黑"/>
@@ -7451,7 +7451,7 @@
             <a:avLst/>
           </a:prstGeom>
           <a:solidFill>
-            <a:srgbClr val="028090"/>
+            <a:srgbClr val="4472C4"/>
           </a:solidFill>
           <a:ln>
             <a:noFill/>
@@ -7494,7 +7494,7 @@
             <a:avLst/>
           </a:prstGeom>
           <a:solidFill>
-            <a:srgbClr val="028090"/>
+            <a:srgbClr val="4472C4"/>
           </a:solidFill>
           <a:ln>
             <a:noFill/>
@@ -7563,7 +7563,7 @@
             <a:r>
               <a:rPr sz="2600" b="1">
                 <a:solidFill>
-                  <a:srgbClr val="065A82"/>
+                  <a:srgbClr val="0563C1"/>
                 </a:solidFill>
                 <a:latin typeface="微软雅黑"/>
                 <a:ea typeface="微软雅黑"/>
@@ -7604,7 +7604,7 @@
             <a:r>
               <a:rPr sz="9600" b="1">
                 <a:solidFill>
-                  <a:srgbClr val="065A82"/>
+                  <a:srgbClr val="0563C1"/>
                 </a:solidFill>
                 <a:latin typeface="微软雅黑"/>
                 <a:ea typeface="微软雅黑"/>
@@ -7717,7 +7717,7 @@
             <a:r>
               <a:rPr sz="1600" b="0">
                 <a:solidFill>
-                  <a:srgbClr val="B83A3A"/>
+                  <a:srgbClr val="C0502D"/>
                 </a:solidFill>
                 <a:latin typeface="微软雅黑"/>
                 <a:ea typeface="微软雅黑"/>
@@ -7735,7 +7735,7 @@
             <a:r>
               <a:rPr sz="1600" b="0">
                 <a:solidFill>
-                  <a:srgbClr val="B83A3A"/>
+                  <a:srgbClr val="C0502D"/>
                 </a:solidFill>
                 <a:latin typeface="微软雅黑"/>
                 <a:ea typeface="微软雅黑"/>
@@ -7828,7 +7828,7 @@
             <a:avLst/>
           </a:prstGeom>
           <a:solidFill>
-            <a:srgbClr val="028090"/>
+            <a:srgbClr val="4472C4"/>
           </a:solidFill>
           <a:ln>
             <a:noFill/>
@@ -7886,7 +7886,7 @@
             <a:r>
               <a:rPr sz="2600" b="1">
                 <a:solidFill>
-                  <a:srgbClr val="065A82"/>
+                  <a:srgbClr val="0563C1"/>
                 </a:solidFill>
                 <a:latin typeface="微软雅黑"/>
                 <a:ea typeface="微软雅黑"/>
@@ -8003,7 +8003,7 @@
             <a:avLst/>
           </a:prstGeom>
           <a:solidFill>
-            <a:srgbClr val="028090"/>
+            <a:srgbClr val="4472C4"/>
           </a:solidFill>
           <a:ln>
             <a:noFill/>
@@ -8061,7 +8061,7 @@
             <a:r>
               <a:rPr sz="2600" b="1">
                 <a:solidFill>
-                  <a:srgbClr val="065A82"/>
+                  <a:srgbClr val="0563C1"/>
                 </a:solidFill>
                 <a:latin typeface="微软雅黑"/>
                 <a:ea typeface="微软雅黑"/>
@@ -8178,7 +8178,7 @@
             <a:avLst/>
           </a:prstGeom>
           <a:solidFill>
-            <a:srgbClr val="028090"/>
+            <a:srgbClr val="4472C4"/>
           </a:solidFill>
           <a:ln>
             <a:noFill/>
@@ -8236,7 +8236,7 @@
             <a:r>
               <a:rPr sz="2600" b="1">
                 <a:solidFill>
-                  <a:srgbClr val="065A82"/>
+                  <a:srgbClr val="0563C1"/>
                 </a:solidFill>
                 <a:latin typeface="微软雅黑"/>
                 <a:ea typeface="微软雅黑"/>
@@ -8353,7 +8353,7 @@
             <a:avLst/>
           </a:prstGeom>
           <a:solidFill>
-            <a:srgbClr val="028090"/>
+            <a:srgbClr val="4472C4"/>
           </a:solidFill>
           <a:ln>
             <a:noFill/>
@@ -8411,7 +8411,7 @@
             <a:r>
               <a:rPr sz="2600" b="1">
                 <a:solidFill>
-                  <a:srgbClr val="065A82"/>
+                  <a:srgbClr val="0563C1"/>
                 </a:solidFill>
                 <a:latin typeface="微软雅黑"/>
                 <a:ea typeface="微软雅黑"/>
@@ -8528,7 +8528,7 @@
             <a:avLst/>
           </a:prstGeom>
           <a:solidFill>
-            <a:srgbClr val="028090"/>
+            <a:srgbClr val="4472C4"/>
           </a:solidFill>
           <a:ln>
             <a:noFill/>
@@ -8586,7 +8586,7 @@
             <a:r>
               <a:rPr sz="2600" b="1">
                 <a:solidFill>
-                  <a:srgbClr val="065A82"/>
+                  <a:srgbClr val="0563C1"/>
                 </a:solidFill>
                 <a:latin typeface="微软雅黑"/>
                 <a:ea typeface="微软雅黑"/>
@@ -8703,7 +8703,7 @@
             <a:avLst/>
           </a:prstGeom>
           <a:solidFill>
-            <a:srgbClr val="028090"/>
+            <a:srgbClr val="4472C4"/>
           </a:solidFill>
           <a:ln>
             <a:noFill/>
@@ -8761,7 +8761,7 @@
             <a:r>
               <a:rPr sz="2600" b="1">
                 <a:solidFill>
-                  <a:srgbClr val="065A82"/>
+                  <a:srgbClr val="0563C1"/>
                 </a:solidFill>
                 <a:latin typeface="微软雅黑"/>
                 <a:ea typeface="微软雅黑"/>
@@ -8851,7 +8851,7 @@
     <p:bg>
       <p:bgPr>
         <a:solidFill>
-          <a:srgbClr val="1E2961"/>
+          <a:srgbClr val="0A2A66"/>
         </a:solidFill>
         <a:effectLst/>
       </p:bgPr>
@@ -8878,7 +8878,7 @@
             <a:avLst/>
           </a:prstGeom>
           <a:solidFill>
-            <a:srgbClr val="02C39A"/>
+            <a:srgbClr val="5B9BD5"/>
           </a:solidFill>
           <a:ln>
             <a:noFill/>
@@ -8921,7 +8921,7 @@
             <a:avLst/>
           </a:prstGeom>
           <a:solidFill>
-            <a:srgbClr val="02C39A"/>
+            <a:srgbClr val="5B9BD5"/>
           </a:solidFill>
           <a:ln>
             <a:noFill/>
@@ -8990,7 +8990,7 @@
             <a:r>
               <a:rPr sz="2200" b="1">
                 <a:solidFill>
-                  <a:srgbClr val="02C39A"/>
+                  <a:srgbClr val="5B9BD5"/>
                 </a:solidFill>
                 <a:latin typeface="微软雅黑"/>
                 <a:ea typeface="微软雅黑"/>
@@ -9090,7 +9090,7 @@
             <a:r>
               <a:rPr sz="1700" b="0">
                 <a:solidFill>
-                  <a:srgbClr val="CADCFC"/>
+                  <a:srgbClr val="D6E4F7"/>
                 </a:solidFill>
                 <a:latin typeface="微软雅黑"/>
                 <a:ea typeface="微软雅黑"/>
@@ -9142,7 +9142,7 @@
             <a:avLst/>
           </a:prstGeom>
           <a:solidFill>
-            <a:srgbClr val="028090"/>
+            <a:srgbClr val="4472C4"/>
           </a:solidFill>
           <a:ln>
             <a:noFill/>
@@ -9185,7 +9185,7 @@
             <a:avLst/>
           </a:prstGeom>
           <a:solidFill>
-            <a:srgbClr val="028090"/>
+            <a:srgbClr val="4472C4"/>
           </a:solidFill>
           <a:ln>
             <a:noFill/>
@@ -9254,7 +9254,7 @@
             <a:r>
               <a:rPr sz="2600" b="1">
                 <a:solidFill>
-                  <a:srgbClr val="065A82"/>
+                  <a:srgbClr val="0563C1"/>
                 </a:solidFill>
                 <a:latin typeface="微软雅黑"/>
                 <a:ea typeface="微软雅黑"/>
@@ -9381,7 +9381,7 @@
             <a:r>
               <a:rPr sz="1500" b="1">
                 <a:solidFill>
-                  <a:srgbClr val="028090"/>
+                  <a:srgbClr val="4472C4"/>
                 </a:solidFill>
                 <a:latin typeface="微软雅黑"/>
                 <a:ea typeface="微软雅黑"/>
@@ -9549,7 +9549,7 @@
             <a:r>
               <a:rPr sz="1500" b="1">
                 <a:solidFill>
-                  <a:srgbClr val="028090"/>
+                  <a:srgbClr val="4472C4"/>
                 </a:solidFill>
                 <a:latin typeface="微软雅黑"/>
                 <a:ea typeface="微软雅黑"/>
@@ -9717,7 +9717,7 @@
             <a:r>
               <a:rPr sz="1500" b="1">
                 <a:solidFill>
-                  <a:srgbClr val="028090"/>
+                  <a:srgbClr val="4472C4"/>
                 </a:solidFill>
                 <a:latin typeface="微软雅黑"/>
                 <a:ea typeface="微软雅黑"/>
@@ -9885,7 +9885,7 @@
             <a:r>
               <a:rPr sz="1500" b="1">
                 <a:solidFill>
-                  <a:srgbClr val="028090"/>
+                  <a:srgbClr val="4472C4"/>
                 </a:solidFill>
                 <a:latin typeface="微软雅黑"/>
                 <a:ea typeface="微软雅黑"/>
@@ -10053,7 +10053,7 @@
             <a:r>
               <a:rPr sz="1500" b="1">
                 <a:solidFill>
-                  <a:srgbClr val="028090"/>
+                  <a:srgbClr val="4472C4"/>
                 </a:solidFill>
                 <a:latin typeface="微软雅黑"/>
                 <a:ea typeface="微软雅黑"/>
@@ -10221,7 +10221,7 @@
             <a:r>
               <a:rPr sz="1500" b="1">
                 <a:solidFill>
-                  <a:srgbClr val="028090"/>
+                  <a:srgbClr val="4472C4"/>
                 </a:solidFill>
                 <a:latin typeface="微软雅黑"/>
                 <a:ea typeface="微软雅黑"/>
@@ -10314,7 +10314,7 @@
             <a:avLst/>
           </a:prstGeom>
           <a:solidFill>
-            <a:srgbClr val="028090"/>
+            <a:srgbClr val="4472C4"/>
           </a:solidFill>
           <a:ln>
             <a:noFill/>
@@ -10357,7 +10357,7 @@
             <a:avLst/>
           </a:prstGeom>
           <a:solidFill>
-            <a:srgbClr val="028090"/>
+            <a:srgbClr val="4472C4"/>
           </a:solidFill>
           <a:ln>
             <a:noFill/>
@@ -10426,7 +10426,7 @@
             <a:r>
               <a:rPr sz="2600" b="1">
                 <a:solidFill>
-                  <a:srgbClr val="065A82"/>
+                  <a:srgbClr val="0563C1"/>
                 </a:solidFill>
                 <a:latin typeface="微软雅黑"/>
                 <a:ea typeface="微软雅黑"/>
@@ -10452,7 +10452,7 @@
             <a:avLst/>
           </a:prstGeom>
           <a:solidFill>
-            <a:srgbClr val="028090"/>
+            <a:srgbClr val="4472C4"/>
           </a:solidFill>
           <a:ln>
             <a:noFill/>
@@ -10588,7 +10588,7 @@
             <a:avLst/>
           </a:prstGeom>
           <a:solidFill>
-            <a:srgbClr val="065A82"/>
+            <a:srgbClr val="0563C1"/>
           </a:solidFill>
           <a:ln>
             <a:noFill/>
@@ -10724,7 +10724,7 @@
             <a:avLst/>
           </a:prstGeom>
           <a:solidFill>
-            <a:srgbClr val="028090"/>
+            <a:srgbClr val="4472C4"/>
           </a:solidFill>
           <a:ln>
             <a:noFill/>
@@ -10860,7 +10860,7 @@
             <a:avLst/>
           </a:prstGeom>
           <a:solidFill>
-            <a:srgbClr val="065A82"/>
+            <a:srgbClr val="0563C1"/>
           </a:solidFill>
           <a:ln>
             <a:noFill/>
@@ -10996,7 +10996,7 @@
             <a:avLst/>
           </a:prstGeom>
           <a:solidFill>
-            <a:srgbClr val="028090"/>
+            <a:srgbClr val="4472C4"/>
           </a:solidFill>
           <a:ln>
             <a:noFill/>
@@ -11158,7 +11158,7 @@
             <a:avLst/>
           </a:prstGeom>
           <a:solidFill>
-            <a:srgbClr val="028090"/>
+            <a:srgbClr val="4472C4"/>
           </a:solidFill>
           <a:ln>
             <a:noFill/>
@@ -11201,7 +11201,7 @@
             <a:avLst/>
           </a:prstGeom>
           <a:solidFill>
-            <a:srgbClr val="028090"/>
+            <a:srgbClr val="4472C4"/>
           </a:solidFill>
           <a:ln>
             <a:noFill/>
@@ -11270,7 +11270,7 @@
             <a:r>
               <a:rPr sz="2600" b="1">
                 <a:solidFill>
-                  <a:srgbClr val="065A82"/>
+                  <a:srgbClr val="0563C1"/>
                 </a:solidFill>
                 <a:latin typeface="微软雅黑"/>
                 <a:ea typeface="微软雅黑"/>
@@ -11387,7 +11387,7 @@
             <a:avLst/>
           </a:prstGeom>
           <a:solidFill>
-            <a:srgbClr val="028090"/>
+            <a:srgbClr val="4472C4"/>
           </a:solidFill>
           <a:ln>
             <a:noFill/>
@@ -11430,7 +11430,7 @@
             <a:avLst/>
           </a:prstGeom>
           <a:solidFill>
-            <a:srgbClr val="028090"/>
+            <a:srgbClr val="4472C4"/>
           </a:solidFill>
           <a:ln>
             <a:noFill/>
@@ -11499,7 +11499,7 @@
             <a:r>
               <a:rPr sz="2600" b="1">
                 <a:solidFill>
-                  <a:srgbClr val="065A82"/>
+                  <a:srgbClr val="0563C1"/>
                 </a:solidFill>
                 <a:latin typeface="微软雅黑"/>
                 <a:ea typeface="微软雅黑"/>
@@ -11765,7 +11765,7 @@
             <a:avLst/>
           </a:prstGeom>
           <a:solidFill>
-            <a:srgbClr val="028090"/>
+            <a:srgbClr val="4472C4"/>
           </a:solidFill>
           <a:ln>
             <a:noFill/>
@@ -11808,7 +11808,7 @@
             <a:avLst/>
           </a:prstGeom>
           <a:solidFill>
-            <a:srgbClr val="028090"/>
+            <a:srgbClr val="4472C4"/>
           </a:solidFill>
           <a:ln>
             <a:noFill/>
@@ -11877,7 +11877,7 @@
             <a:r>
               <a:rPr sz="2600" b="1">
                 <a:solidFill>
-                  <a:srgbClr val="065A82"/>
+                  <a:srgbClr val="0563C1"/>
                 </a:solidFill>
                 <a:latin typeface="微软雅黑"/>
                 <a:ea typeface="微软雅黑"/>
@@ -11994,7 +11994,7 @@
             <a:avLst/>
           </a:prstGeom>
           <a:solidFill>
-            <a:srgbClr val="028090"/>
+            <a:srgbClr val="4472C4"/>
           </a:solidFill>
           <a:ln>
             <a:noFill/>
@@ -12037,7 +12037,7 @@
             <a:avLst/>
           </a:prstGeom>
           <a:solidFill>
-            <a:srgbClr val="028090"/>
+            <a:srgbClr val="4472C4"/>
           </a:solidFill>
           <a:ln>
             <a:noFill/>
@@ -12106,7 +12106,7 @@
             <a:r>
               <a:rPr sz="2600" b="1">
                 <a:solidFill>
-                  <a:srgbClr val="065A82"/>
+                  <a:srgbClr val="0563C1"/>
                 </a:solidFill>
                 <a:latin typeface="微软雅黑"/>
                 <a:ea typeface="微软雅黑"/>
@@ -12225,7 +12225,7 @@
             <a:r>
               <a:rPr sz="1600" b="1">
                 <a:solidFill>
-                  <a:srgbClr val="B83A3A"/>
+                  <a:srgbClr val="C0502D"/>
                 </a:solidFill>
                 <a:latin typeface="微软雅黑"/>
                 <a:ea typeface="微软雅黑"/>

</xml_diff>

<commit_message>
Add XJTU logo + campus building to deck: white logo on cover/dark slides, building backdrop on cover, university name on content-slide corners (extracted from official template)
从模板提取校徽(白色横版image3)+创新港建筑(image1)存assets/。封面:顶部白色校徽+底部建筑半幅叠深蓝+西安交通大学署名。深色页:右上白色校徽。内容页:右上角校名。真正带上学校视觉标识。

Co-Authored-By: Claude Opus 4.8 (1M context) <noreply@anthropic.com>
</commit_message>
<xml_diff>
--- a/autoresearch/energy_m100/experiments/midterm_defense.pptx
+++ b/autoresearch/energy_m100/experiments/midterm_defense.pptx
@@ -3120,22 +3120,46 @@
         <p:nvPr/>
       </p:nvGrpSpPr>
       <p:grpSpPr/>
-      <p:sp>
-        <p:nvSpPr>
-          <p:cNvPr id="2" name="Rectangle 1"/>
+      <p:pic>
+        <p:nvPicPr>
+          <p:cNvPr id="2" name="Picture 1" descr="xjtu_building.jpg"/>
+          <p:cNvPicPr>
+            <a:picLocks noChangeAspect="1"/>
+          </p:cNvPicPr>
+          <p:nvPr/>
+        </p:nvPicPr>
+        <p:blipFill>
+          <a:blip r:embed="rId2"/>
+          <a:stretch>
+            <a:fillRect/>
+          </a:stretch>
+        </p:blipFill>
+        <p:spPr>
+          <a:xfrm>
+            <a:off x="0" y="4297680"/>
+            <a:ext cx="12191695" cy="2560320"/>
+          </a:xfrm>
+          <a:prstGeom prst="rect">
+            <a:avLst/>
+          </a:prstGeom>
+        </p:spPr>
+      </p:pic>
+      <p:sp>
+        <p:nvSpPr>
+          <p:cNvPr id="3" name="Rectangle 2"/>
           <p:cNvSpPr/>
           <p:nvPr/>
         </p:nvSpPr>
         <p:spPr>
           <a:xfrm>
-            <a:off x="0" y="0"/>
-            <a:ext cx="109728" cy="6858000"/>
+            <a:off x="0" y="4297680"/>
+            <a:ext cx="12191695" cy="2560320"/>
           </a:xfrm>
           <a:prstGeom prst="rect">
             <a:avLst/>
           </a:prstGeom>
           <a:solidFill>
-            <a:srgbClr val="5B9BD5"/>
+            <a:srgbClr val="0A2A66"/>
           </a:solidFill>
           <a:ln>
             <a:noFill/>
@@ -3163,15 +3187,39 @@
           </a:p>
         </p:txBody>
       </p:sp>
-      <p:sp>
-        <p:nvSpPr>
-          <p:cNvPr id="3" name="TextBox 2"/>
+      <p:pic>
+        <p:nvPicPr>
+          <p:cNvPr id="4" name="Picture 3" descr="xjtu_logo_white.png"/>
+          <p:cNvPicPr>
+            <a:picLocks noChangeAspect="1"/>
+          </p:cNvPicPr>
+          <p:nvPr/>
+        </p:nvPicPr>
+        <p:blipFill>
+          <a:blip r:embed="rId3"/>
+          <a:stretch>
+            <a:fillRect/>
+          </a:stretch>
+        </p:blipFill>
+        <p:spPr>
+          <a:xfrm>
+            <a:off x="777240" y="640080"/>
+            <a:ext cx="2902289" cy="777240"/>
+          </a:xfrm>
+          <a:prstGeom prst="rect">
+            <a:avLst/>
+          </a:prstGeom>
+        </p:spPr>
+      </p:pic>
+      <p:sp>
+        <p:nvSpPr>
+          <p:cNvPr id="5" name="TextBox 4"/>
           <p:cNvSpPr txBox="1"/>
           <p:nvPr/>
         </p:nvSpPr>
         <p:spPr>
           <a:xfrm>
-            <a:off x="822960" y="2011680"/>
+            <a:off x="822960" y="2194560"/>
             <a:ext cx="10515600" cy="1737360"/>
           </a:xfrm>
           <a:prstGeom prst="rect">
@@ -3211,7 +3259,7 @@
             <a:r>
               <a:rPr sz="4000" b="1">
                 <a:solidFill>
-                  <a:srgbClr val="5B9BD5"/>
+                  <a:srgbClr val="8CC0FF"/>
                 </a:solidFill>
                 <a:latin typeface="微软雅黑"/>
                 <a:ea typeface="微软雅黑"/>
@@ -3224,14 +3272,14 @@
       </p:sp>
       <p:sp>
         <p:nvSpPr>
-          <p:cNvPr id="4" name="TextBox 3"/>
+          <p:cNvPr id="6" name="TextBox 5"/>
           <p:cNvSpPr txBox="1"/>
           <p:nvPr/>
         </p:nvSpPr>
         <p:spPr>
           <a:xfrm>
-            <a:off x="822960" y="4023360"/>
-            <a:ext cx="10515600" cy="1097280"/>
+            <a:off x="822960" y="3703320"/>
+            <a:ext cx="10515600" cy="822960"/>
           </a:xfrm>
           <a:prstGeom prst="rect">
             <a:avLst/>
@@ -3250,7 +3298,7 @@
               </a:spcAft>
             </a:pPr>
             <a:r>
-              <a:rPr sz="1500" b="0">
+              <a:rPr sz="1400" b="0">
                 <a:solidFill>
                   <a:srgbClr val="D6E4F7"/>
                 </a:solidFill>
@@ -3268,7 +3316,7 @@
               </a:spcAft>
             </a:pPr>
             <a:r>
-              <a:rPr sz="1500" b="0">
+              <a:rPr sz="1400" b="0">
                 <a:solidFill>
                   <a:srgbClr val="D6E4F7"/>
                 </a:solidFill>
@@ -3283,13 +3331,13 @@
       </p:sp>
       <p:sp>
         <p:nvSpPr>
-          <p:cNvPr id="5" name="TextBox 4"/>
+          <p:cNvPr id="7" name="TextBox 6"/>
           <p:cNvSpPr txBox="1"/>
           <p:nvPr/>
         </p:nvSpPr>
         <p:spPr>
           <a:xfrm>
-            <a:off x="822960" y="5669280"/>
+            <a:off x="822960" y="5943600"/>
             <a:ext cx="10515600" cy="548640"/>
           </a:xfrm>
           <a:prstGeom prst="rect">
@@ -3298,7 +3346,7 @@
           <a:noFill/>
         </p:spPr>
         <p:txBody>
-          <a:bodyPr wrap="square" anchor="t" lIns="25400" rIns="25400" tIns="25400" bIns="25400">
+          <a:bodyPr wrap="square" anchor="ctr" lIns="25400" rIns="25400" tIns="25400" bIns="25400">
             <a:spAutoFit/>
           </a:bodyPr>
           <a:lstStyle/>
@@ -3317,7 +3365,7 @@
                 <a:ea typeface="微软雅黑"/>
                 <a:cs typeface="微软雅黑"/>
               </a:rPr>
-              <a:t>硕士学位论文·中期答辩　|　2026</a:t>
+              <a:t>西安交通大学　硕士学位论文·中期答辩　|　2026</a:t>
             </a:r>
           </a:p>
         </p:txBody>
@@ -3393,7 +3441,48 @@
       </p:sp>
       <p:sp>
         <p:nvSpPr>
-          <p:cNvPr id="3" name="Rounded Rectangle 2"/>
+          <p:cNvPr id="3" name="TextBox 2"/>
+          <p:cNvSpPr txBox="1"/>
+          <p:nvPr/>
+        </p:nvSpPr>
+        <p:spPr>
+          <a:xfrm>
+            <a:off x="9052560" y="292608"/>
+            <a:ext cx="2834640" cy="365760"/>
+          </a:xfrm>
+          <a:prstGeom prst="rect">
+            <a:avLst/>
+          </a:prstGeom>
+          <a:noFill/>
+        </p:spPr>
+        <p:txBody>
+          <a:bodyPr wrap="square" anchor="t" lIns="25400" rIns="25400" tIns="25400" bIns="25400">
+            <a:spAutoFit/>
+          </a:bodyPr>
+          <a:lstStyle/>
+          <a:p>
+            <a:pPr algn="r">
+              <a:spcAft>
+                <a:spcPts val="400"/>
+              </a:spcAft>
+            </a:pPr>
+            <a:r>
+              <a:rPr sz="1200" b="0">
+                <a:solidFill>
+                  <a:srgbClr val="9AA8B8"/>
+                </a:solidFill>
+                <a:latin typeface="微软雅黑"/>
+                <a:ea typeface="微软雅黑"/>
+                <a:cs typeface="微软雅黑"/>
+              </a:rPr>
+              <a:t>西安交通大学</a:t>
+            </a:r>
+          </a:p>
+        </p:txBody>
+      </p:sp>
+      <p:sp>
+        <p:nvSpPr>
+          <p:cNvPr id="4" name="Rounded Rectangle 3"/>
           <p:cNvSpPr/>
           <p:nvPr/>
         </p:nvSpPr>
@@ -3447,7 +3536,7 @@
       </p:sp>
       <p:sp>
         <p:nvSpPr>
-          <p:cNvPr id="4" name="TextBox 3"/>
+          <p:cNvPr id="5" name="TextBox 4"/>
           <p:cNvSpPr txBox="1"/>
           <p:nvPr/>
         </p:nvSpPr>
@@ -3488,7 +3577,7 @@
       </p:sp>
       <p:pic>
         <p:nvPicPr>
-          <p:cNvPr id="5" name="Picture 4" descr="真机代价改变决策.png"/>
+          <p:cNvPr id="6" name="Picture 5" descr="真机代价改变决策.png"/>
           <p:cNvPicPr>
             <a:picLocks noChangeAspect="1"/>
           </p:cNvPicPr>
@@ -3512,7 +3601,7 @@
       </p:pic>
       <p:pic>
         <p:nvPicPr>
-          <p:cNvPr id="6" name="Picture 5" descr="video_corridor.gif"/>
+          <p:cNvPr id="7" name="Picture 6" descr="video_corridor.gif"/>
           <p:cNvPicPr>
             <a:picLocks noChangeAspect="1"/>
           </p:cNvPicPr>
@@ -3536,7 +3625,7 @@
       </p:pic>
       <p:sp>
         <p:nvSpPr>
-          <p:cNvPr id="7" name="TextBox 6"/>
+          <p:cNvPr id="8" name="TextBox 7"/>
           <p:cNvSpPr txBox="1"/>
           <p:nvPr/>
         </p:nvSpPr>
@@ -3667,7 +3756,7 @@
       </p:sp>
       <p:sp>
         <p:nvSpPr>
-          <p:cNvPr id="8" name="TextBox 7"/>
+          <p:cNvPr id="9" name="TextBox 8"/>
           <p:cNvSpPr txBox="1"/>
           <p:nvPr/>
         </p:nvSpPr>
@@ -3777,7 +3866,48 @@
       </p:sp>
       <p:sp>
         <p:nvSpPr>
-          <p:cNvPr id="3" name="Rounded Rectangle 2"/>
+          <p:cNvPr id="3" name="TextBox 2"/>
+          <p:cNvSpPr txBox="1"/>
+          <p:nvPr/>
+        </p:nvSpPr>
+        <p:spPr>
+          <a:xfrm>
+            <a:off x="9052560" y="292608"/>
+            <a:ext cx="2834640" cy="365760"/>
+          </a:xfrm>
+          <a:prstGeom prst="rect">
+            <a:avLst/>
+          </a:prstGeom>
+          <a:noFill/>
+        </p:spPr>
+        <p:txBody>
+          <a:bodyPr wrap="square" anchor="t" lIns="25400" rIns="25400" tIns="25400" bIns="25400">
+            <a:spAutoFit/>
+          </a:bodyPr>
+          <a:lstStyle/>
+          <a:p>
+            <a:pPr algn="r">
+              <a:spcAft>
+                <a:spcPts val="400"/>
+              </a:spcAft>
+            </a:pPr>
+            <a:r>
+              <a:rPr sz="1200" b="0">
+                <a:solidFill>
+                  <a:srgbClr val="9AA8B8"/>
+                </a:solidFill>
+                <a:latin typeface="微软雅黑"/>
+                <a:ea typeface="微软雅黑"/>
+                <a:cs typeface="微软雅黑"/>
+              </a:rPr>
+              <a:t>西安交通大学</a:t>
+            </a:r>
+          </a:p>
+        </p:txBody>
+      </p:sp>
+      <p:sp>
+        <p:nvSpPr>
+          <p:cNvPr id="4" name="Rounded Rectangle 3"/>
           <p:cNvSpPr/>
           <p:nvPr/>
         </p:nvSpPr>
@@ -3831,7 +3961,7 @@
       </p:sp>
       <p:sp>
         <p:nvSpPr>
-          <p:cNvPr id="4" name="TextBox 3"/>
+          <p:cNvPr id="5" name="TextBox 4"/>
           <p:cNvSpPr txBox="1"/>
           <p:nvPr/>
         </p:nvSpPr>
@@ -3872,7 +4002,7 @@
       </p:sp>
       <p:pic>
         <p:nvPicPr>
-          <p:cNvPr id="5" name="Picture 4" descr="PX4真飞控_AB对比.png"/>
+          <p:cNvPr id="6" name="Picture 5" descr="PX4真飞控_AB对比.png"/>
           <p:cNvPicPr>
             <a:picLocks noChangeAspect="1"/>
           </p:cNvPicPr>
@@ -3896,7 +4026,7 @@
       </p:pic>
       <p:pic>
         <p:nvPicPr>
-          <p:cNvPr id="6" name="Picture 5" descr="px4_flight.gif"/>
+          <p:cNvPr id="7" name="Picture 6" descr="px4_flight.gif"/>
           <p:cNvPicPr>
             <a:picLocks noChangeAspect="1"/>
           </p:cNvPicPr>
@@ -3920,7 +4050,7 @@
       </p:pic>
       <p:sp>
         <p:nvSpPr>
-          <p:cNvPr id="7" name="TextBox 6"/>
+          <p:cNvPr id="8" name="TextBox 7"/>
           <p:cNvSpPr txBox="1"/>
           <p:nvPr/>
         </p:nvSpPr>
@@ -4051,7 +4181,7 @@
       </p:sp>
       <p:sp>
         <p:nvSpPr>
-          <p:cNvPr id="8" name="TextBox 7"/>
+          <p:cNvPr id="9" name="TextBox 8"/>
           <p:cNvSpPr txBox="1"/>
           <p:nvPr/>
         </p:nvSpPr>
@@ -4161,7 +4291,48 @@
       </p:sp>
       <p:sp>
         <p:nvSpPr>
-          <p:cNvPr id="3" name="Rounded Rectangle 2"/>
+          <p:cNvPr id="3" name="TextBox 2"/>
+          <p:cNvSpPr txBox="1"/>
+          <p:nvPr/>
+        </p:nvSpPr>
+        <p:spPr>
+          <a:xfrm>
+            <a:off x="9052560" y="292608"/>
+            <a:ext cx="2834640" cy="365760"/>
+          </a:xfrm>
+          <a:prstGeom prst="rect">
+            <a:avLst/>
+          </a:prstGeom>
+          <a:noFill/>
+        </p:spPr>
+        <p:txBody>
+          <a:bodyPr wrap="square" anchor="t" lIns="25400" rIns="25400" tIns="25400" bIns="25400">
+            <a:spAutoFit/>
+          </a:bodyPr>
+          <a:lstStyle/>
+          <a:p>
+            <a:pPr algn="r">
+              <a:spcAft>
+                <a:spcPts val="400"/>
+              </a:spcAft>
+            </a:pPr>
+            <a:r>
+              <a:rPr sz="1200" b="0">
+                <a:solidFill>
+                  <a:srgbClr val="9AA8B8"/>
+                </a:solidFill>
+                <a:latin typeface="微软雅黑"/>
+                <a:ea typeface="微软雅黑"/>
+                <a:cs typeface="微软雅黑"/>
+              </a:rPr>
+              <a:t>西安交通大学</a:t>
+            </a:r>
+          </a:p>
+        </p:txBody>
+      </p:sp>
+      <p:sp>
+        <p:nvSpPr>
+          <p:cNvPr id="4" name="Rounded Rectangle 3"/>
           <p:cNvSpPr/>
           <p:nvPr/>
         </p:nvSpPr>
@@ -4215,7 +4386,7 @@
       </p:sp>
       <p:sp>
         <p:nvSpPr>
-          <p:cNvPr id="4" name="TextBox 3"/>
+          <p:cNvPr id="5" name="TextBox 4"/>
           <p:cNvSpPr txBox="1"/>
           <p:nvPr/>
         </p:nvSpPr>
@@ -4256,7 +4427,7 @@
       </p:sp>
       <p:sp>
         <p:nvSpPr>
-          <p:cNvPr id="5" name="Rectangle 4"/>
+          <p:cNvPr id="6" name="Rectangle 5"/>
           <p:cNvSpPr/>
           <p:nvPr/>
         </p:nvSpPr>
@@ -4301,7 +4472,7 @@
       </p:sp>
       <p:sp>
         <p:nvSpPr>
-          <p:cNvPr id="6" name="TextBox 5"/>
+          <p:cNvPr id="7" name="TextBox 6"/>
           <p:cNvSpPr txBox="1"/>
           <p:nvPr/>
         </p:nvSpPr>
@@ -4342,7 +4513,7 @@
       </p:sp>
       <p:sp>
         <p:nvSpPr>
-          <p:cNvPr id="7" name="TextBox 6"/>
+          <p:cNvPr id="8" name="TextBox 7"/>
           <p:cNvSpPr txBox="1"/>
           <p:nvPr/>
         </p:nvSpPr>
@@ -4383,7 +4554,7 @@
       </p:sp>
       <p:sp>
         <p:nvSpPr>
-          <p:cNvPr id="8" name="Rectangle 7"/>
+          <p:cNvPr id="9" name="Rectangle 8"/>
           <p:cNvSpPr/>
           <p:nvPr/>
         </p:nvSpPr>
@@ -4428,7 +4599,7 @@
       </p:sp>
       <p:sp>
         <p:nvSpPr>
-          <p:cNvPr id="9" name="TextBox 8"/>
+          <p:cNvPr id="10" name="TextBox 9"/>
           <p:cNvSpPr txBox="1"/>
           <p:nvPr/>
         </p:nvSpPr>
@@ -4469,7 +4640,7 @@
       </p:sp>
       <p:sp>
         <p:nvSpPr>
-          <p:cNvPr id="10" name="TextBox 9"/>
+          <p:cNvPr id="11" name="TextBox 10"/>
           <p:cNvSpPr txBox="1"/>
           <p:nvPr/>
         </p:nvSpPr>
@@ -4510,7 +4681,7 @@
       </p:sp>
       <p:sp>
         <p:nvSpPr>
-          <p:cNvPr id="11" name="Rectangle 10"/>
+          <p:cNvPr id="12" name="Rectangle 11"/>
           <p:cNvSpPr/>
           <p:nvPr/>
         </p:nvSpPr>
@@ -4555,7 +4726,7 @@
       </p:sp>
       <p:sp>
         <p:nvSpPr>
-          <p:cNvPr id="12" name="TextBox 11"/>
+          <p:cNvPr id="13" name="TextBox 12"/>
           <p:cNvSpPr txBox="1"/>
           <p:nvPr/>
         </p:nvSpPr>
@@ -4596,7 +4767,7 @@
       </p:sp>
       <p:sp>
         <p:nvSpPr>
-          <p:cNvPr id="13" name="TextBox 12"/>
+          <p:cNvPr id="14" name="TextBox 13"/>
           <p:cNvSpPr txBox="1"/>
           <p:nvPr/>
         </p:nvSpPr>
@@ -4637,7 +4808,7 @@
       </p:sp>
       <p:sp>
         <p:nvSpPr>
-          <p:cNvPr id="14" name="Rectangle 13"/>
+          <p:cNvPr id="15" name="Rectangle 14"/>
           <p:cNvSpPr/>
           <p:nvPr/>
         </p:nvSpPr>
@@ -4682,7 +4853,7 @@
       </p:sp>
       <p:sp>
         <p:nvSpPr>
-          <p:cNvPr id="15" name="TextBox 14"/>
+          <p:cNvPr id="16" name="TextBox 15"/>
           <p:cNvSpPr txBox="1"/>
           <p:nvPr/>
         </p:nvSpPr>
@@ -4723,7 +4894,7 @@
       </p:sp>
       <p:sp>
         <p:nvSpPr>
-          <p:cNvPr id="16" name="TextBox 15"/>
+          <p:cNvPr id="17" name="TextBox 16"/>
           <p:cNvSpPr txBox="1"/>
           <p:nvPr/>
         </p:nvSpPr>
@@ -4764,7 +4935,7 @@
       </p:sp>
       <p:sp>
         <p:nvSpPr>
-          <p:cNvPr id="17" name="Rectangle 16"/>
+          <p:cNvPr id="18" name="Rectangle 17"/>
           <p:cNvSpPr/>
           <p:nvPr/>
         </p:nvSpPr>
@@ -4809,7 +4980,7 @@
       </p:sp>
       <p:sp>
         <p:nvSpPr>
-          <p:cNvPr id="18" name="TextBox 17"/>
+          <p:cNvPr id="19" name="TextBox 18"/>
           <p:cNvSpPr txBox="1"/>
           <p:nvPr/>
         </p:nvSpPr>
@@ -4850,7 +5021,7 @@
       </p:sp>
       <p:sp>
         <p:nvSpPr>
-          <p:cNvPr id="19" name="TextBox 18"/>
+          <p:cNvPr id="20" name="TextBox 19"/>
           <p:cNvSpPr txBox="1"/>
           <p:nvPr/>
         </p:nvSpPr>
@@ -4891,7 +5062,7 @@
       </p:sp>
       <p:sp>
         <p:nvSpPr>
-          <p:cNvPr id="20" name="TextBox 19"/>
+          <p:cNvPr id="21" name="TextBox 20"/>
           <p:cNvSpPr txBox="1"/>
           <p:nvPr/>
         </p:nvSpPr>
@@ -5001,7 +5172,48 @@
       </p:sp>
       <p:sp>
         <p:nvSpPr>
-          <p:cNvPr id="3" name="Rounded Rectangle 2"/>
+          <p:cNvPr id="3" name="TextBox 2"/>
+          <p:cNvSpPr txBox="1"/>
+          <p:nvPr/>
+        </p:nvSpPr>
+        <p:spPr>
+          <a:xfrm>
+            <a:off x="9052560" y="292608"/>
+            <a:ext cx="2834640" cy="365760"/>
+          </a:xfrm>
+          <a:prstGeom prst="rect">
+            <a:avLst/>
+          </a:prstGeom>
+          <a:noFill/>
+        </p:spPr>
+        <p:txBody>
+          <a:bodyPr wrap="square" anchor="t" lIns="25400" rIns="25400" tIns="25400" bIns="25400">
+            <a:spAutoFit/>
+          </a:bodyPr>
+          <a:lstStyle/>
+          <a:p>
+            <a:pPr algn="r">
+              <a:spcAft>
+                <a:spcPts val="400"/>
+              </a:spcAft>
+            </a:pPr>
+            <a:r>
+              <a:rPr sz="1200" b="0">
+                <a:solidFill>
+                  <a:srgbClr val="9AA8B8"/>
+                </a:solidFill>
+                <a:latin typeface="微软雅黑"/>
+                <a:ea typeface="微软雅黑"/>
+                <a:cs typeface="微软雅黑"/>
+              </a:rPr>
+              <a:t>西安交通大学</a:t>
+            </a:r>
+          </a:p>
+        </p:txBody>
+      </p:sp>
+      <p:sp>
+        <p:nvSpPr>
+          <p:cNvPr id="4" name="Rounded Rectangle 3"/>
           <p:cNvSpPr/>
           <p:nvPr/>
         </p:nvSpPr>
@@ -5055,7 +5267,7 @@
       </p:sp>
       <p:sp>
         <p:nvSpPr>
-          <p:cNvPr id="4" name="TextBox 3"/>
+          <p:cNvPr id="5" name="TextBox 4"/>
           <p:cNvSpPr txBox="1"/>
           <p:nvPr/>
         </p:nvSpPr>
@@ -5096,7 +5308,7 @@
       </p:sp>
       <p:pic>
         <p:nvPicPr>
-          <p:cNvPr id="5" name="Picture 4" descr="框架消融_局部最优.png"/>
+          <p:cNvPr id="6" name="Picture 5" descr="框架消融_局部最优.png"/>
           <p:cNvPicPr>
             <a:picLocks noChangeAspect="1"/>
           </p:cNvPicPr>
@@ -5120,7 +5332,7 @@
       </p:pic>
       <p:sp>
         <p:nvSpPr>
-          <p:cNvPr id="6" name="TextBox 5"/>
+          <p:cNvPr id="7" name="TextBox 6"/>
           <p:cNvSpPr txBox="1"/>
           <p:nvPr/>
         </p:nvSpPr>
@@ -5305,7 +5517,7 @@
       </p:sp>
       <p:sp>
         <p:nvSpPr>
-          <p:cNvPr id="7" name="TextBox 6"/>
+          <p:cNvPr id="8" name="TextBox 7"/>
           <p:cNvSpPr txBox="1"/>
           <p:nvPr/>
         </p:nvSpPr>
@@ -5415,7 +5627,48 @@
       </p:sp>
       <p:sp>
         <p:nvSpPr>
-          <p:cNvPr id="3" name="Rounded Rectangle 2"/>
+          <p:cNvPr id="3" name="TextBox 2"/>
+          <p:cNvSpPr txBox="1"/>
+          <p:nvPr/>
+        </p:nvSpPr>
+        <p:spPr>
+          <a:xfrm>
+            <a:off x="9052560" y="292608"/>
+            <a:ext cx="2834640" cy="365760"/>
+          </a:xfrm>
+          <a:prstGeom prst="rect">
+            <a:avLst/>
+          </a:prstGeom>
+          <a:noFill/>
+        </p:spPr>
+        <p:txBody>
+          <a:bodyPr wrap="square" anchor="t" lIns="25400" rIns="25400" tIns="25400" bIns="25400">
+            <a:spAutoFit/>
+          </a:bodyPr>
+          <a:lstStyle/>
+          <a:p>
+            <a:pPr algn="r">
+              <a:spcAft>
+                <a:spcPts val="400"/>
+              </a:spcAft>
+            </a:pPr>
+            <a:r>
+              <a:rPr sz="1200" b="0">
+                <a:solidFill>
+                  <a:srgbClr val="9AA8B8"/>
+                </a:solidFill>
+                <a:latin typeface="微软雅黑"/>
+                <a:ea typeface="微软雅黑"/>
+                <a:cs typeface="微软雅黑"/>
+              </a:rPr>
+              <a:t>西安交通大学</a:t>
+            </a:r>
+          </a:p>
+        </p:txBody>
+      </p:sp>
+      <p:sp>
+        <p:nvSpPr>
+          <p:cNvPr id="4" name="Rounded Rectangle 3"/>
           <p:cNvSpPr/>
           <p:nvPr/>
         </p:nvSpPr>
@@ -5469,7 +5722,7 @@
       </p:sp>
       <p:sp>
         <p:nvSpPr>
-          <p:cNvPr id="4" name="TextBox 3"/>
+          <p:cNvPr id="5" name="TextBox 4"/>
           <p:cNvSpPr txBox="1"/>
           <p:nvPr/>
         </p:nvSpPr>
@@ -5510,7 +5763,7 @@
       </p:sp>
       <p:pic>
         <p:nvPicPr>
-          <p:cNvPr id="5" name="Picture 4" descr="噪声地板.png"/>
+          <p:cNvPr id="6" name="Picture 5" descr="噪声地板.png"/>
           <p:cNvPicPr>
             <a:picLocks noChangeAspect="1"/>
           </p:cNvPicPr>
@@ -5534,7 +5787,7 @@
       </p:pic>
       <p:sp>
         <p:nvSpPr>
-          <p:cNvPr id="6" name="TextBox 5"/>
+          <p:cNvPr id="7" name="TextBox 6"/>
           <p:cNvSpPr txBox="1"/>
           <p:nvPr/>
         </p:nvSpPr>
@@ -5647,7 +5900,7 @@
       </p:sp>
       <p:sp>
         <p:nvSpPr>
-          <p:cNvPr id="7" name="TextBox 6"/>
+          <p:cNvPr id="8" name="TextBox 7"/>
           <p:cNvSpPr txBox="1"/>
           <p:nvPr/>
         </p:nvSpPr>
@@ -5757,7 +6010,48 @@
       </p:sp>
       <p:sp>
         <p:nvSpPr>
-          <p:cNvPr id="3" name="Rounded Rectangle 2"/>
+          <p:cNvPr id="3" name="TextBox 2"/>
+          <p:cNvSpPr txBox="1"/>
+          <p:nvPr/>
+        </p:nvSpPr>
+        <p:spPr>
+          <a:xfrm>
+            <a:off x="9052560" y="292608"/>
+            <a:ext cx="2834640" cy="365760"/>
+          </a:xfrm>
+          <a:prstGeom prst="rect">
+            <a:avLst/>
+          </a:prstGeom>
+          <a:noFill/>
+        </p:spPr>
+        <p:txBody>
+          <a:bodyPr wrap="square" anchor="t" lIns="25400" rIns="25400" tIns="25400" bIns="25400">
+            <a:spAutoFit/>
+          </a:bodyPr>
+          <a:lstStyle/>
+          <a:p>
+            <a:pPr algn="r">
+              <a:spcAft>
+                <a:spcPts val="400"/>
+              </a:spcAft>
+            </a:pPr>
+            <a:r>
+              <a:rPr sz="1200" b="0">
+                <a:solidFill>
+                  <a:srgbClr val="9AA8B8"/>
+                </a:solidFill>
+                <a:latin typeface="微软雅黑"/>
+                <a:ea typeface="微软雅黑"/>
+                <a:cs typeface="微软雅黑"/>
+              </a:rPr>
+              <a:t>西安交通大学</a:t>
+            </a:r>
+          </a:p>
+        </p:txBody>
+      </p:sp>
+      <p:sp>
+        <p:nvSpPr>
+          <p:cNvPr id="4" name="Rounded Rectangle 3"/>
           <p:cNvSpPr/>
           <p:nvPr/>
         </p:nvSpPr>
@@ -5811,7 +6105,7 @@
       </p:sp>
       <p:sp>
         <p:nvSpPr>
-          <p:cNvPr id="4" name="TextBox 3"/>
+          <p:cNvPr id="5" name="TextBox 4"/>
           <p:cNvSpPr txBox="1"/>
           <p:nvPr/>
         </p:nvSpPr>
@@ -5852,7 +6146,7 @@
       </p:sp>
       <p:pic>
         <p:nvPicPr>
-          <p:cNvPr id="5" name="Picture 4" descr="两域显著性.png"/>
+          <p:cNvPr id="6" name="Picture 5" descr="两域显著性.png"/>
           <p:cNvPicPr>
             <a:picLocks noChangeAspect="1"/>
           </p:cNvPicPr>
@@ -5876,7 +6170,7 @@
       </p:pic>
       <p:sp>
         <p:nvSpPr>
-          <p:cNvPr id="6" name="TextBox 5"/>
+          <p:cNvPr id="7" name="TextBox 6"/>
           <p:cNvSpPr txBox="1"/>
           <p:nvPr/>
         </p:nvSpPr>
@@ -6025,7 +6319,7 @@
       </p:sp>
       <p:sp>
         <p:nvSpPr>
-          <p:cNvPr id="7" name="TextBox 6"/>
+          <p:cNvPr id="8" name="TextBox 7"/>
           <p:cNvSpPr txBox="1"/>
           <p:nvPr/>
         </p:nvSpPr>
@@ -6135,7 +6429,48 @@
       </p:sp>
       <p:sp>
         <p:nvSpPr>
-          <p:cNvPr id="3" name="Rounded Rectangle 2"/>
+          <p:cNvPr id="3" name="TextBox 2"/>
+          <p:cNvSpPr txBox="1"/>
+          <p:nvPr/>
+        </p:nvSpPr>
+        <p:spPr>
+          <a:xfrm>
+            <a:off x="9052560" y="292608"/>
+            <a:ext cx="2834640" cy="365760"/>
+          </a:xfrm>
+          <a:prstGeom prst="rect">
+            <a:avLst/>
+          </a:prstGeom>
+          <a:noFill/>
+        </p:spPr>
+        <p:txBody>
+          <a:bodyPr wrap="square" anchor="t" lIns="25400" rIns="25400" tIns="25400" bIns="25400">
+            <a:spAutoFit/>
+          </a:bodyPr>
+          <a:lstStyle/>
+          <a:p>
+            <a:pPr algn="r">
+              <a:spcAft>
+                <a:spcPts val="400"/>
+              </a:spcAft>
+            </a:pPr>
+            <a:r>
+              <a:rPr sz="1200" b="0">
+                <a:solidFill>
+                  <a:srgbClr val="9AA8B8"/>
+                </a:solidFill>
+                <a:latin typeface="微软雅黑"/>
+                <a:ea typeface="微软雅黑"/>
+                <a:cs typeface="微软雅黑"/>
+              </a:rPr>
+              <a:t>西安交通大学</a:t>
+            </a:r>
+          </a:p>
+        </p:txBody>
+      </p:sp>
+      <p:sp>
+        <p:nvSpPr>
+          <p:cNvPr id="4" name="Rounded Rectangle 3"/>
           <p:cNvSpPr/>
           <p:nvPr/>
         </p:nvSpPr>
@@ -6189,7 +6524,7 @@
       </p:sp>
       <p:sp>
         <p:nvSpPr>
-          <p:cNvPr id="4" name="TextBox 3"/>
+          <p:cNvPr id="5" name="TextBox 4"/>
           <p:cNvSpPr txBox="1"/>
           <p:nvPr/>
         </p:nvSpPr>
@@ -6230,7 +6565,7 @@
       </p:sp>
       <p:pic>
         <p:nvPicPr>
-          <p:cNvPr id="5" name="Picture 4" descr="naive_vs_trustworthy.png"/>
+          <p:cNvPr id="6" name="Picture 5" descr="naive_vs_trustworthy.png"/>
           <p:cNvPicPr>
             <a:picLocks noChangeAspect="1"/>
           </p:cNvPicPr>
@@ -6254,7 +6589,7 @@
       </p:pic>
       <p:sp>
         <p:nvSpPr>
-          <p:cNvPr id="6" name="TextBox 5"/>
+          <p:cNvPr id="7" name="TextBox 6"/>
           <p:cNvSpPr txBox="1"/>
           <p:nvPr/>
         </p:nvSpPr>
@@ -6385,7 +6720,7 @@
       </p:sp>
       <p:sp>
         <p:nvSpPr>
-          <p:cNvPr id="7" name="TextBox 6"/>
+          <p:cNvPr id="8" name="TextBox 7"/>
           <p:cNvSpPr txBox="1"/>
           <p:nvPr/>
         </p:nvSpPr>
@@ -6495,7 +6830,48 @@
       </p:sp>
       <p:sp>
         <p:nvSpPr>
-          <p:cNvPr id="3" name="Rounded Rectangle 2"/>
+          <p:cNvPr id="3" name="TextBox 2"/>
+          <p:cNvSpPr txBox="1"/>
+          <p:nvPr/>
+        </p:nvSpPr>
+        <p:spPr>
+          <a:xfrm>
+            <a:off x="9052560" y="292608"/>
+            <a:ext cx="2834640" cy="365760"/>
+          </a:xfrm>
+          <a:prstGeom prst="rect">
+            <a:avLst/>
+          </a:prstGeom>
+          <a:noFill/>
+        </p:spPr>
+        <p:txBody>
+          <a:bodyPr wrap="square" anchor="t" lIns="25400" rIns="25400" tIns="25400" bIns="25400">
+            <a:spAutoFit/>
+          </a:bodyPr>
+          <a:lstStyle/>
+          <a:p>
+            <a:pPr algn="r">
+              <a:spcAft>
+                <a:spcPts val="400"/>
+              </a:spcAft>
+            </a:pPr>
+            <a:r>
+              <a:rPr sz="1200" b="0">
+                <a:solidFill>
+                  <a:srgbClr val="9AA8B8"/>
+                </a:solidFill>
+                <a:latin typeface="微软雅黑"/>
+                <a:ea typeface="微软雅黑"/>
+                <a:cs typeface="微软雅黑"/>
+              </a:rPr>
+              <a:t>西安交通大学</a:t>
+            </a:r>
+          </a:p>
+        </p:txBody>
+      </p:sp>
+      <p:sp>
+        <p:nvSpPr>
+          <p:cNvPr id="4" name="Rounded Rectangle 3"/>
           <p:cNvSpPr/>
           <p:nvPr/>
         </p:nvSpPr>
@@ -6549,7 +6925,7 @@
       </p:sp>
       <p:sp>
         <p:nvSpPr>
-          <p:cNvPr id="4" name="TextBox 3"/>
+          <p:cNvPr id="5" name="TextBox 4"/>
           <p:cNvSpPr txBox="1"/>
           <p:nvPr/>
         </p:nvSpPr>
@@ -6590,7 +6966,7 @@
       </p:sp>
       <p:pic>
         <p:nvPicPr>
-          <p:cNvPr id="5" name="Picture 4" descr="省能分布_n250.png"/>
+          <p:cNvPr id="6" name="Picture 5" descr="省能分布_n250.png"/>
           <p:cNvPicPr>
             <a:picLocks noChangeAspect="1"/>
           </p:cNvPicPr>
@@ -6614,7 +6990,7 @@
       </p:pic>
       <p:sp>
         <p:nvSpPr>
-          <p:cNvPr id="6" name="TextBox 5"/>
+          <p:cNvPr id="7" name="TextBox 6"/>
           <p:cNvSpPr txBox="1"/>
           <p:nvPr/>
         </p:nvSpPr>
@@ -6745,7 +7121,7 @@
       </p:sp>
       <p:sp>
         <p:nvSpPr>
-          <p:cNvPr id="7" name="TextBox 6"/>
+          <p:cNvPr id="8" name="TextBox 7"/>
           <p:cNvSpPr txBox="1"/>
           <p:nvPr/>
         </p:nvSpPr>
@@ -6853,9 +7229,33 @@
           </a:p>
         </p:txBody>
       </p:sp>
-      <p:sp>
-        <p:nvSpPr>
-          <p:cNvPr id="3" name="Rounded Rectangle 2"/>
+      <p:pic>
+        <p:nvPicPr>
+          <p:cNvPr id="3" name="Picture 2" descr="xjtu_logo_white.png"/>
+          <p:cNvPicPr>
+            <a:picLocks noChangeAspect="1"/>
+          </p:cNvPicPr>
+          <p:nvPr/>
+        </p:nvPicPr>
+        <p:blipFill>
+          <a:blip r:embed="rId2"/>
+          <a:stretch>
+            <a:fillRect/>
+          </a:stretch>
+        </p:blipFill>
+        <p:spPr>
+          <a:xfrm>
+            <a:off x="8686800" y="365760"/>
+            <a:ext cx="1707229" cy="457200"/>
+          </a:xfrm>
+          <a:prstGeom prst="rect">
+            <a:avLst/>
+          </a:prstGeom>
+        </p:spPr>
+      </p:pic>
+      <p:sp>
+        <p:nvSpPr>
+          <p:cNvPr id="4" name="Rounded Rectangle 3"/>
           <p:cNvSpPr/>
           <p:nvPr/>
         </p:nvSpPr>
@@ -6909,7 +7309,7 @@
       </p:sp>
       <p:sp>
         <p:nvSpPr>
-          <p:cNvPr id="4" name="TextBox 3"/>
+          <p:cNvPr id="5" name="TextBox 4"/>
           <p:cNvSpPr txBox="1"/>
           <p:nvPr/>
         </p:nvSpPr>
@@ -6950,7 +7350,7 @@
       </p:sp>
       <p:sp>
         <p:nvSpPr>
-          <p:cNvPr id="5" name="TextBox 4"/>
+          <p:cNvPr id="6" name="TextBox 5"/>
           <p:cNvSpPr txBox="1"/>
           <p:nvPr/>
         </p:nvSpPr>
@@ -7132,7 +7532,48 @@
       </p:sp>
       <p:sp>
         <p:nvSpPr>
-          <p:cNvPr id="3" name="Rounded Rectangle 2"/>
+          <p:cNvPr id="3" name="TextBox 2"/>
+          <p:cNvSpPr txBox="1"/>
+          <p:nvPr/>
+        </p:nvSpPr>
+        <p:spPr>
+          <a:xfrm>
+            <a:off x="9052560" y="292608"/>
+            <a:ext cx="2834640" cy="365760"/>
+          </a:xfrm>
+          <a:prstGeom prst="rect">
+            <a:avLst/>
+          </a:prstGeom>
+          <a:noFill/>
+        </p:spPr>
+        <p:txBody>
+          <a:bodyPr wrap="square" anchor="t" lIns="25400" rIns="25400" tIns="25400" bIns="25400">
+            <a:spAutoFit/>
+          </a:bodyPr>
+          <a:lstStyle/>
+          <a:p>
+            <a:pPr algn="r">
+              <a:spcAft>
+                <a:spcPts val="400"/>
+              </a:spcAft>
+            </a:pPr>
+            <a:r>
+              <a:rPr sz="1200" b="0">
+                <a:solidFill>
+                  <a:srgbClr val="9AA8B8"/>
+                </a:solidFill>
+                <a:latin typeface="微软雅黑"/>
+                <a:ea typeface="微软雅黑"/>
+                <a:cs typeface="微软雅黑"/>
+              </a:rPr>
+              <a:t>西安交通大学</a:t>
+            </a:r>
+          </a:p>
+        </p:txBody>
+      </p:sp>
+      <p:sp>
+        <p:nvSpPr>
+          <p:cNvPr id="4" name="Rounded Rectangle 3"/>
           <p:cNvSpPr/>
           <p:nvPr/>
         </p:nvSpPr>
@@ -7186,7 +7627,7 @@
       </p:sp>
       <p:sp>
         <p:nvSpPr>
-          <p:cNvPr id="4" name="TextBox 3"/>
+          <p:cNvPr id="5" name="TextBox 4"/>
           <p:cNvSpPr txBox="1"/>
           <p:nvPr/>
         </p:nvSpPr>
@@ -7227,7 +7668,7 @@
       </p:sp>
       <p:sp>
         <p:nvSpPr>
-          <p:cNvPr id="5" name="TextBox 4"/>
+          <p:cNvPr id="6" name="TextBox 5"/>
           <p:cNvSpPr txBox="1"/>
           <p:nvPr/>
         </p:nvSpPr>
@@ -7481,7 +7922,48 @@
       </p:sp>
       <p:sp>
         <p:nvSpPr>
-          <p:cNvPr id="3" name="Rounded Rectangle 2"/>
+          <p:cNvPr id="3" name="TextBox 2"/>
+          <p:cNvSpPr txBox="1"/>
+          <p:nvPr/>
+        </p:nvSpPr>
+        <p:spPr>
+          <a:xfrm>
+            <a:off x="9052560" y="292608"/>
+            <a:ext cx="2834640" cy="365760"/>
+          </a:xfrm>
+          <a:prstGeom prst="rect">
+            <a:avLst/>
+          </a:prstGeom>
+          <a:noFill/>
+        </p:spPr>
+        <p:txBody>
+          <a:bodyPr wrap="square" anchor="t" lIns="25400" rIns="25400" tIns="25400" bIns="25400">
+            <a:spAutoFit/>
+          </a:bodyPr>
+          <a:lstStyle/>
+          <a:p>
+            <a:pPr algn="r">
+              <a:spcAft>
+                <a:spcPts val="400"/>
+              </a:spcAft>
+            </a:pPr>
+            <a:r>
+              <a:rPr sz="1200" b="0">
+                <a:solidFill>
+                  <a:srgbClr val="9AA8B8"/>
+                </a:solidFill>
+                <a:latin typeface="微软雅黑"/>
+                <a:ea typeface="微软雅黑"/>
+                <a:cs typeface="微软雅黑"/>
+              </a:rPr>
+              <a:t>西安交通大学</a:t>
+            </a:r>
+          </a:p>
+        </p:txBody>
+      </p:sp>
+      <p:sp>
+        <p:nvSpPr>
+          <p:cNvPr id="4" name="Rounded Rectangle 3"/>
           <p:cNvSpPr/>
           <p:nvPr/>
         </p:nvSpPr>
@@ -7535,7 +8017,7 @@
       </p:sp>
       <p:sp>
         <p:nvSpPr>
-          <p:cNvPr id="4" name="TextBox 3"/>
+          <p:cNvPr id="5" name="TextBox 4"/>
           <p:cNvSpPr txBox="1"/>
           <p:nvPr/>
         </p:nvSpPr>
@@ -7576,7 +8058,7 @@
       </p:sp>
       <p:sp>
         <p:nvSpPr>
-          <p:cNvPr id="5" name="TextBox 4"/>
+          <p:cNvPr id="6" name="TextBox 5"/>
           <p:cNvSpPr txBox="1"/>
           <p:nvPr/>
         </p:nvSpPr>
@@ -7635,7 +8117,7 @@
       </p:sp>
       <p:sp>
         <p:nvSpPr>
-          <p:cNvPr id="6" name="TextBox 5"/>
+          <p:cNvPr id="7" name="TextBox 6"/>
           <p:cNvSpPr txBox="1"/>
           <p:nvPr/>
         </p:nvSpPr>
@@ -7748,7 +8230,7 @@
       </p:sp>
       <p:sp>
         <p:nvSpPr>
-          <p:cNvPr id="7" name="TextBox 6"/>
+          <p:cNvPr id="8" name="TextBox 7"/>
           <p:cNvSpPr txBox="1"/>
           <p:nvPr/>
         </p:nvSpPr>
@@ -7864,8 +8346,8 @@
         </p:nvSpPr>
         <p:spPr>
           <a:xfrm>
-            <a:off x="1143000" y="347472"/>
-            <a:ext cx="10607040" cy="914400"/>
+            <a:off x="9052560" y="292608"/>
+            <a:ext cx="2834640" cy="365760"/>
           </a:xfrm>
           <a:prstGeom prst="rect">
             <a:avLst/>
@@ -7878,6 +8360,47 @@
           </a:bodyPr>
           <a:lstStyle/>
           <a:p>
+            <a:pPr algn="r">
+              <a:spcAft>
+                <a:spcPts val="400"/>
+              </a:spcAft>
+            </a:pPr>
+            <a:r>
+              <a:rPr sz="1200" b="0">
+                <a:solidFill>
+                  <a:srgbClr val="9AA8B8"/>
+                </a:solidFill>
+                <a:latin typeface="微软雅黑"/>
+                <a:ea typeface="微软雅黑"/>
+                <a:cs typeface="微软雅黑"/>
+              </a:rPr>
+              <a:t>西安交通大学</a:t>
+            </a:r>
+          </a:p>
+        </p:txBody>
+      </p:sp>
+      <p:sp>
+        <p:nvSpPr>
+          <p:cNvPr id="4" name="TextBox 3"/>
+          <p:cNvSpPr txBox="1"/>
+          <p:nvPr/>
+        </p:nvSpPr>
+        <p:spPr>
+          <a:xfrm>
+            <a:off x="1143000" y="347472"/>
+            <a:ext cx="10607040" cy="914400"/>
+          </a:xfrm>
+          <a:prstGeom prst="rect">
+            <a:avLst/>
+          </a:prstGeom>
+          <a:noFill/>
+        </p:spPr>
+        <p:txBody>
+          <a:bodyPr wrap="square" anchor="t" lIns="25400" rIns="25400" tIns="25400" bIns="25400">
+            <a:spAutoFit/>
+          </a:bodyPr>
+          <a:lstStyle/>
+          <a:p>
             <a:pPr algn="l">
               <a:spcAft>
                 <a:spcPts val="400"/>
@@ -7899,7 +8422,7 @@
       </p:sp>
       <p:pic>
         <p:nvPicPr>
-          <p:cNvPr id="4" name="Picture 3" descr="消融阶梯.png"/>
+          <p:cNvPr id="5" name="Picture 4" descr="消融阶梯.png"/>
           <p:cNvPicPr>
             <a:picLocks noChangeAspect="1"/>
           </p:cNvPicPr>
@@ -7923,7 +8446,7 @@
       </p:pic>
       <p:sp>
         <p:nvSpPr>
-          <p:cNvPr id="5" name="TextBox 4"/>
+          <p:cNvPr id="6" name="TextBox 5"/>
           <p:cNvSpPr txBox="1"/>
           <p:nvPr/>
         </p:nvSpPr>
@@ -8039,8 +8562,8 @@
         </p:nvSpPr>
         <p:spPr>
           <a:xfrm>
-            <a:off x="1143000" y="347472"/>
-            <a:ext cx="10607040" cy="914400"/>
+            <a:off x="9052560" y="292608"/>
+            <a:ext cx="2834640" cy="365760"/>
           </a:xfrm>
           <a:prstGeom prst="rect">
             <a:avLst/>
@@ -8053,6 +8576,47 @@
           </a:bodyPr>
           <a:lstStyle/>
           <a:p>
+            <a:pPr algn="r">
+              <a:spcAft>
+                <a:spcPts val="400"/>
+              </a:spcAft>
+            </a:pPr>
+            <a:r>
+              <a:rPr sz="1200" b="0">
+                <a:solidFill>
+                  <a:srgbClr val="9AA8B8"/>
+                </a:solidFill>
+                <a:latin typeface="微软雅黑"/>
+                <a:ea typeface="微软雅黑"/>
+                <a:cs typeface="微软雅黑"/>
+              </a:rPr>
+              <a:t>西安交通大学</a:t>
+            </a:r>
+          </a:p>
+        </p:txBody>
+      </p:sp>
+      <p:sp>
+        <p:nvSpPr>
+          <p:cNvPr id="4" name="TextBox 3"/>
+          <p:cNvSpPr txBox="1"/>
+          <p:nvPr/>
+        </p:nvSpPr>
+        <p:spPr>
+          <a:xfrm>
+            <a:off x="1143000" y="347472"/>
+            <a:ext cx="10607040" cy="914400"/>
+          </a:xfrm>
+          <a:prstGeom prst="rect">
+            <a:avLst/>
+          </a:prstGeom>
+          <a:noFill/>
+        </p:spPr>
+        <p:txBody>
+          <a:bodyPr wrap="square" anchor="t" lIns="25400" rIns="25400" tIns="25400" bIns="25400">
+            <a:spAutoFit/>
+          </a:bodyPr>
+          <a:lstStyle/>
+          <a:p>
             <a:pPr algn="l">
               <a:spcAft>
                 <a:spcPts val="400"/>
@@ -8074,7 +8638,7 @@
       </p:sp>
       <p:pic>
         <p:nvPicPr>
-          <p:cNvPr id="4" name="Picture 3" descr="翻越绕行权衡.png"/>
+          <p:cNvPr id="5" name="Picture 4" descr="翻越绕行权衡.png"/>
           <p:cNvPicPr>
             <a:picLocks noChangeAspect="1"/>
           </p:cNvPicPr>
@@ -8098,7 +8662,7 @@
       </p:pic>
       <p:sp>
         <p:nvSpPr>
-          <p:cNvPr id="5" name="TextBox 4"/>
+          <p:cNvPr id="6" name="TextBox 5"/>
           <p:cNvSpPr txBox="1"/>
           <p:nvPr/>
         </p:nvSpPr>
@@ -8214,8 +8778,8 @@
         </p:nvSpPr>
         <p:spPr>
           <a:xfrm>
-            <a:off x="1143000" y="347472"/>
-            <a:ext cx="10607040" cy="914400"/>
+            <a:off x="9052560" y="292608"/>
+            <a:ext cx="2834640" cy="365760"/>
           </a:xfrm>
           <a:prstGeom prst="rect">
             <a:avLst/>
@@ -8228,6 +8792,47 @@
           </a:bodyPr>
           <a:lstStyle/>
           <a:p>
+            <a:pPr algn="r">
+              <a:spcAft>
+                <a:spcPts val="400"/>
+              </a:spcAft>
+            </a:pPr>
+            <a:r>
+              <a:rPr sz="1200" b="0">
+                <a:solidFill>
+                  <a:srgbClr val="9AA8B8"/>
+                </a:solidFill>
+                <a:latin typeface="微软雅黑"/>
+                <a:ea typeface="微软雅黑"/>
+                <a:cs typeface="微软雅黑"/>
+              </a:rPr>
+              <a:t>西安交通大学</a:t>
+            </a:r>
+          </a:p>
+        </p:txBody>
+      </p:sp>
+      <p:sp>
+        <p:nvSpPr>
+          <p:cNvPr id="4" name="TextBox 3"/>
+          <p:cNvSpPr txBox="1"/>
+          <p:nvPr/>
+        </p:nvSpPr>
+        <p:spPr>
+          <a:xfrm>
+            <a:off x="1143000" y="347472"/>
+            <a:ext cx="10607040" cy="914400"/>
+          </a:xfrm>
+          <a:prstGeom prst="rect">
+            <a:avLst/>
+          </a:prstGeom>
+          <a:noFill/>
+        </p:spPr>
+        <p:txBody>
+          <a:bodyPr wrap="square" anchor="t" lIns="25400" rIns="25400" tIns="25400" bIns="25400">
+            <a:spAutoFit/>
+          </a:bodyPr>
+          <a:lstStyle/>
+          <a:p>
             <a:pPr algn="l">
               <a:spcAft>
                 <a:spcPts val="400"/>
@@ -8249,7 +8854,7 @@
       </p:sp>
       <p:pic>
         <p:nvPicPr>
-          <p:cNvPr id="4" name="Picture 3" descr="操作包络相图.png"/>
+          <p:cNvPr id="5" name="Picture 4" descr="操作包络相图.png"/>
           <p:cNvPicPr>
             <a:picLocks noChangeAspect="1"/>
           </p:cNvPicPr>
@@ -8273,7 +8878,7 @@
       </p:pic>
       <p:sp>
         <p:nvSpPr>
-          <p:cNvPr id="5" name="TextBox 4"/>
+          <p:cNvPr id="6" name="TextBox 5"/>
           <p:cNvSpPr txBox="1"/>
           <p:nvPr/>
         </p:nvSpPr>
@@ -8389,8 +8994,8 @@
         </p:nvSpPr>
         <p:spPr>
           <a:xfrm>
-            <a:off x="1143000" y="347472"/>
-            <a:ext cx="10607040" cy="914400"/>
+            <a:off x="9052560" y="292608"/>
+            <a:ext cx="2834640" cy="365760"/>
           </a:xfrm>
           <a:prstGeom prst="rect">
             <a:avLst/>
@@ -8403,6 +9008,47 @@
           </a:bodyPr>
           <a:lstStyle/>
           <a:p>
+            <a:pPr algn="r">
+              <a:spcAft>
+                <a:spcPts val="400"/>
+              </a:spcAft>
+            </a:pPr>
+            <a:r>
+              <a:rPr sz="1200" b="0">
+                <a:solidFill>
+                  <a:srgbClr val="9AA8B8"/>
+                </a:solidFill>
+                <a:latin typeface="微软雅黑"/>
+                <a:ea typeface="微软雅黑"/>
+                <a:cs typeface="微软雅黑"/>
+              </a:rPr>
+              <a:t>西安交通大学</a:t>
+            </a:r>
+          </a:p>
+        </p:txBody>
+      </p:sp>
+      <p:sp>
+        <p:nvSpPr>
+          <p:cNvPr id="4" name="TextBox 3"/>
+          <p:cNvSpPr txBox="1"/>
+          <p:nvPr/>
+        </p:nvSpPr>
+        <p:spPr>
+          <a:xfrm>
+            <a:off x="1143000" y="347472"/>
+            <a:ext cx="10607040" cy="914400"/>
+          </a:xfrm>
+          <a:prstGeom prst="rect">
+            <a:avLst/>
+          </a:prstGeom>
+          <a:noFill/>
+        </p:spPr>
+        <p:txBody>
+          <a:bodyPr wrap="square" anchor="t" lIns="25400" rIns="25400" tIns="25400" bIns="25400">
+            <a:spAutoFit/>
+          </a:bodyPr>
+          <a:lstStyle/>
+          <a:p>
             <a:pPr algn="l">
               <a:spcAft>
                 <a:spcPts val="400"/>
@@ -8424,7 +9070,7 @@
       </p:sp>
       <p:pic>
         <p:nvPicPr>
-          <p:cNvPr id="4" name="Picture 3" descr="safeguard_ablation.png"/>
+          <p:cNvPr id="5" name="Picture 4" descr="safeguard_ablation.png"/>
           <p:cNvPicPr>
             <a:picLocks noChangeAspect="1"/>
           </p:cNvPicPr>
@@ -8448,7 +9094,7 @@
       </p:pic>
       <p:sp>
         <p:nvSpPr>
-          <p:cNvPr id="5" name="TextBox 4"/>
+          <p:cNvPr id="6" name="TextBox 5"/>
           <p:cNvSpPr txBox="1"/>
           <p:nvPr/>
         </p:nvSpPr>
@@ -8564,8 +9210,8 @@
         </p:nvSpPr>
         <p:spPr>
           <a:xfrm>
-            <a:off x="1143000" y="347472"/>
-            <a:ext cx="10607040" cy="914400"/>
+            <a:off x="9052560" y="292608"/>
+            <a:ext cx="2834640" cy="365760"/>
           </a:xfrm>
           <a:prstGeom prst="rect">
             <a:avLst/>
@@ -8578,6 +9224,47 @@
           </a:bodyPr>
           <a:lstStyle/>
           <a:p>
+            <a:pPr algn="r">
+              <a:spcAft>
+                <a:spcPts val="400"/>
+              </a:spcAft>
+            </a:pPr>
+            <a:r>
+              <a:rPr sz="1200" b="0">
+                <a:solidFill>
+                  <a:srgbClr val="9AA8B8"/>
+                </a:solidFill>
+                <a:latin typeface="微软雅黑"/>
+                <a:ea typeface="微软雅黑"/>
+                <a:cs typeface="微软雅黑"/>
+              </a:rPr>
+              <a:t>西安交通大学</a:t>
+            </a:r>
+          </a:p>
+        </p:txBody>
+      </p:sp>
+      <p:sp>
+        <p:nvSpPr>
+          <p:cNvPr id="4" name="TextBox 3"/>
+          <p:cNvSpPr txBox="1"/>
+          <p:nvPr/>
+        </p:nvSpPr>
+        <p:spPr>
+          <a:xfrm>
+            <a:off x="1143000" y="347472"/>
+            <a:ext cx="10607040" cy="914400"/>
+          </a:xfrm>
+          <a:prstGeom prst="rect">
+            <a:avLst/>
+          </a:prstGeom>
+          <a:noFill/>
+        </p:spPr>
+        <p:txBody>
+          <a:bodyPr wrap="square" anchor="t" lIns="25400" rIns="25400" tIns="25400" bIns="25400">
+            <a:spAutoFit/>
+          </a:bodyPr>
+          <a:lstStyle/>
+          <a:p>
             <a:pPr algn="l">
               <a:spcAft>
                 <a:spcPts val="400"/>
@@ -8599,7 +9286,7 @@
       </p:sp>
       <p:pic>
         <p:nvPicPr>
-          <p:cNvPr id="4" name="Picture 3" descr="sim_flight.png"/>
+          <p:cNvPr id="5" name="Picture 4" descr="sim_flight.png"/>
           <p:cNvPicPr>
             <a:picLocks noChangeAspect="1"/>
           </p:cNvPicPr>
@@ -8623,7 +9310,7 @@
       </p:pic>
       <p:sp>
         <p:nvSpPr>
-          <p:cNvPr id="5" name="TextBox 4"/>
+          <p:cNvPr id="6" name="TextBox 5"/>
           <p:cNvSpPr txBox="1"/>
           <p:nvPr/>
         </p:nvSpPr>
@@ -8739,8 +9426,8 @@
         </p:nvSpPr>
         <p:spPr>
           <a:xfrm>
-            <a:off x="1143000" y="347472"/>
-            <a:ext cx="10607040" cy="914400"/>
+            <a:off x="9052560" y="292608"/>
+            <a:ext cx="2834640" cy="365760"/>
           </a:xfrm>
           <a:prstGeom prst="rect">
             <a:avLst/>
@@ -8753,6 +9440,47 @@
           </a:bodyPr>
           <a:lstStyle/>
           <a:p>
+            <a:pPr algn="r">
+              <a:spcAft>
+                <a:spcPts val="400"/>
+              </a:spcAft>
+            </a:pPr>
+            <a:r>
+              <a:rPr sz="1200" b="0">
+                <a:solidFill>
+                  <a:srgbClr val="9AA8B8"/>
+                </a:solidFill>
+                <a:latin typeface="微软雅黑"/>
+                <a:ea typeface="微软雅黑"/>
+                <a:cs typeface="微软雅黑"/>
+              </a:rPr>
+              <a:t>西安交通大学</a:t>
+            </a:r>
+          </a:p>
+        </p:txBody>
+      </p:sp>
+      <p:sp>
+        <p:nvSpPr>
+          <p:cNvPr id="4" name="TextBox 3"/>
+          <p:cNvSpPr txBox="1"/>
+          <p:nvPr/>
+        </p:nvSpPr>
+        <p:spPr>
+          <a:xfrm>
+            <a:off x="1143000" y="347472"/>
+            <a:ext cx="10607040" cy="914400"/>
+          </a:xfrm>
+          <a:prstGeom prst="rect">
+            <a:avLst/>
+          </a:prstGeom>
+          <a:noFill/>
+        </p:spPr>
+        <p:txBody>
+          <a:bodyPr wrap="square" anchor="t" lIns="25400" rIns="25400" tIns="25400" bIns="25400">
+            <a:spAutoFit/>
+          </a:bodyPr>
+          <a:lstStyle/>
+          <a:p>
             <a:pPr algn="l">
               <a:spcAft>
                 <a:spcPts val="400"/>
@@ -8774,7 +9502,7 @@
       </p:sp>
       <p:pic>
         <p:nvPicPr>
-          <p:cNvPr id="4" name="Picture 3" descr="px4_traj.png"/>
+          <p:cNvPr id="5" name="Picture 4" descr="px4_traj.png"/>
           <p:cNvPicPr>
             <a:picLocks noChangeAspect="1"/>
           </p:cNvPicPr>
@@ -8798,7 +9526,7 @@
       </p:pic>
       <p:sp>
         <p:nvSpPr>
-          <p:cNvPr id="5" name="TextBox 4"/>
+          <p:cNvPr id="6" name="TextBox 5"/>
           <p:cNvSpPr txBox="1"/>
           <p:nvPr/>
         </p:nvSpPr>
@@ -8906,9 +9634,33 @@
           </a:p>
         </p:txBody>
       </p:sp>
-      <p:sp>
-        <p:nvSpPr>
-          <p:cNvPr id="3" name="Rounded Rectangle 2"/>
+      <p:pic>
+        <p:nvPicPr>
+          <p:cNvPr id="3" name="Picture 2" descr="xjtu_logo_white.png"/>
+          <p:cNvPicPr>
+            <a:picLocks noChangeAspect="1"/>
+          </p:cNvPicPr>
+          <p:nvPr/>
+        </p:nvPicPr>
+        <p:blipFill>
+          <a:blip r:embed="rId2"/>
+          <a:stretch>
+            <a:fillRect/>
+          </a:stretch>
+        </p:blipFill>
+        <p:spPr>
+          <a:xfrm>
+            <a:off x="8686800" y="365760"/>
+            <a:ext cx="1707229" cy="457200"/>
+          </a:xfrm>
+          <a:prstGeom prst="rect">
+            <a:avLst/>
+          </a:prstGeom>
+        </p:spPr>
+      </p:pic>
+      <p:sp>
+        <p:nvSpPr>
+          <p:cNvPr id="4" name="Rounded Rectangle 3"/>
           <p:cNvSpPr/>
           <p:nvPr/>
         </p:nvSpPr>
@@ -8962,7 +9714,7 @@
       </p:sp>
       <p:sp>
         <p:nvSpPr>
-          <p:cNvPr id="4" name="TextBox 3"/>
+          <p:cNvPr id="5" name="TextBox 4"/>
           <p:cNvSpPr txBox="1"/>
           <p:nvPr/>
         </p:nvSpPr>
@@ -9003,7 +9755,7 @@
       </p:sp>
       <p:sp>
         <p:nvSpPr>
-          <p:cNvPr id="5" name="TextBox 4"/>
+          <p:cNvPr id="6" name="TextBox 5"/>
           <p:cNvSpPr txBox="1"/>
           <p:nvPr/>
         </p:nvSpPr>
@@ -9062,7 +9814,7 @@
       </p:sp>
       <p:sp>
         <p:nvSpPr>
-          <p:cNvPr id="6" name="TextBox 5"/>
+          <p:cNvPr id="7" name="TextBox 6"/>
           <p:cNvSpPr txBox="1"/>
           <p:nvPr/>
         </p:nvSpPr>
@@ -9172,7 +9924,48 @@
       </p:sp>
       <p:sp>
         <p:nvSpPr>
-          <p:cNvPr id="3" name="Rounded Rectangle 2"/>
+          <p:cNvPr id="3" name="TextBox 2"/>
+          <p:cNvSpPr txBox="1"/>
+          <p:nvPr/>
+        </p:nvSpPr>
+        <p:spPr>
+          <a:xfrm>
+            <a:off x="9052560" y="292608"/>
+            <a:ext cx="2834640" cy="365760"/>
+          </a:xfrm>
+          <a:prstGeom prst="rect">
+            <a:avLst/>
+          </a:prstGeom>
+          <a:noFill/>
+        </p:spPr>
+        <p:txBody>
+          <a:bodyPr wrap="square" anchor="t" lIns="25400" rIns="25400" tIns="25400" bIns="25400">
+            <a:spAutoFit/>
+          </a:bodyPr>
+          <a:lstStyle/>
+          <a:p>
+            <a:pPr algn="r">
+              <a:spcAft>
+                <a:spcPts val="400"/>
+              </a:spcAft>
+            </a:pPr>
+            <a:r>
+              <a:rPr sz="1200" b="0">
+                <a:solidFill>
+                  <a:srgbClr val="9AA8B8"/>
+                </a:solidFill>
+                <a:latin typeface="微软雅黑"/>
+                <a:ea typeface="微软雅黑"/>
+                <a:cs typeface="微软雅黑"/>
+              </a:rPr>
+              <a:t>西安交通大学</a:t>
+            </a:r>
+          </a:p>
+        </p:txBody>
+      </p:sp>
+      <p:sp>
+        <p:nvSpPr>
+          <p:cNvPr id="4" name="Rounded Rectangle 3"/>
           <p:cNvSpPr/>
           <p:nvPr/>
         </p:nvSpPr>
@@ -9226,7 +10019,7 @@
       </p:sp>
       <p:sp>
         <p:nvSpPr>
-          <p:cNvPr id="4" name="TextBox 3"/>
+          <p:cNvPr id="5" name="TextBox 4"/>
           <p:cNvSpPr txBox="1"/>
           <p:nvPr/>
         </p:nvSpPr>
@@ -9267,7 +10060,7 @@
       </p:sp>
       <p:sp>
         <p:nvSpPr>
-          <p:cNvPr id="5" name="Rectangle 4"/>
+          <p:cNvPr id="6" name="Rectangle 5"/>
           <p:cNvSpPr/>
           <p:nvPr/>
         </p:nvSpPr>
@@ -9312,7 +10105,7 @@
       </p:sp>
       <p:sp>
         <p:nvSpPr>
-          <p:cNvPr id="6" name="TextBox 5"/>
+          <p:cNvPr id="7" name="TextBox 6"/>
           <p:cNvSpPr txBox="1"/>
           <p:nvPr/>
         </p:nvSpPr>
@@ -9353,7 +10146,7 @@
       </p:sp>
       <p:sp>
         <p:nvSpPr>
-          <p:cNvPr id="7" name="TextBox 6"/>
+          <p:cNvPr id="8" name="TextBox 7"/>
           <p:cNvSpPr txBox="1"/>
           <p:nvPr/>
         </p:nvSpPr>
@@ -9394,7 +10187,7 @@
       </p:sp>
       <p:sp>
         <p:nvSpPr>
-          <p:cNvPr id="8" name="TextBox 7"/>
+          <p:cNvPr id="9" name="TextBox 8"/>
           <p:cNvSpPr txBox="1"/>
           <p:nvPr/>
         </p:nvSpPr>
@@ -9435,7 +10228,7 @@
       </p:sp>
       <p:sp>
         <p:nvSpPr>
-          <p:cNvPr id="9" name="Rectangle 8"/>
+          <p:cNvPr id="10" name="Rectangle 9"/>
           <p:cNvSpPr/>
           <p:nvPr/>
         </p:nvSpPr>
@@ -9480,7 +10273,7 @@
       </p:sp>
       <p:sp>
         <p:nvSpPr>
-          <p:cNvPr id="10" name="TextBox 9"/>
+          <p:cNvPr id="11" name="TextBox 10"/>
           <p:cNvSpPr txBox="1"/>
           <p:nvPr/>
         </p:nvSpPr>
@@ -9521,7 +10314,7 @@
       </p:sp>
       <p:sp>
         <p:nvSpPr>
-          <p:cNvPr id="11" name="TextBox 10"/>
+          <p:cNvPr id="12" name="TextBox 11"/>
           <p:cNvSpPr txBox="1"/>
           <p:nvPr/>
         </p:nvSpPr>
@@ -9562,7 +10355,7 @@
       </p:sp>
       <p:sp>
         <p:nvSpPr>
-          <p:cNvPr id="12" name="TextBox 11"/>
+          <p:cNvPr id="13" name="TextBox 12"/>
           <p:cNvSpPr txBox="1"/>
           <p:nvPr/>
         </p:nvSpPr>
@@ -9603,7 +10396,7 @@
       </p:sp>
       <p:sp>
         <p:nvSpPr>
-          <p:cNvPr id="13" name="Rectangle 12"/>
+          <p:cNvPr id="14" name="Rectangle 13"/>
           <p:cNvSpPr/>
           <p:nvPr/>
         </p:nvSpPr>
@@ -9648,7 +10441,7 @@
       </p:sp>
       <p:sp>
         <p:nvSpPr>
-          <p:cNvPr id="14" name="TextBox 13"/>
+          <p:cNvPr id="15" name="TextBox 14"/>
           <p:cNvSpPr txBox="1"/>
           <p:nvPr/>
         </p:nvSpPr>
@@ -9689,7 +10482,7 @@
       </p:sp>
       <p:sp>
         <p:nvSpPr>
-          <p:cNvPr id="15" name="TextBox 14"/>
+          <p:cNvPr id="16" name="TextBox 15"/>
           <p:cNvSpPr txBox="1"/>
           <p:nvPr/>
         </p:nvSpPr>
@@ -9730,7 +10523,7 @@
       </p:sp>
       <p:sp>
         <p:nvSpPr>
-          <p:cNvPr id="16" name="TextBox 15"/>
+          <p:cNvPr id="17" name="TextBox 16"/>
           <p:cNvSpPr txBox="1"/>
           <p:nvPr/>
         </p:nvSpPr>
@@ -9771,7 +10564,7 @@
       </p:sp>
       <p:sp>
         <p:nvSpPr>
-          <p:cNvPr id="17" name="Rectangle 16"/>
+          <p:cNvPr id="18" name="Rectangle 17"/>
           <p:cNvSpPr/>
           <p:nvPr/>
         </p:nvSpPr>
@@ -9816,7 +10609,7 @@
       </p:sp>
       <p:sp>
         <p:nvSpPr>
-          <p:cNvPr id="18" name="TextBox 17"/>
+          <p:cNvPr id="19" name="TextBox 18"/>
           <p:cNvSpPr txBox="1"/>
           <p:nvPr/>
         </p:nvSpPr>
@@ -9857,7 +10650,7 @@
       </p:sp>
       <p:sp>
         <p:nvSpPr>
-          <p:cNvPr id="19" name="TextBox 18"/>
+          <p:cNvPr id="20" name="TextBox 19"/>
           <p:cNvSpPr txBox="1"/>
           <p:nvPr/>
         </p:nvSpPr>
@@ -9898,7 +10691,7 @@
       </p:sp>
       <p:sp>
         <p:nvSpPr>
-          <p:cNvPr id="20" name="TextBox 19"/>
+          <p:cNvPr id="21" name="TextBox 20"/>
           <p:cNvSpPr txBox="1"/>
           <p:nvPr/>
         </p:nvSpPr>
@@ -9939,7 +10732,7 @@
       </p:sp>
       <p:sp>
         <p:nvSpPr>
-          <p:cNvPr id="21" name="Rectangle 20"/>
+          <p:cNvPr id="22" name="Rectangle 21"/>
           <p:cNvSpPr/>
           <p:nvPr/>
         </p:nvSpPr>
@@ -9984,7 +10777,7 @@
       </p:sp>
       <p:sp>
         <p:nvSpPr>
-          <p:cNvPr id="22" name="TextBox 21"/>
+          <p:cNvPr id="23" name="TextBox 22"/>
           <p:cNvSpPr txBox="1"/>
           <p:nvPr/>
         </p:nvSpPr>
@@ -10025,7 +10818,7 @@
       </p:sp>
       <p:sp>
         <p:nvSpPr>
-          <p:cNvPr id="23" name="TextBox 22"/>
+          <p:cNvPr id="24" name="TextBox 23"/>
           <p:cNvSpPr txBox="1"/>
           <p:nvPr/>
         </p:nvSpPr>
@@ -10066,7 +10859,7 @@
       </p:sp>
       <p:sp>
         <p:nvSpPr>
-          <p:cNvPr id="24" name="TextBox 23"/>
+          <p:cNvPr id="25" name="TextBox 24"/>
           <p:cNvSpPr txBox="1"/>
           <p:nvPr/>
         </p:nvSpPr>
@@ -10107,7 +10900,7 @@
       </p:sp>
       <p:sp>
         <p:nvSpPr>
-          <p:cNvPr id="25" name="Rectangle 24"/>
+          <p:cNvPr id="26" name="Rectangle 25"/>
           <p:cNvSpPr/>
           <p:nvPr/>
         </p:nvSpPr>
@@ -10152,7 +10945,7 @@
       </p:sp>
       <p:sp>
         <p:nvSpPr>
-          <p:cNvPr id="26" name="TextBox 25"/>
+          <p:cNvPr id="27" name="TextBox 26"/>
           <p:cNvSpPr txBox="1"/>
           <p:nvPr/>
         </p:nvSpPr>
@@ -10193,7 +10986,7 @@
       </p:sp>
       <p:sp>
         <p:nvSpPr>
-          <p:cNvPr id="27" name="TextBox 26"/>
+          <p:cNvPr id="28" name="TextBox 27"/>
           <p:cNvSpPr txBox="1"/>
           <p:nvPr/>
         </p:nvSpPr>
@@ -10234,7 +11027,7 @@
       </p:sp>
       <p:sp>
         <p:nvSpPr>
-          <p:cNvPr id="28" name="TextBox 27"/>
+          <p:cNvPr id="29" name="TextBox 28"/>
           <p:cNvSpPr txBox="1"/>
           <p:nvPr/>
         </p:nvSpPr>
@@ -10344,7 +11137,48 @@
       </p:sp>
       <p:sp>
         <p:nvSpPr>
-          <p:cNvPr id="3" name="Rounded Rectangle 2"/>
+          <p:cNvPr id="3" name="TextBox 2"/>
+          <p:cNvSpPr txBox="1"/>
+          <p:nvPr/>
+        </p:nvSpPr>
+        <p:spPr>
+          <a:xfrm>
+            <a:off x="9052560" y="292608"/>
+            <a:ext cx="2834640" cy="365760"/>
+          </a:xfrm>
+          <a:prstGeom prst="rect">
+            <a:avLst/>
+          </a:prstGeom>
+          <a:noFill/>
+        </p:spPr>
+        <p:txBody>
+          <a:bodyPr wrap="square" anchor="t" lIns="25400" rIns="25400" tIns="25400" bIns="25400">
+            <a:spAutoFit/>
+          </a:bodyPr>
+          <a:lstStyle/>
+          <a:p>
+            <a:pPr algn="r">
+              <a:spcAft>
+                <a:spcPts val="400"/>
+              </a:spcAft>
+            </a:pPr>
+            <a:r>
+              <a:rPr sz="1200" b="0">
+                <a:solidFill>
+                  <a:srgbClr val="9AA8B8"/>
+                </a:solidFill>
+                <a:latin typeface="微软雅黑"/>
+                <a:ea typeface="微软雅黑"/>
+                <a:cs typeface="微软雅黑"/>
+              </a:rPr>
+              <a:t>西安交通大学</a:t>
+            </a:r>
+          </a:p>
+        </p:txBody>
+      </p:sp>
+      <p:sp>
+        <p:nvSpPr>
+          <p:cNvPr id="4" name="Rounded Rectangle 3"/>
           <p:cNvSpPr/>
           <p:nvPr/>
         </p:nvSpPr>
@@ -10398,7 +11232,7 @@
       </p:sp>
       <p:sp>
         <p:nvSpPr>
-          <p:cNvPr id="4" name="TextBox 3"/>
+          <p:cNvPr id="5" name="TextBox 4"/>
           <p:cNvSpPr txBox="1"/>
           <p:nvPr/>
         </p:nvSpPr>
@@ -10439,7 +11273,7 @@
       </p:sp>
       <p:sp>
         <p:nvSpPr>
-          <p:cNvPr id="5" name="Rounded Rectangle 4"/>
+          <p:cNvPr id="6" name="Rounded Rectangle 5"/>
           <p:cNvSpPr/>
           <p:nvPr/>
         </p:nvSpPr>
@@ -10493,7 +11327,7 @@
       </p:sp>
       <p:sp>
         <p:nvSpPr>
-          <p:cNvPr id="6" name="TextBox 5"/>
+          <p:cNvPr id="7" name="TextBox 6"/>
           <p:cNvSpPr txBox="1"/>
           <p:nvPr/>
         </p:nvSpPr>
@@ -10534,7 +11368,7 @@
       </p:sp>
       <p:sp>
         <p:nvSpPr>
-          <p:cNvPr id="7" name="TextBox 6"/>
+          <p:cNvPr id="8" name="TextBox 7"/>
           <p:cNvSpPr txBox="1"/>
           <p:nvPr/>
         </p:nvSpPr>
@@ -10575,7 +11409,7 @@
       </p:sp>
       <p:sp>
         <p:nvSpPr>
-          <p:cNvPr id="8" name="Rounded Rectangle 7"/>
+          <p:cNvPr id="9" name="Rounded Rectangle 8"/>
           <p:cNvSpPr/>
           <p:nvPr/>
         </p:nvSpPr>
@@ -10629,7 +11463,7 @@
       </p:sp>
       <p:sp>
         <p:nvSpPr>
-          <p:cNvPr id="9" name="TextBox 8"/>
+          <p:cNvPr id="10" name="TextBox 9"/>
           <p:cNvSpPr txBox="1"/>
           <p:nvPr/>
         </p:nvSpPr>
@@ -10670,7 +11504,7 @@
       </p:sp>
       <p:sp>
         <p:nvSpPr>
-          <p:cNvPr id="10" name="TextBox 9"/>
+          <p:cNvPr id="11" name="TextBox 10"/>
           <p:cNvSpPr txBox="1"/>
           <p:nvPr/>
         </p:nvSpPr>
@@ -10711,7 +11545,7 @@
       </p:sp>
       <p:sp>
         <p:nvSpPr>
-          <p:cNvPr id="11" name="Rounded Rectangle 10"/>
+          <p:cNvPr id="12" name="Rounded Rectangle 11"/>
           <p:cNvSpPr/>
           <p:nvPr/>
         </p:nvSpPr>
@@ -10765,7 +11599,7 @@
       </p:sp>
       <p:sp>
         <p:nvSpPr>
-          <p:cNvPr id="12" name="TextBox 11"/>
+          <p:cNvPr id="13" name="TextBox 12"/>
           <p:cNvSpPr txBox="1"/>
           <p:nvPr/>
         </p:nvSpPr>
@@ -10806,7 +11640,7 @@
       </p:sp>
       <p:sp>
         <p:nvSpPr>
-          <p:cNvPr id="13" name="TextBox 12"/>
+          <p:cNvPr id="14" name="TextBox 13"/>
           <p:cNvSpPr txBox="1"/>
           <p:nvPr/>
         </p:nvSpPr>
@@ -10847,7 +11681,7 @@
       </p:sp>
       <p:sp>
         <p:nvSpPr>
-          <p:cNvPr id="14" name="Rounded Rectangle 13"/>
+          <p:cNvPr id="15" name="Rounded Rectangle 14"/>
           <p:cNvSpPr/>
           <p:nvPr/>
         </p:nvSpPr>
@@ -10901,7 +11735,7 @@
       </p:sp>
       <p:sp>
         <p:nvSpPr>
-          <p:cNvPr id="15" name="TextBox 14"/>
+          <p:cNvPr id="16" name="TextBox 15"/>
           <p:cNvSpPr txBox="1"/>
           <p:nvPr/>
         </p:nvSpPr>
@@ -10942,7 +11776,7 @@
       </p:sp>
       <p:sp>
         <p:nvSpPr>
-          <p:cNvPr id="16" name="TextBox 15"/>
+          <p:cNvPr id="17" name="TextBox 16"/>
           <p:cNvSpPr txBox="1"/>
           <p:nvPr/>
         </p:nvSpPr>
@@ -10983,7 +11817,7 @@
       </p:sp>
       <p:sp>
         <p:nvSpPr>
-          <p:cNvPr id="17" name="Rounded Rectangle 16"/>
+          <p:cNvPr id="18" name="Rounded Rectangle 17"/>
           <p:cNvSpPr/>
           <p:nvPr/>
         </p:nvSpPr>
@@ -11037,7 +11871,7 @@
       </p:sp>
       <p:sp>
         <p:nvSpPr>
-          <p:cNvPr id="18" name="TextBox 17"/>
+          <p:cNvPr id="19" name="TextBox 18"/>
           <p:cNvSpPr txBox="1"/>
           <p:nvPr/>
         </p:nvSpPr>
@@ -11078,7 +11912,7 @@
       </p:sp>
       <p:sp>
         <p:nvSpPr>
-          <p:cNvPr id="19" name="TextBox 18"/>
+          <p:cNvPr id="20" name="TextBox 19"/>
           <p:cNvSpPr txBox="1"/>
           <p:nvPr/>
         </p:nvSpPr>
@@ -11188,7 +12022,48 @@
       </p:sp>
       <p:sp>
         <p:nvSpPr>
-          <p:cNvPr id="3" name="Rounded Rectangle 2"/>
+          <p:cNvPr id="3" name="TextBox 2"/>
+          <p:cNvSpPr txBox="1"/>
+          <p:nvPr/>
+        </p:nvSpPr>
+        <p:spPr>
+          <a:xfrm>
+            <a:off x="9052560" y="292608"/>
+            <a:ext cx="2834640" cy="365760"/>
+          </a:xfrm>
+          <a:prstGeom prst="rect">
+            <a:avLst/>
+          </a:prstGeom>
+          <a:noFill/>
+        </p:spPr>
+        <p:txBody>
+          <a:bodyPr wrap="square" anchor="t" lIns="25400" rIns="25400" tIns="25400" bIns="25400">
+            <a:spAutoFit/>
+          </a:bodyPr>
+          <a:lstStyle/>
+          <a:p>
+            <a:pPr algn="r">
+              <a:spcAft>
+                <a:spcPts val="400"/>
+              </a:spcAft>
+            </a:pPr>
+            <a:r>
+              <a:rPr sz="1200" b="0">
+                <a:solidFill>
+                  <a:srgbClr val="9AA8B8"/>
+                </a:solidFill>
+                <a:latin typeface="微软雅黑"/>
+                <a:ea typeface="微软雅黑"/>
+                <a:cs typeface="微软雅黑"/>
+              </a:rPr>
+              <a:t>西安交通大学</a:t>
+            </a:r>
+          </a:p>
+        </p:txBody>
+      </p:sp>
+      <p:sp>
+        <p:nvSpPr>
+          <p:cNvPr id="4" name="Rounded Rectangle 3"/>
           <p:cNvSpPr/>
           <p:nvPr/>
         </p:nvSpPr>
@@ -11242,7 +12117,7 @@
       </p:sp>
       <p:sp>
         <p:nvSpPr>
-          <p:cNvPr id="4" name="TextBox 3"/>
+          <p:cNvPr id="5" name="TextBox 4"/>
           <p:cNvSpPr txBox="1"/>
           <p:nvPr/>
         </p:nvSpPr>
@@ -11283,7 +12158,7 @@
       </p:sp>
       <p:pic>
         <p:nvPicPr>
-          <p:cNvPr id="5" name="Picture 4" descr="框架架构图.png"/>
+          <p:cNvPr id="6" name="Picture 5" descr="框架架构图.png"/>
           <p:cNvPicPr>
             <a:picLocks noChangeAspect="1"/>
           </p:cNvPicPr>
@@ -11307,7 +12182,7 @@
       </p:pic>
       <p:sp>
         <p:nvSpPr>
-          <p:cNvPr id="6" name="TextBox 5"/>
+          <p:cNvPr id="7" name="TextBox 6"/>
           <p:cNvSpPr txBox="1"/>
           <p:nvPr/>
         </p:nvSpPr>
@@ -11417,7 +12292,48 @@
       </p:sp>
       <p:sp>
         <p:nvSpPr>
-          <p:cNvPr id="3" name="Rounded Rectangle 2"/>
+          <p:cNvPr id="3" name="TextBox 2"/>
+          <p:cNvSpPr txBox="1"/>
+          <p:nvPr/>
+        </p:nvSpPr>
+        <p:spPr>
+          <a:xfrm>
+            <a:off x="9052560" y="292608"/>
+            <a:ext cx="2834640" cy="365760"/>
+          </a:xfrm>
+          <a:prstGeom prst="rect">
+            <a:avLst/>
+          </a:prstGeom>
+          <a:noFill/>
+        </p:spPr>
+        <p:txBody>
+          <a:bodyPr wrap="square" anchor="t" lIns="25400" rIns="25400" tIns="25400" bIns="25400">
+            <a:spAutoFit/>
+          </a:bodyPr>
+          <a:lstStyle/>
+          <a:p>
+            <a:pPr algn="r">
+              <a:spcAft>
+                <a:spcPts val="400"/>
+              </a:spcAft>
+            </a:pPr>
+            <a:r>
+              <a:rPr sz="1200" b="0">
+                <a:solidFill>
+                  <a:srgbClr val="9AA8B8"/>
+                </a:solidFill>
+                <a:latin typeface="微软雅黑"/>
+                <a:ea typeface="微软雅黑"/>
+                <a:cs typeface="微软雅黑"/>
+              </a:rPr>
+              <a:t>西安交通大学</a:t>
+            </a:r>
+          </a:p>
+        </p:txBody>
+      </p:sp>
+      <p:sp>
+        <p:nvSpPr>
+          <p:cNvPr id="4" name="Rounded Rectangle 3"/>
           <p:cNvSpPr/>
           <p:nvPr/>
         </p:nvSpPr>
@@ -11471,7 +12387,7 @@
       </p:sp>
       <p:sp>
         <p:nvSpPr>
-          <p:cNvPr id="4" name="TextBox 3"/>
+          <p:cNvPr id="5" name="TextBox 4"/>
           <p:cNvSpPr txBox="1"/>
           <p:nvPr/>
         </p:nvSpPr>
@@ -11512,7 +12428,7 @@
       </p:sp>
       <p:pic>
         <p:nvPicPr>
-          <p:cNvPr id="5" name="Picture 4" descr="loop_process.png"/>
+          <p:cNvPr id="6" name="Picture 5" descr="loop_process.png"/>
           <p:cNvPicPr>
             <a:picLocks noChangeAspect="1"/>
           </p:cNvPicPr>
@@ -11536,7 +12452,7 @@
       </p:pic>
       <p:sp>
         <p:nvSpPr>
-          <p:cNvPr id="6" name="TextBox 5"/>
+          <p:cNvPr id="7" name="TextBox 6"/>
           <p:cNvSpPr txBox="1"/>
           <p:nvPr/>
         </p:nvSpPr>
@@ -11685,7 +12601,7 @@
       </p:sp>
       <p:sp>
         <p:nvSpPr>
-          <p:cNvPr id="7" name="TextBox 6"/>
+          <p:cNvPr id="8" name="TextBox 7"/>
           <p:cNvSpPr txBox="1"/>
           <p:nvPr/>
         </p:nvSpPr>
@@ -11795,7 +12711,48 @@
       </p:sp>
       <p:sp>
         <p:nvSpPr>
-          <p:cNvPr id="3" name="Rounded Rectangle 2"/>
+          <p:cNvPr id="3" name="TextBox 2"/>
+          <p:cNvSpPr txBox="1"/>
+          <p:nvPr/>
+        </p:nvSpPr>
+        <p:spPr>
+          <a:xfrm>
+            <a:off x="9052560" y="292608"/>
+            <a:ext cx="2834640" cy="365760"/>
+          </a:xfrm>
+          <a:prstGeom prst="rect">
+            <a:avLst/>
+          </a:prstGeom>
+          <a:noFill/>
+        </p:spPr>
+        <p:txBody>
+          <a:bodyPr wrap="square" anchor="t" lIns="25400" rIns="25400" tIns="25400" bIns="25400">
+            <a:spAutoFit/>
+          </a:bodyPr>
+          <a:lstStyle/>
+          <a:p>
+            <a:pPr algn="r">
+              <a:spcAft>
+                <a:spcPts val="400"/>
+              </a:spcAft>
+            </a:pPr>
+            <a:r>
+              <a:rPr sz="1200" b="0">
+                <a:solidFill>
+                  <a:srgbClr val="9AA8B8"/>
+                </a:solidFill>
+                <a:latin typeface="微软雅黑"/>
+                <a:ea typeface="微软雅黑"/>
+                <a:cs typeface="微软雅黑"/>
+              </a:rPr>
+              <a:t>西安交通大学</a:t>
+            </a:r>
+          </a:p>
+        </p:txBody>
+      </p:sp>
+      <p:sp>
+        <p:nvSpPr>
+          <p:cNvPr id="4" name="Rounded Rectangle 3"/>
           <p:cNvSpPr/>
           <p:nvPr/>
         </p:nvSpPr>
@@ -11849,7 +12806,7 @@
       </p:sp>
       <p:sp>
         <p:nvSpPr>
-          <p:cNvPr id="4" name="TextBox 3"/>
+          <p:cNvPr id="5" name="TextBox 4"/>
           <p:cNvSpPr txBox="1"/>
           <p:nvPr/>
         </p:nvSpPr>
@@ -11890,7 +12847,7 @@
       </p:sp>
       <p:pic>
         <p:nvPicPr>
-          <p:cNvPr id="5" name="Picture 4" descr="突破阈值叙事.png"/>
+          <p:cNvPr id="6" name="Picture 5" descr="突破阈值叙事.png"/>
           <p:cNvPicPr>
             <a:picLocks noChangeAspect="1"/>
           </p:cNvPicPr>
@@ -11914,7 +12871,7 @@
       </p:pic>
       <p:sp>
         <p:nvSpPr>
-          <p:cNvPr id="6" name="TextBox 5"/>
+          <p:cNvPr id="7" name="TextBox 6"/>
           <p:cNvSpPr txBox="1"/>
           <p:nvPr/>
         </p:nvSpPr>
@@ -12024,7 +12981,48 @@
       </p:sp>
       <p:sp>
         <p:nvSpPr>
-          <p:cNvPr id="3" name="Rounded Rectangle 2"/>
+          <p:cNvPr id="3" name="TextBox 2"/>
+          <p:cNvSpPr txBox="1"/>
+          <p:nvPr/>
+        </p:nvSpPr>
+        <p:spPr>
+          <a:xfrm>
+            <a:off x="9052560" y="292608"/>
+            <a:ext cx="2834640" cy="365760"/>
+          </a:xfrm>
+          <a:prstGeom prst="rect">
+            <a:avLst/>
+          </a:prstGeom>
+          <a:noFill/>
+        </p:spPr>
+        <p:txBody>
+          <a:bodyPr wrap="square" anchor="t" lIns="25400" rIns="25400" tIns="25400" bIns="25400">
+            <a:spAutoFit/>
+          </a:bodyPr>
+          <a:lstStyle/>
+          <a:p>
+            <a:pPr algn="r">
+              <a:spcAft>
+                <a:spcPts val="400"/>
+              </a:spcAft>
+            </a:pPr>
+            <a:r>
+              <a:rPr sz="1200" b="0">
+                <a:solidFill>
+                  <a:srgbClr val="9AA8B8"/>
+                </a:solidFill>
+                <a:latin typeface="微软雅黑"/>
+                <a:ea typeface="微软雅黑"/>
+                <a:cs typeface="微软雅黑"/>
+              </a:rPr>
+              <a:t>西安交通大学</a:t>
+            </a:r>
+          </a:p>
+        </p:txBody>
+      </p:sp>
+      <p:sp>
+        <p:nvSpPr>
+          <p:cNvPr id="4" name="Rounded Rectangle 3"/>
           <p:cNvSpPr/>
           <p:nvPr/>
         </p:nvSpPr>
@@ -12078,7 +13076,7 @@
       </p:sp>
       <p:sp>
         <p:nvSpPr>
-          <p:cNvPr id="4" name="TextBox 3"/>
+          <p:cNvPr id="5" name="TextBox 4"/>
           <p:cNvSpPr txBox="1"/>
           <p:nvPr/>
         </p:nvSpPr>
@@ -12119,7 +13117,7 @@
       </p:sp>
       <p:pic>
         <p:nvPicPr>
-          <p:cNvPr id="5" name="Picture 4" descr="fig_summary.png"/>
+          <p:cNvPr id="6" name="Picture 5" descr="fig_summary.png"/>
           <p:cNvPicPr>
             <a:picLocks noChangeAspect="1"/>
           </p:cNvPicPr>
@@ -12143,7 +13141,7 @@
       </p:pic>
       <p:sp>
         <p:nvSpPr>
-          <p:cNvPr id="6" name="TextBox 5"/>
+          <p:cNvPr id="7" name="TextBox 6"/>
           <p:cNvSpPr txBox="1"/>
           <p:nvPr/>
         </p:nvSpPr>
@@ -12256,7 +13254,7 @@
       </p:sp>
       <p:sp>
         <p:nvSpPr>
-          <p:cNvPr id="7" name="TextBox 6"/>
+          <p:cNvPr id="8" name="TextBox 7"/>
           <p:cNvSpPr txBox="1"/>
           <p:nvPr/>
         </p:nvSpPr>

</xml_diff>

<commit_message>
Redraw loop flow diagram with Graphviz (fixes tangled arrows) + complexity-scaling research confirms guided-search advantage grows with search-space size (validates 'energy tie = small space, not framework failure')
loop_flow_gv.py: Graphviz重画loop机制流程图(读→提→评→keep/revert→记账循环+外搜支路),箭头自动布局不乱,替换matplotlib手画乱箭头。loop_process.py只留迭代轨迹。loop页改双图并排。deep-research证实用户猜想:引导搜索优势随空间复杂度增长(Bergstra2012低有效维/REMBO 15-20维临界/NAS去混淆后0.07→0.90/FunSearch超宇宙原子数空间)——能耗域打平=小空间规律预测,规划器域胜27%=复杂端点,同框架横跨两端亲手复现规律。COMPLEXITY_SCALING_RESEARCH.md+AI4S_POSITIONING决定性论点。

Co-Authored-By: Claude Opus 4.8 (1M context) <noreply@anthropic.com>
</commit_message>
<xml_diff>
--- a/autoresearch/energy_m100/experiments/midterm_defense.pptx
+++ b/autoresearch/energy_m100/experiments/midterm_defense.pptx
@@ -12442,24 +12442,48 @@
         </p:blipFill>
         <p:spPr>
           <a:xfrm>
-            <a:off x="1061985" y="1783080"/>
-            <a:ext cx="7111470" cy="4297680"/>
+            <a:off x="457200" y="2656971"/>
+            <a:ext cx="6949440" cy="2458457"/>
           </a:xfrm>
           <a:prstGeom prst="rect">
             <a:avLst/>
           </a:prstGeom>
         </p:spPr>
       </p:pic>
-      <p:sp>
-        <p:nvSpPr>
-          <p:cNvPr id="7" name="TextBox 6"/>
+      <p:pic>
+        <p:nvPicPr>
+          <p:cNvPr id="7" name="Picture 6" descr="loop流程图.png"/>
+          <p:cNvPicPr>
+            <a:picLocks noChangeAspect="1"/>
+          </p:cNvPicPr>
+          <p:nvPr/>
+        </p:nvPicPr>
+        <p:blipFill>
+          <a:blip r:embed="rId3"/>
+          <a:stretch>
+            <a:fillRect/>
+          </a:stretch>
+        </p:blipFill>
+        <p:spPr>
+          <a:xfrm>
+            <a:off x="7968515" y="1737360"/>
+            <a:ext cx="3448250" cy="4480560"/>
+          </a:xfrm>
+          <a:prstGeom prst="rect">
+            <a:avLst/>
+          </a:prstGeom>
+        </p:spPr>
+      </p:pic>
+      <p:sp>
+        <p:nvSpPr>
+          <p:cNvPr id="8" name="TextBox 7"/>
           <p:cNvSpPr txBox="1"/>
           <p:nvPr/>
         </p:nvSpPr>
         <p:spPr>
           <a:xfrm>
-            <a:off x="8869680" y="1920240"/>
-            <a:ext cx="3017520" cy="4206240"/>
+            <a:off x="502920" y="6400800"/>
+            <a:ext cx="11155680" cy="320040"/>
           </a:xfrm>
           <a:prstGeom prst="rect">
             <a:avLst/>
@@ -12474,29 +12498,11 @@
           <a:p>
             <a:pPr algn="l">
               <a:spcAft>
-                <a:spcPts val="1000"/>
-              </a:spcAft>
-            </a:pPr>
-            <a:r>
-              <a:rPr sz="1600" b="1">
-                <a:solidFill>
-                  <a:srgbClr val="1A2333"/>
-                </a:solidFill>
-                <a:latin typeface="微软雅黑"/>
-                <a:ea typeface="微软雅黑"/>
-                <a:cs typeface="微软雅黑"/>
-              </a:rPr>
-              <a:t>价值不在最终模型</a:t>
-            </a:r>
-          </a:p>
-          <a:p>
-            <a:pPr algn="l">
-              <a:spcAft>
-                <a:spcPts val="1000"/>
-              </a:spcAft>
-            </a:pPr>
-            <a:r>
-              <a:rPr sz="1500" b="0">
+                <a:spcPts val="400"/>
+              </a:spcAft>
+            </a:pPr>
+            <a:r>
+              <a:rPr sz="1100" b="0">
                 <a:solidFill>
                   <a:srgbClr val="6B7A8D"/>
                 </a:solidFill>
@@ -12504,138 +12510,7 @@
                 <a:ea typeface="微软雅黑"/>
                 <a:cs typeface="微软雅黑"/>
               </a:rPr>
-              <a:t>(prior art),</a:t>
-            </a:r>
-          </a:p>
-          <a:p>
-            <a:pPr algn="l">
-              <a:spcAft>
-                <a:spcPts val="1000"/>
-              </a:spcAft>
-            </a:pPr>
-            <a:r>
-              <a:rPr sz="1600" b="1">
-                <a:solidFill>
-                  <a:srgbClr val="1A2333"/>
-                </a:solidFill>
-                <a:latin typeface="微软雅黑"/>
-                <a:ea typeface="微软雅黑"/>
-                <a:cs typeface="微软雅黑"/>
-              </a:rPr>
-              <a:t>在这套过程:</a:t>
-            </a:r>
-          </a:p>
-          <a:p>
-            <a:pPr algn="l">
-              <a:spcAft>
-                <a:spcPts val="1000"/>
-              </a:spcAft>
-            </a:pPr>
-            <a:r>
-              <a:rPr sz="1500" b="0">
-                <a:solidFill>
-                  <a:srgbClr val="1A2333"/>
-                </a:solidFill>
-                <a:latin typeface="微软雅黑"/>
-                <a:ea typeface="微软雅黑"/>
-                <a:cs typeface="微软雅黑"/>
-              </a:rPr>
-              <a:t>· 卡 4.24% → 查文献</a:t>
-            </a:r>
-          </a:p>
-          <a:p>
-            <a:pPr algn="l">
-              <a:spcAft>
-                <a:spcPts val="1000"/>
-              </a:spcAft>
-            </a:pPr>
-            <a:r>
-              <a:rPr sz="1500" b="0">
-                <a:solidFill>
-                  <a:srgbClr val="1A2333"/>
-                </a:solidFill>
-                <a:latin typeface="微软雅黑"/>
-                <a:ea typeface="微软雅黑"/>
-                <a:cs typeface="微软雅黑"/>
-              </a:rPr>
-              <a:t>· wind 试→REVERT 记库</a:t>
-            </a:r>
-          </a:p>
-          <a:p>
-            <a:pPr algn="l">
-              <a:spcAft>
-                <a:spcPts val="1000"/>
-              </a:spcAft>
-            </a:pPr>
-            <a:r>
-              <a:rPr sz="1500" b="0">
-                <a:solidFill>
-                  <a:srgbClr val="1A2333"/>
-                </a:solidFill>
-                <a:latin typeface="微软雅黑"/>
-                <a:ea typeface="微软雅黑"/>
-                <a:cs typeface="微软雅黑"/>
-              </a:rPr>
-              <a:t>· 物理≈线性→诚实报</a:t>
-            </a:r>
-          </a:p>
-          <a:p>
-            <a:pPr algn="l">
-              <a:spcAft>
-                <a:spcPts val="1000"/>
-              </a:spcAft>
-            </a:pPr>
-            <a:r>
-              <a:rPr sz="1500" b="0">
-                <a:solidFill>
-                  <a:srgbClr val="1A2333"/>
-                </a:solidFill>
-                <a:latin typeface="微软雅黑"/>
-                <a:ea typeface="微软雅黑"/>
-                <a:cs typeface="微软雅黑"/>
-              </a:rPr>
-              <a:t>· loop≈随机→报边界</a:t>
-            </a:r>
-          </a:p>
-        </p:txBody>
-      </p:sp>
-      <p:sp>
-        <p:nvSpPr>
-          <p:cNvPr id="8" name="TextBox 7"/>
-          <p:cNvSpPr txBox="1"/>
-          <p:nvPr/>
-        </p:nvSpPr>
-        <p:spPr>
-          <a:xfrm>
-            <a:off x="502920" y="6400800"/>
-            <a:ext cx="11155680" cy="320040"/>
-          </a:xfrm>
-          <a:prstGeom prst="rect">
-            <a:avLst/>
-          </a:prstGeom>
-          <a:noFill/>
-        </p:spPr>
-        <p:txBody>
-          <a:bodyPr wrap="square" anchor="t" lIns="25400" rIns="25400" tIns="25400" bIns="25400">
-            <a:spAutoFit/>
-          </a:bodyPr>
-          <a:lstStyle/>
-          <a:p>
-            <a:pPr algn="l">
-              <a:spcAft>
-                <a:spcPts val="400"/>
-              </a:spcAft>
-            </a:pPr>
-            <a:r>
-              <a:rPr sz="1100" b="0">
-                <a:solidFill>
-                  <a:srgbClr val="6B7A8D"/>
-                </a:solidFill>
-                <a:latin typeface="微软雅黑"/>
-                <a:ea typeface="微软雅黑"/>
-                <a:cs typeface="微软雅黑"/>
-              </a:rPr>
-              <a:t>真实 agent_log.jsonl + KNOWLEDGE.md;下半为 loop 机制流程</a:t>
+              <a:t>左:真实迭代轨迹(卡4.24%→外搜→突破1.9%);右:loop 机制流程。数据 agent_log.jsonl + KNOWLEDGE.md</a:t>
             </a:r>
           </a:p>
         </p:txBody>

</xml_diff>

<commit_message>
Add complexity-regularity slide (guided-search advantage grows with search-space complexity: literature curve + our 2 real endpoints) + fix chip wrapping for 2-digit slide numbers
complexity_regularity_fig.py: 规律图(文献虚线曲线+3边界点+我们两真实端点:能耗域打平/规划器域胜27%),把'打平'讲成规律必然。加进翻页幻灯12b+PPT。修chip:两位数字加宽+缩字号,不再挤两行。翻页幻灯25页。

Co-Authored-By: Claude Opus 4.8 (1M context) <noreply@anthropic.com>
</commit_message>
<xml_diff>
--- a/autoresearch/energy_m100/experiments/midterm_defense.pptx
+++ b/autoresearch/energy_m100/experiments/midterm_defense.pptx
@@ -30,6 +30,7 @@
     <p:sldId id="278" r:id="rId29"/>
     <p:sldId id="279" r:id="rId30"/>
     <p:sldId id="280" r:id="rId31"/>
+    <p:sldId id="281" r:id="rId32"/>
   </p:sldIdLst>
   <p:sldSz cx="12191695" cy="6858000" type="screen4x3"/>
   <p:notesSz cx="6858000" cy="9144000"/>
@@ -3516,7 +3517,7 @@
           </a:fontRef>
         </p:style>
         <p:txBody>
-          <a:bodyPr rtlCol="0" anchor="ctr" tIns="0" bIns="0"/>
+          <a:bodyPr rtlCol="0" anchor="ctr" tIns="0" bIns="0" lIns="0" rIns="0" wrap="none"/>
           <a:lstStyle/>
           <a:p>
             <a:pPr algn="ctr"/>
@@ -3914,7 +3915,7 @@
         <p:spPr>
           <a:xfrm>
             <a:off x="502920" y="365760"/>
-            <a:ext cx="457200" cy="457200"/>
+            <a:ext cx="566928" cy="457200"/>
           </a:xfrm>
           <a:prstGeom prst="roundRect">
             <a:avLst/>
@@ -3941,12 +3942,12 @@
           </a:fontRef>
         </p:style>
         <p:txBody>
-          <a:bodyPr rtlCol="0" anchor="ctr" tIns="0" bIns="0"/>
+          <a:bodyPr rtlCol="0" anchor="ctr" tIns="0" bIns="0" lIns="0" rIns="0" wrap="none"/>
           <a:lstStyle/>
           <a:p>
             <a:pPr algn="ctr"/>
             <a:r>
-              <a:rPr sz="2000" b="1">
+              <a:rPr sz="1600" b="1">
                 <a:solidFill>
                   <a:srgbClr val="FFFFFF"/>
                 </a:solidFill>
@@ -4339,7 +4340,7 @@
         <p:spPr>
           <a:xfrm>
             <a:off x="502920" y="365760"/>
-            <a:ext cx="457200" cy="457200"/>
+            <a:ext cx="566928" cy="457200"/>
           </a:xfrm>
           <a:prstGeom prst="roundRect">
             <a:avLst/>
@@ -4366,12 +4367,12 @@
           </a:fontRef>
         </p:style>
         <p:txBody>
-          <a:bodyPr rtlCol="0" anchor="ctr" tIns="0" bIns="0"/>
+          <a:bodyPr rtlCol="0" anchor="ctr" tIns="0" bIns="0" lIns="0" rIns="0" wrap="none"/>
           <a:lstStyle/>
           <a:p>
             <a:pPr algn="ctr"/>
             <a:r>
-              <a:rPr sz="2000" b="1">
+              <a:rPr sz="1600" b="1">
                 <a:solidFill>
                   <a:srgbClr val="FFFFFF"/>
                 </a:solidFill>
@@ -5220,7 +5221,7 @@
         <p:spPr>
           <a:xfrm>
             <a:off x="502920" y="365760"/>
-            <a:ext cx="457200" cy="457200"/>
+            <a:ext cx="566928" cy="457200"/>
           </a:xfrm>
           <a:prstGeom prst="roundRect">
             <a:avLst/>
@@ -5247,12 +5248,12 @@
           </a:fontRef>
         </p:style>
         <p:txBody>
-          <a:bodyPr rtlCol="0" anchor="ctr" tIns="0" bIns="0"/>
+          <a:bodyPr rtlCol="0" anchor="ctr" tIns="0" bIns="0" lIns="0" rIns="0" wrap="none"/>
           <a:lstStyle/>
           <a:p>
             <a:pPr algn="ctr"/>
             <a:r>
-              <a:rPr sz="2000" b="1">
+              <a:rPr sz="1600" b="1">
                 <a:solidFill>
                   <a:srgbClr val="FFFFFF"/>
                 </a:solidFill>
@@ -5675,7 +5676,7 @@
         <p:spPr>
           <a:xfrm>
             <a:off x="502920" y="365760"/>
-            <a:ext cx="457200" cy="457200"/>
+            <a:ext cx="566928" cy="457200"/>
           </a:xfrm>
           <a:prstGeom prst="roundRect">
             <a:avLst/>
@@ -5702,12 +5703,12 @@
           </a:fontRef>
         </p:style>
         <p:txBody>
-          <a:bodyPr rtlCol="0" anchor="ctr" tIns="0" bIns="0"/>
+          <a:bodyPr rtlCol="0" anchor="ctr" tIns="0" bIns="0" lIns="0" rIns="0" wrap="none"/>
           <a:lstStyle/>
           <a:p>
             <a:pPr algn="ctr"/>
             <a:r>
-              <a:rPr sz="2000" b="1">
+              <a:rPr sz="1600" b="1">
                 <a:solidFill>
                   <a:srgbClr val="FFFFFF"/>
                 </a:solidFill>
@@ -6058,7 +6059,7 @@
         <p:spPr>
           <a:xfrm>
             <a:off x="502920" y="365760"/>
-            <a:ext cx="457200" cy="457200"/>
+            <a:ext cx="566928" cy="457200"/>
           </a:xfrm>
           <a:prstGeom prst="roundRect">
             <a:avLst/>
@@ -6085,12 +6086,12 @@
           </a:fontRef>
         </p:style>
         <p:txBody>
-          <a:bodyPr rtlCol="0" anchor="ctr" tIns="0" bIns="0"/>
+          <a:bodyPr rtlCol="0" anchor="ctr" tIns="0" bIns="0" lIns="0" rIns="0" wrap="none"/>
           <a:lstStyle/>
           <a:p>
             <a:pPr algn="ctr"/>
             <a:r>
-              <a:rPr sz="2000" b="1">
+              <a:rPr sz="1600" b="1">
                 <a:solidFill>
                   <a:srgbClr val="FFFFFF"/>
                 </a:solidFill>
@@ -6477,7 +6478,7 @@
         <p:spPr>
           <a:xfrm>
             <a:off x="502920" y="365760"/>
-            <a:ext cx="457200" cy="457200"/>
+            <a:ext cx="566928" cy="457200"/>
           </a:xfrm>
           <a:prstGeom prst="roundRect">
             <a:avLst/>
@@ -6504,12 +6505,12 @@
           </a:fontRef>
         </p:style>
         <p:txBody>
-          <a:bodyPr rtlCol="0" anchor="ctr" tIns="0" bIns="0"/>
+          <a:bodyPr rtlCol="0" anchor="ctr" tIns="0" bIns="0" lIns="0" rIns="0" wrap="none"/>
           <a:lstStyle/>
           <a:p>
             <a:pPr algn="ctr"/>
             <a:r>
-              <a:rPr sz="2000" b="1">
+              <a:rPr sz="1600" b="1">
                 <a:solidFill>
                   <a:srgbClr val="FFFFFF"/>
                 </a:solidFill>
@@ -6558,14 +6559,14 @@
                 <a:ea typeface="微软雅黑"/>
                 <a:cs typeface="微软雅黑"/>
               </a:rPr>
-              <a:t>用 vs 不用:朴素 AI4S 声称 4 项假发现且藏负结果,我们相反</a:t>
+              <a:t>为什么打平?引导搜索的优势随搜索空间复杂度增长(文献规律)</a:t>
             </a:r>
           </a:p>
         </p:txBody>
       </p:sp>
       <p:pic>
         <p:nvPicPr>
-          <p:cNvPr id="6" name="Picture 5" descr="naive_vs_trustworthy.png"/>
+          <p:cNvPr id="6" name="Picture 5" descr="复杂度规律.png"/>
           <p:cNvPicPr>
             <a:picLocks noChangeAspect="1"/>
           </p:cNvPicPr>
@@ -6579,8 +6580,8 @@
         </p:blipFill>
         <p:spPr>
           <a:xfrm>
-            <a:off x="548640" y="2326234"/>
-            <a:ext cx="8412480" cy="3028492"/>
+            <a:off x="457200" y="2095384"/>
+            <a:ext cx="6766560" cy="3673072"/>
           </a:xfrm>
           <a:prstGeom prst="rect">
             <a:avLst/>
@@ -6595,8 +6596,8 @@
         </p:nvSpPr>
         <p:spPr>
           <a:xfrm>
-            <a:off x="9144000" y="2011680"/>
-            <a:ext cx="2651760" cy="4023360"/>
+            <a:off x="7406640" y="1920240"/>
+            <a:ext cx="4480560" cy="4389120"/>
           </a:xfrm>
           <a:prstGeom prst="rect">
             <a:avLst/>
@@ -6611,47 +6612,101 @@
           <a:p>
             <a:pPr algn="l">
               <a:spcAft>
-                <a:spcPts val="1200"/>
+                <a:spcPts val="900"/>
               </a:spcAft>
             </a:pPr>
             <a:r>
               <a:rPr sz="1600" b="1">
                 <a:solidFill>
+                  <a:srgbClr val="1A2333"/>
+                </a:solidFill>
+                <a:latin typeface="微软雅黑"/>
+                <a:ea typeface="微软雅黑"/>
+                <a:cs typeface="微软雅黑"/>
+              </a:rPr>
+              <a:t>不是框架无能,是规律预测:</a:t>
+            </a:r>
+          </a:p>
+          <a:p>
+            <a:pPr algn="l">
+              <a:spcAft>
+                <a:spcPts val="900"/>
+              </a:spcAft>
+            </a:pPr>
+            <a:r>
+              <a:rPr sz="1400" b="0">
+                <a:solidFill>
+                  <a:srgbClr val="1A2333"/>
+                </a:solidFill>
+                <a:latin typeface="微软雅黑"/>
+                <a:ea typeface="微软雅黑"/>
+                <a:cs typeface="微软雅黑"/>
+              </a:rPr>
+              <a:t>· Bergstra'12:低有效维→随机追平</a:t>
+            </a:r>
+          </a:p>
+          <a:p>
+            <a:pPr algn="l">
+              <a:spcAft>
+                <a:spcPts val="900"/>
+              </a:spcAft>
+            </a:pPr>
+            <a:r>
+              <a:rPr sz="1400" b="0">
+                <a:solidFill>
+                  <a:srgbClr val="1A2333"/>
+                </a:solidFill>
+                <a:latin typeface="微软雅黑"/>
+                <a:ea typeface="微软雅黑"/>
+                <a:cs typeface="微软雅黑"/>
+              </a:rPr>
+              <a:t>· REMBO:~15–20 维临界点</a:t>
+            </a:r>
+          </a:p>
+          <a:p>
+            <a:pPr algn="l">
+              <a:spcAft>
+                <a:spcPts val="900"/>
+              </a:spcAft>
+            </a:pPr>
+            <a:r>
+              <a:rPr sz="1400" b="0">
+                <a:solidFill>
+                  <a:srgbClr val="1A2333"/>
+                </a:solidFill>
+                <a:latin typeface="微软雅黑"/>
+                <a:ea typeface="微软雅黑"/>
+                <a:cs typeface="微软雅黑"/>
+              </a:rPr>
+              <a:t>· FunSearch:巨大程序空间→引导才行</a:t>
+            </a:r>
+          </a:p>
+          <a:p>
+            <a:pPr algn="l">
+              <a:spcAft>
+                <a:spcPts val="900"/>
+              </a:spcAft>
+            </a:pPr>
+            <a:r>
+              <a:rPr sz="1500" b="1">
+                <a:solidFill>
                   <a:srgbClr val="C0502D"/>
                 </a:solidFill>
                 <a:latin typeface="微软雅黑"/>
                 <a:ea typeface="微软雅黑"/>
                 <a:cs typeface="微软雅黑"/>
               </a:rPr>
-              <a:t>朴素:</a:t>
-            </a:r>
-          </a:p>
-          <a:p>
-            <a:pPr algn="l">
-              <a:spcAft>
-                <a:spcPts val="1200"/>
-              </a:spcAft>
-            </a:pPr>
-            <a:r>
-              <a:rPr sz="1500" b="0">
-                <a:solidFill>
-                  <a:srgbClr val="1A2333"/>
-                </a:solidFill>
-                <a:latin typeface="微软雅黑"/>
-                <a:ea typeface="微软雅黑"/>
-                <a:cs typeface="微软雅黑"/>
-              </a:rPr>
-              <a:t>4 假发现 + 0 负结果</a:t>
-            </a:r>
-          </a:p>
-          <a:p>
-            <a:pPr algn="l">
-              <a:spcAft>
-                <a:spcPts val="1200"/>
-              </a:spcAft>
-            </a:pPr>
-            <a:r>
-              <a:rPr sz="1600" b="1">
+              <a:t>· 我们能耗域(小)→打平</a:t>
+            </a:r>
+          </a:p>
+          <a:p>
+            <a:pPr algn="l">
+              <a:spcAft>
+                <a:spcPts val="900"/>
+              </a:spcAft>
+            </a:pPr>
+            <a:r>
+              <a:rPr sz="1500" b="1">
                 <a:solidFill>
                   <a:srgbClr val="5B9BD5"/>
                 </a:solidFill>
@@ -6659,61 +6714,25 @@
                 <a:ea typeface="微软雅黑"/>
                 <a:cs typeface="微软雅黑"/>
               </a:rPr>
-              <a:t>我们:</a:t>
-            </a:r>
-          </a:p>
-          <a:p>
-            <a:pPr algn="l">
-              <a:spcAft>
-                <a:spcPts val="1200"/>
-              </a:spcAft>
-            </a:pPr>
-            <a:r>
-              <a:rPr sz="1500" b="0">
-                <a:solidFill>
-                  <a:srgbClr val="1A2333"/>
-                </a:solidFill>
-                <a:latin typeface="微软雅黑"/>
-                <a:ea typeface="微软雅黑"/>
-                <a:cs typeface="微软雅黑"/>
-              </a:rPr>
-              <a:t>0 真新 + 4 负结果</a:t>
-            </a:r>
-          </a:p>
-          <a:p>
-            <a:pPr algn="l">
-              <a:spcAft>
-                <a:spcPts val="1200"/>
-              </a:spcAft>
-            </a:pPr>
-            <a:r>
-              <a:rPr sz="1500" b="0">
-                <a:solidFill>
-                  <a:srgbClr val="1A2333"/>
-                </a:solidFill>
-                <a:latin typeface="微软雅黑"/>
-                <a:ea typeface="微软雅黑"/>
-                <a:cs typeface="微软雅黑"/>
-              </a:rPr>
-              <a:t>一个自信但错,</a:t>
-            </a:r>
-          </a:p>
-          <a:p>
-            <a:pPr algn="l">
-              <a:spcAft>
-                <a:spcPts val="1200"/>
+              <a:t>· 我们规划器域(大)→胜 27%</a:t>
+            </a:r>
+          </a:p>
+          <a:p>
+            <a:pPr algn="l">
+              <a:spcAft>
+                <a:spcPts val="900"/>
               </a:spcAft>
             </a:pPr>
             <a:r>
               <a:rPr sz="1500" b="1">
                 <a:solidFill>
-                  <a:srgbClr val="1A2333"/>
-                </a:solidFill>
-                <a:latin typeface="微软雅黑"/>
-                <a:ea typeface="微软雅黑"/>
-                <a:cs typeface="微软雅黑"/>
-              </a:rPr>
-              <a:t>一个 humbler 但对。</a:t>
+                  <a:srgbClr val="0563C1"/>
+                </a:solidFill>
+                <a:latin typeface="微软雅黑"/>
+                <a:ea typeface="微软雅黑"/>
+                <a:cs typeface="微软雅黑"/>
+              </a:rPr>
+              <a:t>→ 同框架横跨两端点,亲手印证规律</a:t>
             </a:r>
           </a:p>
         </p:txBody>
@@ -6754,7 +6773,7 @@
                 <a:ea typeface="微软雅黑"/>
                 <a:cs typeface="微软雅黑"/>
               </a:rPr>
-              <a:t>naive_vs_trustworthy.py(同数据同候选,端到端产出对照)</a:t>
+              <a:t>规律=文献综合;两端点=我们实测。CMU《Hidden Pitfalls》2509.08713 反证可信性为刚需</a:t>
             </a:r>
           </a:p>
         </p:txBody>
@@ -6878,7 +6897,7 @@
         <p:spPr>
           <a:xfrm>
             <a:off x="502920" y="365760"/>
-            <a:ext cx="457200" cy="457200"/>
+            <a:ext cx="566928" cy="457200"/>
           </a:xfrm>
           <a:prstGeom prst="roundRect">
             <a:avLst/>
@@ -6905,12 +6924,12 @@
           </a:fontRef>
         </p:style>
         <p:txBody>
-          <a:bodyPr rtlCol="0" anchor="ctr" tIns="0" bIns="0"/>
+          <a:bodyPr rtlCol="0" anchor="ctr" tIns="0" bIns="0" lIns="0" rIns="0" wrap="none"/>
           <a:lstStyle/>
           <a:p>
             <a:pPr algn="ctr"/>
             <a:r>
-              <a:rPr sz="2000" b="1">
+              <a:rPr sz="1600" b="1">
                 <a:solidFill>
                   <a:srgbClr val="FFFFFF"/>
                 </a:solidFill>
@@ -6959,14 +6978,14 @@
                 <a:ea typeface="微软雅黑"/>
                 <a:cs typeface="微软雅黑"/>
               </a:rPr>
-              <a:t>诚实边界:多数场景无收益,载荷无效,贡献是方法学而非发现</a:t>
+              <a:t>用 vs 不用:朴素 AI4S 声称 4 项假发现且藏负结果,我们相反</a:t>
             </a:r>
           </a:p>
         </p:txBody>
       </p:sp>
       <p:pic>
         <p:nvPicPr>
-          <p:cNvPr id="6" name="Picture 5" descr="省能分布_n250.png"/>
+          <p:cNvPr id="6" name="Picture 5" descr="naive_vs_trustworthy.png"/>
           <p:cNvPicPr>
             <a:picLocks noChangeAspect="1"/>
           </p:cNvPicPr>
@@ -6980,8 +6999,8 @@
         </p:blipFill>
         <p:spPr>
           <a:xfrm>
-            <a:off x="562672" y="1828800"/>
-            <a:ext cx="6829936" cy="4114800"/>
+            <a:off x="548640" y="2326234"/>
+            <a:ext cx="8412480" cy="3028492"/>
           </a:xfrm>
           <a:prstGeom prst="rect">
             <a:avLst/>
@@ -6996,8 +7015,8 @@
         </p:nvSpPr>
         <p:spPr>
           <a:xfrm>
-            <a:off x="7680960" y="1920240"/>
-            <a:ext cx="4114800" cy="4206240"/>
+            <a:off x="9144000" y="2011680"/>
+            <a:ext cx="2651760" cy="4023360"/>
           </a:xfrm>
           <a:prstGeom prst="rect">
             <a:avLst/>
@@ -7012,11 +7031,29 @@
           <a:p>
             <a:pPr algn="l">
               <a:spcAft>
-                <a:spcPts val="1100"/>
-              </a:spcAft>
-            </a:pPr>
-            <a:r>
-              <a:rPr sz="1600" b="0">
+                <a:spcPts val="1200"/>
+              </a:spcAft>
+            </a:pPr>
+            <a:r>
+              <a:rPr sz="1600" b="1">
+                <a:solidFill>
+                  <a:srgbClr val="C0502D"/>
+                </a:solidFill>
+                <a:latin typeface="微软雅黑"/>
+                <a:ea typeface="微软雅黑"/>
+                <a:cs typeface="微软雅黑"/>
+              </a:rPr>
+              <a:t>朴素:</a:t>
+            </a:r>
+          </a:p>
+          <a:p>
+            <a:pPr algn="l">
+              <a:spcAft>
+                <a:spcPts val="1200"/>
+              </a:spcAft>
+            </a:pPr>
+            <a:r>
+              <a:rPr sz="1500" b="0">
                 <a:solidFill>
                   <a:srgbClr val="1A2333"/>
                 </a:solidFill>
@@ -7024,17 +7061,35 @@
                 <a:ea typeface="微软雅黑"/>
                 <a:cs typeface="微软雅黑"/>
               </a:rPr>
-              <a:t>· n=250 场景:中位省能 0%</a:t>
-            </a:r>
-          </a:p>
-          <a:p>
-            <a:pPr algn="l">
-              <a:spcAft>
-                <a:spcPts val="1100"/>
-              </a:spcAft>
-            </a:pPr>
-            <a:r>
-              <a:rPr sz="1600" b="0">
+              <a:t>4 假发现 + 0 负结果</a:t>
+            </a:r>
+          </a:p>
+          <a:p>
+            <a:pPr algn="l">
+              <a:spcAft>
+                <a:spcPts val="1200"/>
+              </a:spcAft>
+            </a:pPr>
+            <a:r>
+              <a:rPr sz="1600" b="1">
+                <a:solidFill>
+                  <a:srgbClr val="5B9BD5"/>
+                </a:solidFill>
+                <a:latin typeface="微软雅黑"/>
+                <a:ea typeface="微软雅黑"/>
+                <a:cs typeface="微软雅黑"/>
+              </a:rPr>
+              <a:t>我们:</a:t>
+            </a:r>
+          </a:p>
+          <a:p>
+            <a:pPr algn="l">
+              <a:spcAft>
+                <a:spcPts val="1200"/>
+              </a:spcAft>
+            </a:pPr>
+            <a:r>
+              <a:rPr sz="1500" b="0">
                 <a:solidFill>
                   <a:srgbClr val="1A2333"/>
                 </a:solidFill>
@@ -7042,17 +7097,17 @@
                 <a:ea typeface="微软雅黑"/>
                 <a:cs typeface="微软雅黑"/>
               </a:rPr>
-              <a:t>· 77% 场景零收益(有低空走廊)</a:t>
-            </a:r>
-          </a:p>
-          <a:p>
-            <a:pPr algn="l">
-              <a:spcAft>
-                <a:spcPts val="1100"/>
-              </a:spcAft>
-            </a:pPr>
-            <a:r>
-              <a:rPr sz="1600" b="0">
+              <a:t>0 真新 + 4 负结果</a:t>
+            </a:r>
+          </a:p>
+          <a:p>
+            <a:pPr algn="l">
+              <a:spcAft>
+                <a:spcPts val="1200"/>
+              </a:spcAft>
+            </a:pPr>
+            <a:r>
+              <a:rPr sz="1500" b="0">
                 <a:solidFill>
                   <a:srgbClr val="1A2333"/>
                 </a:solidFill>
@@ -7060,17 +7115,17 @@
                 <a:ea typeface="微软雅黑"/>
                 <a:cs typeface="微软雅黑"/>
               </a:rPr>
-              <a:t>· 仅 20% ≥3%,CI[15.5,25.4]%</a:t>
-            </a:r>
-          </a:p>
-          <a:p>
-            <a:pPr algn="l">
-              <a:spcAft>
-                <a:spcPts val="1100"/>
-              </a:spcAft>
-            </a:pPr>
-            <a:r>
-              <a:rPr sz="1600" b="0">
+              <a:t>一个自信但错,</a:t>
+            </a:r>
+          </a:p>
+          <a:p>
+            <a:pPr algn="l">
+              <a:spcAft>
+                <a:spcPts val="1200"/>
+              </a:spcAft>
+            </a:pPr>
+            <a:r>
+              <a:rPr sz="1500" b="1">
                 <a:solidFill>
                   <a:srgbClr val="1A2333"/>
                 </a:solidFill>
@@ -7078,43 +7133,7 @@
                 <a:ea typeface="微软雅黑"/>
                 <a:cs typeface="微软雅黑"/>
               </a:rPr>
-              <a:t>· 载荷 ≤500g:全扫不改变路径</a:t>
-            </a:r>
-          </a:p>
-          <a:p>
-            <a:pPr algn="l">
-              <a:spcAft>
-                <a:spcPts val="1100"/>
-              </a:spcAft>
-            </a:pPr>
-            <a:r>
-              <a:rPr sz="1600" b="0">
-                <a:solidFill>
-                  <a:srgbClr val="1A2333"/>
-                </a:solidFill>
-                <a:latin typeface="微软雅黑"/>
-                <a:ea typeface="微软雅黑"/>
-                <a:cs typeface="微软雅黑"/>
-              </a:rPr>
-              <a:t>· 无真机飞行(止于仿真)</a:t>
-            </a:r>
-          </a:p>
-          <a:p>
-            <a:pPr algn="l">
-              <a:spcAft>
-                <a:spcPts val="1100"/>
-              </a:spcAft>
-            </a:pPr>
-            <a:r>
-              <a:rPr sz="1600" b="1">
-                <a:solidFill>
-                  <a:srgbClr val="0563C1"/>
-                </a:solidFill>
-                <a:latin typeface="微软雅黑"/>
-                <a:ea typeface="微软雅黑"/>
-                <a:cs typeface="微软雅黑"/>
-              </a:rPr>
-              <a:t>→ 不挑场景、不硬凑,诚实统计</a:t>
+              <a:t>一个 humbler 但对。</a:t>
             </a:r>
           </a:p>
         </p:txBody>
@@ -7155,7 +7174,7 @@
                 <a:ea typeface="微软雅黑"/>
                 <a:cs typeface="微软雅黑"/>
               </a:rPr>
-              <a:t>large_scale_savings.py;可信 null 是被接受的贡献(ICML 2024)</a:t>
+              <a:t>naive_vs_trustworthy.py(同数据同候选,端到端产出对照)</a:t>
             </a:r>
           </a:p>
         </p:txBody>
@@ -7169,6 +7188,407 @@
 </file>
 
 <file path=ppt/slides/slide18.xml><?xml version="1.0" encoding="utf-8"?>
+<p:sld xmlns:a="http://schemas.openxmlformats.org/drawingml/2006/main" xmlns:p="http://schemas.openxmlformats.org/presentationml/2006/main" xmlns:r="http://schemas.openxmlformats.org/officeDocument/2006/relationships">
+  <p:cSld>
+    <p:bg>
+      <p:bgPr>
+        <a:solidFill>
+          <a:srgbClr val="FFFFFF"/>
+        </a:solidFill>
+        <a:effectLst/>
+      </p:bgPr>
+    </p:bg>
+    <p:spTree>
+      <p:nvGrpSpPr>
+        <p:cNvPr id="1" name=""/>
+        <p:cNvGrpSpPr/>
+        <p:nvPr/>
+      </p:nvGrpSpPr>
+      <p:grpSpPr/>
+      <p:sp>
+        <p:nvSpPr>
+          <p:cNvPr id="2" name="Rectangle 1"/>
+          <p:cNvSpPr/>
+          <p:nvPr/>
+        </p:nvSpPr>
+        <p:spPr>
+          <a:xfrm>
+            <a:off x="0" y="0"/>
+            <a:ext cx="109728" cy="6858000"/>
+          </a:xfrm>
+          <a:prstGeom prst="rect">
+            <a:avLst/>
+          </a:prstGeom>
+          <a:solidFill>
+            <a:srgbClr val="4472C4"/>
+          </a:solidFill>
+          <a:ln>
+            <a:noFill/>
+          </a:ln>
+        </p:spPr>
+        <p:style>
+          <a:lnRef idx="1">
+            <a:schemeClr val="accent1"/>
+          </a:lnRef>
+          <a:fillRef idx="3">
+            <a:schemeClr val="accent1"/>
+          </a:fillRef>
+          <a:effectRef idx="2">
+            <a:schemeClr val="accent1"/>
+          </a:effectRef>
+          <a:fontRef idx="minor">
+            <a:schemeClr val="lt1"/>
+          </a:fontRef>
+        </p:style>
+        <p:txBody>
+          <a:bodyPr rtlCol="0" anchor="ctr"/>
+          <a:lstStyle/>
+          <a:p>
+            <a:pPr algn="ctr"/>
+          </a:p>
+        </p:txBody>
+      </p:sp>
+      <p:sp>
+        <p:nvSpPr>
+          <p:cNvPr id="3" name="TextBox 2"/>
+          <p:cNvSpPr txBox="1"/>
+          <p:nvPr/>
+        </p:nvSpPr>
+        <p:spPr>
+          <a:xfrm>
+            <a:off x="9052560" y="292608"/>
+            <a:ext cx="2834640" cy="365760"/>
+          </a:xfrm>
+          <a:prstGeom prst="rect">
+            <a:avLst/>
+          </a:prstGeom>
+          <a:noFill/>
+        </p:spPr>
+        <p:txBody>
+          <a:bodyPr wrap="square" anchor="t" lIns="25400" rIns="25400" tIns="25400" bIns="25400">
+            <a:spAutoFit/>
+          </a:bodyPr>
+          <a:lstStyle/>
+          <a:p>
+            <a:pPr algn="r">
+              <a:spcAft>
+                <a:spcPts val="400"/>
+              </a:spcAft>
+            </a:pPr>
+            <a:r>
+              <a:rPr sz="1200" b="0">
+                <a:solidFill>
+                  <a:srgbClr val="9AA8B8"/>
+                </a:solidFill>
+                <a:latin typeface="微软雅黑"/>
+                <a:ea typeface="微软雅黑"/>
+                <a:cs typeface="微软雅黑"/>
+              </a:rPr>
+              <a:t>西安交通大学</a:t>
+            </a:r>
+          </a:p>
+        </p:txBody>
+      </p:sp>
+      <p:sp>
+        <p:nvSpPr>
+          <p:cNvPr id="4" name="Rounded Rectangle 3"/>
+          <p:cNvSpPr/>
+          <p:nvPr/>
+        </p:nvSpPr>
+        <p:spPr>
+          <a:xfrm>
+            <a:off x="502920" y="365760"/>
+            <a:ext cx="566928" cy="457200"/>
+          </a:xfrm>
+          <a:prstGeom prst="roundRect">
+            <a:avLst/>
+          </a:prstGeom>
+          <a:solidFill>
+            <a:srgbClr val="4472C4"/>
+          </a:solidFill>
+          <a:ln>
+            <a:noFill/>
+          </a:ln>
+        </p:spPr>
+        <p:style>
+          <a:lnRef idx="1">
+            <a:schemeClr val="accent1"/>
+          </a:lnRef>
+          <a:fillRef idx="3">
+            <a:schemeClr val="accent1"/>
+          </a:fillRef>
+          <a:effectRef idx="2">
+            <a:schemeClr val="accent1"/>
+          </a:effectRef>
+          <a:fontRef idx="minor">
+            <a:schemeClr val="lt1"/>
+          </a:fontRef>
+        </p:style>
+        <p:txBody>
+          <a:bodyPr rtlCol="0" anchor="ctr" tIns="0" bIns="0" lIns="0" rIns="0" wrap="none"/>
+          <a:lstStyle/>
+          <a:p>
+            <a:pPr algn="ctr"/>
+            <a:r>
+              <a:rPr sz="1600" b="1">
+                <a:solidFill>
+                  <a:srgbClr val="FFFFFF"/>
+                </a:solidFill>
+                <a:latin typeface="微软雅黑"/>
+                <a:ea typeface="微软雅黑"/>
+                <a:cs typeface="微软雅黑"/>
+              </a:rPr>
+              <a:t>17</a:t>
+            </a:r>
+          </a:p>
+        </p:txBody>
+      </p:sp>
+      <p:sp>
+        <p:nvSpPr>
+          <p:cNvPr id="5" name="TextBox 4"/>
+          <p:cNvSpPr txBox="1"/>
+          <p:nvPr/>
+        </p:nvSpPr>
+        <p:spPr>
+          <a:xfrm>
+            <a:off x="1143000" y="347472"/>
+            <a:ext cx="10607040" cy="914400"/>
+          </a:xfrm>
+          <a:prstGeom prst="rect">
+            <a:avLst/>
+          </a:prstGeom>
+          <a:noFill/>
+        </p:spPr>
+        <p:txBody>
+          <a:bodyPr wrap="square" anchor="t" lIns="25400" rIns="25400" tIns="25400" bIns="25400">
+            <a:spAutoFit/>
+          </a:bodyPr>
+          <a:lstStyle/>
+          <a:p>
+            <a:pPr algn="l">
+              <a:spcAft>
+                <a:spcPts val="400"/>
+              </a:spcAft>
+            </a:pPr>
+            <a:r>
+              <a:rPr sz="2600" b="1">
+                <a:solidFill>
+                  <a:srgbClr val="0563C1"/>
+                </a:solidFill>
+                <a:latin typeface="微软雅黑"/>
+                <a:ea typeface="微软雅黑"/>
+                <a:cs typeface="微软雅黑"/>
+              </a:rPr>
+              <a:t>诚实边界:多数场景无收益,载荷无效,贡献是方法学而非发现</a:t>
+            </a:r>
+          </a:p>
+        </p:txBody>
+      </p:sp>
+      <p:pic>
+        <p:nvPicPr>
+          <p:cNvPr id="6" name="Picture 5" descr="省能分布_n250.png"/>
+          <p:cNvPicPr>
+            <a:picLocks noChangeAspect="1"/>
+          </p:cNvPicPr>
+          <p:nvPr/>
+        </p:nvPicPr>
+        <p:blipFill>
+          <a:blip r:embed="rId2"/>
+          <a:stretch>
+            <a:fillRect/>
+          </a:stretch>
+        </p:blipFill>
+        <p:spPr>
+          <a:xfrm>
+            <a:off x="562672" y="1828800"/>
+            <a:ext cx="6829936" cy="4114800"/>
+          </a:xfrm>
+          <a:prstGeom prst="rect">
+            <a:avLst/>
+          </a:prstGeom>
+        </p:spPr>
+      </p:pic>
+      <p:sp>
+        <p:nvSpPr>
+          <p:cNvPr id="7" name="TextBox 6"/>
+          <p:cNvSpPr txBox="1"/>
+          <p:nvPr/>
+        </p:nvSpPr>
+        <p:spPr>
+          <a:xfrm>
+            <a:off x="7680960" y="1920240"/>
+            <a:ext cx="4114800" cy="4206240"/>
+          </a:xfrm>
+          <a:prstGeom prst="rect">
+            <a:avLst/>
+          </a:prstGeom>
+          <a:noFill/>
+        </p:spPr>
+        <p:txBody>
+          <a:bodyPr wrap="square" anchor="t" lIns="25400" rIns="25400" tIns="25400" bIns="25400">
+            <a:spAutoFit/>
+          </a:bodyPr>
+          <a:lstStyle/>
+          <a:p>
+            <a:pPr algn="l">
+              <a:spcAft>
+                <a:spcPts val="1100"/>
+              </a:spcAft>
+            </a:pPr>
+            <a:r>
+              <a:rPr sz="1600" b="0">
+                <a:solidFill>
+                  <a:srgbClr val="1A2333"/>
+                </a:solidFill>
+                <a:latin typeface="微软雅黑"/>
+                <a:ea typeface="微软雅黑"/>
+                <a:cs typeface="微软雅黑"/>
+              </a:rPr>
+              <a:t>· n=250 场景:中位省能 0%</a:t>
+            </a:r>
+          </a:p>
+          <a:p>
+            <a:pPr algn="l">
+              <a:spcAft>
+                <a:spcPts val="1100"/>
+              </a:spcAft>
+            </a:pPr>
+            <a:r>
+              <a:rPr sz="1600" b="0">
+                <a:solidFill>
+                  <a:srgbClr val="1A2333"/>
+                </a:solidFill>
+                <a:latin typeface="微软雅黑"/>
+                <a:ea typeface="微软雅黑"/>
+                <a:cs typeface="微软雅黑"/>
+              </a:rPr>
+              <a:t>· 77% 场景零收益(有低空走廊)</a:t>
+            </a:r>
+          </a:p>
+          <a:p>
+            <a:pPr algn="l">
+              <a:spcAft>
+                <a:spcPts val="1100"/>
+              </a:spcAft>
+            </a:pPr>
+            <a:r>
+              <a:rPr sz="1600" b="0">
+                <a:solidFill>
+                  <a:srgbClr val="1A2333"/>
+                </a:solidFill>
+                <a:latin typeface="微软雅黑"/>
+                <a:ea typeface="微软雅黑"/>
+                <a:cs typeface="微软雅黑"/>
+              </a:rPr>
+              <a:t>· 仅 20% ≥3%,CI[15.5,25.4]%</a:t>
+            </a:r>
+          </a:p>
+          <a:p>
+            <a:pPr algn="l">
+              <a:spcAft>
+                <a:spcPts val="1100"/>
+              </a:spcAft>
+            </a:pPr>
+            <a:r>
+              <a:rPr sz="1600" b="0">
+                <a:solidFill>
+                  <a:srgbClr val="1A2333"/>
+                </a:solidFill>
+                <a:latin typeface="微软雅黑"/>
+                <a:ea typeface="微软雅黑"/>
+                <a:cs typeface="微软雅黑"/>
+              </a:rPr>
+              <a:t>· 载荷 ≤500g:全扫不改变路径</a:t>
+            </a:r>
+          </a:p>
+          <a:p>
+            <a:pPr algn="l">
+              <a:spcAft>
+                <a:spcPts val="1100"/>
+              </a:spcAft>
+            </a:pPr>
+            <a:r>
+              <a:rPr sz="1600" b="0">
+                <a:solidFill>
+                  <a:srgbClr val="1A2333"/>
+                </a:solidFill>
+                <a:latin typeface="微软雅黑"/>
+                <a:ea typeface="微软雅黑"/>
+                <a:cs typeface="微软雅黑"/>
+              </a:rPr>
+              <a:t>· 无真机飞行(止于仿真)</a:t>
+            </a:r>
+          </a:p>
+          <a:p>
+            <a:pPr algn="l">
+              <a:spcAft>
+                <a:spcPts val="1100"/>
+              </a:spcAft>
+            </a:pPr>
+            <a:r>
+              <a:rPr sz="1600" b="1">
+                <a:solidFill>
+                  <a:srgbClr val="0563C1"/>
+                </a:solidFill>
+                <a:latin typeface="微软雅黑"/>
+                <a:ea typeface="微软雅黑"/>
+                <a:cs typeface="微软雅黑"/>
+              </a:rPr>
+              <a:t>→ 不挑场景、不硬凑,诚实统计</a:t>
+            </a:r>
+          </a:p>
+        </p:txBody>
+      </p:sp>
+      <p:sp>
+        <p:nvSpPr>
+          <p:cNvPr id="8" name="TextBox 7"/>
+          <p:cNvSpPr txBox="1"/>
+          <p:nvPr/>
+        </p:nvSpPr>
+        <p:spPr>
+          <a:xfrm>
+            <a:off x="502920" y="6400800"/>
+            <a:ext cx="11155680" cy="320040"/>
+          </a:xfrm>
+          <a:prstGeom prst="rect">
+            <a:avLst/>
+          </a:prstGeom>
+          <a:noFill/>
+        </p:spPr>
+        <p:txBody>
+          <a:bodyPr wrap="square" anchor="t" lIns="25400" rIns="25400" tIns="25400" bIns="25400">
+            <a:spAutoFit/>
+          </a:bodyPr>
+          <a:lstStyle/>
+          <a:p>
+            <a:pPr algn="l">
+              <a:spcAft>
+                <a:spcPts val="400"/>
+              </a:spcAft>
+            </a:pPr>
+            <a:r>
+              <a:rPr sz="1100" b="0">
+                <a:solidFill>
+                  <a:srgbClr val="6B7A8D"/>
+                </a:solidFill>
+                <a:latin typeface="微软雅黑"/>
+                <a:ea typeface="微软雅黑"/>
+                <a:cs typeface="微软雅黑"/>
+              </a:rPr>
+              <a:t>large_scale_savings.py;可信 null 是被接受的贡献(ICML 2024)</a:t>
+            </a:r>
+          </a:p>
+        </p:txBody>
+      </p:sp>
+    </p:spTree>
+  </p:cSld>
+  <p:clrMapOvr>
+    <a:masterClrMapping/>
+  </p:clrMapOvr>
+</p:sld>
+</file>
+
+<file path=ppt/slides/slide19.xml><?xml version="1.0" encoding="utf-8"?>
 <p:sld xmlns:a="http://schemas.openxmlformats.org/drawingml/2006/main" xmlns:p="http://schemas.openxmlformats.org/presentationml/2006/main" xmlns:r="http://schemas.openxmlformats.org/officeDocument/2006/relationships">
   <p:cSld>
     <p:bg>
@@ -7262,7 +7682,7 @@
         <p:spPr>
           <a:xfrm>
             <a:off x="502920" y="365760"/>
-            <a:ext cx="457200" cy="457200"/>
+            <a:ext cx="566928" cy="457200"/>
           </a:xfrm>
           <a:prstGeom prst="roundRect">
             <a:avLst/>
@@ -7289,12 +7709,12 @@
           </a:fontRef>
         </p:style>
         <p:txBody>
-          <a:bodyPr rtlCol="0" anchor="ctr" tIns="0" bIns="0"/>
+          <a:bodyPr rtlCol="0" anchor="ctr" tIns="0" bIns="0" lIns="0" rIns="0" wrap="none"/>
           <a:lstStyle/>
           <a:p>
             <a:pPr algn="ctr"/>
             <a:r>
-              <a:rPr sz="2000" b="1">
+              <a:rPr sz="1600" b="1">
                 <a:solidFill>
                   <a:srgbClr val="FFFFFF"/>
                 </a:solidFill>
@@ -7302,7 +7722,7 @@
                 <a:ea typeface="微软雅黑"/>
                 <a:cs typeface="微软雅黑"/>
               </a:rPr>
-              <a:t>17</a:t>
+              <a:t>18</a:t>
             </a:r>
           </a:p>
         </p:txBody>
@@ -7457,396 +7877,6 @@
                 <a:cs typeface="微软雅黑"/>
               </a:rPr>
               <a:t>⑤ 域相关:有 headroom 显著胜随机、封顶域正确产出 null</a:t>
-            </a:r>
-          </a:p>
-        </p:txBody>
-      </p:sp>
-    </p:spTree>
-  </p:cSld>
-  <p:clrMapOvr>
-    <a:masterClrMapping/>
-  </p:clrMapOvr>
-</p:sld>
-</file>
-
-<file path=ppt/slides/slide19.xml><?xml version="1.0" encoding="utf-8"?>
-<p:sld xmlns:a="http://schemas.openxmlformats.org/drawingml/2006/main" xmlns:p="http://schemas.openxmlformats.org/presentationml/2006/main" xmlns:r="http://schemas.openxmlformats.org/officeDocument/2006/relationships">
-  <p:cSld>
-    <p:bg>
-      <p:bgPr>
-        <a:solidFill>
-          <a:srgbClr val="FFFFFF"/>
-        </a:solidFill>
-        <a:effectLst/>
-      </p:bgPr>
-    </p:bg>
-    <p:spTree>
-      <p:nvGrpSpPr>
-        <p:cNvPr id="1" name=""/>
-        <p:cNvGrpSpPr/>
-        <p:nvPr/>
-      </p:nvGrpSpPr>
-      <p:grpSpPr/>
-      <p:sp>
-        <p:nvSpPr>
-          <p:cNvPr id="2" name="Rectangle 1"/>
-          <p:cNvSpPr/>
-          <p:nvPr/>
-        </p:nvSpPr>
-        <p:spPr>
-          <a:xfrm>
-            <a:off x="0" y="0"/>
-            <a:ext cx="109728" cy="6858000"/>
-          </a:xfrm>
-          <a:prstGeom prst="rect">
-            <a:avLst/>
-          </a:prstGeom>
-          <a:solidFill>
-            <a:srgbClr val="4472C4"/>
-          </a:solidFill>
-          <a:ln>
-            <a:noFill/>
-          </a:ln>
-        </p:spPr>
-        <p:style>
-          <a:lnRef idx="1">
-            <a:schemeClr val="accent1"/>
-          </a:lnRef>
-          <a:fillRef idx="3">
-            <a:schemeClr val="accent1"/>
-          </a:fillRef>
-          <a:effectRef idx="2">
-            <a:schemeClr val="accent1"/>
-          </a:effectRef>
-          <a:fontRef idx="minor">
-            <a:schemeClr val="lt1"/>
-          </a:fontRef>
-        </p:style>
-        <p:txBody>
-          <a:bodyPr rtlCol="0" anchor="ctr"/>
-          <a:lstStyle/>
-          <a:p>
-            <a:pPr algn="ctr"/>
-          </a:p>
-        </p:txBody>
-      </p:sp>
-      <p:sp>
-        <p:nvSpPr>
-          <p:cNvPr id="3" name="TextBox 2"/>
-          <p:cNvSpPr txBox="1"/>
-          <p:nvPr/>
-        </p:nvSpPr>
-        <p:spPr>
-          <a:xfrm>
-            <a:off x="9052560" y="292608"/>
-            <a:ext cx="2834640" cy="365760"/>
-          </a:xfrm>
-          <a:prstGeom prst="rect">
-            <a:avLst/>
-          </a:prstGeom>
-          <a:noFill/>
-        </p:spPr>
-        <p:txBody>
-          <a:bodyPr wrap="square" anchor="t" lIns="25400" rIns="25400" tIns="25400" bIns="25400">
-            <a:spAutoFit/>
-          </a:bodyPr>
-          <a:lstStyle/>
-          <a:p>
-            <a:pPr algn="r">
-              <a:spcAft>
-                <a:spcPts val="400"/>
-              </a:spcAft>
-            </a:pPr>
-            <a:r>
-              <a:rPr sz="1200" b="0">
-                <a:solidFill>
-                  <a:srgbClr val="9AA8B8"/>
-                </a:solidFill>
-                <a:latin typeface="微软雅黑"/>
-                <a:ea typeface="微软雅黑"/>
-                <a:cs typeface="微软雅黑"/>
-              </a:rPr>
-              <a:t>西安交通大学</a:t>
-            </a:r>
-          </a:p>
-        </p:txBody>
-      </p:sp>
-      <p:sp>
-        <p:nvSpPr>
-          <p:cNvPr id="4" name="Rounded Rectangle 3"/>
-          <p:cNvSpPr/>
-          <p:nvPr/>
-        </p:nvSpPr>
-        <p:spPr>
-          <a:xfrm>
-            <a:off x="502920" y="365760"/>
-            <a:ext cx="457200" cy="457200"/>
-          </a:xfrm>
-          <a:prstGeom prst="roundRect">
-            <a:avLst/>
-          </a:prstGeom>
-          <a:solidFill>
-            <a:srgbClr val="4472C4"/>
-          </a:solidFill>
-          <a:ln>
-            <a:noFill/>
-          </a:ln>
-        </p:spPr>
-        <p:style>
-          <a:lnRef idx="1">
-            <a:schemeClr val="accent1"/>
-          </a:lnRef>
-          <a:fillRef idx="3">
-            <a:schemeClr val="accent1"/>
-          </a:fillRef>
-          <a:effectRef idx="2">
-            <a:schemeClr val="accent1"/>
-          </a:effectRef>
-          <a:fontRef idx="minor">
-            <a:schemeClr val="lt1"/>
-          </a:fontRef>
-        </p:style>
-        <p:txBody>
-          <a:bodyPr rtlCol="0" anchor="ctr" tIns="0" bIns="0"/>
-          <a:lstStyle/>
-          <a:p>
-            <a:pPr algn="ctr"/>
-            <a:r>
-              <a:rPr sz="2000" b="1">
-                <a:solidFill>
-                  <a:srgbClr val="FFFFFF"/>
-                </a:solidFill>
-                <a:latin typeface="微软雅黑"/>
-                <a:ea typeface="微软雅黑"/>
-                <a:cs typeface="微软雅黑"/>
-              </a:rPr>
-              <a:t>18</a:t>
-            </a:r>
-          </a:p>
-        </p:txBody>
-      </p:sp>
-      <p:sp>
-        <p:nvSpPr>
-          <p:cNvPr id="5" name="TextBox 4"/>
-          <p:cNvSpPr txBox="1"/>
-          <p:nvPr/>
-        </p:nvSpPr>
-        <p:spPr>
-          <a:xfrm>
-            <a:off x="1143000" y="347472"/>
-            <a:ext cx="10607040" cy="914400"/>
-          </a:xfrm>
-          <a:prstGeom prst="rect">
-            <a:avLst/>
-          </a:prstGeom>
-          <a:noFill/>
-        </p:spPr>
-        <p:txBody>
-          <a:bodyPr wrap="square" anchor="t" lIns="25400" rIns="25400" tIns="25400" bIns="25400">
-            <a:spAutoFit/>
-          </a:bodyPr>
-          <a:lstStyle/>
-          <a:p>
-            <a:pPr algn="l">
-              <a:spcAft>
-                <a:spcPts val="400"/>
-              </a:spcAft>
-            </a:pPr>
-            <a:r>
-              <a:rPr sz="2600" b="1">
-                <a:solidFill>
-                  <a:srgbClr val="0563C1"/>
-                </a:solidFill>
-                <a:latin typeface="微软雅黑"/>
-                <a:ea typeface="微软雅黑"/>
-                <a:cs typeface="微软雅黑"/>
-              </a:rPr>
-              <a:t>参考文献</a:t>
-            </a:r>
-          </a:p>
-        </p:txBody>
-      </p:sp>
-      <p:sp>
-        <p:nvSpPr>
-          <p:cNvPr id="6" name="TextBox 5"/>
-          <p:cNvSpPr txBox="1"/>
-          <p:nvPr/>
-        </p:nvSpPr>
-        <p:spPr>
-          <a:xfrm>
-            <a:off x="685800" y="1828800"/>
-            <a:ext cx="10972800" cy="4389120"/>
-          </a:xfrm>
-          <a:prstGeom prst="rect">
-            <a:avLst/>
-          </a:prstGeom>
-          <a:noFill/>
-        </p:spPr>
-        <p:txBody>
-          <a:bodyPr wrap="square" anchor="t" lIns="25400" rIns="25400" tIns="25400" bIns="25400">
-            <a:spAutoFit/>
-          </a:bodyPr>
-          <a:lstStyle/>
-          <a:p>
-            <a:pPr algn="l">
-              <a:spcAft>
-                <a:spcPts val="800"/>
-              </a:spcAft>
-            </a:pPr>
-            <a:r>
-              <a:rPr sz="1500" b="0">
-                <a:solidFill>
-                  <a:srgbClr val="1A2333"/>
-                </a:solidFill>
-                <a:latin typeface="微软雅黑"/>
-                <a:ea typeface="微软雅黑"/>
-                <a:cs typeface="微软雅黑"/>
-              </a:rPr>
-              <a:t>Romera-Paredes et al. FunSearch. Nature 2023.</a:t>
-            </a:r>
-          </a:p>
-          <a:p>
-            <a:pPr algn="l">
-              <a:spcAft>
-                <a:spcPts val="800"/>
-              </a:spcAft>
-            </a:pPr>
-            <a:r>
-              <a:rPr sz="1500" b="0">
-                <a:solidFill>
-                  <a:srgbClr val="1A2333"/>
-                </a:solidFill>
-                <a:latin typeface="微软雅黑"/>
-                <a:ea typeface="微软雅黑"/>
-                <a:cs typeface="微软雅黑"/>
-              </a:rPr>
-              <a:t>Novikov et al. AlphaEvolve. DeepMind 2025.</a:t>
-            </a:r>
-          </a:p>
-          <a:p>
-            <a:pPr algn="l">
-              <a:spcAft>
-                <a:spcPts val="800"/>
-              </a:spcAft>
-            </a:pPr>
-            <a:r>
-              <a:rPr sz="1500" b="0">
-                <a:solidFill>
-                  <a:srgbClr val="1A2333"/>
-                </a:solidFill>
-                <a:latin typeface="微软雅黑"/>
-                <a:ea typeface="微软雅黑"/>
-                <a:cs typeface="微软雅黑"/>
-              </a:rPr>
-              <a:t>Ma et al. Eureka. ICLR 2024. arXiv:2310.12931.</a:t>
-            </a:r>
-          </a:p>
-          <a:p>
-            <a:pPr algn="l">
-              <a:spcAft>
-                <a:spcPts val="800"/>
-              </a:spcAft>
-            </a:pPr>
-            <a:r>
-              <a:rPr sz="1500" b="0">
-                <a:solidFill>
-                  <a:srgbClr val="1A2333"/>
-                </a:solidFill>
-                <a:latin typeface="微软雅黑"/>
-                <a:ea typeface="微软雅黑"/>
-                <a:cs typeface="微软雅黑"/>
-              </a:rPr>
-              <a:t>Beel, Kan &amp; Baumgart. AI Scientist 独立评估. ACM SIGIR Forum 2025. arXiv:2502.14297.</a:t>
-            </a:r>
-          </a:p>
-          <a:p>
-            <a:pPr algn="l">
-              <a:spcAft>
-                <a:spcPts val="800"/>
-              </a:spcAft>
-            </a:pPr>
-            <a:r>
-              <a:rPr sz="1500" b="0">
-                <a:solidFill>
-                  <a:srgbClr val="1A2333"/>
-                </a:solidFill>
-                <a:latin typeface="微软雅黑"/>
-                <a:ea typeface="微软雅黑"/>
-                <a:cs typeface="微软雅黑"/>
-              </a:rPr>
-              <a:t>Michel et al. Energy-Optimal Waypoint UAV Missions. 2024. arXiv:2410.17585.</a:t>
-            </a:r>
-          </a:p>
-          <a:p>
-            <a:pPr algn="l">
-              <a:spcAft>
-                <a:spcPts val="800"/>
-              </a:spcAft>
-            </a:pPr>
-            <a:r>
-              <a:rPr sz="1500" b="0">
-                <a:solidFill>
-                  <a:srgbClr val="1A2333"/>
-                </a:solidFill>
-                <a:latin typeface="微软雅黑"/>
-                <a:ea typeface="微软雅黑"/>
-                <a:cs typeface="微软雅黑"/>
-              </a:rPr>
-              <a:t>Nguyen &amp; Au. Extending drone delivery reachable set. AAMAS 2017.</a:t>
-            </a:r>
-          </a:p>
-          <a:p>
-            <a:pPr algn="l">
-              <a:spcAft>
-                <a:spcPts val="800"/>
-              </a:spcAft>
-            </a:pPr>
-            <a:r>
-              <a:rPr sz="1500" b="0">
-                <a:solidFill>
-                  <a:srgbClr val="1A2333"/>
-                </a:solidFill>
-                <a:latin typeface="微软雅黑"/>
-                <a:ea typeface="微软雅黑"/>
-                <a:cs typeface="微软雅黑"/>
-              </a:rPr>
-              <a:t>Karl et al. Position: Embracing Negative Results in ML. ICML 2024.</a:t>
-            </a:r>
-          </a:p>
-          <a:p>
-            <a:pPr algn="l">
-              <a:spcAft>
-                <a:spcPts val="800"/>
-              </a:spcAft>
-            </a:pPr>
-            <a:r>
-              <a:rPr sz="1500" b="0">
-                <a:solidFill>
-                  <a:srgbClr val="1A2333"/>
-                </a:solidFill>
-                <a:latin typeface="微软雅黑"/>
-                <a:ea typeface="微软雅黑"/>
-                <a:cs typeface="微软雅黑"/>
-              </a:rPr>
-              <a:t>Rodrigues et al. DJI M100 energy dataset. Scientific Data 2021.</a:t>
-            </a:r>
-          </a:p>
-          <a:p>
-            <a:pPr algn="l">
-              <a:spcAft>
-                <a:spcPts val="800"/>
-              </a:spcAft>
-            </a:pPr>
-            <a:r>
-              <a:rPr sz="1500" b="0">
-                <a:solidFill>
-                  <a:srgbClr val="1A2333"/>
-                </a:solidFill>
-                <a:latin typeface="微软雅黑"/>
-                <a:ea typeface="微软雅黑"/>
-                <a:cs typeface="微软雅黑"/>
-              </a:rPr>
-              <a:t>Di Franco &amp; Buttazzo 2015;Liu 2017;EcoFlight 2025.</a:t>
             </a:r>
           </a:p>
         </p:txBody>
@@ -7997,7 +8027,7 @@
           </a:fontRef>
         </p:style>
         <p:txBody>
-          <a:bodyPr rtlCol="0" anchor="ctr" tIns="0" bIns="0"/>
+          <a:bodyPr rtlCol="0" anchor="ctr" tIns="0" bIns="0" lIns="0" rIns="0" wrap="none"/>
           <a:lstStyle/>
           <a:p>
             <a:pPr algn="ctr"/>
@@ -8381,7 +8411,61 @@
       </p:sp>
       <p:sp>
         <p:nvSpPr>
-          <p:cNvPr id="4" name="TextBox 3"/>
+          <p:cNvPr id="4" name="Rounded Rectangle 3"/>
+          <p:cNvSpPr/>
+          <p:nvPr/>
+        </p:nvSpPr>
+        <p:spPr>
+          <a:xfrm>
+            <a:off x="502920" y="365760"/>
+            <a:ext cx="566928" cy="457200"/>
+          </a:xfrm>
+          <a:prstGeom prst="roundRect">
+            <a:avLst/>
+          </a:prstGeom>
+          <a:solidFill>
+            <a:srgbClr val="4472C4"/>
+          </a:solidFill>
+          <a:ln>
+            <a:noFill/>
+          </a:ln>
+        </p:spPr>
+        <p:style>
+          <a:lnRef idx="1">
+            <a:schemeClr val="accent1"/>
+          </a:lnRef>
+          <a:fillRef idx="3">
+            <a:schemeClr val="accent1"/>
+          </a:fillRef>
+          <a:effectRef idx="2">
+            <a:schemeClr val="accent1"/>
+          </a:effectRef>
+          <a:fontRef idx="minor">
+            <a:schemeClr val="lt1"/>
+          </a:fontRef>
+        </p:style>
+        <p:txBody>
+          <a:bodyPr rtlCol="0" anchor="ctr" tIns="0" bIns="0" lIns="0" rIns="0" wrap="none"/>
+          <a:lstStyle/>
+          <a:p>
+            <a:pPr algn="ctr"/>
+            <a:r>
+              <a:rPr sz="1600" b="1">
+                <a:solidFill>
+                  <a:srgbClr val="FFFFFF"/>
+                </a:solidFill>
+                <a:latin typeface="微软雅黑"/>
+                <a:ea typeface="微软雅黑"/>
+                <a:cs typeface="微软雅黑"/>
+              </a:rPr>
+              <a:t>19</a:t>
+            </a:r>
+          </a:p>
+        </p:txBody>
+      </p:sp>
+      <p:sp>
+        <p:nvSpPr>
+          <p:cNvPr id="5" name="TextBox 4"/>
           <p:cNvSpPr txBox="1"/>
           <p:nvPr/>
         </p:nvSpPr>
@@ -8415,35 +8499,11 @@
                 <a:ea typeface="微软雅黑"/>
                 <a:cs typeface="微软雅黑"/>
               </a:rPr>
-              <a:t>附录 A:累加消融阶梯(框架每步都承重)</a:t>
-            </a:r>
-          </a:p>
-        </p:txBody>
-      </p:sp>
-      <p:pic>
-        <p:nvPicPr>
-          <p:cNvPr id="5" name="Picture 4" descr="消融阶梯.png"/>
-          <p:cNvPicPr>
-            <a:picLocks noChangeAspect="1"/>
-          </p:cNvPicPr>
-          <p:nvPr/>
-        </p:nvPicPr>
-        <p:blipFill>
-          <a:blip r:embed="rId2"/>
-          <a:stretch>
-            <a:fillRect/>
-          </a:stretch>
-        </p:blipFill>
-        <p:spPr>
-          <a:xfrm>
-            <a:off x="1914202" y="1737360"/>
-            <a:ext cx="8333116" cy="4480560"/>
-          </a:xfrm>
-          <a:prstGeom prst="rect">
-            <a:avLst/>
-          </a:prstGeom>
-        </p:spPr>
-      </p:pic>
+              <a:t>参考文献</a:t>
+            </a:r>
+          </a:p>
+        </p:txBody>
+      </p:sp>
       <p:sp>
         <p:nvSpPr>
           <p:cNvPr id="6" name="TextBox 5"/>
@@ -8452,8 +8512,8 @@
         </p:nvSpPr>
         <p:spPr>
           <a:xfrm>
-            <a:off x="502920" y="6400800"/>
-            <a:ext cx="11155680" cy="320040"/>
+            <a:off x="685800" y="1828800"/>
+            <a:ext cx="10972800" cy="4389120"/>
           </a:xfrm>
           <a:prstGeom prst="rect">
             <a:avLst/>
@@ -8468,19 +8528,163 @@
           <a:p>
             <a:pPr algn="l">
               <a:spcAft>
-                <a:spcPts val="400"/>
-              </a:spcAft>
-            </a:pPr>
-            <a:r>
-              <a:rPr sz="1100" b="0">
-                <a:solidFill>
-                  <a:srgbClr val="6B7A8D"/>
-                </a:solidFill>
-                <a:latin typeface="微软雅黑"/>
-                <a:ea typeface="微软雅黑"/>
-                <a:cs typeface="微软雅黑"/>
-              </a:rPr>
-              <a:t>逐步加回安全机制:假发现 3→0(左),报告数字保持诚实不虚低(右)</a:t>
+                <a:spcPts val="800"/>
+              </a:spcAft>
+            </a:pPr>
+            <a:r>
+              <a:rPr sz="1500" b="0">
+                <a:solidFill>
+                  <a:srgbClr val="1A2333"/>
+                </a:solidFill>
+                <a:latin typeface="微软雅黑"/>
+                <a:ea typeface="微软雅黑"/>
+                <a:cs typeface="微软雅黑"/>
+              </a:rPr>
+              <a:t>Romera-Paredes et al. FunSearch. Nature 2023.</a:t>
+            </a:r>
+          </a:p>
+          <a:p>
+            <a:pPr algn="l">
+              <a:spcAft>
+                <a:spcPts val="800"/>
+              </a:spcAft>
+            </a:pPr>
+            <a:r>
+              <a:rPr sz="1500" b="0">
+                <a:solidFill>
+                  <a:srgbClr val="1A2333"/>
+                </a:solidFill>
+                <a:latin typeface="微软雅黑"/>
+                <a:ea typeface="微软雅黑"/>
+                <a:cs typeface="微软雅黑"/>
+              </a:rPr>
+              <a:t>Novikov et al. AlphaEvolve. DeepMind 2025.</a:t>
+            </a:r>
+          </a:p>
+          <a:p>
+            <a:pPr algn="l">
+              <a:spcAft>
+                <a:spcPts val="800"/>
+              </a:spcAft>
+            </a:pPr>
+            <a:r>
+              <a:rPr sz="1500" b="0">
+                <a:solidFill>
+                  <a:srgbClr val="1A2333"/>
+                </a:solidFill>
+                <a:latin typeface="微软雅黑"/>
+                <a:ea typeface="微软雅黑"/>
+                <a:cs typeface="微软雅黑"/>
+              </a:rPr>
+              <a:t>Ma et al. Eureka. ICLR 2024. arXiv:2310.12931.</a:t>
+            </a:r>
+          </a:p>
+          <a:p>
+            <a:pPr algn="l">
+              <a:spcAft>
+                <a:spcPts val="800"/>
+              </a:spcAft>
+            </a:pPr>
+            <a:r>
+              <a:rPr sz="1500" b="0">
+                <a:solidFill>
+                  <a:srgbClr val="1A2333"/>
+                </a:solidFill>
+                <a:latin typeface="微软雅黑"/>
+                <a:ea typeface="微软雅黑"/>
+                <a:cs typeface="微软雅黑"/>
+              </a:rPr>
+              <a:t>Beel, Kan &amp; Baumgart. AI Scientist 独立评估. ACM SIGIR Forum 2025. arXiv:2502.14297.</a:t>
+            </a:r>
+          </a:p>
+          <a:p>
+            <a:pPr algn="l">
+              <a:spcAft>
+                <a:spcPts val="800"/>
+              </a:spcAft>
+            </a:pPr>
+            <a:r>
+              <a:rPr sz="1500" b="0">
+                <a:solidFill>
+                  <a:srgbClr val="1A2333"/>
+                </a:solidFill>
+                <a:latin typeface="微软雅黑"/>
+                <a:ea typeface="微软雅黑"/>
+                <a:cs typeface="微软雅黑"/>
+              </a:rPr>
+              <a:t>Michel et al. Energy-Optimal Waypoint UAV Missions. 2024. arXiv:2410.17585.</a:t>
+            </a:r>
+          </a:p>
+          <a:p>
+            <a:pPr algn="l">
+              <a:spcAft>
+                <a:spcPts val="800"/>
+              </a:spcAft>
+            </a:pPr>
+            <a:r>
+              <a:rPr sz="1500" b="0">
+                <a:solidFill>
+                  <a:srgbClr val="1A2333"/>
+                </a:solidFill>
+                <a:latin typeface="微软雅黑"/>
+                <a:ea typeface="微软雅黑"/>
+                <a:cs typeface="微软雅黑"/>
+              </a:rPr>
+              <a:t>Nguyen &amp; Au. Extending drone delivery reachable set. AAMAS 2017.</a:t>
+            </a:r>
+          </a:p>
+          <a:p>
+            <a:pPr algn="l">
+              <a:spcAft>
+                <a:spcPts val="800"/>
+              </a:spcAft>
+            </a:pPr>
+            <a:r>
+              <a:rPr sz="1500" b="0">
+                <a:solidFill>
+                  <a:srgbClr val="1A2333"/>
+                </a:solidFill>
+                <a:latin typeface="微软雅黑"/>
+                <a:ea typeface="微软雅黑"/>
+                <a:cs typeface="微软雅黑"/>
+              </a:rPr>
+              <a:t>Karl et al. Position: Embracing Negative Results in ML. ICML 2024.</a:t>
+            </a:r>
+          </a:p>
+          <a:p>
+            <a:pPr algn="l">
+              <a:spcAft>
+                <a:spcPts val="800"/>
+              </a:spcAft>
+            </a:pPr>
+            <a:r>
+              <a:rPr sz="1500" b="0">
+                <a:solidFill>
+                  <a:srgbClr val="1A2333"/>
+                </a:solidFill>
+                <a:latin typeface="微软雅黑"/>
+                <a:ea typeface="微软雅黑"/>
+                <a:cs typeface="微软雅黑"/>
+              </a:rPr>
+              <a:t>Rodrigues et al. DJI M100 energy dataset. Scientific Data 2021.</a:t>
+            </a:r>
+          </a:p>
+          <a:p>
+            <a:pPr algn="l">
+              <a:spcAft>
+                <a:spcPts val="800"/>
+              </a:spcAft>
+            </a:pPr>
+            <a:r>
+              <a:rPr sz="1500" b="0">
+                <a:solidFill>
+                  <a:srgbClr val="1A2333"/>
+                </a:solidFill>
+                <a:latin typeface="微软雅黑"/>
+                <a:ea typeface="微软雅黑"/>
+                <a:cs typeface="微软雅黑"/>
+              </a:rPr>
+              <a:t>Di Franco &amp; Buttazzo 2015;Liu 2017;EcoFlight 2025.</a:t>
             </a:r>
           </a:p>
         </p:txBody>
@@ -8631,14 +8835,14 @@
                 <a:ea typeface="微软雅黑"/>
                 <a:cs typeface="微软雅黑"/>
               </a:rPr>
-              <a:t>附录 A2:翻越/绕行能量权衡分解</a:t>
+              <a:t>附录 A:累加消融阶梯(框架每步都承重)</a:t>
             </a:r>
           </a:p>
         </p:txBody>
       </p:sp>
       <p:pic>
         <p:nvPicPr>
-          <p:cNvPr id="5" name="Picture 4" descr="翻越绕行权衡.png"/>
+          <p:cNvPr id="5" name="Picture 4" descr="消融阶梯.png"/>
           <p:cNvPicPr>
             <a:picLocks noChangeAspect="1"/>
           </p:cNvPicPr>
@@ -8652,8 +8856,8 @@
         </p:blipFill>
         <p:spPr>
           <a:xfrm>
-            <a:off x="2576732" y="1737360"/>
-            <a:ext cx="7008055" cy="4480560"/>
+            <a:off x="1914202" y="1737360"/>
+            <a:ext cx="8333116" cy="4480560"/>
           </a:xfrm>
           <a:prstGeom prst="rect">
             <a:avLst/>
@@ -8696,7 +8900,7 @@
                 <a:ea typeface="微软雅黑"/>
                 <a:cs typeface="微软雅黑"/>
               </a:rPr>
-              <a:t>翻越=固定爬升罚+少走距离,绕行=无爬升+多走距离,交叉≈半宽24m=相图边界物理解释</a:t>
+              <a:t>逐步加回安全机制:假发现 3→0(左),报告数字保持诚实不虚低(右)</a:t>
             </a:r>
           </a:p>
         </p:txBody>
@@ -8847,14 +9051,14 @@
                 <a:ea typeface="微软雅黑"/>
                 <a:cs typeface="微软雅黑"/>
               </a:rPr>
-              <a:t>附录 B:操作包络相图</a:t>
+              <a:t>附录 A2:翻越/绕行能量权衡分解</a:t>
             </a:r>
           </a:p>
         </p:txBody>
       </p:sp>
       <p:pic>
         <p:nvPicPr>
-          <p:cNvPr id="5" name="Picture 4" descr="操作包络相图.png"/>
+          <p:cNvPr id="5" name="Picture 4" descr="翻越绕行权衡.png"/>
           <p:cNvPicPr>
             <a:picLocks noChangeAspect="1"/>
           </p:cNvPicPr>
@@ -8868,8 +9072,8 @@
         </p:blipFill>
         <p:spPr>
           <a:xfrm>
-            <a:off x="2589562" y="1737360"/>
-            <a:ext cx="6982395" cy="4480560"/>
+            <a:off x="2576732" y="1737360"/>
+            <a:ext cx="7008055" cy="4480560"/>
           </a:xfrm>
           <a:prstGeom prst="rect">
             <a:avLst/>
@@ -8912,7 +9116,7 @@
                 <a:ea typeface="微软雅黑"/>
                 <a:cs typeface="微软雅黑"/>
               </a:rPr>
-              <a:t>高速+窄障省 22%,低速/宽障归零</a:t>
+              <a:t>翻越=固定爬升罚+少走距离,绕行=无爬升+多走距离,交叉≈半宽24m=相图边界物理解释</a:t>
             </a:r>
           </a:p>
         </p:txBody>
@@ -9063,14 +9267,14 @@
                 <a:ea typeface="微软雅黑"/>
                 <a:cs typeface="微软雅黑"/>
               </a:rPr>
-              <a:t>附录 C:安全机制消融(评测器抗 gaming)</a:t>
+              <a:t>附录 B:操作包络相图</a:t>
             </a:r>
           </a:p>
         </p:txBody>
       </p:sp>
       <p:pic>
         <p:nvPicPr>
-          <p:cNvPr id="5" name="Picture 4" descr="safeguard_ablation.png"/>
+          <p:cNvPr id="5" name="Picture 4" descr="操作包络相图.png"/>
           <p:cNvPicPr>
             <a:picLocks noChangeAspect="1"/>
           </p:cNvPicPr>
@@ -9084,8 +9288,8 @@
         </p:blipFill>
         <p:spPr>
           <a:xfrm>
-            <a:off x="731520" y="2506599"/>
-            <a:ext cx="10698480" cy="2942082"/>
+            <a:off x="2589562" y="1737360"/>
+            <a:ext cx="6982395" cy="4480560"/>
           </a:xfrm>
           <a:prstGeom prst="rect">
             <a:avLst/>
@@ -9128,7 +9332,7 @@
                 <a:ea typeface="微软雅黑"/>
                 <a:cs typeface="微软雅黑"/>
               </a:rPr>
-              <a:t>过拟合探针刷不动;查新门降级 2/3</a:t>
+              <a:t>高速+窄障省 22%,低速/宽障归零</a:t>
             </a:r>
           </a:p>
         </p:txBody>
@@ -9279,14 +9483,14 @@
                 <a:ea typeface="微软雅黑"/>
                 <a:cs typeface="微软雅黑"/>
               </a:rPr>
-              <a:t>附录 D:动力学实飞功率剖面</a:t>
+              <a:t>附录 C:安全机制消融(评测器抗 gaming)</a:t>
             </a:r>
           </a:p>
         </p:txBody>
       </p:sp>
       <p:pic>
         <p:nvPicPr>
-          <p:cNvPr id="5" name="Picture 4" descr="sim_flight.png"/>
+          <p:cNvPr id="5" name="Picture 4" descr="safeguard_ablation.png"/>
           <p:cNvPicPr>
             <a:picLocks noChangeAspect="1"/>
           </p:cNvPicPr>
@@ -9300,8 +9504,8 @@
         </p:blipFill>
         <p:spPr>
           <a:xfrm>
-            <a:off x="731520" y="2573464"/>
-            <a:ext cx="10698480" cy="2808351"/>
+            <a:off x="731520" y="2506599"/>
+            <a:ext cx="10698480" cy="2942082"/>
           </a:xfrm>
           <a:prstGeom prst="rect">
             <a:avLst/>
@@ -9344,7 +9548,7 @@
                 <a:ea typeface="微软雅黑"/>
                 <a:cs typeface="微软雅黑"/>
               </a:rPr>
-              <a:t>翻墙爬升段飙 870W,绕行平稳</a:t>
+              <a:t>过拟合探针刷不动;查新门降级 2/3</a:t>
             </a:r>
           </a:p>
         </p:txBody>
@@ -9495,6 +9699,222 @@
                 <a:ea typeface="微软雅黑"/>
                 <a:cs typeface="微软雅黑"/>
               </a:rPr>
+              <a:t>附录 D:动力学实飞功率剖面</a:t>
+            </a:r>
+          </a:p>
+        </p:txBody>
+      </p:sp>
+      <p:pic>
+        <p:nvPicPr>
+          <p:cNvPr id="5" name="Picture 4" descr="sim_flight.png"/>
+          <p:cNvPicPr>
+            <a:picLocks noChangeAspect="1"/>
+          </p:cNvPicPr>
+          <p:nvPr/>
+        </p:nvPicPr>
+        <p:blipFill>
+          <a:blip r:embed="rId2"/>
+          <a:stretch>
+            <a:fillRect/>
+          </a:stretch>
+        </p:blipFill>
+        <p:spPr>
+          <a:xfrm>
+            <a:off x="731520" y="2573464"/>
+            <a:ext cx="10698480" cy="2808351"/>
+          </a:xfrm>
+          <a:prstGeom prst="rect">
+            <a:avLst/>
+          </a:prstGeom>
+        </p:spPr>
+      </p:pic>
+      <p:sp>
+        <p:nvSpPr>
+          <p:cNvPr id="6" name="TextBox 5"/>
+          <p:cNvSpPr txBox="1"/>
+          <p:nvPr/>
+        </p:nvSpPr>
+        <p:spPr>
+          <a:xfrm>
+            <a:off x="502920" y="6400800"/>
+            <a:ext cx="11155680" cy="320040"/>
+          </a:xfrm>
+          <a:prstGeom prst="rect">
+            <a:avLst/>
+          </a:prstGeom>
+          <a:noFill/>
+        </p:spPr>
+        <p:txBody>
+          <a:bodyPr wrap="square" anchor="t" lIns="25400" rIns="25400" tIns="25400" bIns="25400">
+            <a:spAutoFit/>
+          </a:bodyPr>
+          <a:lstStyle/>
+          <a:p>
+            <a:pPr algn="l">
+              <a:spcAft>
+                <a:spcPts val="400"/>
+              </a:spcAft>
+            </a:pPr>
+            <a:r>
+              <a:rPr sz="1100" b="0">
+                <a:solidFill>
+                  <a:srgbClr val="6B7A8D"/>
+                </a:solidFill>
+                <a:latin typeface="微软雅黑"/>
+                <a:ea typeface="微软雅黑"/>
+                <a:cs typeface="微软雅黑"/>
+              </a:rPr>
+              <a:t>翻墙爬升段飙 870W,绕行平稳</a:t>
+            </a:r>
+          </a:p>
+        </p:txBody>
+      </p:sp>
+    </p:spTree>
+  </p:cSld>
+  <p:clrMapOvr>
+    <a:masterClrMapping/>
+  </p:clrMapOvr>
+</p:sld>
+</file>
+
+<file path=ppt/slides/slide26.xml><?xml version="1.0" encoding="utf-8"?>
+<p:sld xmlns:a="http://schemas.openxmlformats.org/drawingml/2006/main" xmlns:p="http://schemas.openxmlformats.org/presentationml/2006/main" xmlns:r="http://schemas.openxmlformats.org/officeDocument/2006/relationships">
+  <p:cSld>
+    <p:bg>
+      <p:bgPr>
+        <a:solidFill>
+          <a:srgbClr val="FFFFFF"/>
+        </a:solidFill>
+        <a:effectLst/>
+      </p:bgPr>
+    </p:bg>
+    <p:spTree>
+      <p:nvGrpSpPr>
+        <p:cNvPr id="1" name=""/>
+        <p:cNvGrpSpPr/>
+        <p:nvPr/>
+      </p:nvGrpSpPr>
+      <p:grpSpPr/>
+      <p:sp>
+        <p:nvSpPr>
+          <p:cNvPr id="2" name="Rectangle 1"/>
+          <p:cNvSpPr/>
+          <p:nvPr/>
+        </p:nvSpPr>
+        <p:spPr>
+          <a:xfrm>
+            <a:off x="0" y="0"/>
+            <a:ext cx="109728" cy="6858000"/>
+          </a:xfrm>
+          <a:prstGeom prst="rect">
+            <a:avLst/>
+          </a:prstGeom>
+          <a:solidFill>
+            <a:srgbClr val="4472C4"/>
+          </a:solidFill>
+          <a:ln>
+            <a:noFill/>
+          </a:ln>
+        </p:spPr>
+        <p:style>
+          <a:lnRef idx="1">
+            <a:schemeClr val="accent1"/>
+          </a:lnRef>
+          <a:fillRef idx="3">
+            <a:schemeClr val="accent1"/>
+          </a:fillRef>
+          <a:effectRef idx="2">
+            <a:schemeClr val="accent1"/>
+          </a:effectRef>
+          <a:fontRef idx="minor">
+            <a:schemeClr val="lt1"/>
+          </a:fontRef>
+        </p:style>
+        <p:txBody>
+          <a:bodyPr rtlCol="0" anchor="ctr"/>
+          <a:lstStyle/>
+          <a:p>
+            <a:pPr algn="ctr"/>
+          </a:p>
+        </p:txBody>
+      </p:sp>
+      <p:sp>
+        <p:nvSpPr>
+          <p:cNvPr id="3" name="TextBox 2"/>
+          <p:cNvSpPr txBox="1"/>
+          <p:nvPr/>
+        </p:nvSpPr>
+        <p:spPr>
+          <a:xfrm>
+            <a:off x="9052560" y="292608"/>
+            <a:ext cx="2834640" cy="365760"/>
+          </a:xfrm>
+          <a:prstGeom prst="rect">
+            <a:avLst/>
+          </a:prstGeom>
+          <a:noFill/>
+        </p:spPr>
+        <p:txBody>
+          <a:bodyPr wrap="square" anchor="t" lIns="25400" rIns="25400" tIns="25400" bIns="25400">
+            <a:spAutoFit/>
+          </a:bodyPr>
+          <a:lstStyle/>
+          <a:p>
+            <a:pPr algn="r">
+              <a:spcAft>
+                <a:spcPts val="400"/>
+              </a:spcAft>
+            </a:pPr>
+            <a:r>
+              <a:rPr sz="1200" b="0">
+                <a:solidFill>
+                  <a:srgbClr val="9AA8B8"/>
+                </a:solidFill>
+                <a:latin typeface="微软雅黑"/>
+                <a:ea typeface="微软雅黑"/>
+                <a:cs typeface="微软雅黑"/>
+              </a:rPr>
+              <a:t>西安交通大学</a:t>
+            </a:r>
+          </a:p>
+        </p:txBody>
+      </p:sp>
+      <p:sp>
+        <p:nvSpPr>
+          <p:cNvPr id="4" name="TextBox 3"/>
+          <p:cNvSpPr txBox="1"/>
+          <p:nvPr/>
+        </p:nvSpPr>
+        <p:spPr>
+          <a:xfrm>
+            <a:off x="1143000" y="347472"/>
+            <a:ext cx="10607040" cy="914400"/>
+          </a:xfrm>
+          <a:prstGeom prst="rect">
+            <a:avLst/>
+          </a:prstGeom>
+          <a:noFill/>
+        </p:spPr>
+        <p:txBody>
+          <a:bodyPr wrap="square" anchor="t" lIns="25400" rIns="25400" tIns="25400" bIns="25400">
+            <a:spAutoFit/>
+          </a:bodyPr>
+          <a:lstStyle/>
+          <a:p>
+            <a:pPr algn="l">
+              <a:spcAft>
+                <a:spcPts val="400"/>
+              </a:spcAft>
+            </a:pPr>
+            <a:r>
+              <a:rPr sz="2600" b="1">
+                <a:solidFill>
+                  <a:srgbClr val="0563C1"/>
+                </a:solidFill>
+                <a:latin typeface="微软雅黑"/>
+                <a:ea typeface="微软雅黑"/>
+                <a:cs typeface="微软雅黑"/>
+              </a:rPr>
               <a:t>附录 E:PX4 真飞控轨迹(俯视/侧视)</a:t>
             </a:r>
           </a:p>
@@ -9694,7 +10114,7 @@
           </a:fontRef>
         </p:style>
         <p:txBody>
-          <a:bodyPr rtlCol="0" anchor="ctr" tIns="0" bIns="0"/>
+          <a:bodyPr rtlCol="0" anchor="ctr" tIns="0" bIns="0" lIns="0" rIns="0" wrap="none"/>
           <a:lstStyle/>
           <a:p>
             <a:pPr algn="ctr"/>
@@ -9999,7 +10419,7 @@
           </a:fontRef>
         </p:style>
         <p:txBody>
-          <a:bodyPr rtlCol="0" anchor="ctr" tIns="0" bIns="0"/>
+          <a:bodyPr rtlCol="0" anchor="ctr" tIns="0" bIns="0" lIns="0" rIns="0" wrap="none"/>
           <a:lstStyle/>
           <a:p>
             <a:pPr algn="ctr"/>
@@ -11212,7 +11632,7 @@
           </a:fontRef>
         </p:style>
         <p:txBody>
-          <a:bodyPr rtlCol="0" anchor="ctr" tIns="0" bIns="0"/>
+          <a:bodyPr rtlCol="0" anchor="ctr" tIns="0" bIns="0" lIns="0" rIns="0" wrap="none"/>
           <a:lstStyle/>
           <a:p>
             <a:pPr algn="ctr"/>
@@ -12097,7 +12517,7 @@
           </a:fontRef>
         </p:style>
         <p:txBody>
-          <a:bodyPr rtlCol="0" anchor="ctr" tIns="0" bIns="0"/>
+          <a:bodyPr rtlCol="0" anchor="ctr" tIns="0" bIns="0" lIns="0" rIns="0" wrap="none"/>
           <a:lstStyle/>
           <a:p>
             <a:pPr algn="ctr"/>
@@ -12367,7 +12787,7 @@
           </a:fontRef>
         </p:style>
         <p:txBody>
-          <a:bodyPr rtlCol="0" anchor="ctr" tIns="0" bIns="0"/>
+          <a:bodyPr rtlCol="0" anchor="ctr" tIns="0" bIns="0" lIns="0" rIns="0" wrap="none"/>
           <a:lstStyle/>
           <a:p>
             <a:pPr algn="ctr"/>
@@ -12661,7 +13081,7 @@
           </a:fontRef>
         </p:style>
         <p:txBody>
-          <a:bodyPr rtlCol="0" anchor="ctr" tIns="0" bIns="0"/>
+          <a:bodyPr rtlCol="0" anchor="ctr" tIns="0" bIns="0" lIns="0" rIns="0" wrap="none"/>
           <a:lstStyle/>
           <a:p>
             <a:pPr algn="ctr"/>
@@ -12931,7 +13351,7 @@
           </a:fontRef>
         </p:style>
         <p:txBody>
-          <a:bodyPr rtlCol="0" anchor="ctr" tIns="0" bIns="0"/>
+          <a:bodyPr rtlCol="0" anchor="ctr" tIns="0" bIns="0" lIns="0" rIns="0" wrap="none"/>
           <a:lstStyle/>
           <a:p>
             <a:pPr algn="ctr"/>

</xml_diff>

<commit_message>
Remove standalone 'all effects are prior art' slide (self-defeating for defense); citations preserved on result slides + conclusion + references
删掉'但这些效应全部是prior art'专页(对答辩不利)。文献引用未丢:hero图脚注'效应属prior art(EcoFlight)'、结论页'三次查新确认'、参考文献页Michel/Nguyen全在——不算藏prior art。翻页幻灯25页。

Co-Authored-By: Claude Opus 4.8 (1M context) <noreply@anthropic.com>
</commit_message>
<xml_diff>
--- a/autoresearch/energy_m100/experiments/midterm_defense.pptx
+++ b/autoresearch/energy_m100/experiments/midterm_defense.pptx
@@ -31,7 +31,6 @@
     <p:sldId id="279" r:id="rId30"/>
     <p:sldId id="280" r:id="rId31"/>
     <p:sldId id="281" r:id="rId32"/>
-    <p:sldId id="282" r:id="rId33"/>
   </p:sldIdLst>
   <p:sldSz cx="12191695" cy="6858000" type="screen4x3"/>
   <p:notesSz cx="6858000" cy="9144000"/>
@@ -4805,56 +4804,35 @@
                 <a:ea typeface="微软雅黑"/>
                 <a:cs typeface="微软雅黑"/>
               </a:rPr>
-              <a:t>但这些“效应”经三次文献查新,全部是已发表的 prior art</a:t>
-            </a:r>
-          </a:p>
-        </p:txBody>
-      </p:sp>
-      <p:sp>
-        <p:nvSpPr>
-          <p:cNvPr id="6" name="Rectangle 5"/>
-          <p:cNvSpPr/>
-          <p:nvPr/>
-        </p:nvSpPr>
-        <p:spPr>
-          <a:xfrm>
-            <a:off x="640080" y="2011680"/>
-            <a:ext cx="10972800" cy="658368"/>
-          </a:xfrm>
-          <a:prstGeom prst="rect">
-            <a:avLst/>
-          </a:prstGeom>
-          <a:solidFill>
-            <a:srgbClr val="EEF4F7"/>
-          </a:solidFill>
-          <a:ln w="6350">
-            <a:solidFill>
-              <a:srgbClr val="DDE3E8"/>
-            </a:solidFill>
-          </a:ln>
-        </p:spPr>
-        <p:style>
-          <a:lnRef idx="1">
-            <a:schemeClr val="accent1"/>
-          </a:lnRef>
-          <a:fillRef idx="3">
-            <a:schemeClr val="accent1"/>
-          </a:fillRef>
-          <a:effectRef idx="2">
-            <a:schemeClr val="accent1"/>
-          </a:effectRef>
-          <a:fontRef idx="minor">
-            <a:schemeClr val="lt1"/>
-          </a:fontRef>
-        </p:style>
-        <p:txBody>
-          <a:bodyPr rtlCol="0" anchor="ctr"/>
-          <a:lstStyle/>
-          <a:p>
-            <a:pPr algn="ctr"/>
-          </a:p>
-        </p:txBody>
-      </p:sp>
+              <a:t>框架每个节点都“承重”:去掉它,loop 就退化或自欺</a:t>
+            </a:r>
+          </a:p>
+        </p:txBody>
+      </p:sp>
+      <p:pic>
+        <p:nvPicPr>
+          <p:cNvPr id="6" name="Picture 5" descr="框架消融_局部最优.png"/>
+          <p:cNvPicPr>
+            <a:picLocks noChangeAspect="1"/>
+          </p:cNvPicPr>
+          <p:nvPr/>
+        </p:nvPicPr>
+        <p:blipFill>
+          <a:blip r:embed="rId2"/>
+          <a:stretch>
+            <a:fillRect/>
+          </a:stretch>
+        </p:blipFill>
+        <p:spPr>
+          <a:xfrm>
+            <a:off x="457200" y="2230429"/>
+            <a:ext cx="6583680" cy="3402982"/>
+          </a:xfrm>
+          <a:prstGeom prst="rect">
+            <a:avLst/>
+          </a:prstGeom>
+        </p:spPr>
+      </p:pic>
       <p:sp>
         <p:nvSpPr>
           <p:cNvPr id="7" name="TextBox 6"/>
@@ -4863,8 +4841,8 @@
         </p:nvSpPr>
         <p:spPr>
           <a:xfrm>
-            <a:off x="868680" y="2130552"/>
-            <a:ext cx="6035040" cy="457200"/>
+            <a:off x="7223760" y="1828800"/>
+            <a:ext cx="4572000" cy="4389120"/>
           </a:xfrm>
           <a:prstGeom prst="rect">
             <a:avLst/>
@@ -4879,11 +4857,11 @@
           <a:p>
             <a:pPr algn="l">
               <a:spcAft>
-                <a:spcPts val="400"/>
-              </a:spcAft>
-            </a:pPr>
-            <a:r>
-              <a:rPr sz="1700" b="0">
+                <a:spcPts val="800"/>
+              </a:spcAft>
+            </a:pPr>
+            <a:r>
+              <a:rPr sz="1500" b="1">
                 <a:solidFill>
                   <a:srgbClr val="1A2333"/>
                 </a:solidFill>
@@ -4891,7 +4869,151 @@
                 <a:ea typeface="微软雅黑"/>
                 <a:cs typeface="微软雅黑"/>
               </a:rPr>
-              <a:t>能量感知规划改变路径</a:t>
+              <a:t>消融每个节点 → 去掉会怎样:</a:t>
+            </a:r>
+          </a:p>
+          <a:p>
+            <a:pPr algn="l">
+              <a:spcAft>
+                <a:spcPts val="800"/>
+              </a:spcAft>
+            </a:pPr>
+            <a:r>
+              <a:rPr sz="1400" b="0">
+                <a:solidFill>
+                  <a:srgbClr val="1A2333"/>
+                </a:solidFill>
+                <a:latin typeface="微软雅黑"/>
+                <a:ea typeface="微软雅黑"/>
+                <a:cs typeface="微软雅黑"/>
+              </a:rPr>
+              <a:t>· 评测器→只报训练误差:探针可刷分</a:t>
+            </a:r>
+          </a:p>
+          <a:p>
+            <a:pPr algn="l">
+              <a:spcAft>
+                <a:spcPts val="800"/>
+              </a:spcAft>
+            </a:pPr>
+            <a:r>
+              <a:rPr sz="1400" b="1">
+                <a:solidFill>
+                  <a:srgbClr val="C0502D"/>
+                </a:solidFill>
+                <a:latin typeface="微软雅黑"/>
+                <a:ea typeface="微软雅黑"/>
+                <a:cs typeface="微软雅黑"/>
+              </a:rPr>
+              <a:t>· 外搜→只搜物理形:困 4.2% 盆地</a:t>
+            </a:r>
+          </a:p>
+          <a:p>
+            <a:pPr algn="l">
+              <a:spcAft>
+                <a:spcPts val="800"/>
+              </a:spcAft>
+            </a:pPr>
+            <a:r>
+              <a:rPr sz="1400" b="0">
+                <a:solidFill>
+                  <a:srgbClr val="1A2333"/>
+                </a:solidFill>
+                <a:latin typeface="微软雅黑"/>
+                <a:ea typeface="微软雅黑"/>
+                <a:cs typeface="微软雅黑"/>
+              </a:rPr>
+              <a:t>· 查新门→H1/H3 当发现(实为 prior art)</a:t>
+            </a:r>
+          </a:p>
+          <a:p>
+            <a:pPr algn="l">
+              <a:spcAft>
+                <a:spcPts val="800"/>
+              </a:spcAft>
+            </a:pPr>
+            <a:r>
+              <a:rPr sz="1400" b="0">
+                <a:solidFill>
+                  <a:srgbClr val="1A2333"/>
+                </a:solidFill>
+                <a:latin typeface="微软雅黑"/>
+                <a:ea typeface="微软雅黑"/>
+                <a:cs typeface="微软雅黑"/>
+              </a:rPr>
+              <a:t>· 因果消融→证不了爬升是唯一因</a:t>
+            </a:r>
+          </a:p>
+          <a:p>
+            <a:pPr algn="l">
+              <a:spcAft>
+                <a:spcPts val="800"/>
+              </a:spcAft>
+            </a:pPr>
+            <a:r>
+              <a:rPr sz="1400" b="0">
+                <a:solidFill>
+                  <a:srgbClr val="1A2333"/>
+                </a:solidFill>
+                <a:latin typeface="微软雅黑"/>
+                <a:ea typeface="微软雅黑"/>
+                <a:cs typeface="微软雅黑"/>
+              </a:rPr>
+              <a:t>· 交叉模型→循环(BEMT尺下反贵)</a:t>
+            </a:r>
+          </a:p>
+          <a:p>
+            <a:pPr algn="l">
+              <a:spcAft>
+                <a:spcPts val="800"/>
+              </a:spcAft>
+            </a:pPr>
+            <a:r>
+              <a:rPr sz="1400" b="0">
+                <a:solidFill>
+                  <a:srgbClr val="1A2333"/>
+                </a:solidFill>
+                <a:latin typeface="微软雅黑"/>
+                <a:ea typeface="微软雅黑"/>
+                <a:cs typeface="微软雅黑"/>
+              </a:rPr>
+              <a:t>· 报负结果→漏 loop≈随机/载荷死路</a:t>
+            </a:r>
+          </a:p>
+          <a:p>
+            <a:pPr algn="l">
+              <a:spcAft>
+                <a:spcPts val="800"/>
+              </a:spcAft>
+            </a:pPr>
+            <a:r>
+              <a:rPr sz="1400" b="0">
+                <a:solidFill>
+                  <a:srgbClr val="6B7A8D"/>
+                </a:solidFill>
+                <a:latin typeface="微软雅黑"/>
+                <a:ea typeface="微软雅黑"/>
+                <a:cs typeface="微软雅黑"/>
+              </a:rPr>
+              <a:t>左图:只搜物理形困局部最优,</a:t>
+            </a:r>
+          </a:p>
+          <a:p>
+            <a:pPr algn="l">
+              <a:spcAft>
+                <a:spcPts val="800"/>
+              </a:spcAft>
+            </a:pPr>
+            <a:r>
+              <a:rPr sz="1400" b="0">
+                <a:solidFill>
+                  <a:srgbClr val="6B7A8D"/>
+                </a:solidFill>
+                <a:latin typeface="微软雅黑"/>
+                <a:ea typeface="微软雅黑"/>
+                <a:cs typeface="微软雅黑"/>
+              </a:rPr>
+              <a:t>外搜识别加线性payload才突破1.9%</a:t>
             </a:r>
           </a:p>
         </p:txBody>
@@ -4904,8 +5026,8 @@
         </p:nvSpPr>
         <p:spPr>
           <a:xfrm>
-            <a:off x="7040880" y="2130552"/>
-            <a:ext cx="4480560" cy="457200"/>
+            <a:off x="502920" y="6400800"/>
+            <a:ext cx="11155680" cy="320040"/>
           </a:xfrm>
           <a:prstGeom prst="rect">
             <a:avLst/>
@@ -4924,564 +5046,15 @@
               </a:spcAft>
             </a:pPr>
             <a:r>
-              <a:rPr sz="1500" b="1">
-                <a:solidFill>
-                  <a:srgbClr val="0563C1"/>
-                </a:solidFill>
-                <a:latin typeface="微软雅黑"/>
-                <a:ea typeface="微软雅黑"/>
-                <a:cs typeface="微软雅黑"/>
-              </a:rPr>
-              <a:t>EcoFlight (2025)</a:t>
-            </a:r>
-          </a:p>
-        </p:txBody>
-      </p:sp>
-      <p:sp>
-        <p:nvSpPr>
-          <p:cNvPr id="9" name="Rectangle 8"/>
-          <p:cNvSpPr/>
-          <p:nvPr/>
-        </p:nvSpPr>
-        <p:spPr>
-          <a:xfrm>
-            <a:off x="640080" y="2743200"/>
-            <a:ext cx="10972800" cy="658368"/>
-          </a:xfrm>
-          <a:prstGeom prst="rect">
-            <a:avLst/>
-          </a:prstGeom>
-          <a:solidFill>
-            <a:srgbClr val="FFFFFF"/>
-          </a:solidFill>
-          <a:ln w="6350">
-            <a:solidFill>
-              <a:srgbClr val="DDE3E8"/>
-            </a:solidFill>
-          </a:ln>
-        </p:spPr>
-        <p:style>
-          <a:lnRef idx="1">
-            <a:schemeClr val="accent1"/>
-          </a:lnRef>
-          <a:fillRef idx="3">
-            <a:schemeClr val="accent1"/>
-          </a:fillRef>
-          <a:effectRef idx="2">
-            <a:schemeClr val="accent1"/>
-          </a:effectRef>
-          <a:fontRef idx="minor">
-            <a:schemeClr val="lt1"/>
-          </a:fontRef>
-        </p:style>
-        <p:txBody>
-          <a:bodyPr rtlCol="0" anchor="ctr"/>
-          <a:lstStyle/>
-          <a:p>
-            <a:pPr algn="ctr"/>
-          </a:p>
-        </p:txBody>
-      </p:sp>
-      <p:sp>
-        <p:nvSpPr>
-          <p:cNvPr id="10" name="TextBox 9"/>
-          <p:cNvSpPr txBox="1"/>
-          <p:nvPr/>
-        </p:nvSpPr>
-        <p:spPr>
-          <a:xfrm>
-            <a:off x="868680" y="2862072"/>
-            <a:ext cx="6035040" cy="457200"/>
-          </a:xfrm>
-          <a:prstGeom prst="rect">
-            <a:avLst/>
-          </a:prstGeom>
-          <a:noFill/>
-        </p:spPr>
-        <p:txBody>
-          <a:bodyPr wrap="square" anchor="t" lIns="25400" rIns="25400" tIns="25400" bIns="25400">
-            <a:spAutoFit/>
-          </a:bodyPr>
-          <a:lstStyle/>
-          <a:p>
-            <a:pPr algn="l">
-              <a:spcAft>
-                <a:spcPts val="400"/>
-              </a:spcAft>
-            </a:pPr>
-            <a:r>
-              <a:rPr sz="1700" b="0">
-                <a:solidFill>
-                  <a:srgbClr val="1A2333"/>
-                </a:solidFill>
-                <a:latin typeface="微软雅黑"/>
-                <a:ea typeface="微软雅黑"/>
-                <a:cs typeface="微软雅黑"/>
-              </a:rPr>
-              <a:t>配送顺序因爬降不对称翻转</a:t>
-            </a:r>
-          </a:p>
-        </p:txBody>
-      </p:sp>
-      <p:sp>
-        <p:nvSpPr>
-          <p:cNvPr id="11" name="TextBox 10"/>
-          <p:cNvSpPr txBox="1"/>
-          <p:nvPr/>
-        </p:nvSpPr>
-        <p:spPr>
-          <a:xfrm>
-            <a:off x="7040880" y="2862072"/>
-            <a:ext cx="4480560" cy="457200"/>
-          </a:xfrm>
-          <a:prstGeom prst="rect">
-            <a:avLst/>
-          </a:prstGeom>
-          <a:noFill/>
-        </p:spPr>
-        <p:txBody>
-          <a:bodyPr wrap="square" anchor="t" lIns="25400" rIns="25400" tIns="25400" bIns="25400">
-            <a:spAutoFit/>
-          </a:bodyPr>
-          <a:lstStyle/>
-          <a:p>
-            <a:pPr algn="l">
-              <a:spcAft>
-                <a:spcPts val="400"/>
-              </a:spcAft>
-            </a:pPr>
-            <a:r>
-              <a:rPr sz="1500" b="1">
-                <a:solidFill>
-                  <a:srgbClr val="0563C1"/>
-                </a:solidFill>
-                <a:latin typeface="微软雅黑"/>
-                <a:ea typeface="微软雅黑"/>
-                <a:cs typeface="微软雅黑"/>
-              </a:rPr>
-              <a:t>Michel et al. 2024, arXiv 2410.17585</a:t>
-            </a:r>
-          </a:p>
-        </p:txBody>
-      </p:sp>
-      <p:sp>
-        <p:nvSpPr>
-          <p:cNvPr id="12" name="Rectangle 11"/>
-          <p:cNvSpPr/>
-          <p:nvPr/>
-        </p:nvSpPr>
-        <p:spPr>
-          <a:xfrm>
-            <a:off x="640080" y="3474720"/>
-            <a:ext cx="10972800" cy="658368"/>
-          </a:xfrm>
-          <a:prstGeom prst="rect">
-            <a:avLst/>
-          </a:prstGeom>
-          <a:solidFill>
-            <a:srgbClr val="EEF4F7"/>
-          </a:solidFill>
-          <a:ln w="6350">
-            <a:solidFill>
-              <a:srgbClr val="DDE3E8"/>
-            </a:solidFill>
-          </a:ln>
-        </p:spPr>
-        <p:style>
-          <a:lnRef idx="1">
-            <a:schemeClr val="accent1"/>
-          </a:lnRef>
-          <a:fillRef idx="3">
-            <a:schemeClr val="accent1"/>
-          </a:fillRef>
-          <a:effectRef idx="2">
-            <a:schemeClr val="accent1"/>
-          </a:effectRef>
-          <a:fontRef idx="minor">
-            <a:schemeClr val="lt1"/>
-          </a:fontRef>
-        </p:style>
-        <p:txBody>
-          <a:bodyPr rtlCol="0" anchor="ctr"/>
-          <a:lstStyle/>
-          <a:p>
-            <a:pPr algn="ctr"/>
-          </a:p>
-        </p:txBody>
-      </p:sp>
-      <p:sp>
-        <p:nvSpPr>
-          <p:cNvPr id="13" name="TextBox 12"/>
-          <p:cNvSpPr txBox="1"/>
-          <p:nvPr/>
-        </p:nvSpPr>
-        <p:spPr>
-          <a:xfrm>
-            <a:off x="868680" y="3593592"/>
-            <a:ext cx="6035040" cy="457200"/>
-          </a:xfrm>
-          <a:prstGeom prst="rect">
-            <a:avLst/>
-          </a:prstGeom>
-          <a:noFill/>
-        </p:spPr>
-        <p:txBody>
-          <a:bodyPr wrap="square" anchor="t" lIns="25400" rIns="25400" tIns="25400" bIns="25400">
-            <a:spAutoFit/>
-          </a:bodyPr>
-          <a:lstStyle/>
-          <a:p>
-            <a:pPr algn="l">
-              <a:spcAft>
-                <a:spcPts val="400"/>
-              </a:spcAft>
-            </a:pPr>
-            <a:r>
-              <a:rPr sz="1700" b="0">
-                <a:solidFill>
-                  <a:srgbClr val="1A2333"/>
-                </a:solidFill>
-                <a:latin typeface="微软雅黑"/>
-                <a:ea typeface="微软雅黑"/>
-                <a:cs typeface="微软雅黑"/>
-              </a:rPr>
-              <a:t>电池约束下可达集扩大</a:t>
-            </a:r>
-          </a:p>
-        </p:txBody>
-      </p:sp>
-      <p:sp>
-        <p:nvSpPr>
-          <p:cNvPr id="14" name="TextBox 13"/>
-          <p:cNvSpPr txBox="1"/>
-          <p:nvPr/>
-        </p:nvSpPr>
-        <p:spPr>
-          <a:xfrm>
-            <a:off x="7040880" y="3593592"/>
-            <a:ext cx="4480560" cy="457200"/>
-          </a:xfrm>
-          <a:prstGeom prst="rect">
-            <a:avLst/>
-          </a:prstGeom>
-          <a:noFill/>
-        </p:spPr>
-        <p:txBody>
-          <a:bodyPr wrap="square" anchor="t" lIns="25400" rIns="25400" tIns="25400" bIns="25400">
-            <a:spAutoFit/>
-          </a:bodyPr>
-          <a:lstStyle/>
-          <a:p>
-            <a:pPr algn="l">
-              <a:spcAft>
-                <a:spcPts val="400"/>
-              </a:spcAft>
-            </a:pPr>
-            <a:r>
-              <a:rPr sz="1500" b="1">
-                <a:solidFill>
-                  <a:srgbClr val="0563C1"/>
-                </a:solidFill>
-                <a:latin typeface="微软雅黑"/>
-                <a:ea typeface="微软雅黑"/>
-                <a:cs typeface="微软雅黑"/>
-              </a:rPr>
-              <a:t>Nguyen &amp; Au, AAMAS 2017</a:t>
-            </a:r>
-          </a:p>
-        </p:txBody>
-      </p:sp>
-      <p:sp>
-        <p:nvSpPr>
-          <p:cNvPr id="15" name="Rectangle 14"/>
-          <p:cNvSpPr/>
-          <p:nvPr/>
-        </p:nvSpPr>
-        <p:spPr>
-          <a:xfrm>
-            <a:off x="640080" y="4206240"/>
-            <a:ext cx="10972800" cy="658368"/>
-          </a:xfrm>
-          <a:prstGeom prst="rect">
-            <a:avLst/>
-          </a:prstGeom>
-          <a:solidFill>
-            <a:srgbClr val="FFFFFF"/>
-          </a:solidFill>
-          <a:ln w="6350">
-            <a:solidFill>
-              <a:srgbClr val="DDE3E8"/>
-            </a:solidFill>
-          </a:ln>
-        </p:spPr>
-        <p:style>
-          <a:lnRef idx="1">
-            <a:schemeClr val="accent1"/>
-          </a:lnRef>
-          <a:fillRef idx="3">
-            <a:schemeClr val="accent1"/>
-          </a:fillRef>
-          <a:effectRef idx="2">
-            <a:schemeClr val="accent1"/>
-          </a:effectRef>
-          <a:fontRef idx="minor">
-            <a:schemeClr val="lt1"/>
-          </a:fontRef>
-        </p:style>
-        <p:txBody>
-          <a:bodyPr rtlCol="0" anchor="ctr"/>
-          <a:lstStyle/>
-          <a:p>
-            <a:pPr algn="ctr"/>
-          </a:p>
-        </p:txBody>
-      </p:sp>
-      <p:sp>
-        <p:nvSpPr>
-          <p:cNvPr id="16" name="TextBox 15"/>
-          <p:cNvSpPr txBox="1"/>
-          <p:nvPr/>
-        </p:nvSpPr>
-        <p:spPr>
-          <a:xfrm>
-            <a:off x="868680" y="4325112"/>
-            <a:ext cx="6035040" cy="457200"/>
-          </a:xfrm>
-          <a:prstGeom prst="rect">
-            <a:avLst/>
-          </a:prstGeom>
-          <a:noFill/>
-        </p:spPr>
-        <p:txBody>
-          <a:bodyPr wrap="square" anchor="t" lIns="25400" rIns="25400" tIns="25400" bIns="25400">
-            <a:spAutoFit/>
-          </a:bodyPr>
-          <a:lstStyle/>
-          <a:p>
-            <a:pPr algn="l">
-              <a:spcAft>
-                <a:spcPts val="400"/>
-              </a:spcAft>
-            </a:pPr>
-            <a:r>
-              <a:rPr sz="1700" b="0">
-                <a:solidFill>
-                  <a:srgbClr val="1A2333"/>
-                </a:solidFill>
-                <a:latin typeface="微软雅黑"/>
-                <a:ea typeface="微软雅黑"/>
-                <a:cs typeface="微软雅黑"/>
-              </a:rPr>
-              <a:t>载荷影响爬升 vs 绕行</a:t>
-            </a:r>
-          </a:p>
-        </p:txBody>
-      </p:sp>
-      <p:sp>
-        <p:nvSpPr>
-          <p:cNvPr id="17" name="TextBox 16"/>
-          <p:cNvSpPr txBox="1"/>
-          <p:nvPr/>
-        </p:nvSpPr>
-        <p:spPr>
-          <a:xfrm>
-            <a:off x="7040880" y="4325112"/>
-            <a:ext cx="4480560" cy="457200"/>
-          </a:xfrm>
-          <a:prstGeom prst="rect">
-            <a:avLst/>
-          </a:prstGeom>
-          <a:noFill/>
-        </p:spPr>
-        <p:txBody>
-          <a:bodyPr wrap="square" anchor="t" lIns="25400" rIns="25400" tIns="25400" bIns="25400">
-            <a:spAutoFit/>
-          </a:bodyPr>
-          <a:lstStyle/>
-          <a:p>
-            <a:pPr algn="l">
-              <a:spcAft>
-                <a:spcPts val="400"/>
-              </a:spcAft>
-            </a:pPr>
-            <a:r>
-              <a:rPr sz="1500" b="1">
-                <a:solidFill>
-                  <a:srgbClr val="0563C1"/>
-                </a:solidFill>
-                <a:latin typeface="微软雅黑"/>
-                <a:ea typeface="微软雅黑"/>
-                <a:cs typeface="微软雅黑"/>
-              </a:rPr>
-              <a:t>EcoFlight / 物流 UAV, Drones 2025</a:t>
-            </a:r>
-          </a:p>
-        </p:txBody>
-      </p:sp>
-      <p:sp>
-        <p:nvSpPr>
-          <p:cNvPr id="18" name="Rectangle 17"/>
-          <p:cNvSpPr/>
-          <p:nvPr/>
-        </p:nvSpPr>
-        <p:spPr>
-          <a:xfrm>
-            <a:off x="640080" y="4937760"/>
-            <a:ext cx="10972800" cy="658368"/>
-          </a:xfrm>
-          <a:prstGeom prst="rect">
-            <a:avLst/>
-          </a:prstGeom>
-          <a:solidFill>
-            <a:srgbClr val="EEF4F7"/>
-          </a:solidFill>
-          <a:ln w="6350">
-            <a:solidFill>
-              <a:srgbClr val="DDE3E8"/>
-            </a:solidFill>
-          </a:ln>
-        </p:spPr>
-        <p:style>
-          <a:lnRef idx="1">
-            <a:schemeClr val="accent1"/>
-          </a:lnRef>
-          <a:fillRef idx="3">
-            <a:schemeClr val="accent1"/>
-          </a:fillRef>
-          <a:effectRef idx="2">
-            <a:schemeClr val="accent1"/>
-          </a:effectRef>
-          <a:fontRef idx="minor">
-            <a:schemeClr val="lt1"/>
-          </a:fontRef>
-        </p:style>
-        <p:txBody>
-          <a:bodyPr rtlCol="0" anchor="ctr"/>
-          <a:lstStyle/>
-          <a:p>
-            <a:pPr algn="ctr"/>
-          </a:p>
-        </p:txBody>
-      </p:sp>
-      <p:sp>
-        <p:nvSpPr>
-          <p:cNvPr id="19" name="TextBox 18"/>
-          <p:cNvSpPr txBox="1"/>
-          <p:nvPr/>
-        </p:nvSpPr>
-        <p:spPr>
-          <a:xfrm>
-            <a:off x="868680" y="5056632"/>
-            <a:ext cx="6035040" cy="457200"/>
-          </a:xfrm>
-          <a:prstGeom prst="rect">
-            <a:avLst/>
-          </a:prstGeom>
-          <a:noFill/>
-        </p:spPr>
-        <p:txBody>
-          <a:bodyPr wrap="square" anchor="t" lIns="25400" rIns="25400" tIns="25400" bIns="25400">
-            <a:spAutoFit/>
-          </a:bodyPr>
-          <a:lstStyle/>
-          <a:p>
-            <a:pPr algn="l">
-              <a:spcAft>
-                <a:spcPts val="400"/>
-              </a:spcAft>
-            </a:pPr>
-            <a:r>
-              <a:rPr sz="1700" b="0">
-                <a:solidFill>
-                  <a:srgbClr val="1A2333"/>
-                </a:solidFill>
-                <a:latin typeface="微软雅黑"/>
-                <a:ea typeface="微软雅黑"/>
-                <a:cs typeface="微软雅黑"/>
-              </a:rPr>
-              <a:t>M100 能耗建模 / v* / 爬降不对称</a:t>
-            </a:r>
-          </a:p>
-        </p:txBody>
-      </p:sp>
-      <p:sp>
-        <p:nvSpPr>
-          <p:cNvPr id="20" name="TextBox 19"/>
-          <p:cNvSpPr txBox="1"/>
-          <p:nvPr/>
-        </p:nvSpPr>
-        <p:spPr>
-          <a:xfrm>
-            <a:off x="7040880" y="5056632"/>
-            <a:ext cx="4480560" cy="457200"/>
-          </a:xfrm>
-          <a:prstGeom prst="rect">
-            <a:avLst/>
-          </a:prstGeom>
-          <a:noFill/>
-        </p:spPr>
-        <p:txBody>
-          <a:bodyPr wrap="square" anchor="t" lIns="25400" rIns="25400" tIns="25400" bIns="25400">
-            <a:spAutoFit/>
-          </a:bodyPr>
-          <a:lstStyle/>
-          <a:p>
-            <a:pPr algn="l">
-              <a:spcAft>
-                <a:spcPts val="400"/>
-              </a:spcAft>
-            </a:pPr>
-            <a:r>
-              <a:rPr sz="1500" b="1">
-                <a:solidFill>
-                  <a:srgbClr val="0563C1"/>
-                </a:solidFill>
-                <a:latin typeface="微软雅黑"/>
-                <a:ea typeface="微软雅黑"/>
-                <a:cs typeface="微软雅黑"/>
-              </a:rPr>
-              <a:t>Dai;Di Franco 2015;Liu 2017</a:t>
-            </a:r>
-          </a:p>
-        </p:txBody>
-      </p:sp>
-      <p:sp>
-        <p:nvSpPr>
-          <p:cNvPr id="21" name="TextBox 20"/>
-          <p:cNvSpPr txBox="1"/>
-          <p:nvPr/>
-        </p:nvSpPr>
-        <p:spPr>
-          <a:xfrm>
-            <a:off x="640080" y="5943600"/>
-            <a:ext cx="10972800" cy="457200"/>
-          </a:xfrm>
-          <a:prstGeom prst="rect">
-            <a:avLst/>
-          </a:prstGeom>
-          <a:noFill/>
-        </p:spPr>
-        <p:txBody>
-          <a:bodyPr wrap="square" anchor="t" lIns="25400" rIns="25400" tIns="25400" bIns="25400">
-            <a:spAutoFit/>
-          </a:bodyPr>
-          <a:lstStyle/>
-          <a:p>
-            <a:pPr algn="l">
-              <a:spcAft>
-                <a:spcPts val="400"/>
-              </a:spcAft>
-            </a:pPr>
-            <a:r>
-              <a:rPr sz="1600" b="1">
-                <a:solidFill>
-                  <a:srgbClr val="C0502D"/>
-                </a:solidFill>
-                <a:latin typeface="微软雅黑"/>
-                <a:ea typeface="微软雅黑"/>
-                <a:cs typeface="微软雅黑"/>
-              </a:rPr>
-              <a:t>→ 我们主动引用、不声称首创。查新门拦住了把“复现”当“发现”。</a:t>
+              <a:rPr sz="1100" b="0">
+                <a:solidFill>
+                  <a:srgbClr val="6B7A8D"/>
+                </a:solidFill>
+                <a:latin typeface="微软雅黑"/>
+                <a:ea typeface="微软雅黑"/>
+                <a:cs typeface="微软雅黑"/>
+              </a:rPr>
+              <a:t>framework_ablation.py / safeguard_ablation.py(每节点一个可复现消融)</a:t>
             </a:r>
           </a:p>
         </p:txBody>
@@ -5686,14 +5259,14 @@
                 <a:ea typeface="微软雅黑"/>
                 <a:cs typeface="微软雅黑"/>
               </a:rPr>
-              <a:t>框架每个节点都“承重”:去掉它,loop 就退化或自欺</a:t>
+              <a:t>性能被数据噪声封顶:52 项模型也压不下 6 项——不是方法不足</a:t>
             </a:r>
           </a:p>
         </p:txBody>
       </p:sp>
       <p:pic>
         <p:nvPicPr>
-          <p:cNvPr id="6" name="Picture 5" descr="框架消融_局部最优.png"/>
+          <p:cNvPr id="6" name="Picture 5" descr="噪声地板.png"/>
           <p:cNvPicPr>
             <a:picLocks noChangeAspect="1"/>
           </p:cNvPicPr>
@@ -5707,8 +5280,8 @@
         </p:blipFill>
         <p:spPr>
           <a:xfrm>
-            <a:off x="457200" y="2230429"/>
-            <a:ext cx="6583680" cy="3402982"/>
+            <a:off x="1906341" y="1828800"/>
+            <a:ext cx="5056998" cy="4114800"/>
           </a:xfrm>
           <a:prstGeom prst="rect">
             <a:avLst/>
@@ -5723,8 +5296,8 @@
         </p:nvSpPr>
         <p:spPr>
           <a:xfrm>
-            <a:off x="7223760" y="1828800"/>
-            <a:ext cx="4572000" cy="4389120"/>
+            <a:off x="8595360" y="1920240"/>
+            <a:ext cx="3200400" cy="4206240"/>
           </a:xfrm>
           <a:prstGeom prst="rect">
             <a:avLst/>
@@ -5739,11 +5312,11 @@
           <a:p>
             <a:pPr algn="l">
               <a:spcAft>
-                <a:spcPts val="800"/>
-              </a:spcAft>
-            </a:pPr>
-            <a:r>
-              <a:rPr sz="1500" b="1">
+                <a:spcPts val="1200"/>
+              </a:spcAft>
+            </a:pPr>
+            <a:r>
+              <a:rPr sz="1600" b="0">
                 <a:solidFill>
                   <a:srgbClr val="1A2333"/>
                 </a:solidFill>
@@ -5751,17 +5324,17 @@
                 <a:ea typeface="微软雅黑"/>
                 <a:cs typeface="微软雅黑"/>
               </a:rPr>
-              <a:t>消融每个节点 → 去掉会怎样:</a:t>
-            </a:r>
-          </a:p>
-          <a:p>
-            <a:pPr algn="l">
-              <a:spcAft>
-                <a:spcPts val="800"/>
-              </a:spcAft>
-            </a:pPr>
-            <a:r>
-              <a:rPr sz="1400" b="0">
+              <a:t>· held-out 6 项即触底 1.88%</a:t>
+            </a:r>
+          </a:p>
+          <a:p>
+            <a:pPr algn="l">
+              <a:spcAft>
+                <a:spcPts val="1200"/>
+              </a:spcAft>
+            </a:pPr>
+            <a:r>
+              <a:rPr sz="1600" b="0">
                 <a:solidFill>
                   <a:srgbClr val="1A2333"/>
                 </a:solidFill>
@@ -5769,35 +5342,35 @@
                 <a:ea typeface="微软雅黑"/>
                 <a:cs typeface="微软雅黑"/>
               </a:rPr>
-              <a:t>· 评测器→只报训练误差:探针可刷分</a:t>
-            </a:r>
-          </a:p>
-          <a:p>
-            <a:pPr algn="l">
-              <a:spcAft>
-                <a:spcPts val="800"/>
-              </a:spcAft>
-            </a:pPr>
-            <a:r>
-              <a:rPr sz="1400" b="1">
-                <a:solidFill>
-                  <a:srgbClr val="C0502D"/>
-                </a:solidFill>
-                <a:latin typeface="微软雅黑"/>
-                <a:ea typeface="微软雅黑"/>
-                <a:cs typeface="微软雅黑"/>
-              </a:rPr>
-              <a:t>· 外搜→只搜物理形:困 4.2% 盆地</a:t>
-            </a:r>
-          </a:p>
-          <a:p>
-            <a:pPr algn="l">
-              <a:spcAft>
-                <a:spcPts val="800"/>
-              </a:spcAft>
-            </a:pPr>
-            <a:r>
-              <a:rPr sz="1400" b="0">
+              <a:t>· 加到 12/20/52 项不降反升</a:t>
+            </a:r>
+          </a:p>
+          <a:p>
+            <a:pPr algn="l">
+              <a:spcAft>
+                <a:spcPts val="1200"/>
+              </a:spcAft>
+            </a:pPr>
+            <a:r>
+              <a:rPr sz="1600" b="1">
+                <a:solidFill>
+                  <a:srgbClr val="5B9BD5"/>
+                </a:solidFill>
+                <a:latin typeface="微软雅黑"/>
+                <a:ea typeface="微软雅黑"/>
+                <a:cs typeface="微软雅黑"/>
+              </a:rPr>
+              <a:t>· 4 种方法殊途同归 ~1.9%</a:t>
+            </a:r>
+          </a:p>
+          <a:p>
+            <a:pPr algn="l">
+              <a:spcAft>
+                <a:spcPts val="1200"/>
+              </a:spcAft>
+            </a:pPr>
+            <a:r>
+              <a:rPr sz="1500" b="0">
                 <a:solidFill>
                   <a:srgbClr val="1A2333"/>
                 </a:solidFill>
@@ -5805,97 +5378,25 @@
                 <a:ea typeface="微软雅黑"/>
                 <a:cs typeface="微软雅黑"/>
               </a:rPr>
-              <a:t>· 查新门→H1/H3 当发现(实为 prior art)</a:t>
-            </a:r>
-          </a:p>
-          <a:p>
-            <a:pPr algn="l">
-              <a:spcAft>
-                <a:spcPts val="800"/>
-              </a:spcAft>
-            </a:pPr>
-            <a:r>
-              <a:rPr sz="1400" b="0">
-                <a:solidFill>
-                  <a:srgbClr val="1A2333"/>
-                </a:solidFill>
-                <a:latin typeface="微软雅黑"/>
-                <a:ea typeface="微软雅黑"/>
-                <a:cs typeface="微软雅黑"/>
-              </a:rPr>
-              <a:t>· 因果消融→证不了爬升是唯一因</a:t>
-            </a:r>
-          </a:p>
-          <a:p>
-            <a:pPr algn="l">
-              <a:spcAft>
-                <a:spcPts val="800"/>
-              </a:spcAft>
-            </a:pPr>
-            <a:r>
-              <a:rPr sz="1400" b="0">
-                <a:solidFill>
-                  <a:srgbClr val="1A2333"/>
-                </a:solidFill>
-                <a:latin typeface="微软雅黑"/>
-                <a:ea typeface="微软雅黑"/>
-                <a:cs typeface="微软雅黑"/>
-              </a:rPr>
-              <a:t>· 交叉模型→循环(BEMT尺下反贵)</a:t>
-            </a:r>
-          </a:p>
-          <a:p>
-            <a:pPr algn="l">
-              <a:spcAft>
-                <a:spcPts val="800"/>
-              </a:spcAft>
-            </a:pPr>
-            <a:r>
-              <a:rPr sz="1400" b="0">
-                <a:solidFill>
-                  <a:srgbClr val="1A2333"/>
-                </a:solidFill>
-                <a:latin typeface="微软雅黑"/>
-                <a:ea typeface="微软雅黑"/>
-                <a:cs typeface="微软雅黑"/>
-              </a:rPr>
-              <a:t>· 报负结果→漏 loop≈随机/载荷死路</a:t>
-            </a:r>
-          </a:p>
-          <a:p>
-            <a:pPr algn="l">
-              <a:spcAft>
-                <a:spcPts val="800"/>
-              </a:spcAft>
-            </a:pPr>
-            <a:r>
-              <a:rPr sz="1400" b="0">
-                <a:solidFill>
-                  <a:srgbClr val="6B7A8D"/>
-                </a:solidFill>
-                <a:latin typeface="微软雅黑"/>
-                <a:ea typeface="微软雅黑"/>
-                <a:cs typeface="微软雅黑"/>
-              </a:rPr>
-              <a:t>左图:只搜物理形困局部最优,</a:t>
-            </a:r>
-          </a:p>
-          <a:p>
-            <a:pPr algn="l">
-              <a:spcAft>
-                <a:spcPts val="800"/>
-              </a:spcAft>
-            </a:pPr>
-            <a:r>
-              <a:rPr sz="1400" b="0">
-                <a:solidFill>
-                  <a:srgbClr val="6B7A8D"/>
-                </a:solidFill>
-                <a:latin typeface="微软雅黑"/>
-                <a:ea typeface="微软雅黑"/>
-                <a:cs typeface="微软雅黑"/>
-              </a:rPr>
-              <a:t>外搜识别加线性payload才突破1.9%</a:t>
+              <a:t>· 运动学只解释 &lt;40% 瞬时功率</a:t>
+            </a:r>
+          </a:p>
+          <a:p>
+            <a:pPr algn="l">
+              <a:spcAft>
+                <a:spcPts val="1200"/>
+              </a:spcAft>
+            </a:pPr>
+            <a:r>
+              <a:rPr sz="1600" b="1">
+                <a:solidFill>
+                  <a:srgbClr val="0563C1"/>
+                </a:solidFill>
+                <a:latin typeface="微软雅黑"/>
+                <a:ea typeface="微软雅黑"/>
+                <a:cs typeface="微软雅黑"/>
+              </a:rPr>
+              <a:t>“数据封顶”从主张变测量</a:t>
             </a:r>
           </a:p>
         </p:txBody>
@@ -5936,7 +5437,7 @@
                 <a:ea typeface="微软雅黑"/>
                 <a:cs typeface="微软雅黑"/>
               </a:rPr>
-              <a:t>framework_ablation.py / safeguard_ablation.py(每节点一个可复现消融)</a:t>
+              <a:t>domain_value.py;对标 Tseng 多项式(数据集既定最优)</a:t>
             </a:r>
           </a:p>
         </p:txBody>
@@ -6141,14 +5642,14 @@
                 <a:ea typeface="微软雅黑"/>
                 <a:cs typeface="微软雅黑"/>
               </a:rPr>
-              <a:t>性能被数据噪声封顶:52 项模型也压不下 6 项——不是方法不足</a:t>
+              <a:t>同框架:有改进空间的域显著胜随机,噪声封顶的域统计打平</a:t>
             </a:r>
           </a:p>
         </p:txBody>
       </p:sp>
       <p:pic>
         <p:nvPicPr>
-          <p:cNvPr id="6" name="Picture 5" descr="噪声地板.png"/>
+          <p:cNvPr id="6" name="Picture 5" descr="两域显著性.png"/>
           <p:cNvPicPr>
             <a:picLocks noChangeAspect="1"/>
           </p:cNvPicPr>
@@ -6162,8 +5663,8 @@
         </p:blipFill>
         <p:spPr>
           <a:xfrm>
-            <a:off x="1906341" y="1828800"/>
-            <a:ext cx="5056998" cy="4114800"/>
+            <a:off x="457200" y="2527503"/>
+            <a:ext cx="5760720" cy="2991714"/>
           </a:xfrm>
           <a:prstGeom prst="rect">
             <a:avLst/>
@@ -6178,8 +5679,8 @@
         </p:nvSpPr>
         <p:spPr>
           <a:xfrm>
-            <a:off x="8595360" y="1920240"/>
-            <a:ext cx="3200400" cy="4206240"/>
+            <a:off x="6309360" y="1920240"/>
+            <a:ext cx="5486400" cy="4389120"/>
           </a:xfrm>
           <a:prstGeom prst="rect">
             <a:avLst/>
@@ -6198,6 +5699,24 @@
               </a:spcAft>
             </a:pPr>
             <a:r>
+              <a:rPr sz="1700" b="1">
+                <a:solidFill>
+                  <a:srgbClr val="1A2333"/>
+                </a:solidFill>
+                <a:latin typeface="微软雅黑"/>
+                <a:ea typeface="微软雅黑"/>
+                <a:cs typeface="微软雅黑"/>
+              </a:rPr>
+              <a:t>能耗域(封顶):</a:t>
+            </a:r>
+          </a:p>
+          <a:p>
+            <a:pPr algn="l">
+              <a:spcAft>
+                <a:spcPts val="1200"/>
+              </a:spcAft>
+            </a:pPr>
+            <a:r>
               <a:rPr sz="1600" b="0">
                 <a:solidFill>
                   <a:srgbClr val="1A2333"/>
@@ -6206,7 +5725,7 @@
                 <a:ea typeface="微软雅黑"/>
                 <a:cs typeface="微软雅黑"/>
               </a:rPr>
-              <a:t>· held-out 6 项即触底 1.88%</a:t>
+              <a:t>  loop 1.86% vs 随机 1.87±0.03,z=−0.35</a:t>
             </a:r>
           </a:p>
           <a:p>
@@ -6224,7 +5743,7 @@
                 <a:ea typeface="微软雅黑"/>
                 <a:cs typeface="微软雅黑"/>
               </a:rPr>
-              <a:t>· 加到 12/20/52 项不降反升</a:t>
+              <a:t>  52% 随机更好 → 统计打平</a:t>
             </a:r>
           </a:p>
           <a:p>
@@ -6234,6 +5753,24 @@
               </a:spcAft>
             </a:pPr>
             <a:r>
+              <a:rPr sz="1700" b="1">
+                <a:solidFill>
+                  <a:srgbClr val="1A2333"/>
+                </a:solidFill>
+                <a:latin typeface="微软雅黑"/>
+                <a:ea typeface="微软雅黑"/>
+                <a:cs typeface="微软雅黑"/>
+              </a:rPr>
+              <a:t>规划器域(有 headroom):</a:t>
+            </a:r>
+          </a:p>
+          <a:p>
+            <a:pPr algn="l">
+              <a:spcAft>
+                <a:spcPts val="1200"/>
+              </a:spcAft>
+            </a:pPr>
+            <a:r>
               <a:rPr sz="1600" b="1">
                 <a:solidFill>
                   <a:srgbClr val="5B9BD5"/>
@@ -6242,7 +5779,7 @@
                 <a:ea typeface="微软雅黑"/>
                 <a:cs typeface="微软雅黑"/>
               </a:rPr>
-              <a:t>· 4 种方法殊途同归 ~1.9%</a:t>
+              <a:t>  loop 显著低于随机,z=−2.38</a:t>
             </a:r>
           </a:p>
           <a:p>
@@ -6252,7 +5789,7 @@
               </a:spcAft>
             </a:pPr>
             <a:r>
-              <a:rPr sz="1500" b="0">
+              <a:rPr sz="1600" b="0">
                 <a:solidFill>
                   <a:srgbClr val="1A2333"/>
                 </a:solidFill>
@@ -6260,7 +5797,7 @@
                 <a:ea typeface="微软雅黑"/>
                 <a:cs typeface="微软雅黑"/>
               </a:rPr>
-              <a:t>· 运动学只解释 &lt;40% 瞬时功率</a:t>
+              <a:t>  0% 随机更好 → 显著胜</a:t>
             </a:r>
           </a:p>
           <a:p>
@@ -6270,7 +5807,7 @@
               </a:spcAft>
             </a:pPr>
             <a:r>
-              <a:rPr sz="1600" b="1">
+              <a:rPr sz="1700" b="1">
                 <a:solidFill>
                   <a:srgbClr val="0563C1"/>
                 </a:solidFill>
@@ -6278,7 +5815,7 @@
                 <a:ea typeface="微软雅黑"/>
                 <a:cs typeface="微软雅黑"/>
               </a:rPr>
-              <a:t>“数据封顶”从主张变测量</a:t>
+              <a:t>→ 打平因任务简单,换复杂任务就赢随机</a:t>
             </a:r>
           </a:p>
         </p:txBody>
@@ -6319,7 +5856,7 @@
                 <a:ea typeface="微软雅黑"/>
                 <a:cs typeface="微软雅黑"/>
               </a:rPr>
-              <a:t>domain_value.py;对标 Tseng 多项式(数据集既定最优)</a:t>
+              <a:t>significance_test.py / planner_significance.py(随机分布 + z 检验)</a:t>
             </a:r>
           </a:p>
         </p:txBody>
@@ -6524,14 +6061,14 @@
                 <a:ea typeface="微软雅黑"/>
                 <a:cs typeface="微软雅黑"/>
               </a:rPr>
-              <a:t>同框架:有改进空间的域显著胜随机,噪声封顶的域统计打平</a:t>
+              <a:t>为什么打平?引导搜索的优势随搜索空间复杂度增长(文献规律)</a:t>
             </a:r>
           </a:p>
         </p:txBody>
       </p:sp>
       <p:pic>
         <p:nvPicPr>
-          <p:cNvPr id="6" name="Picture 5" descr="两域显著性.png"/>
+          <p:cNvPr id="6" name="Picture 5" descr="复杂度规律.png"/>
           <p:cNvPicPr>
             <a:picLocks noChangeAspect="1"/>
           </p:cNvPicPr>
@@ -6545,8 +6082,8 @@
         </p:blipFill>
         <p:spPr>
           <a:xfrm>
-            <a:off x="457200" y="2527503"/>
-            <a:ext cx="5760720" cy="2991714"/>
+            <a:off x="457200" y="2095384"/>
+            <a:ext cx="6766560" cy="3673072"/>
           </a:xfrm>
           <a:prstGeom prst="rect">
             <a:avLst/>
@@ -6561,8 +6098,8 @@
         </p:nvSpPr>
         <p:spPr>
           <a:xfrm>
-            <a:off x="6309360" y="1920240"/>
-            <a:ext cx="5486400" cy="4389120"/>
+            <a:off x="7406640" y="1920240"/>
+            <a:ext cx="4480560" cy="4389120"/>
           </a:xfrm>
           <a:prstGeom prst="rect">
             <a:avLst/>
@@ -6577,11 +6114,11 @@
           <a:p>
             <a:pPr algn="l">
               <a:spcAft>
-                <a:spcPts val="1200"/>
-              </a:spcAft>
-            </a:pPr>
-            <a:r>
-              <a:rPr sz="1700" b="1">
+                <a:spcPts val="900"/>
+              </a:spcAft>
+            </a:pPr>
+            <a:r>
+              <a:rPr sz="1600" b="1">
                 <a:solidFill>
                   <a:srgbClr val="1A2333"/>
                 </a:solidFill>
@@ -6589,17 +6126,17 @@
                 <a:ea typeface="微软雅黑"/>
                 <a:cs typeface="微软雅黑"/>
               </a:rPr>
-              <a:t>能耗域(封顶):</a:t>
-            </a:r>
-          </a:p>
-          <a:p>
-            <a:pPr algn="l">
-              <a:spcAft>
-                <a:spcPts val="1200"/>
-              </a:spcAft>
-            </a:pPr>
-            <a:r>
-              <a:rPr sz="1600" b="0">
+              <a:t>不是框架无能,是规律预测:</a:t>
+            </a:r>
+          </a:p>
+          <a:p>
+            <a:pPr algn="l">
+              <a:spcAft>
+                <a:spcPts val="900"/>
+              </a:spcAft>
+            </a:pPr>
+            <a:r>
+              <a:rPr sz="1400" b="0">
                 <a:solidFill>
                   <a:srgbClr val="1A2333"/>
                 </a:solidFill>
@@ -6607,17 +6144,17 @@
                 <a:ea typeface="微软雅黑"/>
                 <a:cs typeface="微软雅黑"/>
               </a:rPr>
-              <a:t>  loop 1.86% vs 随机 1.87±0.03,z=−0.35</a:t>
-            </a:r>
-          </a:p>
-          <a:p>
-            <a:pPr algn="l">
-              <a:spcAft>
-                <a:spcPts val="1200"/>
-              </a:spcAft>
-            </a:pPr>
-            <a:r>
-              <a:rPr sz="1600" b="0">
+              <a:t>· Bergstra'12:低有效维→随机追平</a:t>
+            </a:r>
+          </a:p>
+          <a:p>
+            <a:pPr algn="l">
+              <a:spcAft>
+                <a:spcPts val="900"/>
+              </a:spcAft>
+            </a:pPr>
+            <a:r>
+              <a:rPr sz="1400" b="0">
                 <a:solidFill>
                   <a:srgbClr val="1A2333"/>
                 </a:solidFill>
@@ -6625,17 +6162,17 @@
                 <a:ea typeface="微软雅黑"/>
                 <a:cs typeface="微软雅黑"/>
               </a:rPr>
-              <a:t>  52% 随机更好 → 统计打平</a:t>
-            </a:r>
-          </a:p>
-          <a:p>
-            <a:pPr algn="l">
-              <a:spcAft>
-                <a:spcPts val="1200"/>
-              </a:spcAft>
-            </a:pPr>
-            <a:r>
-              <a:rPr sz="1700" b="1">
+              <a:t>· REMBO:~15–20 维临界点</a:t>
+            </a:r>
+          </a:p>
+          <a:p>
+            <a:pPr algn="l">
+              <a:spcAft>
+                <a:spcPts val="900"/>
+              </a:spcAft>
+            </a:pPr>
+            <a:r>
+              <a:rPr sz="1400" b="0">
                 <a:solidFill>
                   <a:srgbClr val="1A2333"/>
                 </a:solidFill>
@@ -6643,17 +6180,35 @@
                 <a:ea typeface="微软雅黑"/>
                 <a:cs typeface="微软雅黑"/>
               </a:rPr>
-              <a:t>规划器域(有 headroom):</a:t>
-            </a:r>
-          </a:p>
-          <a:p>
-            <a:pPr algn="l">
-              <a:spcAft>
-                <a:spcPts val="1200"/>
-              </a:spcAft>
-            </a:pPr>
-            <a:r>
-              <a:rPr sz="1600" b="1">
+              <a:t>· FunSearch:巨大程序空间→引导才行</a:t>
+            </a:r>
+          </a:p>
+          <a:p>
+            <a:pPr algn="l">
+              <a:spcAft>
+                <a:spcPts val="900"/>
+              </a:spcAft>
+            </a:pPr>
+            <a:r>
+              <a:rPr sz="1500" b="1">
+                <a:solidFill>
+                  <a:srgbClr val="C0502D"/>
+                </a:solidFill>
+                <a:latin typeface="微软雅黑"/>
+                <a:ea typeface="微软雅黑"/>
+                <a:cs typeface="微软雅黑"/>
+              </a:rPr>
+              <a:t>· 我们能耗域(小)→打平</a:t>
+            </a:r>
+          </a:p>
+          <a:p>
+            <a:pPr algn="l">
+              <a:spcAft>
+                <a:spcPts val="900"/>
+              </a:spcAft>
+            </a:pPr>
+            <a:r>
+              <a:rPr sz="1500" b="1">
                 <a:solidFill>
                   <a:srgbClr val="5B9BD5"/>
                 </a:solidFill>
@@ -6661,35 +6216,17 @@
                 <a:ea typeface="微软雅黑"/>
                 <a:cs typeface="微软雅黑"/>
               </a:rPr>
-              <a:t>  loop 显著低于随机,z=−2.38</a:t>
-            </a:r>
-          </a:p>
-          <a:p>
-            <a:pPr algn="l">
-              <a:spcAft>
-                <a:spcPts val="1200"/>
-              </a:spcAft>
-            </a:pPr>
-            <a:r>
-              <a:rPr sz="1600" b="0">
-                <a:solidFill>
-                  <a:srgbClr val="1A2333"/>
-                </a:solidFill>
-                <a:latin typeface="微软雅黑"/>
-                <a:ea typeface="微软雅黑"/>
-                <a:cs typeface="微软雅黑"/>
-              </a:rPr>
-              <a:t>  0% 随机更好 → 显著胜</a:t>
-            </a:r>
-          </a:p>
-          <a:p>
-            <a:pPr algn="l">
-              <a:spcAft>
-                <a:spcPts val="1200"/>
-              </a:spcAft>
-            </a:pPr>
-            <a:r>
-              <a:rPr sz="1700" b="1">
+              <a:t>· 我们规划器域(大)→胜 27%</a:t>
+            </a:r>
+          </a:p>
+          <a:p>
+            <a:pPr algn="l">
+              <a:spcAft>
+                <a:spcPts val="900"/>
+              </a:spcAft>
+            </a:pPr>
+            <a:r>
+              <a:rPr sz="1500" b="1">
                 <a:solidFill>
                   <a:srgbClr val="0563C1"/>
                 </a:solidFill>
@@ -6697,7 +6234,7 @@
                 <a:ea typeface="微软雅黑"/>
                 <a:cs typeface="微软雅黑"/>
               </a:rPr>
-              <a:t>→ 打平因任务简单,换复杂任务就赢随机</a:t>
+              <a:t>→ 同框架横跨两端点,亲手印证规律</a:t>
             </a:r>
           </a:p>
         </p:txBody>
@@ -6738,7 +6275,7 @@
                 <a:ea typeface="微软雅黑"/>
                 <a:cs typeface="微软雅黑"/>
               </a:rPr>
-              <a:t>significance_test.py / planner_significance.py(随机分布 + z 检验)</a:t>
+              <a:t>规律=文献综合;两端点=我们实测。CMU《Hidden Pitfalls》2509.08713 反证可信性为刚需</a:t>
             </a:r>
           </a:p>
         </p:txBody>
@@ -6943,14 +6480,14 @@
                 <a:ea typeface="微软雅黑"/>
                 <a:cs typeface="微软雅黑"/>
               </a:rPr>
-              <a:t>为什么打平?引导搜索的优势随搜索空间复杂度增长(文献规律)</a:t>
+              <a:t>用 vs 不用:朴素 AI4S 声称 4 项假发现且藏负结果,我们相反</a:t>
             </a:r>
           </a:p>
         </p:txBody>
       </p:sp>
       <p:pic>
         <p:nvPicPr>
-          <p:cNvPr id="6" name="Picture 5" descr="复杂度规律.png"/>
+          <p:cNvPr id="6" name="Picture 5" descr="naive_vs_trustworthy.png"/>
           <p:cNvPicPr>
             <a:picLocks noChangeAspect="1"/>
           </p:cNvPicPr>
@@ -6964,8 +6501,8 @@
         </p:blipFill>
         <p:spPr>
           <a:xfrm>
-            <a:off x="457200" y="2095384"/>
-            <a:ext cx="6766560" cy="3673072"/>
+            <a:off x="548640" y="2326234"/>
+            <a:ext cx="8412480" cy="3028492"/>
           </a:xfrm>
           <a:prstGeom prst="rect">
             <a:avLst/>
@@ -6980,8 +6517,8 @@
         </p:nvSpPr>
         <p:spPr>
           <a:xfrm>
-            <a:off x="7406640" y="1920240"/>
-            <a:ext cx="4480560" cy="4389120"/>
+            <a:off x="9144000" y="2011680"/>
+            <a:ext cx="2651760" cy="4023360"/>
           </a:xfrm>
           <a:prstGeom prst="rect">
             <a:avLst/>
@@ -6996,29 +6533,65 @@
           <a:p>
             <a:pPr algn="l">
               <a:spcAft>
-                <a:spcPts val="900"/>
+                <a:spcPts val="1200"/>
               </a:spcAft>
             </a:pPr>
             <a:r>
               <a:rPr sz="1600" b="1">
                 <a:solidFill>
+                  <a:srgbClr val="C0502D"/>
+                </a:solidFill>
+                <a:latin typeface="微软雅黑"/>
+                <a:ea typeface="微软雅黑"/>
+                <a:cs typeface="微软雅黑"/>
+              </a:rPr>
+              <a:t>朴素:</a:t>
+            </a:r>
+          </a:p>
+          <a:p>
+            <a:pPr algn="l">
+              <a:spcAft>
+                <a:spcPts val="1200"/>
+              </a:spcAft>
+            </a:pPr>
+            <a:r>
+              <a:rPr sz="1500" b="0">
+                <a:solidFill>
                   <a:srgbClr val="1A2333"/>
                 </a:solidFill>
                 <a:latin typeface="微软雅黑"/>
                 <a:ea typeface="微软雅黑"/>
                 <a:cs typeface="微软雅黑"/>
               </a:rPr>
-              <a:t>不是框架无能,是规律预测:</a:t>
-            </a:r>
-          </a:p>
-          <a:p>
-            <a:pPr algn="l">
-              <a:spcAft>
-                <a:spcPts val="900"/>
-              </a:spcAft>
-            </a:pPr>
-            <a:r>
-              <a:rPr sz="1400" b="0">
+              <a:t>4 假发现 + 0 负结果</a:t>
+            </a:r>
+          </a:p>
+          <a:p>
+            <a:pPr algn="l">
+              <a:spcAft>
+                <a:spcPts val="1200"/>
+              </a:spcAft>
+            </a:pPr>
+            <a:r>
+              <a:rPr sz="1600" b="1">
+                <a:solidFill>
+                  <a:srgbClr val="5B9BD5"/>
+                </a:solidFill>
+                <a:latin typeface="微软雅黑"/>
+                <a:ea typeface="微软雅黑"/>
+                <a:cs typeface="微软雅黑"/>
+              </a:rPr>
+              <a:t>我们:</a:t>
+            </a:r>
+          </a:p>
+          <a:p>
+            <a:pPr algn="l">
+              <a:spcAft>
+                <a:spcPts val="1200"/>
+              </a:spcAft>
+            </a:pPr>
+            <a:r>
+              <a:rPr sz="1500" b="0">
                 <a:solidFill>
                   <a:srgbClr val="1A2333"/>
                 </a:solidFill>
@@ -7026,17 +6599,17 @@
                 <a:ea typeface="微软雅黑"/>
                 <a:cs typeface="微软雅黑"/>
               </a:rPr>
-              <a:t>· Bergstra'12:低有效维→随机追平</a:t>
-            </a:r>
-          </a:p>
-          <a:p>
-            <a:pPr algn="l">
-              <a:spcAft>
-                <a:spcPts val="900"/>
-              </a:spcAft>
-            </a:pPr>
-            <a:r>
-              <a:rPr sz="1400" b="0">
+              <a:t>0 真新 + 4 负结果</a:t>
+            </a:r>
+          </a:p>
+          <a:p>
+            <a:pPr algn="l">
+              <a:spcAft>
+                <a:spcPts val="1200"/>
+              </a:spcAft>
+            </a:pPr>
+            <a:r>
+              <a:rPr sz="1500" b="0">
                 <a:solidFill>
                   <a:srgbClr val="1A2333"/>
                 </a:solidFill>
@@ -7044,17 +6617,17 @@
                 <a:ea typeface="微软雅黑"/>
                 <a:cs typeface="微软雅黑"/>
               </a:rPr>
-              <a:t>· REMBO:~15–20 维临界点</a:t>
-            </a:r>
-          </a:p>
-          <a:p>
-            <a:pPr algn="l">
-              <a:spcAft>
-                <a:spcPts val="900"/>
-              </a:spcAft>
-            </a:pPr>
-            <a:r>
-              <a:rPr sz="1400" b="0">
+              <a:t>一个自信但错,</a:t>
+            </a:r>
+          </a:p>
+          <a:p>
+            <a:pPr algn="l">
+              <a:spcAft>
+                <a:spcPts val="1200"/>
+              </a:spcAft>
+            </a:pPr>
+            <a:r>
+              <a:rPr sz="1500" b="1">
                 <a:solidFill>
                   <a:srgbClr val="1A2333"/>
                 </a:solidFill>
@@ -7062,61 +6635,7 @@
                 <a:ea typeface="微软雅黑"/>
                 <a:cs typeface="微软雅黑"/>
               </a:rPr>
-              <a:t>· FunSearch:巨大程序空间→引导才行</a:t>
-            </a:r>
-          </a:p>
-          <a:p>
-            <a:pPr algn="l">
-              <a:spcAft>
-                <a:spcPts val="900"/>
-              </a:spcAft>
-            </a:pPr>
-            <a:r>
-              <a:rPr sz="1500" b="1">
-                <a:solidFill>
-                  <a:srgbClr val="C0502D"/>
-                </a:solidFill>
-                <a:latin typeface="微软雅黑"/>
-                <a:ea typeface="微软雅黑"/>
-                <a:cs typeface="微软雅黑"/>
-              </a:rPr>
-              <a:t>· 我们能耗域(小)→打平</a:t>
-            </a:r>
-          </a:p>
-          <a:p>
-            <a:pPr algn="l">
-              <a:spcAft>
-                <a:spcPts val="900"/>
-              </a:spcAft>
-            </a:pPr>
-            <a:r>
-              <a:rPr sz="1500" b="1">
-                <a:solidFill>
-                  <a:srgbClr val="5B9BD5"/>
-                </a:solidFill>
-                <a:latin typeface="微软雅黑"/>
-                <a:ea typeface="微软雅黑"/>
-                <a:cs typeface="微软雅黑"/>
-              </a:rPr>
-              <a:t>· 我们规划器域(大)→胜 27%</a:t>
-            </a:r>
-          </a:p>
-          <a:p>
-            <a:pPr algn="l">
-              <a:spcAft>
-                <a:spcPts val="900"/>
-              </a:spcAft>
-            </a:pPr>
-            <a:r>
-              <a:rPr sz="1500" b="1">
-                <a:solidFill>
-                  <a:srgbClr val="0563C1"/>
-                </a:solidFill>
-                <a:latin typeface="微软雅黑"/>
-                <a:ea typeface="微软雅黑"/>
-                <a:cs typeface="微软雅黑"/>
-              </a:rPr>
-              <a:t>→ 同框架横跨两端点,亲手印证规律</a:t>
+              <a:t>一个 humbler 但对。</a:t>
             </a:r>
           </a:p>
         </p:txBody>
@@ -7157,7 +6676,7 @@
                 <a:ea typeface="微软雅黑"/>
                 <a:cs typeface="微软雅黑"/>
               </a:rPr>
-              <a:t>规律=文献综合;两端点=我们实测。CMU《Hidden Pitfalls》2509.08713 反证可信性为刚需</a:t>
+              <a:t>naive_vs_trustworthy.py(同数据同候选,端到端产出对照)</a:t>
             </a:r>
           </a:p>
         </p:txBody>
@@ -7362,14 +6881,14 @@
                 <a:ea typeface="微软雅黑"/>
                 <a:cs typeface="微软雅黑"/>
               </a:rPr>
-              <a:t>用 vs 不用:朴素 AI4S 声称 4 项假发现且藏负结果,我们相反</a:t>
+              <a:t>诚实边界:多数场景无收益,载荷无效,贡献是方法学而非发现</a:t>
             </a:r>
           </a:p>
         </p:txBody>
       </p:sp>
       <p:pic>
         <p:nvPicPr>
-          <p:cNvPr id="6" name="Picture 5" descr="naive_vs_trustworthy.png"/>
+          <p:cNvPr id="6" name="Picture 5" descr="省能分布_n250.png"/>
           <p:cNvPicPr>
             <a:picLocks noChangeAspect="1"/>
           </p:cNvPicPr>
@@ -7383,8 +6902,8 @@
         </p:blipFill>
         <p:spPr>
           <a:xfrm>
-            <a:off x="548640" y="2326234"/>
-            <a:ext cx="8412480" cy="3028492"/>
+            <a:off x="562672" y="1828800"/>
+            <a:ext cx="6829936" cy="4114800"/>
           </a:xfrm>
           <a:prstGeom prst="rect">
             <a:avLst/>
@@ -7399,8 +6918,8 @@
         </p:nvSpPr>
         <p:spPr>
           <a:xfrm>
-            <a:off x="9144000" y="2011680"/>
-            <a:ext cx="2651760" cy="4023360"/>
+            <a:off x="7680960" y="1920240"/>
+            <a:ext cx="4114800" cy="4206240"/>
           </a:xfrm>
           <a:prstGeom prst="rect">
             <a:avLst/>
@@ -7415,109 +6934,109 @@
           <a:p>
             <a:pPr algn="l">
               <a:spcAft>
-                <a:spcPts val="1200"/>
+                <a:spcPts val="1100"/>
+              </a:spcAft>
+            </a:pPr>
+            <a:r>
+              <a:rPr sz="1600" b="0">
+                <a:solidFill>
+                  <a:srgbClr val="1A2333"/>
+                </a:solidFill>
+                <a:latin typeface="微软雅黑"/>
+                <a:ea typeface="微软雅黑"/>
+                <a:cs typeface="微软雅黑"/>
+              </a:rPr>
+              <a:t>· n=250 场景:中位省能 0%</a:t>
+            </a:r>
+          </a:p>
+          <a:p>
+            <a:pPr algn="l">
+              <a:spcAft>
+                <a:spcPts val="1100"/>
+              </a:spcAft>
+            </a:pPr>
+            <a:r>
+              <a:rPr sz="1600" b="0">
+                <a:solidFill>
+                  <a:srgbClr val="1A2333"/>
+                </a:solidFill>
+                <a:latin typeface="微软雅黑"/>
+                <a:ea typeface="微软雅黑"/>
+                <a:cs typeface="微软雅黑"/>
+              </a:rPr>
+              <a:t>· 77% 场景零收益(有低空走廊)</a:t>
+            </a:r>
+          </a:p>
+          <a:p>
+            <a:pPr algn="l">
+              <a:spcAft>
+                <a:spcPts val="1100"/>
+              </a:spcAft>
+            </a:pPr>
+            <a:r>
+              <a:rPr sz="1600" b="0">
+                <a:solidFill>
+                  <a:srgbClr val="1A2333"/>
+                </a:solidFill>
+                <a:latin typeface="微软雅黑"/>
+                <a:ea typeface="微软雅黑"/>
+                <a:cs typeface="微软雅黑"/>
+              </a:rPr>
+              <a:t>· 仅 20% ≥3%,CI[15.5,25.4]%</a:t>
+            </a:r>
+          </a:p>
+          <a:p>
+            <a:pPr algn="l">
+              <a:spcAft>
+                <a:spcPts val="1100"/>
+              </a:spcAft>
+            </a:pPr>
+            <a:r>
+              <a:rPr sz="1600" b="0">
+                <a:solidFill>
+                  <a:srgbClr val="1A2333"/>
+                </a:solidFill>
+                <a:latin typeface="微软雅黑"/>
+                <a:ea typeface="微软雅黑"/>
+                <a:cs typeface="微软雅黑"/>
+              </a:rPr>
+              <a:t>· 载荷 ≤500g:全扫不改变路径</a:t>
+            </a:r>
+          </a:p>
+          <a:p>
+            <a:pPr algn="l">
+              <a:spcAft>
+                <a:spcPts val="1100"/>
+              </a:spcAft>
+            </a:pPr>
+            <a:r>
+              <a:rPr sz="1600" b="0">
+                <a:solidFill>
+                  <a:srgbClr val="1A2333"/>
+                </a:solidFill>
+                <a:latin typeface="微软雅黑"/>
+                <a:ea typeface="微软雅黑"/>
+                <a:cs typeface="微软雅黑"/>
+              </a:rPr>
+              <a:t>· 无真机飞行(止于仿真)</a:t>
+            </a:r>
+          </a:p>
+          <a:p>
+            <a:pPr algn="l">
+              <a:spcAft>
+                <a:spcPts val="1100"/>
               </a:spcAft>
             </a:pPr>
             <a:r>
               <a:rPr sz="1600" b="1">
                 <a:solidFill>
-                  <a:srgbClr val="C0502D"/>
-                </a:solidFill>
-                <a:latin typeface="微软雅黑"/>
-                <a:ea typeface="微软雅黑"/>
-                <a:cs typeface="微软雅黑"/>
-              </a:rPr>
-              <a:t>朴素:</a:t>
-            </a:r>
-          </a:p>
-          <a:p>
-            <a:pPr algn="l">
-              <a:spcAft>
-                <a:spcPts val="1200"/>
-              </a:spcAft>
-            </a:pPr>
-            <a:r>
-              <a:rPr sz="1500" b="0">
-                <a:solidFill>
-                  <a:srgbClr val="1A2333"/>
-                </a:solidFill>
-                <a:latin typeface="微软雅黑"/>
-                <a:ea typeface="微软雅黑"/>
-                <a:cs typeface="微软雅黑"/>
-              </a:rPr>
-              <a:t>4 假发现 + 0 负结果</a:t>
-            </a:r>
-          </a:p>
-          <a:p>
-            <a:pPr algn="l">
-              <a:spcAft>
-                <a:spcPts val="1200"/>
-              </a:spcAft>
-            </a:pPr>
-            <a:r>
-              <a:rPr sz="1600" b="1">
-                <a:solidFill>
-                  <a:srgbClr val="5B9BD5"/>
-                </a:solidFill>
-                <a:latin typeface="微软雅黑"/>
-                <a:ea typeface="微软雅黑"/>
-                <a:cs typeface="微软雅黑"/>
-              </a:rPr>
-              <a:t>我们:</a:t>
-            </a:r>
-          </a:p>
-          <a:p>
-            <a:pPr algn="l">
-              <a:spcAft>
-                <a:spcPts val="1200"/>
-              </a:spcAft>
-            </a:pPr>
-            <a:r>
-              <a:rPr sz="1500" b="0">
-                <a:solidFill>
-                  <a:srgbClr val="1A2333"/>
-                </a:solidFill>
-                <a:latin typeface="微软雅黑"/>
-                <a:ea typeface="微软雅黑"/>
-                <a:cs typeface="微软雅黑"/>
-              </a:rPr>
-              <a:t>0 真新 + 4 负结果</a:t>
-            </a:r>
-          </a:p>
-          <a:p>
-            <a:pPr algn="l">
-              <a:spcAft>
-                <a:spcPts val="1200"/>
-              </a:spcAft>
-            </a:pPr>
-            <a:r>
-              <a:rPr sz="1500" b="0">
-                <a:solidFill>
-                  <a:srgbClr val="1A2333"/>
-                </a:solidFill>
-                <a:latin typeface="微软雅黑"/>
-                <a:ea typeface="微软雅黑"/>
-                <a:cs typeface="微软雅黑"/>
-              </a:rPr>
-              <a:t>一个自信但错,</a:t>
-            </a:r>
-          </a:p>
-          <a:p>
-            <a:pPr algn="l">
-              <a:spcAft>
-                <a:spcPts val="1200"/>
-              </a:spcAft>
-            </a:pPr>
-            <a:r>
-              <a:rPr sz="1500" b="1">
-                <a:solidFill>
-                  <a:srgbClr val="1A2333"/>
-                </a:solidFill>
-                <a:latin typeface="微软雅黑"/>
-                <a:ea typeface="微软雅黑"/>
-                <a:cs typeface="微软雅黑"/>
-              </a:rPr>
-              <a:t>一个 humbler 但对。</a:t>
+                  <a:srgbClr val="0563C1"/>
+                </a:solidFill>
+                <a:latin typeface="微软雅黑"/>
+                <a:ea typeface="微软雅黑"/>
+                <a:cs typeface="微软雅黑"/>
+              </a:rPr>
+              <a:t>→ 不挑场景、不硬凑,诚实统计</a:t>
             </a:r>
           </a:p>
         </p:txBody>
@@ -7558,7 +7077,7 @@
                 <a:ea typeface="微软雅黑"/>
                 <a:cs typeface="微软雅黑"/>
               </a:rPr>
-              <a:t>naive_vs_trustworthy.py(同数据同候选,端到端产出对照)</a:t>
+              <a:t>large_scale_savings.py;可信 null 是被接受的贡献(ICML 2024)</a:t>
             </a:r>
           </a:p>
         </p:txBody>
@@ -7577,7 +7096,7 @@
     <p:bg>
       <p:bgPr>
         <a:solidFill>
-          <a:srgbClr val="FFFFFF"/>
+          <a:srgbClr val="0A2A66"/>
         </a:solidFill>
         <a:effectLst/>
       </p:bgPr>
@@ -7604,7 +7123,7 @@
             <a:avLst/>
           </a:prstGeom>
           <a:solidFill>
-            <a:srgbClr val="4472C4"/>
+            <a:srgbClr val="5B9BD5"/>
           </a:solidFill>
           <a:ln>
             <a:noFill/>
@@ -7632,145 +7151,9 @@
           </a:p>
         </p:txBody>
       </p:sp>
-      <p:sp>
-        <p:nvSpPr>
-          <p:cNvPr id="3" name="TextBox 2"/>
-          <p:cNvSpPr txBox="1"/>
-          <p:nvPr/>
-        </p:nvSpPr>
-        <p:spPr>
-          <a:xfrm>
-            <a:off x="9052560" y="292608"/>
-            <a:ext cx="2834640" cy="365760"/>
-          </a:xfrm>
-          <a:prstGeom prst="rect">
-            <a:avLst/>
-          </a:prstGeom>
-          <a:noFill/>
-        </p:spPr>
-        <p:txBody>
-          <a:bodyPr wrap="square" anchor="t" lIns="25400" rIns="25400" tIns="25400" bIns="25400">
-            <a:spAutoFit/>
-          </a:bodyPr>
-          <a:lstStyle/>
-          <a:p>
-            <a:pPr algn="r">
-              <a:spcAft>
-                <a:spcPts val="400"/>
-              </a:spcAft>
-            </a:pPr>
-            <a:r>
-              <a:rPr sz="1200" b="0">
-                <a:solidFill>
-                  <a:srgbClr val="9AA8B8"/>
-                </a:solidFill>
-                <a:latin typeface="微软雅黑"/>
-                <a:ea typeface="微软雅黑"/>
-                <a:cs typeface="微软雅黑"/>
-              </a:rPr>
-              <a:t>西安交通大学</a:t>
-            </a:r>
-          </a:p>
-        </p:txBody>
-      </p:sp>
-      <p:sp>
-        <p:nvSpPr>
-          <p:cNvPr id="4" name="Rounded Rectangle 3"/>
-          <p:cNvSpPr/>
-          <p:nvPr/>
-        </p:nvSpPr>
-        <p:spPr>
-          <a:xfrm>
-            <a:off x="502920" y="365760"/>
-            <a:ext cx="566928" cy="457200"/>
-          </a:xfrm>
-          <a:prstGeom prst="roundRect">
-            <a:avLst/>
-          </a:prstGeom>
-          <a:solidFill>
-            <a:srgbClr val="4472C4"/>
-          </a:solidFill>
-          <a:ln>
-            <a:noFill/>
-          </a:ln>
-        </p:spPr>
-        <p:style>
-          <a:lnRef idx="1">
-            <a:schemeClr val="accent1"/>
-          </a:lnRef>
-          <a:fillRef idx="3">
-            <a:schemeClr val="accent1"/>
-          </a:fillRef>
-          <a:effectRef idx="2">
-            <a:schemeClr val="accent1"/>
-          </a:effectRef>
-          <a:fontRef idx="minor">
-            <a:schemeClr val="lt1"/>
-          </a:fontRef>
-        </p:style>
-        <p:txBody>
-          <a:bodyPr rtlCol="0" anchor="ctr" tIns="0" bIns="0" lIns="0" rIns="0" wrap="none"/>
-          <a:lstStyle/>
-          <a:p>
-            <a:pPr algn="ctr"/>
-            <a:r>
-              <a:rPr sz="1600" b="1">
-                <a:solidFill>
-                  <a:srgbClr val="FFFFFF"/>
-                </a:solidFill>
-                <a:latin typeface="微软雅黑"/>
-                <a:ea typeface="微软雅黑"/>
-                <a:cs typeface="微软雅黑"/>
-              </a:rPr>
-              <a:t>16</a:t>
-            </a:r>
-          </a:p>
-        </p:txBody>
-      </p:sp>
-      <p:sp>
-        <p:nvSpPr>
-          <p:cNvPr id="5" name="TextBox 4"/>
-          <p:cNvSpPr txBox="1"/>
-          <p:nvPr/>
-        </p:nvSpPr>
-        <p:spPr>
-          <a:xfrm>
-            <a:off x="1143000" y="347472"/>
-            <a:ext cx="10607040" cy="914400"/>
-          </a:xfrm>
-          <a:prstGeom prst="rect">
-            <a:avLst/>
-          </a:prstGeom>
-          <a:noFill/>
-        </p:spPr>
-        <p:txBody>
-          <a:bodyPr wrap="square" anchor="t" lIns="25400" rIns="25400" tIns="25400" bIns="25400">
-            <a:spAutoFit/>
-          </a:bodyPr>
-          <a:lstStyle/>
-          <a:p>
-            <a:pPr algn="l">
-              <a:spcAft>
-                <a:spcPts val="400"/>
-              </a:spcAft>
-            </a:pPr>
-            <a:r>
-              <a:rPr sz="2600" b="1">
-                <a:solidFill>
-                  <a:srgbClr val="0563C1"/>
-                </a:solidFill>
-                <a:latin typeface="微软雅黑"/>
-                <a:ea typeface="微软雅黑"/>
-                <a:cs typeface="微软雅黑"/>
-              </a:rPr>
-              <a:t>诚实边界:多数场景无收益,载荷无效,贡献是方法学而非发现</a:t>
-            </a:r>
-          </a:p>
-        </p:txBody>
-      </p:sp>
       <p:pic>
         <p:nvPicPr>
-          <p:cNvPr id="6" name="Picture 5" descr="省能分布_n250.png"/>
+          <p:cNvPr id="3" name="Picture 2" descr="xjtu_logo_white.png"/>
           <p:cNvPicPr>
             <a:picLocks noChangeAspect="1"/>
           </p:cNvPicPr>
@@ -7784,8 +7167,8 @@
         </p:blipFill>
         <p:spPr>
           <a:xfrm>
-            <a:off x="562672" y="1828800"/>
-            <a:ext cx="6829936" cy="4114800"/>
+            <a:off x="8686800" y="365760"/>
+            <a:ext cx="1707229" cy="457200"/>
           </a:xfrm>
           <a:prstGeom prst="rect">
             <a:avLst/>
@@ -7794,14 +7177,68 @@
       </p:pic>
       <p:sp>
         <p:nvSpPr>
-          <p:cNvPr id="7" name="TextBox 6"/>
+          <p:cNvPr id="4" name="Rounded Rectangle 3"/>
+          <p:cNvSpPr/>
+          <p:nvPr/>
+        </p:nvSpPr>
+        <p:spPr>
+          <a:xfrm>
+            <a:off x="502920" y="365760"/>
+            <a:ext cx="566928" cy="457200"/>
+          </a:xfrm>
+          <a:prstGeom prst="roundRect">
+            <a:avLst/>
+          </a:prstGeom>
+          <a:solidFill>
+            <a:srgbClr val="5B9BD5"/>
+          </a:solidFill>
+          <a:ln>
+            <a:noFill/>
+          </a:ln>
+        </p:spPr>
+        <p:style>
+          <a:lnRef idx="1">
+            <a:schemeClr val="accent1"/>
+          </a:lnRef>
+          <a:fillRef idx="3">
+            <a:schemeClr val="accent1"/>
+          </a:fillRef>
+          <a:effectRef idx="2">
+            <a:schemeClr val="accent1"/>
+          </a:effectRef>
+          <a:fontRef idx="minor">
+            <a:schemeClr val="lt1"/>
+          </a:fontRef>
+        </p:style>
+        <p:txBody>
+          <a:bodyPr rtlCol="0" anchor="ctr" tIns="0" bIns="0" lIns="0" rIns="0" wrap="none"/>
+          <a:lstStyle/>
+          <a:p>
+            <a:pPr algn="ctr"/>
+            <a:r>
+              <a:rPr sz="1600" b="1">
+                <a:solidFill>
+                  <a:srgbClr val="FFFFFF"/>
+                </a:solidFill>
+                <a:latin typeface="微软雅黑"/>
+                <a:ea typeface="微软雅黑"/>
+                <a:cs typeface="微软雅黑"/>
+              </a:rPr>
+              <a:t>16</a:t>
+            </a:r>
+          </a:p>
+        </p:txBody>
+      </p:sp>
+      <p:sp>
+        <p:nvSpPr>
+          <p:cNvPr id="5" name="TextBox 4"/>
           <p:cNvSpPr txBox="1"/>
           <p:nvPr/>
         </p:nvSpPr>
         <p:spPr>
           <a:xfrm>
-            <a:off x="7680960" y="1920240"/>
-            <a:ext cx="4114800" cy="4206240"/>
+            <a:off x="822960" y="1188720"/>
+            <a:ext cx="10515600" cy="640080"/>
           </a:xfrm>
           <a:prstGeom prst="rect">
             <a:avLst/>
@@ -7816,123 +7253,33 @@
           <a:p>
             <a:pPr algn="l">
               <a:spcAft>
-                <a:spcPts val="1100"/>
-              </a:spcAft>
-            </a:pPr>
-            <a:r>
-              <a:rPr sz="1600" b="0">
-                <a:solidFill>
-                  <a:srgbClr val="1A2333"/>
-                </a:solidFill>
-                <a:latin typeface="微软雅黑"/>
-                <a:ea typeface="微软雅黑"/>
-                <a:cs typeface="微软雅黑"/>
-              </a:rPr>
-              <a:t>· n=250 场景:中位省能 0%</a:t>
-            </a:r>
-          </a:p>
-          <a:p>
-            <a:pPr algn="l">
-              <a:spcAft>
-                <a:spcPts val="1100"/>
-              </a:spcAft>
-            </a:pPr>
-            <a:r>
-              <a:rPr sz="1600" b="0">
-                <a:solidFill>
-                  <a:srgbClr val="1A2333"/>
-                </a:solidFill>
-                <a:latin typeface="微软雅黑"/>
-                <a:ea typeface="微软雅黑"/>
-                <a:cs typeface="微软雅黑"/>
-              </a:rPr>
-              <a:t>· 77% 场景零收益(有低空走廊)</a:t>
-            </a:r>
-          </a:p>
-          <a:p>
-            <a:pPr algn="l">
-              <a:spcAft>
-                <a:spcPts val="1100"/>
-              </a:spcAft>
-            </a:pPr>
-            <a:r>
-              <a:rPr sz="1600" b="0">
-                <a:solidFill>
-                  <a:srgbClr val="1A2333"/>
-                </a:solidFill>
-                <a:latin typeface="微软雅黑"/>
-                <a:ea typeface="微软雅黑"/>
-                <a:cs typeface="微软雅黑"/>
-              </a:rPr>
-              <a:t>· 仅 20% ≥3%,CI[15.5,25.4]%</a:t>
-            </a:r>
-          </a:p>
-          <a:p>
-            <a:pPr algn="l">
-              <a:spcAft>
-                <a:spcPts val="1100"/>
-              </a:spcAft>
-            </a:pPr>
-            <a:r>
-              <a:rPr sz="1600" b="0">
-                <a:solidFill>
-                  <a:srgbClr val="1A2333"/>
-                </a:solidFill>
-                <a:latin typeface="微软雅黑"/>
-                <a:ea typeface="微软雅黑"/>
-                <a:cs typeface="微软雅黑"/>
-              </a:rPr>
-              <a:t>· 载荷 ≤500g:全扫不改变路径</a:t>
-            </a:r>
-          </a:p>
-          <a:p>
-            <a:pPr algn="l">
-              <a:spcAft>
-                <a:spcPts val="1100"/>
-              </a:spcAft>
-            </a:pPr>
-            <a:r>
-              <a:rPr sz="1600" b="0">
-                <a:solidFill>
-                  <a:srgbClr val="1A2333"/>
-                </a:solidFill>
-                <a:latin typeface="微软雅黑"/>
-                <a:ea typeface="微软雅黑"/>
-                <a:cs typeface="微软雅黑"/>
-              </a:rPr>
-              <a:t>· 无真机飞行(止于仿真)</a:t>
-            </a:r>
-          </a:p>
-          <a:p>
-            <a:pPr algn="l">
-              <a:spcAft>
-                <a:spcPts val="1100"/>
-              </a:spcAft>
-            </a:pPr>
-            <a:r>
-              <a:rPr sz="1600" b="1">
-                <a:solidFill>
-                  <a:srgbClr val="0563C1"/>
-                </a:solidFill>
-                <a:latin typeface="微软雅黑"/>
-                <a:ea typeface="微软雅黑"/>
-                <a:cs typeface="微软雅黑"/>
-              </a:rPr>
-              <a:t>→ 不挑场景、不硬凑,诚实统计</a:t>
-            </a:r>
-          </a:p>
-        </p:txBody>
-      </p:sp>
-      <p:sp>
-        <p:nvSpPr>
-          <p:cNvPr id="8" name="TextBox 7"/>
+                <a:spcPts val="400"/>
+              </a:spcAft>
+            </a:pPr>
+            <a:r>
+              <a:rPr sz="2400" b="1">
+                <a:solidFill>
+                  <a:srgbClr val="5B9BD5"/>
+                </a:solidFill>
+                <a:latin typeface="微软雅黑"/>
+                <a:ea typeface="微软雅黑"/>
+                <a:cs typeface="微软雅黑"/>
+              </a:rPr>
+              <a:t>结论</a:t>
+            </a:r>
+          </a:p>
+        </p:txBody>
+      </p:sp>
+      <p:sp>
+        <p:nvSpPr>
+          <p:cNvPr id="6" name="TextBox 5"/>
           <p:cNvSpPr txBox="1"/>
           <p:nvPr/>
         </p:nvSpPr>
         <p:spPr>
           <a:xfrm>
-            <a:off x="502920" y="6400800"/>
-            <a:ext cx="11155680" cy="320040"/>
+            <a:off x="822960" y="2103120"/>
+            <a:ext cx="10698480" cy="4023360"/>
           </a:xfrm>
           <a:prstGeom prst="rect">
             <a:avLst/>
@@ -7947,19 +7294,91 @@
           <a:p>
             <a:pPr algn="l">
               <a:spcAft>
-                <a:spcPts val="400"/>
-              </a:spcAft>
-            </a:pPr>
-            <a:r>
-              <a:rPr sz="1100" b="0">
-                <a:solidFill>
-                  <a:srgbClr val="6B7A8D"/>
-                </a:solidFill>
-                <a:latin typeface="微软雅黑"/>
-                <a:ea typeface="微软雅黑"/>
-                <a:cs typeface="微软雅黑"/>
-              </a:rPr>
-              <a:t>large_scale_savings.py;可信 null 是被接受的贡献(ICML 2024)</a:t>
+                <a:spcPts val="1600"/>
+              </a:spcAft>
+            </a:pPr>
+            <a:r>
+              <a:rPr sz="2100" b="0">
+                <a:solidFill>
+                  <a:srgbClr val="FFFFFF"/>
+                </a:solidFill>
+                <a:latin typeface="微软雅黑"/>
+                <a:ea typeface="微软雅黑"/>
+                <a:cs typeface="微软雅黑"/>
+              </a:rPr>
+              <a:t>① 不声称新算法/新效应——三次查新确认均为 prior art,主动引用</a:t>
+            </a:r>
+          </a:p>
+          <a:p>
+            <a:pPr algn="l">
+              <a:spcAft>
+                <a:spcPts val="1600"/>
+              </a:spcAft>
+            </a:pPr>
+            <a:r>
+              <a:rPr sz="2100" b="1">
+                <a:solidFill>
+                  <a:srgbClr val="5B9BD5"/>
+                </a:solidFill>
+                <a:latin typeface="微软雅黑"/>
+                <a:ea typeface="微软雅黑"/>
+                <a:cs typeface="微软雅黑"/>
+              </a:rPr>
+              <a:t>② 贡献 = 可信自动科研方法学 + 真机数据锚定 + 诚实能力边界</a:t>
+            </a:r>
+          </a:p>
+          <a:p>
+            <a:pPr algn="l">
+              <a:spcAft>
+                <a:spcPts val="1600"/>
+              </a:spcAft>
+            </a:pPr>
+            <a:r>
+              <a:rPr sz="2100" b="0">
+                <a:solidFill>
+                  <a:srgbClr val="FFFFFF"/>
+                </a:solidFill>
+                <a:latin typeface="微软雅黑"/>
+                <a:ea typeface="微软雅黑"/>
+                <a:cs typeface="微软雅黑"/>
+              </a:rPr>
+              <a:t>③ 逐个消融证明每道节点“承重”:去掉即退化/overclaim</a:t>
+            </a:r>
+          </a:p>
+          <a:p>
+            <a:pPr algn="l">
+              <a:spcAft>
+                <a:spcPts val="1600"/>
+              </a:spcAft>
+            </a:pPr>
+            <a:r>
+              <a:rPr sz="2100" b="0">
+                <a:solidFill>
+                  <a:srgbClr val="FFFFFF"/>
+                </a:solidFill>
+                <a:latin typeface="微软雅黑"/>
+                <a:ea typeface="微软雅黑"/>
+                <a:cs typeface="微软雅黑"/>
+              </a:rPr>
+              <a:t>④ 价值 = 在该 overclaim 处不 overclaim,并量化能力边界</a:t>
+            </a:r>
+          </a:p>
+          <a:p>
+            <a:pPr algn="l">
+              <a:spcAft>
+                <a:spcPts val="1600"/>
+              </a:spcAft>
+            </a:pPr>
+            <a:r>
+              <a:rPr sz="2100" b="0">
+                <a:solidFill>
+                  <a:srgbClr val="FFFFFF"/>
+                </a:solidFill>
+                <a:latin typeface="微软雅黑"/>
+                <a:ea typeface="微软雅黑"/>
+                <a:cs typeface="微软雅黑"/>
+              </a:rPr>
+              <a:t>⑤ 域相关:有 headroom 显著胜随机、封顶域正确产出 null</a:t>
             </a:r>
           </a:p>
         </p:txBody>
@@ -8361,7 +7780,7 @@
     <p:bg>
       <p:bgPr>
         <a:solidFill>
-          <a:srgbClr val="0A2A66"/>
+          <a:srgbClr val="FFFFFF"/>
         </a:solidFill>
         <a:effectLst/>
       </p:bgPr>
@@ -8388,7 +7807,7 @@
             <a:avLst/>
           </a:prstGeom>
           <a:solidFill>
-            <a:srgbClr val="5B9BD5"/>
+            <a:srgbClr val="4472C4"/>
           </a:solidFill>
           <a:ln>
             <a:noFill/>
@@ -8416,30 +7835,47 @@
           </a:p>
         </p:txBody>
       </p:sp>
-      <p:pic>
-        <p:nvPicPr>
-          <p:cNvPr id="3" name="Picture 2" descr="xjtu_logo_white.png"/>
-          <p:cNvPicPr>
-            <a:picLocks noChangeAspect="1"/>
-          </p:cNvPicPr>
-          <p:nvPr/>
-        </p:nvPicPr>
-        <p:blipFill>
-          <a:blip r:embed="rId2"/>
-          <a:stretch>
-            <a:fillRect/>
-          </a:stretch>
-        </p:blipFill>
-        <p:spPr>
-          <a:xfrm>
-            <a:off x="8686800" y="365760"/>
-            <a:ext cx="1707229" cy="457200"/>
-          </a:xfrm>
-          <a:prstGeom prst="rect">
-            <a:avLst/>
-          </a:prstGeom>
-        </p:spPr>
-      </p:pic>
+      <p:sp>
+        <p:nvSpPr>
+          <p:cNvPr id="3" name="TextBox 2"/>
+          <p:cNvSpPr txBox="1"/>
+          <p:nvPr/>
+        </p:nvSpPr>
+        <p:spPr>
+          <a:xfrm>
+            <a:off x="9052560" y="292608"/>
+            <a:ext cx="2834640" cy="365760"/>
+          </a:xfrm>
+          <a:prstGeom prst="rect">
+            <a:avLst/>
+          </a:prstGeom>
+          <a:noFill/>
+        </p:spPr>
+        <p:txBody>
+          <a:bodyPr wrap="square" anchor="t" lIns="25400" rIns="25400" tIns="25400" bIns="25400">
+            <a:spAutoFit/>
+          </a:bodyPr>
+          <a:lstStyle/>
+          <a:p>
+            <a:pPr algn="r">
+              <a:spcAft>
+                <a:spcPts val="400"/>
+              </a:spcAft>
+            </a:pPr>
+            <a:r>
+              <a:rPr sz="1200" b="0">
+                <a:solidFill>
+                  <a:srgbClr val="9AA8B8"/>
+                </a:solidFill>
+                <a:latin typeface="微软雅黑"/>
+                <a:ea typeface="微软雅黑"/>
+                <a:cs typeface="微软雅黑"/>
+              </a:rPr>
+              <a:t>西安交通大学</a:t>
+            </a:r>
+          </a:p>
+        </p:txBody>
+      </p:sp>
       <p:sp>
         <p:nvSpPr>
           <p:cNvPr id="4" name="Rounded Rectangle 3"/>
@@ -8455,7 +7891,7 @@
             <a:avLst/>
           </a:prstGeom>
           <a:solidFill>
-            <a:srgbClr val="5B9BD5"/>
+            <a:srgbClr val="4472C4"/>
           </a:solidFill>
           <a:ln>
             <a:noFill/>
@@ -8502,8 +7938,8 @@
         </p:nvSpPr>
         <p:spPr>
           <a:xfrm>
-            <a:off x="822960" y="1188720"/>
-            <a:ext cx="10515600" cy="640080"/>
+            <a:off x="1143000" y="347472"/>
+            <a:ext cx="10607040" cy="914400"/>
           </a:xfrm>
           <a:prstGeom prst="rect">
             <a:avLst/>
@@ -8522,15 +7958,15 @@
               </a:spcAft>
             </a:pPr>
             <a:r>
-              <a:rPr sz="2400" b="1">
-                <a:solidFill>
-                  <a:srgbClr val="5B9BD5"/>
-                </a:solidFill>
-                <a:latin typeface="微软雅黑"/>
-                <a:ea typeface="微软雅黑"/>
-                <a:cs typeface="微软雅黑"/>
-              </a:rPr>
-              <a:t>结论</a:t>
+              <a:rPr sz="2600" b="1">
+                <a:solidFill>
+                  <a:srgbClr val="0563C1"/>
+                </a:solidFill>
+                <a:latin typeface="微软雅黑"/>
+                <a:ea typeface="微软雅黑"/>
+                <a:cs typeface="微软雅黑"/>
+              </a:rPr>
+              <a:t>参考文献</a:t>
             </a:r>
           </a:p>
         </p:txBody>
@@ -8543,8 +7979,8 @@
         </p:nvSpPr>
         <p:spPr>
           <a:xfrm>
-            <a:off x="822960" y="2103120"/>
-            <a:ext cx="10698480" cy="4023360"/>
+            <a:off x="685800" y="1828800"/>
+            <a:ext cx="10972800" cy="4389120"/>
           </a:xfrm>
           <a:prstGeom prst="rect">
             <a:avLst/>
@@ -8559,91 +7995,163 @@
           <a:p>
             <a:pPr algn="l">
               <a:spcAft>
-                <a:spcPts val="1600"/>
-              </a:spcAft>
-            </a:pPr>
-            <a:r>
-              <a:rPr sz="2100" b="0">
-                <a:solidFill>
-                  <a:srgbClr val="FFFFFF"/>
-                </a:solidFill>
-                <a:latin typeface="微软雅黑"/>
-                <a:ea typeface="微软雅黑"/>
-                <a:cs typeface="微软雅黑"/>
-              </a:rPr>
-              <a:t>① 不声称新算法/新效应——三次查新确认均为 prior art,主动引用</a:t>
-            </a:r>
-          </a:p>
-          <a:p>
-            <a:pPr algn="l">
-              <a:spcAft>
-                <a:spcPts val="1600"/>
-              </a:spcAft>
-            </a:pPr>
-            <a:r>
-              <a:rPr sz="2100" b="1">
-                <a:solidFill>
-                  <a:srgbClr val="5B9BD5"/>
-                </a:solidFill>
-                <a:latin typeface="微软雅黑"/>
-                <a:ea typeface="微软雅黑"/>
-                <a:cs typeface="微软雅黑"/>
-              </a:rPr>
-              <a:t>② 贡献 = 可信自动科研方法学 + 真机数据锚定 + 诚实能力边界</a:t>
-            </a:r>
-          </a:p>
-          <a:p>
-            <a:pPr algn="l">
-              <a:spcAft>
-                <a:spcPts val="1600"/>
-              </a:spcAft>
-            </a:pPr>
-            <a:r>
-              <a:rPr sz="2100" b="0">
-                <a:solidFill>
-                  <a:srgbClr val="FFFFFF"/>
-                </a:solidFill>
-                <a:latin typeface="微软雅黑"/>
-                <a:ea typeface="微软雅黑"/>
-                <a:cs typeface="微软雅黑"/>
-              </a:rPr>
-              <a:t>③ 逐个消融证明每道节点“承重”:去掉即退化/overclaim</a:t>
-            </a:r>
-          </a:p>
-          <a:p>
-            <a:pPr algn="l">
-              <a:spcAft>
-                <a:spcPts val="1600"/>
-              </a:spcAft>
-            </a:pPr>
-            <a:r>
-              <a:rPr sz="2100" b="0">
-                <a:solidFill>
-                  <a:srgbClr val="FFFFFF"/>
-                </a:solidFill>
-                <a:latin typeface="微软雅黑"/>
-                <a:ea typeface="微软雅黑"/>
-                <a:cs typeface="微软雅黑"/>
-              </a:rPr>
-              <a:t>④ 价值 = 在该 overclaim 处不 overclaim,并量化能力边界</a:t>
-            </a:r>
-          </a:p>
-          <a:p>
-            <a:pPr algn="l">
-              <a:spcAft>
-                <a:spcPts val="1600"/>
-              </a:spcAft>
-            </a:pPr>
-            <a:r>
-              <a:rPr sz="2100" b="0">
-                <a:solidFill>
-                  <a:srgbClr val="FFFFFF"/>
-                </a:solidFill>
-                <a:latin typeface="微软雅黑"/>
-                <a:ea typeface="微软雅黑"/>
-                <a:cs typeface="微软雅黑"/>
-              </a:rPr>
-              <a:t>⑤ 域相关:有 headroom 显著胜随机、封顶域正确产出 null</a:t>
+                <a:spcPts val="800"/>
+              </a:spcAft>
+            </a:pPr>
+            <a:r>
+              <a:rPr sz="1500" b="0">
+                <a:solidFill>
+                  <a:srgbClr val="1A2333"/>
+                </a:solidFill>
+                <a:latin typeface="微软雅黑"/>
+                <a:ea typeface="微软雅黑"/>
+                <a:cs typeface="微软雅黑"/>
+              </a:rPr>
+              <a:t>Romera-Paredes et al. FunSearch. Nature 2023.</a:t>
+            </a:r>
+          </a:p>
+          <a:p>
+            <a:pPr algn="l">
+              <a:spcAft>
+                <a:spcPts val="800"/>
+              </a:spcAft>
+            </a:pPr>
+            <a:r>
+              <a:rPr sz="1500" b="0">
+                <a:solidFill>
+                  <a:srgbClr val="1A2333"/>
+                </a:solidFill>
+                <a:latin typeface="微软雅黑"/>
+                <a:ea typeface="微软雅黑"/>
+                <a:cs typeface="微软雅黑"/>
+              </a:rPr>
+              <a:t>Novikov et al. AlphaEvolve. DeepMind 2025.</a:t>
+            </a:r>
+          </a:p>
+          <a:p>
+            <a:pPr algn="l">
+              <a:spcAft>
+                <a:spcPts val="800"/>
+              </a:spcAft>
+            </a:pPr>
+            <a:r>
+              <a:rPr sz="1500" b="0">
+                <a:solidFill>
+                  <a:srgbClr val="1A2333"/>
+                </a:solidFill>
+                <a:latin typeface="微软雅黑"/>
+                <a:ea typeface="微软雅黑"/>
+                <a:cs typeface="微软雅黑"/>
+              </a:rPr>
+              <a:t>Ma et al. Eureka. ICLR 2024. arXiv:2310.12931.</a:t>
+            </a:r>
+          </a:p>
+          <a:p>
+            <a:pPr algn="l">
+              <a:spcAft>
+                <a:spcPts val="800"/>
+              </a:spcAft>
+            </a:pPr>
+            <a:r>
+              <a:rPr sz="1500" b="0">
+                <a:solidFill>
+                  <a:srgbClr val="1A2333"/>
+                </a:solidFill>
+                <a:latin typeface="微软雅黑"/>
+                <a:ea typeface="微软雅黑"/>
+                <a:cs typeface="微软雅黑"/>
+              </a:rPr>
+              <a:t>Beel, Kan &amp; Baumgart. AI Scientist 独立评估. ACM SIGIR Forum 2025. arXiv:2502.14297.</a:t>
+            </a:r>
+          </a:p>
+          <a:p>
+            <a:pPr algn="l">
+              <a:spcAft>
+                <a:spcPts val="800"/>
+              </a:spcAft>
+            </a:pPr>
+            <a:r>
+              <a:rPr sz="1500" b="0">
+                <a:solidFill>
+                  <a:srgbClr val="1A2333"/>
+                </a:solidFill>
+                <a:latin typeface="微软雅黑"/>
+                <a:ea typeface="微软雅黑"/>
+                <a:cs typeface="微软雅黑"/>
+              </a:rPr>
+              <a:t>Michel et al. Energy-Optimal Waypoint UAV Missions. 2024. arXiv:2410.17585.</a:t>
+            </a:r>
+          </a:p>
+          <a:p>
+            <a:pPr algn="l">
+              <a:spcAft>
+                <a:spcPts val="800"/>
+              </a:spcAft>
+            </a:pPr>
+            <a:r>
+              <a:rPr sz="1500" b="0">
+                <a:solidFill>
+                  <a:srgbClr val="1A2333"/>
+                </a:solidFill>
+                <a:latin typeface="微软雅黑"/>
+                <a:ea typeface="微软雅黑"/>
+                <a:cs typeface="微软雅黑"/>
+              </a:rPr>
+              <a:t>Nguyen &amp; Au. Extending drone delivery reachable set. AAMAS 2017.</a:t>
+            </a:r>
+          </a:p>
+          <a:p>
+            <a:pPr algn="l">
+              <a:spcAft>
+                <a:spcPts val="800"/>
+              </a:spcAft>
+            </a:pPr>
+            <a:r>
+              <a:rPr sz="1500" b="0">
+                <a:solidFill>
+                  <a:srgbClr val="1A2333"/>
+                </a:solidFill>
+                <a:latin typeface="微软雅黑"/>
+                <a:ea typeface="微软雅黑"/>
+                <a:cs typeface="微软雅黑"/>
+              </a:rPr>
+              <a:t>Karl et al. Position: Embracing Negative Results in ML. ICML 2024.</a:t>
+            </a:r>
+          </a:p>
+          <a:p>
+            <a:pPr algn="l">
+              <a:spcAft>
+                <a:spcPts val="800"/>
+              </a:spcAft>
+            </a:pPr>
+            <a:r>
+              <a:rPr sz="1500" b="0">
+                <a:solidFill>
+                  <a:srgbClr val="1A2333"/>
+                </a:solidFill>
+                <a:latin typeface="微软雅黑"/>
+                <a:ea typeface="微软雅黑"/>
+                <a:cs typeface="微软雅黑"/>
+              </a:rPr>
+              <a:t>Rodrigues et al. DJI M100 energy dataset. Scientific Data 2021.</a:t>
+            </a:r>
+          </a:p>
+          <a:p>
+            <a:pPr algn="l">
+              <a:spcAft>
+                <a:spcPts val="800"/>
+              </a:spcAft>
+            </a:pPr>
+            <a:r>
+              <a:rPr sz="1500" b="0">
+                <a:solidFill>
+                  <a:srgbClr val="1A2333"/>
+                </a:solidFill>
+                <a:latin typeface="微软雅黑"/>
+                <a:ea typeface="微软雅黑"/>
+                <a:cs typeface="微软雅黑"/>
+              </a:rPr>
+              <a:t>Di Franco &amp; Buttazzo 2015;Liu 2017;EcoFlight 2025.</a:t>
             </a:r>
           </a:p>
         </p:txBody>
@@ -8760,61 +8268,7 @@
       </p:sp>
       <p:sp>
         <p:nvSpPr>
-          <p:cNvPr id="4" name="Rounded Rectangle 3"/>
-          <p:cNvSpPr/>
-          <p:nvPr/>
-        </p:nvSpPr>
-        <p:spPr>
-          <a:xfrm>
-            <a:off x="502920" y="365760"/>
-            <a:ext cx="566928" cy="457200"/>
-          </a:xfrm>
-          <a:prstGeom prst="roundRect">
-            <a:avLst/>
-          </a:prstGeom>
-          <a:solidFill>
-            <a:srgbClr val="4472C4"/>
-          </a:solidFill>
-          <a:ln>
-            <a:noFill/>
-          </a:ln>
-        </p:spPr>
-        <p:style>
-          <a:lnRef idx="1">
-            <a:schemeClr val="accent1"/>
-          </a:lnRef>
-          <a:fillRef idx="3">
-            <a:schemeClr val="accent1"/>
-          </a:fillRef>
-          <a:effectRef idx="2">
-            <a:schemeClr val="accent1"/>
-          </a:effectRef>
-          <a:fontRef idx="minor">
-            <a:schemeClr val="lt1"/>
-          </a:fontRef>
-        </p:style>
-        <p:txBody>
-          <a:bodyPr rtlCol="0" anchor="ctr" tIns="0" bIns="0" lIns="0" rIns="0" wrap="none"/>
-          <a:lstStyle/>
-          <a:p>
-            <a:pPr algn="ctr"/>
-            <a:r>
-              <a:rPr sz="1600" b="1">
-                <a:solidFill>
-                  <a:srgbClr val="FFFFFF"/>
-                </a:solidFill>
-                <a:latin typeface="微软雅黑"/>
-                <a:ea typeface="微软雅黑"/>
-                <a:cs typeface="微软雅黑"/>
-              </a:rPr>
-              <a:t>18</a:t>
-            </a:r>
-          </a:p>
-        </p:txBody>
-      </p:sp>
-      <p:sp>
-        <p:nvSpPr>
-          <p:cNvPr id="5" name="TextBox 4"/>
+          <p:cNvPr id="4" name="TextBox 3"/>
           <p:cNvSpPr txBox="1"/>
           <p:nvPr/>
         </p:nvSpPr>
@@ -8848,11 +8302,35 @@
                 <a:ea typeface="微软雅黑"/>
                 <a:cs typeface="微软雅黑"/>
               </a:rPr>
-              <a:t>参考文献</a:t>
-            </a:r>
-          </a:p>
-        </p:txBody>
-      </p:sp>
+              <a:t>附录 A:累加消融阶梯(框架每步都承重)</a:t>
+            </a:r>
+          </a:p>
+        </p:txBody>
+      </p:sp>
+      <p:pic>
+        <p:nvPicPr>
+          <p:cNvPr id="5" name="Picture 4" descr="消融阶梯.png"/>
+          <p:cNvPicPr>
+            <a:picLocks noChangeAspect="1"/>
+          </p:cNvPicPr>
+          <p:nvPr/>
+        </p:nvPicPr>
+        <p:blipFill>
+          <a:blip r:embed="rId2"/>
+          <a:stretch>
+            <a:fillRect/>
+          </a:stretch>
+        </p:blipFill>
+        <p:spPr>
+          <a:xfrm>
+            <a:off x="1914202" y="1737360"/>
+            <a:ext cx="8333116" cy="4480560"/>
+          </a:xfrm>
+          <a:prstGeom prst="rect">
+            <a:avLst/>
+          </a:prstGeom>
+        </p:spPr>
+      </p:pic>
       <p:sp>
         <p:nvSpPr>
           <p:cNvPr id="6" name="TextBox 5"/>
@@ -8861,8 +8339,8 @@
         </p:nvSpPr>
         <p:spPr>
           <a:xfrm>
-            <a:off x="685800" y="1828800"/>
-            <a:ext cx="10972800" cy="4389120"/>
+            <a:off x="502920" y="6400800"/>
+            <a:ext cx="11155680" cy="320040"/>
           </a:xfrm>
           <a:prstGeom prst="rect">
             <a:avLst/>
@@ -8877,163 +8355,19 @@
           <a:p>
             <a:pPr algn="l">
               <a:spcAft>
-                <a:spcPts val="800"/>
-              </a:spcAft>
-            </a:pPr>
-            <a:r>
-              <a:rPr sz="1500" b="0">
-                <a:solidFill>
-                  <a:srgbClr val="1A2333"/>
-                </a:solidFill>
-                <a:latin typeface="微软雅黑"/>
-                <a:ea typeface="微软雅黑"/>
-                <a:cs typeface="微软雅黑"/>
-              </a:rPr>
-              <a:t>Romera-Paredes et al. FunSearch. Nature 2023.</a:t>
-            </a:r>
-          </a:p>
-          <a:p>
-            <a:pPr algn="l">
-              <a:spcAft>
-                <a:spcPts val="800"/>
-              </a:spcAft>
-            </a:pPr>
-            <a:r>
-              <a:rPr sz="1500" b="0">
-                <a:solidFill>
-                  <a:srgbClr val="1A2333"/>
-                </a:solidFill>
-                <a:latin typeface="微软雅黑"/>
-                <a:ea typeface="微软雅黑"/>
-                <a:cs typeface="微软雅黑"/>
-              </a:rPr>
-              <a:t>Novikov et al. AlphaEvolve. DeepMind 2025.</a:t>
-            </a:r>
-          </a:p>
-          <a:p>
-            <a:pPr algn="l">
-              <a:spcAft>
-                <a:spcPts val="800"/>
-              </a:spcAft>
-            </a:pPr>
-            <a:r>
-              <a:rPr sz="1500" b="0">
-                <a:solidFill>
-                  <a:srgbClr val="1A2333"/>
-                </a:solidFill>
-                <a:latin typeface="微软雅黑"/>
-                <a:ea typeface="微软雅黑"/>
-                <a:cs typeface="微软雅黑"/>
-              </a:rPr>
-              <a:t>Ma et al. Eureka. ICLR 2024. arXiv:2310.12931.</a:t>
-            </a:r>
-          </a:p>
-          <a:p>
-            <a:pPr algn="l">
-              <a:spcAft>
-                <a:spcPts val="800"/>
-              </a:spcAft>
-            </a:pPr>
-            <a:r>
-              <a:rPr sz="1500" b="0">
-                <a:solidFill>
-                  <a:srgbClr val="1A2333"/>
-                </a:solidFill>
-                <a:latin typeface="微软雅黑"/>
-                <a:ea typeface="微软雅黑"/>
-                <a:cs typeface="微软雅黑"/>
-              </a:rPr>
-              <a:t>Beel, Kan &amp; Baumgart. AI Scientist 独立评估. ACM SIGIR Forum 2025. arXiv:2502.14297.</a:t>
-            </a:r>
-          </a:p>
-          <a:p>
-            <a:pPr algn="l">
-              <a:spcAft>
-                <a:spcPts val="800"/>
-              </a:spcAft>
-            </a:pPr>
-            <a:r>
-              <a:rPr sz="1500" b="0">
-                <a:solidFill>
-                  <a:srgbClr val="1A2333"/>
-                </a:solidFill>
-                <a:latin typeface="微软雅黑"/>
-                <a:ea typeface="微软雅黑"/>
-                <a:cs typeface="微软雅黑"/>
-              </a:rPr>
-              <a:t>Michel et al. Energy-Optimal Waypoint UAV Missions. 2024. arXiv:2410.17585.</a:t>
-            </a:r>
-          </a:p>
-          <a:p>
-            <a:pPr algn="l">
-              <a:spcAft>
-                <a:spcPts val="800"/>
-              </a:spcAft>
-            </a:pPr>
-            <a:r>
-              <a:rPr sz="1500" b="0">
-                <a:solidFill>
-                  <a:srgbClr val="1A2333"/>
-                </a:solidFill>
-                <a:latin typeface="微软雅黑"/>
-                <a:ea typeface="微软雅黑"/>
-                <a:cs typeface="微软雅黑"/>
-              </a:rPr>
-              <a:t>Nguyen &amp; Au. Extending drone delivery reachable set. AAMAS 2017.</a:t>
-            </a:r>
-          </a:p>
-          <a:p>
-            <a:pPr algn="l">
-              <a:spcAft>
-                <a:spcPts val="800"/>
-              </a:spcAft>
-            </a:pPr>
-            <a:r>
-              <a:rPr sz="1500" b="0">
-                <a:solidFill>
-                  <a:srgbClr val="1A2333"/>
-                </a:solidFill>
-                <a:latin typeface="微软雅黑"/>
-                <a:ea typeface="微软雅黑"/>
-                <a:cs typeface="微软雅黑"/>
-              </a:rPr>
-              <a:t>Karl et al. Position: Embracing Negative Results in ML. ICML 2024.</a:t>
-            </a:r>
-          </a:p>
-          <a:p>
-            <a:pPr algn="l">
-              <a:spcAft>
-                <a:spcPts val="800"/>
-              </a:spcAft>
-            </a:pPr>
-            <a:r>
-              <a:rPr sz="1500" b="0">
-                <a:solidFill>
-                  <a:srgbClr val="1A2333"/>
-                </a:solidFill>
-                <a:latin typeface="微软雅黑"/>
-                <a:ea typeface="微软雅黑"/>
-                <a:cs typeface="微软雅黑"/>
-              </a:rPr>
-              <a:t>Rodrigues et al. DJI M100 energy dataset. Scientific Data 2021.</a:t>
-            </a:r>
-          </a:p>
-          <a:p>
-            <a:pPr algn="l">
-              <a:spcAft>
-                <a:spcPts val="800"/>
-              </a:spcAft>
-            </a:pPr>
-            <a:r>
-              <a:rPr sz="1500" b="0">
-                <a:solidFill>
-                  <a:srgbClr val="1A2333"/>
-                </a:solidFill>
-                <a:latin typeface="微软雅黑"/>
-                <a:ea typeface="微软雅黑"/>
-                <a:cs typeface="微软雅黑"/>
-              </a:rPr>
-              <a:t>Di Franco &amp; Buttazzo 2015;Liu 2017;EcoFlight 2025.</a:t>
+                <a:spcPts val="400"/>
+              </a:spcAft>
+            </a:pPr>
+            <a:r>
+              <a:rPr sz="1100" b="0">
+                <a:solidFill>
+                  <a:srgbClr val="6B7A8D"/>
+                </a:solidFill>
+                <a:latin typeface="微软雅黑"/>
+                <a:ea typeface="微软雅黑"/>
+                <a:cs typeface="微软雅黑"/>
+              </a:rPr>
+              <a:t>逐步加回安全机制:假发现 3→0(左),报告数字保持诚实不虚低(右)</a:t>
             </a:r>
           </a:p>
         </p:txBody>
@@ -9184,14 +8518,14 @@
                 <a:ea typeface="微软雅黑"/>
                 <a:cs typeface="微软雅黑"/>
               </a:rPr>
-              <a:t>附录 A:累加消融阶梯(框架每步都承重)</a:t>
+              <a:t>附录 A2:翻越/绕行能量权衡分解</a:t>
             </a:r>
           </a:p>
         </p:txBody>
       </p:sp>
       <p:pic>
         <p:nvPicPr>
-          <p:cNvPr id="5" name="Picture 4" descr="消融阶梯.png"/>
+          <p:cNvPr id="5" name="Picture 4" descr="翻越绕行权衡.png"/>
           <p:cNvPicPr>
             <a:picLocks noChangeAspect="1"/>
           </p:cNvPicPr>
@@ -9205,8 +8539,8 @@
         </p:blipFill>
         <p:spPr>
           <a:xfrm>
-            <a:off x="1914202" y="1737360"/>
-            <a:ext cx="8333116" cy="4480560"/>
+            <a:off x="2576732" y="1737360"/>
+            <a:ext cx="7008055" cy="4480560"/>
           </a:xfrm>
           <a:prstGeom prst="rect">
             <a:avLst/>
@@ -9249,7 +8583,7 @@
                 <a:ea typeface="微软雅黑"/>
                 <a:cs typeface="微软雅黑"/>
               </a:rPr>
-              <a:t>逐步加回安全机制:假发现 3→0(左),报告数字保持诚实不虚低(右)</a:t>
+              <a:t>翻越=固定爬升罚+少走距离,绕行=无爬升+多走距离,交叉≈半宽24m=相图边界物理解释</a:t>
             </a:r>
           </a:p>
         </p:txBody>
@@ -9400,14 +8734,14 @@
                 <a:ea typeface="微软雅黑"/>
                 <a:cs typeface="微软雅黑"/>
               </a:rPr>
-              <a:t>附录 A2:翻越/绕行能量权衡分解</a:t>
+              <a:t>附录 B:操作包络相图</a:t>
             </a:r>
           </a:p>
         </p:txBody>
       </p:sp>
       <p:pic>
         <p:nvPicPr>
-          <p:cNvPr id="5" name="Picture 4" descr="翻越绕行权衡.png"/>
+          <p:cNvPr id="5" name="Picture 4" descr="操作包络相图.png"/>
           <p:cNvPicPr>
             <a:picLocks noChangeAspect="1"/>
           </p:cNvPicPr>
@@ -9421,8 +8755,8 @@
         </p:blipFill>
         <p:spPr>
           <a:xfrm>
-            <a:off x="2576732" y="1737360"/>
-            <a:ext cx="7008055" cy="4480560"/>
+            <a:off x="2589562" y="1737360"/>
+            <a:ext cx="6982395" cy="4480560"/>
           </a:xfrm>
           <a:prstGeom prst="rect">
             <a:avLst/>
@@ -9465,7 +8799,7 @@
                 <a:ea typeface="微软雅黑"/>
                 <a:cs typeface="微软雅黑"/>
               </a:rPr>
-              <a:t>翻越=固定爬升罚+少走距离,绕行=无爬升+多走距离,交叉≈半宽24m=相图边界物理解释</a:t>
+              <a:t>高速+窄障省 22%,低速/宽障归零</a:t>
             </a:r>
           </a:p>
         </p:txBody>
@@ -9616,14 +8950,14 @@
                 <a:ea typeface="微软雅黑"/>
                 <a:cs typeface="微软雅黑"/>
               </a:rPr>
-              <a:t>附录 B:操作包络相图</a:t>
+              <a:t>附录 C:安全机制消融(评测器抗 gaming)</a:t>
             </a:r>
           </a:p>
         </p:txBody>
       </p:sp>
       <p:pic>
         <p:nvPicPr>
-          <p:cNvPr id="5" name="Picture 4" descr="操作包络相图.png"/>
+          <p:cNvPr id="5" name="Picture 4" descr="safeguard_ablation.png"/>
           <p:cNvPicPr>
             <a:picLocks noChangeAspect="1"/>
           </p:cNvPicPr>
@@ -9637,8 +8971,8 @@
         </p:blipFill>
         <p:spPr>
           <a:xfrm>
-            <a:off x="2589562" y="1737360"/>
-            <a:ext cx="6982395" cy="4480560"/>
+            <a:off x="731520" y="2506599"/>
+            <a:ext cx="10698480" cy="2942082"/>
           </a:xfrm>
           <a:prstGeom prst="rect">
             <a:avLst/>
@@ -9681,7 +9015,7 @@
                 <a:ea typeface="微软雅黑"/>
                 <a:cs typeface="微软雅黑"/>
               </a:rPr>
-              <a:t>高速+窄障省 22%,低速/宽障归零</a:t>
+              <a:t>过拟合探针刷不动;查新门降级 2/3</a:t>
             </a:r>
           </a:p>
         </p:txBody>
@@ -9832,14 +9166,14 @@
                 <a:ea typeface="微软雅黑"/>
                 <a:cs typeface="微软雅黑"/>
               </a:rPr>
-              <a:t>附录 C:安全机制消融(评测器抗 gaming)</a:t>
+              <a:t>附录 D:动力学实飞功率剖面</a:t>
             </a:r>
           </a:p>
         </p:txBody>
       </p:sp>
       <p:pic>
         <p:nvPicPr>
-          <p:cNvPr id="5" name="Picture 4" descr="safeguard_ablation.png"/>
+          <p:cNvPr id="5" name="Picture 4" descr="sim_flight.png"/>
           <p:cNvPicPr>
             <a:picLocks noChangeAspect="1"/>
           </p:cNvPicPr>
@@ -9853,8 +9187,8 @@
         </p:blipFill>
         <p:spPr>
           <a:xfrm>
-            <a:off x="731520" y="2506599"/>
-            <a:ext cx="10698480" cy="2942082"/>
+            <a:off x="731520" y="2573464"/>
+            <a:ext cx="10698480" cy="2808351"/>
           </a:xfrm>
           <a:prstGeom prst="rect">
             <a:avLst/>
@@ -9897,7 +9231,7 @@
                 <a:ea typeface="微软雅黑"/>
                 <a:cs typeface="微软雅黑"/>
               </a:rPr>
-              <a:t>过拟合探针刷不动;查新门降级 2/3</a:t>
+              <a:t>翻墙爬升段飙 870W,绕行平稳</a:t>
             </a:r>
           </a:p>
         </p:txBody>
@@ -9911,222 +9245,6 @@
 </file>
 
 <file path=ppt/slides/slide26.xml><?xml version="1.0" encoding="utf-8"?>
-<p:sld xmlns:a="http://schemas.openxmlformats.org/drawingml/2006/main" xmlns:p="http://schemas.openxmlformats.org/presentationml/2006/main" xmlns:r="http://schemas.openxmlformats.org/officeDocument/2006/relationships">
-  <p:cSld>
-    <p:bg>
-      <p:bgPr>
-        <a:solidFill>
-          <a:srgbClr val="FFFFFF"/>
-        </a:solidFill>
-        <a:effectLst/>
-      </p:bgPr>
-    </p:bg>
-    <p:spTree>
-      <p:nvGrpSpPr>
-        <p:cNvPr id="1" name=""/>
-        <p:cNvGrpSpPr/>
-        <p:nvPr/>
-      </p:nvGrpSpPr>
-      <p:grpSpPr/>
-      <p:sp>
-        <p:nvSpPr>
-          <p:cNvPr id="2" name="Rectangle 1"/>
-          <p:cNvSpPr/>
-          <p:nvPr/>
-        </p:nvSpPr>
-        <p:spPr>
-          <a:xfrm>
-            <a:off x="0" y="0"/>
-            <a:ext cx="109728" cy="6858000"/>
-          </a:xfrm>
-          <a:prstGeom prst="rect">
-            <a:avLst/>
-          </a:prstGeom>
-          <a:solidFill>
-            <a:srgbClr val="4472C4"/>
-          </a:solidFill>
-          <a:ln>
-            <a:noFill/>
-          </a:ln>
-        </p:spPr>
-        <p:style>
-          <a:lnRef idx="1">
-            <a:schemeClr val="accent1"/>
-          </a:lnRef>
-          <a:fillRef idx="3">
-            <a:schemeClr val="accent1"/>
-          </a:fillRef>
-          <a:effectRef idx="2">
-            <a:schemeClr val="accent1"/>
-          </a:effectRef>
-          <a:fontRef idx="minor">
-            <a:schemeClr val="lt1"/>
-          </a:fontRef>
-        </p:style>
-        <p:txBody>
-          <a:bodyPr rtlCol="0" anchor="ctr"/>
-          <a:lstStyle/>
-          <a:p>
-            <a:pPr algn="ctr"/>
-          </a:p>
-        </p:txBody>
-      </p:sp>
-      <p:sp>
-        <p:nvSpPr>
-          <p:cNvPr id="3" name="TextBox 2"/>
-          <p:cNvSpPr txBox="1"/>
-          <p:nvPr/>
-        </p:nvSpPr>
-        <p:spPr>
-          <a:xfrm>
-            <a:off x="9052560" y="292608"/>
-            <a:ext cx="2834640" cy="365760"/>
-          </a:xfrm>
-          <a:prstGeom prst="rect">
-            <a:avLst/>
-          </a:prstGeom>
-          <a:noFill/>
-        </p:spPr>
-        <p:txBody>
-          <a:bodyPr wrap="square" anchor="t" lIns="25400" rIns="25400" tIns="25400" bIns="25400">
-            <a:spAutoFit/>
-          </a:bodyPr>
-          <a:lstStyle/>
-          <a:p>
-            <a:pPr algn="r">
-              <a:spcAft>
-                <a:spcPts val="400"/>
-              </a:spcAft>
-            </a:pPr>
-            <a:r>
-              <a:rPr sz="1200" b="0">
-                <a:solidFill>
-                  <a:srgbClr val="9AA8B8"/>
-                </a:solidFill>
-                <a:latin typeface="微软雅黑"/>
-                <a:ea typeface="微软雅黑"/>
-                <a:cs typeface="微软雅黑"/>
-              </a:rPr>
-              <a:t>西安交通大学</a:t>
-            </a:r>
-          </a:p>
-        </p:txBody>
-      </p:sp>
-      <p:sp>
-        <p:nvSpPr>
-          <p:cNvPr id="4" name="TextBox 3"/>
-          <p:cNvSpPr txBox="1"/>
-          <p:nvPr/>
-        </p:nvSpPr>
-        <p:spPr>
-          <a:xfrm>
-            <a:off x="1143000" y="347472"/>
-            <a:ext cx="10607040" cy="914400"/>
-          </a:xfrm>
-          <a:prstGeom prst="rect">
-            <a:avLst/>
-          </a:prstGeom>
-          <a:noFill/>
-        </p:spPr>
-        <p:txBody>
-          <a:bodyPr wrap="square" anchor="t" lIns="25400" rIns="25400" tIns="25400" bIns="25400">
-            <a:spAutoFit/>
-          </a:bodyPr>
-          <a:lstStyle/>
-          <a:p>
-            <a:pPr algn="l">
-              <a:spcAft>
-                <a:spcPts val="400"/>
-              </a:spcAft>
-            </a:pPr>
-            <a:r>
-              <a:rPr sz="2600" b="1">
-                <a:solidFill>
-                  <a:srgbClr val="0563C1"/>
-                </a:solidFill>
-                <a:latin typeface="微软雅黑"/>
-                <a:ea typeface="微软雅黑"/>
-                <a:cs typeface="微软雅黑"/>
-              </a:rPr>
-              <a:t>附录 D:动力学实飞功率剖面</a:t>
-            </a:r>
-          </a:p>
-        </p:txBody>
-      </p:sp>
-      <p:pic>
-        <p:nvPicPr>
-          <p:cNvPr id="5" name="Picture 4" descr="sim_flight.png"/>
-          <p:cNvPicPr>
-            <a:picLocks noChangeAspect="1"/>
-          </p:cNvPicPr>
-          <p:nvPr/>
-        </p:nvPicPr>
-        <p:blipFill>
-          <a:blip r:embed="rId2"/>
-          <a:stretch>
-            <a:fillRect/>
-          </a:stretch>
-        </p:blipFill>
-        <p:spPr>
-          <a:xfrm>
-            <a:off x="731520" y="2573464"/>
-            <a:ext cx="10698480" cy="2808351"/>
-          </a:xfrm>
-          <a:prstGeom prst="rect">
-            <a:avLst/>
-          </a:prstGeom>
-        </p:spPr>
-      </p:pic>
-      <p:sp>
-        <p:nvSpPr>
-          <p:cNvPr id="6" name="TextBox 5"/>
-          <p:cNvSpPr txBox="1"/>
-          <p:nvPr/>
-        </p:nvSpPr>
-        <p:spPr>
-          <a:xfrm>
-            <a:off x="502920" y="6400800"/>
-            <a:ext cx="11155680" cy="320040"/>
-          </a:xfrm>
-          <a:prstGeom prst="rect">
-            <a:avLst/>
-          </a:prstGeom>
-          <a:noFill/>
-        </p:spPr>
-        <p:txBody>
-          <a:bodyPr wrap="square" anchor="t" lIns="25400" rIns="25400" tIns="25400" bIns="25400">
-            <a:spAutoFit/>
-          </a:bodyPr>
-          <a:lstStyle/>
-          <a:p>
-            <a:pPr algn="l">
-              <a:spcAft>
-                <a:spcPts val="400"/>
-              </a:spcAft>
-            </a:pPr>
-            <a:r>
-              <a:rPr sz="1100" b="0">
-                <a:solidFill>
-                  <a:srgbClr val="6B7A8D"/>
-                </a:solidFill>
-                <a:latin typeface="微软雅黑"/>
-                <a:ea typeface="微软雅黑"/>
-                <a:cs typeface="微软雅黑"/>
-              </a:rPr>
-              <a:t>翻墙爬升段飙 870W,绕行平稳</a:t>
-            </a:r>
-          </a:p>
-        </p:txBody>
-      </p:sp>
-    </p:spTree>
-  </p:cSld>
-  <p:clrMapOvr>
-    <a:masterClrMapping/>
-  </p:clrMapOvr>
-</p:sld>
-</file>
-
-<file path=ppt/slides/slide27.xml><?xml version="1.0" encoding="utf-8"?>
 <p:sld xmlns:a="http://schemas.openxmlformats.org/drawingml/2006/main" xmlns:p="http://schemas.openxmlformats.org/presentationml/2006/main" xmlns:r="http://schemas.openxmlformats.org/officeDocument/2006/relationships">
   <p:cSld>
     <p:bg>

</xml_diff>

<commit_message>
Remove defensive filler ('not framework failure/incompetence', 'regularity-predicted inevitability') — replace with neutral factual statements across slides + figure titles
去辩解式口水话:'不是方法不足'→'性能上限由数据决定';'不是框架无能,是规律预测的必然'→'引导搜索优势随空间复杂度增长';'打平因任务简单'→'优势取决于搜索空间复杂度'。图标题同步。中性陈述不辩解。

Co-Authored-By: Claude Opus 4.8 (1M context) <noreply@anthropic.com>
</commit_message>
<xml_diff>
--- a/autoresearch/energy_m100/experiments/midterm_defense.pptx
+++ b/autoresearch/energy_m100/experiments/midterm_defense.pptx
@@ -5259,7 +5259,7 @@
                 <a:ea typeface="微软雅黑"/>
                 <a:cs typeface="微软雅黑"/>
               </a:rPr>
-              <a:t>性能被数据噪声封顶:52 项模型也压不下 6 项——不是方法不足</a:t>
+              <a:t>性能上限由数据决定:留出误差 6 项处触底,加到 52 项不再降</a:t>
             </a:r>
           </a:p>
         </p:txBody>
@@ -5807,7 +5807,7 @@
               </a:spcAft>
             </a:pPr>
             <a:r>
-              <a:rPr sz="1700" b="1">
+              <a:rPr sz="1600" b="1">
                 <a:solidFill>
                   <a:srgbClr val="0563C1"/>
                 </a:solidFill>
@@ -5815,7 +5815,7 @@
                 <a:ea typeface="微软雅黑"/>
                 <a:cs typeface="微软雅黑"/>
               </a:rPr>
-              <a:t>→ 打平因任务简单,换复杂任务就赢随机</a:t>
+              <a:t>→ 优势取决于搜索空间复杂度:小空间相当,大空间显著胜</a:t>
             </a:r>
           </a:p>
         </p:txBody>
@@ -6126,7 +6126,7 @@
                 <a:ea typeface="微软雅黑"/>
                 <a:cs typeface="微软雅黑"/>
               </a:rPr>
-              <a:t>不是框架无能,是规律预测:</a:t>
+              <a:t>引导搜索优势随空间复杂度增长:</a:t>
             </a:r>
           </a:p>
           <a:p>

</xml_diff>

<commit_message>
De-jargon: 'headroom'->'改进空间', conclusion 'null/封顶域' -> plain Chinese
Co-Authored-By: Claude Opus 4.8 (1M context) <noreply@anthropic.com>
</commit_message>
<xml_diff>
--- a/autoresearch/energy_m100/experiments/midterm_defense.pptx
+++ b/autoresearch/energy_m100/experiments/midterm_defense.pptx
@@ -5761,7 +5761,7 @@
                 <a:ea typeface="微软雅黑"/>
                 <a:cs typeface="微软雅黑"/>
               </a:rPr>
-              <a:t>规划器域(有 headroom):</a:t>
+              <a:t>规划器域(有改进空间):</a:t>
             </a:r>
           </a:p>
           <a:p>
@@ -7378,7 +7378,7 @@
                 <a:ea typeface="微软雅黑"/>
                 <a:cs typeface="微软雅黑"/>
               </a:rPr>
-              <a:t>⑤ 域相关:有 headroom 显著胜随机、封顶域正确产出 null</a:t>
+              <a:t>⑤ 搜索空间大则显著胜随机,空间小(已封顶)则与随机相当</a:t>
             </a:r>
           </a:p>
         </p:txBody>

</xml_diff>

<commit_message>
Annotate ARE definition on energy-modeling slide + reframe title from '但这不是重点' to positive '误差降73%'
能耗迭代页加ARE定义(|预测-真实|/真实,留出飞行取平均,能量=电压×电流积分)。标题'但这不是重点'→正面'从真机数据自动建模:误差降73%(6.88→1.86)'。去自我否定。

Co-Authored-By: Claude Opus 4.8 (1M context) <noreply@anthropic.com>
</commit_message>
<xml_diff>
--- a/autoresearch/energy_m100/experiments/midterm_defense.pptx
+++ b/autoresearch/energy_m100/experiments/midterm_defense.pptx
@@ -3571,7 +3571,7 @@
                 <a:ea typeface="微软雅黑"/>
                 <a:cs typeface="微软雅黑"/>
               </a:rPr>
-              <a:t>能耗模型自动迭代把留出误差从 6.88% 降到 1.86%——但这不是重点</a:t>
+              <a:t>从真机数据自动建模:能耗预测误差降 73%(6.88% → 1.86%)</a:t>
             </a:r>
           </a:p>
         </p:txBody>
@@ -3608,8 +3608,8 @@
         </p:nvSpPr>
         <p:spPr>
           <a:xfrm>
-            <a:off x="7772400" y="1920240"/>
-            <a:ext cx="4023360" cy="4023360"/>
+            <a:off x="7589520" y="1920240"/>
+            <a:ext cx="4297680" cy="4206240"/>
           </a:xfrm>
           <a:prstGeom prst="rect">
             <a:avLst/>
@@ -3624,7 +3624,7 @@
           <a:p>
             <a:pPr algn="l">
               <a:spcAft>
-                <a:spcPts val="1200"/>
+                <a:spcPts val="800"/>
               </a:spcAft>
             </a:pPr>
             <a:r>
@@ -3636,13 +3636,13 @@
                 <a:ea typeface="微软雅黑"/>
                 <a:cs typeface="微软雅黑"/>
               </a:rPr>
-              <a:t>· 冻结评测器 + LLM 每轮改一次 featurize</a:t>
-            </a:r>
-          </a:p>
-          <a:p>
-            <a:pPr algn="l">
-              <a:spcAft>
-                <a:spcPts val="1200"/>
+              <a:t>· 冻结评测器 + LLM 每轮改一次能耗公式</a:t>
+            </a:r>
+          </a:p>
+          <a:p>
+            <a:pPr algn="l">
+              <a:spcAft>
+                <a:spcPts val="800"/>
               </a:spcAft>
             </a:pPr>
             <a:r>
@@ -3654,53 +3654,35 @@
                 <a:ea typeface="微软雅黑"/>
                 <a:cs typeface="微软雅黑"/>
               </a:rPr>
-              <a:t>· iter1–10 全程留出验证 + keep/revert</a:t>
-            </a:r>
-          </a:p>
-          <a:p>
-            <a:pPr algn="l">
-              <a:spcAft>
-                <a:spcPts val="1200"/>
+              <a:t>· iter1–10 全程留出验证 + 保留/回滚</a:t>
+            </a:r>
+          </a:p>
+          <a:p>
+            <a:pPr algn="l">
+              <a:spcAft>
+                <a:spcPts val="800"/>
               </a:spcAft>
             </a:pPr>
             <a:r>
               <a:rPr sz="1600" b="1">
                 <a:solidFill>
-                  <a:srgbClr val="1A2333"/>
-                </a:solidFill>
-                <a:latin typeface="微软雅黑"/>
-                <a:ea typeface="微软雅黑"/>
-                <a:cs typeface="微软雅黑"/>
-              </a:rPr>
-              <a:t>· 相对提升约 73%</a:t>
-            </a:r>
-          </a:p>
-          <a:p>
-            <a:pPr algn="l">
-              <a:spcAft>
-                <a:spcPts val="1200"/>
-              </a:spcAft>
-            </a:pPr>
-            <a:r>
-              <a:rPr sz="1600" b="1">
-                <a:solidFill>
-                  <a:srgbClr val="C0502D"/>
-                </a:solidFill>
-                <a:latin typeface="微软雅黑"/>
-                <a:ea typeface="微软雅黑"/>
-                <a:cs typeface="微软雅黑"/>
-              </a:rPr>
-              <a:t>· 但——结构搜索与随机搜索打平</a:t>
-            </a:r>
-          </a:p>
-          <a:p>
-            <a:pPr algn="l">
-              <a:spcAft>
-                <a:spcPts val="1200"/>
-              </a:spcAft>
-            </a:pPr>
-            <a:r>
-              <a:rPr sz="1500" b="0">
+                  <a:srgbClr val="0563C1"/>
+                </a:solidFill>
+                <a:latin typeface="微软雅黑"/>
+                <a:ea typeface="微软雅黑"/>
+                <a:cs typeface="微软雅黑"/>
+              </a:rPr>
+              <a:t>· 误差 6.88% → 1.86%(相对提升约 73%)</a:t>
+            </a:r>
+          </a:p>
+          <a:p>
+            <a:pPr algn="l">
+              <a:spcAft>
+                <a:spcPts val="800"/>
+              </a:spcAft>
+            </a:pPr>
+            <a:r>
+              <a:rPr sz="800" b="0">
                 <a:solidFill>
                   <a:srgbClr val="6B7A8D"/>
                 </a:solidFill>
@@ -3708,7 +3690,61 @@
                 <a:ea typeface="微软雅黑"/>
                 <a:cs typeface="微软雅黑"/>
               </a:rPr>
-              <a:t>  (见能力边界)</a:t>
+              <a:t/>
+            </a:r>
+          </a:p>
+          <a:p>
+            <a:pPr algn="l">
+              <a:spcAft>
+                <a:spcPts val="800"/>
+              </a:spcAft>
+            </a:pPr>
+            <a:r>
+              <a:rPr sz="1300" b="0">
+                <a:solidFill>
+                  <a:srgbClr val="6B7A8D"/>
+                </a:solidFill>
+                <a:latin typeface="微软雅黑"/>
+                <a:ea typeface="微软雅黑"/>
+                <a:cs typeface="微软雅黑"/>
+              </a:rPr>
+              <a:t>ARE = |预测能量 − 真实能量| / 真实能量</a:t>
+            </a:r>
+          </a:p>
+          <a:p>
+            <a:pPr algn="l">
+              <a:spcAft>
+                <a:spcPts val="800"/>
+              </a:spcAft>
+            </a:pPr>
+            <a:r>
+              <a:rPr sz="1300" b="0">
+                <a:solidFill>
+                  <a:srgbClr val="6B7A8D"/>
+                </a:solidFill>
+                <a:latin typeface="微软雅黑"/>
+                <a:ea typeface="微软雅黑"/>
+                <a:cs typeface="微软雅黑"/>
+              </a:rPr>
+              <a:t>在“未参与训练的飞行”上取平均(防背答案)</a:t>
+            </a:r>
+          </a:p>
+          <a:p>
+            <a:pPr algn="l">
+              <a:spcAft>
+                <a:spcPts val="800"/>
+              </a:spcAft>
+            </a:pPr>
+            <a:r>
+              <a:rPr sz="1300" b="0">
+                <a:solidFill>
+                  <a:srgbClr val="6B7A8D"/>
+                </a:solidFill>
+                <a:latin typeface="微软雅黑"/>
+                <a:ea typeface="微软雅黑"/>
+                <a:cs typeface="微软雅黑"/>
+              </a:rPr>
+              <a:t>能量真值 = 机载电压 × 电流积分</a:t>
             </a:r>
           </a:p>
         </p:txBody>
@@ -3749,7 +3785,7 @@
                 <a:ea typeface="微软雅黑"/>
                 <a:cs typeface="微软雅黑"/>
               </a:rPr>
-              <a:t>冻结评测器 m100_eval.py;数据:真实 DJI M100(209 航班)</a:t>
+              <a:t>数据:真实 DJI M100(209 航班);评测器 m100_eval.py 冻结</a:t>
             </a:r>
           </a:p>
         </p:txBody>

</xml_diff>

<commit_message>
Add sim-smooth-vs-real-noisy power figure + slide: explains why 1.9% is a data floor (real M100 power CV~0.20, kinematics explains only ~40%, rest is wind/voltage/control noise not in observable inputs)
回应观察:真机功率剧烈波动(变异系数0.20,50-950W)vs模型平滑输出。运动学只解释~40%,~60%是不可观测噪声→任何模型学不到→1.9%是数据地板非模型不足→故用能量ARE不用逐点R²。新图noise_vs_smooth+新页11b。

Co-Authored-By: Claude Opus 4.8 (1M context) <noreply@anthropic.com>
</commit_message>
<xml_diff>
--- a/autoresearch/energy_m100/experiments/midterm_defense.pptx
+++ b/autoresearch/energy_m100/experiments/midterm_defense.pptx
@@ -31,6 +31,7 @@
     <p:sldId id="279" r:id="rId30"/>
     <p:sldId id="280" r:id="rId31"/>
     <p:sldId id="281" r:id="rId32"/>
+    <p:sldId id="282" r:id="rId33"/>
   </p:sldIdLst>
   <p:sldSz cx="12191695" cy="6858000" type="screen4x3"/>
   <p:notesSz cx="6858000" cy="9144000"/>
@@ -5678,14 +5679,14 @@
                 <a:ea typeface="微软雅黑"/>
                 <a:cs typeface="微软雅黑"/>
               </a:rPr>
-              <a:t>同框架:有改进空间的域显著胜随机,噪声封顶的域统计打平</a:t>
+              <a:t>为什么封顶:真机功率含大量不可观测噪声(风/电压/控制)</a:t>
             </a:r>
           </a:p>
         </p:txBody>
       </p:sp>
       <p:pic>
         <p:nvPicPr>
-          <p:cNvPr id="6" name="Picture 5" descr="两域显著性.png"/>
+          <p:cNvPr id="6" name="Picture 5" descr="仿真vs真机波动.png"/>
           <p:cNvPicPr>
             <a:picLocks noChangeAspect="1"/>
           </p:cNvPicPr>
@@ -5699,8 +5700,8 @@
         </p:blipFill>
         <p:spPr>
           <a:xfrm>
-            <a:off x="457200" y="2527503"/>
-            <a:ext cx="5760720" cy="2991714"/>
+            <a:off x="457200" y="2405250"/>
+            <a:ext cx="7132320" cy="2687579"/>
           </a:xfrm>
           <a:prstGeom prst="rect">
             <a:avLst/>
@@ -5715,8 +5716,8 @@
         </p:nvSpPr>
         <p:spPr>
           <a:xfrm>
-            <a:off x="6309360" y="1920240"/>
-            <a:ext cx="5486400" cy="4389120"/>
+            <a:off x="7772400" y="1920240"/>
+            <a:ext cx="4114800" cy="4206240"/>
           </a:xfrm>
           <a:prstGeom prst="rect">
             <a:avLst/>
@@ -5731,11 +5732,11 @@
           <a:p>
             <a:pPr algn="l">
               <a:spcAft>
-                <a:spcPts val="1200"/>
-              </a:spcAft>
-            </a:pPr>
-            <a:r>
-              <a:rPr sz="1700" b="1">
+                <a:spcPts val="1100"/>
+              </a:spcAft>
+            </a:pPr>
+            <a:r>
+              <a:rPr sz="1600" b="1">
                 <a:solidFill>
                   <a:srgbClr val="1A2333"/>
                 </a:solidFill>
@@ -5743,17 +5744,17 @@
                 <a:ea typeface="微软雅黑"/>
                 <a:cs typeface="微软雅黑"/>
               </a:rPr>
-              <a:t>能耗域(封顶):</a:t>
-            </a:r>
-          </a:p>
-          <a:p>
-            <a:pPr algn="l">
-              <a:spcAft>
-                <a:spcPts val="1200"/>
-              </a:spcAft>
-            </a:pPr>
-            <a:r>
-              <a:rPr sz="1600" b="0">
+              <a:t>模型输出平滑,真机实测剧烈波动</a:t>
+            </a:r>
+          </a:p>
+          <a:p>
+            <a:pPr algn="l">
+              <a:spcAft>
+                <a:spcPts val="1100"/>
+              </a:spcAft>
+            </a:pPr>
+            <a:r>
+              <a:rPr sz="1500" b="0">
                 <a:solidFill>
                   <a:srgbClr val="1A2333"/>
                 </a:solidFill>
@@ -5761,17 +5762,17 @@
                 <a:ea typeface="微软雅黑"/>
                 <a:cs typeface="微软雅黑"/>
               </a:rPr>
-              <a:t>  loop 1.86% vs 随机 1.87±0.03,z=−0.35</a:t>
-            </a:r>
-          </a:p>
-          <a:p>
-            <a:pPr algn="l">
-              <a:spcAft>
-                <a:spcPts val="1200"/>
-              </a:spcAft>
-            </a:pPr>
-            <a:r>
-              <a:rPr sz="1600" b="0">
+              <a:t>· 真机功率变异系数 ≈0.20(50–950W)</a:t>
+            </a:r>
+          </a:p>
+          <a:p>
+            <a:pPr algn="l">
+              <a:spcAft>
+                <a:spcPts val="1100"/>
+              </a:spcAft>
+            </a:pPr>
+            <a:r>
+              <a:rPr sz="1500" b="0">
                 <a:solidFill>
                   <a:srgbClr val="1A2333"/>
                 </a:solidFill>
@@ -5779,17 +5780,35 @@
                 <a:ea typeface="微软雅黑"/>
                 <a:cs typeface="微软雅黑"/>
               </a:rPr>
-              <a:t>  52% 随机更好 → 统计打平</a:t>
-            </a:r>
-          </a:p>
-          <a:p>
-            <a:pPr algn="l">
-              <a:spcAft>
-                <a:spcPts val="1200"/>
-              </a:spcAft>
-            </a:pPr>
-            <a:r>
-              <a:rPr sz="1700" b="1">
+              <a:t>· 运动学只解释 ~40%</a:t>
+            </a:r>
+          </a:p>
+          <a:p>
+            <a:pPr algn="l">
+              <a:spcAft>
+                <a:spcPts val="1100"/>
+              </a:spcAft>
+            </a:pPr>
+            <a:r>
+              <a:rPr sz="1500" b="1">
+                <a:solidFill>
+                  <a:srgbClr val="C0502D"/>
+                </a:solidFill>
+                <a:latin typeface="微软雅黑"/>
+                <a:ea typeface="微软雅黑"/>
+                <a:cs typeface="微软雅黑"/>
+              </a:rPr>
+              <a:t>· 其余 ~60%=风/电压/控制噪声</a:t>
+            </a:r>
+          </a:p>
+          <a:p>
+            <a:pPr algn="l">
+              <a:spcAft>
+                <a:spcPts val="1100"/>
+              </a:spcAft>
+            </a:pPr>
+            <a:r>
+              <a:rPr sz="1500" b="0">
                 <a:solidFill>
                   <a:srgbClr val="1A2333"/>
                 </a:solidFill>
@@ -5797,53 +5816,17 @@
                 <a:ea typeface="微软雅黑"/>
                 <a:cs typeface="微软雅黑"/>
               </a:rPr>
-              <a:t>规划器域(有改进空间):</a:t>
-            </a:r>
-          </a:p>
-          <a:p>
-            <a:pPr algn="l">
-              <a:spcAft>
-                <a:spcPts val="1200"/>
-              </a:spcAft>
-            </a:pPr>
-            <a:r>
-              <a:rPr sz="1600" b="1">
-                <a:solidFill>
-                  <a:srgbClr val="5B9BD5"/>
-                </a:solidFill>
-                <a:latin typeface="微软雅黑"/>
-                <a:ea typeface="微软雅黑"/>
-                <a:cs typeface="微软雅黑"/>
-              </a:rPr>
-              <a:t>  loop 显著低于随机,z=−2.38</a:t>
-            </a:r>
-          </a:p>
-          <a:p>
-            <a:pPr algn="l">
-              <a:spcAft>
-                <a:spcPts val="1200"/>
-              </a:spcAft>
-            </a:pPr>
-            <a:r>
-              <a:rPr sz="1600" b="0">
-                <a:solidFill>
-                  <a:srgbClr val="1A2333"/>
-                </a:solidFill>
-                <a:latin typeface="微软雅黑"/>
-                <a:ea typeface="微软雅黑"/>
-                <a:cs typeface="微软雅黑"/>
-              </a:rPr>
-              <a:t>  0% 随机更好 → 显著胜</a:t>
-            </a:r>
-          </a:p>
-          <a:p>
-            <a:pPr algn="l">
-              <a:spcAft>
-                <a:spcPts val="1200"/>
-              </a:spcAft>
-            </a:pPr>
-            <a:r>
-              <a:rPr sz="1600" b="1">
+              <a:t>· 不在可观测输入里 → 学不到</a:t>
+            </a:r>
+          </a:p>
+          <a:p>
+            <a:pPr algn="l">
+              <a:spcAft>
+                <a:spcPts val="1100"/>
+              </a:spcAft>
+            </a:pPr>
+            <a:r>
+              <a:rPr sz="1500" b="1">
                 <a:solidFill>
                   <a:srgbClr val="0563C1"/>
                 </a:solidFill>
@@ -5851,7 +5834,7 @@
                 <a:ea typeface="微软雅黑"/>
                 <a:cs typeface="微软雅黑"/>
               </a:rPr>
-              <a:t>→ 优势取决于搜索空间复杂度:小空间相当,大空间显著胜</a:t>
+              <a:t>→ 改追每趟能量 ARE(积分抹平噪声)</a:t>
             </a:r>
           </a:p>
         </p:txBody>
@@ -5892,7 +5875,7 @@
                 <a:ea typeface="微软雅黑"/>
                 <a:cs typeface="微软雅黑"/>
               </a:rPr>
-              <a:t>significance_test.py / planner_significance.py(随机分布 + z 检验)</a:t>
+              <a:t>真机 DJI M100 实测功率(V×I);左=模型预测(平滑),右=真机片段(波动)</a:t>
             </a:r>
           </a:p>
         </p:txBody>
@@ -6097,14 +6080,14 @@
                 <a:ea typeface="微软雅黑"/>
                 <a:cs typeface="微软雅黑"/>
               </a:rPr>
-              <a:t>为什么打平?引导搜索的优势随搜索空间复杂度增长(文献规律)</a:t>
+              <a:t>同框架:有改进空间的域显著胜随机,噪声封顶的域统计打平</a:t>
             </a:r>
           </a:p>
         </p:txBody>
       </p:sp>
       <p:pic>
         <p:nvPicPr>
-          <p:cNvPr id="6" name="Picture 5" descr="复杂度规律.png"/>
+          <p:cNvPr id="6" name="Picture 5" descr="两域显著性.png"/>
           <p:cNvPicPr>
             <a:picLocks noChangeAspect="1"/>
           </p:cNvPicPr>
@@ -6118,8 +6101,8 @@
         </p:blipFill>
         <p:spPr>
           <a:xfrm>
-            <a:off x="457200" y="2095384"/>
-            <a:ext cx="6766560" cy="3673072"/>
+            <a:off x="457200" y="2527503"/>
+            <a:ext cx="5760720" cy="2991714"/>
           </a:xfrm>
           <a:prstGeom prst="rect">
             <a:avLst/>
@@ -6134,8 +6117,8 @@
         </p:nvSpPr>
         <p:spPr>
           <a:xfrm>
-            <a:off x="7406640" y="1920240"/>
-            <a:ext cx="4480560" cy="4389120"/>
+            <a:off x="6309360" y="1920240"/>
+            <a:ext cx="5486400" cy="4389120"/>
           </a:xfrm>
           <a:prstGeom prst="rect">
             <a:avLst/>
@@ -6150,119 +6133,119 @@
           <a:p>
             <a:pPr algn="l">
               <a:spcAft>
-                <a:spcPts val="900"/>
+                <a:spcPts val="1200"/>
+              </a:spcAft>
+            </a:pPr>
+            <a:r>
+              <a:rPr sz="1700" b="1">
+                <a:solidFill>
+                  <a:srgbClr val="1A2333"/>
+                </a:solidFill>
+                <a:latin typeface="微软雅黑"/>
+                <a:ea typeface="微软雅黑"/>
+                <a:cs typeface="微软雅黑"/>
+              </a:rPr>
+              <a:t>能耗域(封顶):</a:t>
+            </a:r>
+          </a:p>
+          <a:p>
+            <a:pPr algn="l">
+              <a:spcAft>
+                <a:spcPts val="1200"/>
+              </a:spcAft>
+            </a:pPr>
+            <a:r>
+              <a:rPr sz="1600" b="0">
+                <a:solidFill>
+                  <a:srgbClr val="1A2333"/>
+                </a:solidFill>
+                <a:latin typeface="微软雅黑"/>
+                <a:ea typeface="微软雅黑"/>
+                <a:cs typeface="微软雅黑"/>
+              </a:rPr>
+              <a:t>  loop 1.86% vs 随机 1.87±0.03,z=−0.35</a:t>
+            </a:r>
+          </a:p>
+          <a:p>
+            <a:pPr algn="l">
+              <a:spcAft>
+                <a:spcPts val="1200"/>
+              </a:spcAft>
+            </a:pPr>
+            <a:r>
+              <a:rPr sz="1600" b="0">
+                <a:solidFill>
+                  <a:srgbClr val="1A2333"/>
+                </a:solidFill>
+                <a:latin typeface="微软雅黑"/>
+                <a:ea typeface="微软雅黑"/>
+                <a:cs typeface="微软雅黑"/>
+              </a:rPr>
+              <a:t>  52% 随机更好 → 统计打平</a:t>
+            </a:r>
+          </a:p>
+          <a:p>
+            <a:pPr algn="l">
+              <a:spcAft>
+                <a:spcPts val="1200"/>
+              </a:spcAft>
+            </a:pPr>
+            <a:r>
+              <a:rPr sz="1700" b="1">
+                <a:solidFill>
+                  <a:srgbClr val="1A2333"/>
+                </a:solidFill>
+                <a:latin typeface="微软雅黑"/>
+                <a:ea typeface="微软雅黑"/>
+                <a:cs typeface="微软雅黑"/>
+              </a:rPr>
+              <a:t>规划器域(有改进空间):</a:t>
+            </a:r>
+          </a:p>
+          <a:p>
+            <a:pPr algn="l">
+              <a:spcAft>
+                <a:spcPts val="1200"/>
               </a:spcAft>
             </a:pPr>
             <a:r>
               <a:rPr sz="1600" b="1">
                 <a:solidFill>
+                  <a:srgbClr val="5B9BD5"/>
+                </a:solidFill>
+                <a:latin typeface="微软雅黑"/>
+                <a:ea typeface="微软雅黑"/>
+                <a:cs typeface="微软雅黑"/>
+              </a:rPr>
+              <a:t>  loop 显著低于随机,z=−2.38</a:t>
+            </a:r>
+          </a:p>
+          <a:p>
+            <a:pPr algn="l">
+              <a:spcAft>
+                <a:spcPts val="1200"/>
+              </a:spcAft>
+            </a:pPr>
+            <a:r>
+              <a:rPr sz="1600" b="0">
+                <a:solidFill>
                   <a:srgbClr val="1A2333"/>
                 </a:solidFill>
                 <a:latin typeface="微软雅黑"/>
                 <a:ea typeface="微软雅黑"/>
                 <a:cs typeface="微软雅黑"/>
               </a:rPr>
-              <a:t>引导搜索优势随空间复杂度增长:</a:t>
-            </a:r>
-          </a:p>
-          <a:p>
-            <a:pPr algn="l">
-              <a:spcAft>
-                <a:spcPts val="900"/>
-              </a:spcAft>
-            </a:pPr>
-            <a:r>
-              <a:rPr sz="1400" b="0">
-                <a:solidFill>
-                  <a:srgbClr val="1A2333"/>
-                </a:solidFill>
-                <a:latin typeface="微软雅黑"/>
-                <a:ea typeface="微软雅黑"/>
-                <a:cs typeface="微软雅黑"/>
-              </a:rPr>
-              <a:t>· Bergstra'12:低有效维→随机追平</a:t>
-            </a:r>
-          </a:p>
-          <a:p>
-            <a:pPr algn="l">
-              <a:spcAft>
-                <a:spcPts val="900"/>
-              </a:spcAft>
-            </a:pPr>
-            <a:r>
-              <a:rPr sz="1400" b="0">
-                <a:solidFill>
-                  <a:srgbClr val="1A2333"/>
-                </a:solidFill>
-                <a:latin typeface="微软雅黑"/>
-                <a:ea typeface="微软雅黑"/>
-                <a:cs typeface="微软雅黑"/>
-              </a:rPr>
-              <a:t>· REMBO:~15–20 维临界点</a:t>
-            </a:r>
-          </a:p>
-          <a:p>
-            <a:pPr algn="l">
-              <a:spcAft>
-                <a:spcPts val="900"/>
-              </a:spcAft>
-            </a:pPr>
-            <a:r>
-              <a:rPr sz="1400" b="0">
-                <a:solidFill>
-                  <a:srgbClr val="1A2333"/>
-                </a:solidFill>
-                <a:latin typeface="微软雅黑"/>
-                <a:ea typeface="微软雅黑"/>
-                <a:cs typeface="微软雅黑"/>
-              </a:rPr>
-              <a:t>· FunSearch:巨大程序空间→引导才行</a:t>
-            </a:r>
-          </a:p>
-          <a:p>
-            <a:pPr algn="l">
-              <a:spcAft>
-                <a:spcPts val="900"/>
-              </a:spcAft>
-            </a:pPr>
-            <a:r>
-              <a:rPr sz="1500" b="1">
-                <a:solidFill>
-                  <a:srgbClr val="C0502D"/>
-                </a:solidFill>
-                <a:latin typeface="微软雅黑"/>
-                <a:ea typeface="微软雅黑"/>
-                <a:cs typeface="微软雅黑"/>
-              </a:rPr>
-              <a:t>· 我们能耗域(小)→打平</a:t>
-            </a:r>
-          </a:p>
-          <a:p>
-            <a:pPr algn="l">
-              <a:spcAft>
-                <a:spcPts val="900"/>
-              </a:spcAft>
-            </a:pPr>
-            <a:r>
-              <a:rPr sz="1500" b="1">
-                <a:solidFill>
-                  <a:srgbClr val="5B9BD5"/>
-                </a:solidFill>
-                <a:latin typeface="微软雅黑"/>
-                <a:ea typeface="微软雅黑"/>
-                <a:cs typeface="微软雅黑"/>
-              </a:rPr>
-              <a:t>· 我们规划器域(大)→胜 27%</a:t>
-            </a:r>
-          </a:p>
-          <a:p>
-            <a:pPr algn="l">
-              <a:spcAft>
-                <a:spcPts val="900"/>
-              </a:spcAft>
-            </a:pPr>
-            <a:r>
-              <a:rPr sz="1500" b="1">
+              <a:t>  0% 随机更好 → 显著胜</a:t>
+            </a:r>
+          </a:p>
+          <a:p>
+            <a:pPr algn="l">
+              <a:spcAft>
+                <a:spcPts val="1200"/>
+              </a:spcAft>
+            </a:pPr>
+            <a:r>
+              <a:rPr sz="1600" b="1">
                 <a:solidFill>
                   <a:srgbClr val="0563C1"/>
                 </a:solidFill>
@@ -6270,7 +6253,7 @@
                 <a:ea typeface="微软雅黑"/>
                 <a:cs typeface="微软雅黑"/>
               </a:rPr>
-              <a:t>→ 同框架横跨两端点,亲手印证规律</a:t>
+              <a:t>→ 优势取决于搜索空间复杂度:小空间相当,大空间显著胜</a:t>
             </a:r>
           </a:p>
         </p:txBody>
@@ -6311,7 +6294,7 @@
                 <a:ea typeface="微软雅黑"/>
                 <a:cs typeface="微软雅黑"/>
               </a:rPr>
-              <a:t>规律=文献综合;两端点=我们实测。CMU《Hidden Pitfalls》2509.08713 反证可信性为刚需</a:t>
+              <a:t>significance_test.py / planner_significance.py(随机分布 + z 检验)</a:t>
             </a:r>
           </a:p>
         </p:txBody>
@@ -6516,14 +6499,14 @@
                 <a:ea typeface="微软雅黑"/>
                 <a:cs typeface="微软雅黑"/>
               </a:rPr>
-              <a:t>用 vs 不用:朴素 AI4S 声称 4 项假发现且藏负结果,我们相反</a:t>
+              <a:t>为什么打平?引导搜索的优势随搜索空间复杂度增长(文献规律)</a:t>
             </a:r>
           </a:p>
         </p:txBody>
       </p:sp>
       <p:pic>
         <p:nvPicPr>
-          <p:cNvPr id="6" name="Picture 5" descr="naive_vs_trustworthy.png"/>
+          <p:cNvPr id="6" name="Picture 5" descr="复杂度规律.png"/>
           <p:cNvPicPr>
             <a:picLocks noChangeAspect="1"/>
           </p:cNvPicPr>
@@ -6537,8 +6520,8 @@
         </p:blipFill>
         <p:spPr>
           <a:xfrm>
-            <a:off x="548640" y="2326234"/>
-            <a:ext cx="8412480" cy="3028492"/>
+            <a:off x="457200" y="2095384"/>
+            <a:ext cx="6766560" cy="3673072"/>
           </a:xfrm>
           <a:prstGeom prst="rect">
             <a:avLst/>
@@ -6553,8 +6536,8 @@
         </p:nvSpPr>
         <p:spPr>
           <a:xfrm>
-            <a:off x="9144000" y="2011680"/>
-            <a:ext cx="2651760" cy="4023360"/>
+            <a:off x="7406640" y="1920240"/>
+            <a:ext cx="4480560" cy="4389120"/>
           </a:xfrm>
           <a:prstGeom prst="rect">
             <a:avLst/>
@@ -6569,47 +6552,101 @@
           <a:p>
             <a:pPr algn="l">
               <a:spcAft>
-                <a:spcPts val="1200"/>
+                <a:spcPts val="900"/>
               </a:spcAft>
             </a:pPr>
             <a:r>
               <a:rPr sz="1600" b="1">
                 <a:solidFill>
+                  <a:srgbClr val="1A2333"/>
+                </a:solidFill>
+                <a:latin typeface="微软雅黑"/>
+                <a:ea typeface="微软雅黑"/>
+                <a:cs typeface="微软雅黑"/>
+              </a:rPr>
+              <a:t>引导搜索优势随空间复杂度增长:</a:t>
+            </a:r>
+          </a:p>
+          <a:p>
+            <a:pPr algn="l">
+              <a:spcAft>
+                <a:spcPts val="900"/>
+              </a:spcAft>
+            </a:pPr>
+            <a:r>
+              <a:rPr sz="1400" b="0">
+                <a:solidFill>
+                  <a:srgbClr val="1A2333"/>
+                </a:solidFill>
+                <a:latin typeface="微软雅黑"/>
+                <a:ea typeface="微软雅黑"/>
+                <a:cs typeface="微软雅黑"/>
+              </a:rPr>
+              <a:t>· Bergstra'12:低有效维→随机追平</a:t>
+            </a:r>
+          </a:p>
+          <a:p>
+            <a:pPr algn="l">
+              <a:spcAft>
+                <a:spcPts val="900"/>
+              </a:spcAft>
+            </a:pPr>
+            <a:r>
+              <a:rPr sz="1400" b="0">
+                <a:solidFill>
+                  <a:srgbClr val="1A2333"/>
+                </a:solidFill>
+                <a:latin typeface="微软雅黑"/>
+                <a:ea typeface="微软雅黑"/>
+                <a:cs typeface="微软雅黑"/>
+              </a:rPr>
+              <a:t>· REMBO:~15–20 维临界点</a:t>
+            </a:r>
+          </a:p>
+          <a:p>
+            <a:pPr algn="l">
+              <a:spcAft>
+                <a:spcPts val="900"/>
+              </a:spcAft>
+            </a:pPr>
+            <a:r>
+              <a:rPr sz="1400" b="0">
+                <a:solidFill>
+                  <a:srgbClr val="1A2333"/>
+                </a:solidFill>
+                <a:latin typeface="微软雅黑"/>
+                <a:ea typeface="微软雅黑"/>
+                <a:cs typeface="微软雅黑"/>
+              </a:rPr>
+              <a:t>· FunSearch:巨大程序空间→引导才行</a:t>
+            </a:r>
+          </a:p>
+          <a:p>
+            <a:pPr algn="l">
+              <a:spcAft>
+                <a:spcPts val="900"/>
+              </a:spcAft>
+            </a:pPr>
+            <a:r>
+              <a:rPr sz="1500" b="1">
+                <a:solidFill>
                   <a:srgbClr val="C0502D"/>
                 </a:solidFill>
                 <a:latin typeface="微软雅黑"/>
                 <a:ea typeface="微软雅黑"/>
                 <a:cs typeface="微软雅黑"/>
               </a:rPr>
-              <a:t>朴素:</a:t>
-            </a:r>
-          </a:p>
-          <a:p>
-            <a:pPr algn="l">
-              <a:spcAft>
-                <a:spcPts val="1200"/>
-              </a:spcAft>
-            </a:pPr>
-            <a:r>
-              <a:rPr sz="1500" b="0">
-                <a:solidFill>
-                  <a:srgbClr val="1A2333"/>
-                </a:solidFill>
-                <a:latin typeface="微软雅黑"/>
-                <a:ea typeface="微软雅黑"/>
-                <a:cs typeface="微软雅黑"/>
-              </a:rPr>
-              <a:t>4 假发现 + 0 负结果</a:t>
-            </a:r>
-          </a:p>
-          <a:p>
-            <a:pPr algn="l">
-              <a:spcAft>
-                <a:spcPts val="1200"/>
-              </a:spcAft>
-            </a:pPr>
-            <a:r>
-              <a:rPr sz="1600" b="1">
+              <a:t>· 我们能耗域(小)→打平</a:t>
+            </a:r>
+          </a:p>
+          <a:p>
+            <a:pPr algn="l">
+              <a:spcAft>
+                <a:spcPts val="900"/>
+              </a:spcAft>
+            </a:pPr>
+            <a:r>
+              <a:rPr sz="1500" b="1">
                 <a:solidFill>
                   <a:srgbClr val="5B9BD5"/>
                 </a:solidFill>
@@ -6617,61 +6654,25 @@
                 <a:ea typeface="微软雅黑"/>
                 <a:cs typeface="微软雅黑"/>
               </a:rPr>
-              <a:t>我们:</a:t>
-            </a:r>
-          </a:p>
-          <a:p>
-            <a:pPr algn="l">
-              <a:spcAft>
-                <a:spcPts val="1200"/>
-              </a:spcAft>
-            </a:pPr>
-            <a:r>
-              <a:rPr sz="1500" b="0">
-                <a:solidFill>
-                  <a:srgbClr val="1A2333"/>
-                </a:solidFill>
-                <a:latin typeface="微软雅黑"/>
-                <a:ea typeface="微软雅黑"/>
-                <a:cs typeface="微软雅黑"/>
-              </a:rPr>
-              <a:t>0 真新 + 4 负结果</a:t>
-            </a:r>
-          </a:p>
-          <a:p>
-            <a:pPr algn="l">
-              <a:spcAft>
-                <a:spcPts val="1200"/>
-              </a:spcAft>
-            </a:pPr>
-            <a:r>
-              <a:rPr sz="1500" b="0">
-                <a:solidFill>
-                  <a:srgbClr val="1A2333"/>
-                </a:solidFill>
-                <a:latin typeface="微软雅黑"/>
-                <a:ea typeface="微软雅黑"/>
-                <a:cs typeface="微软雅黑"/>
-              </a:rPr>
-              <a:t>一个自信但错,</a:t>
-            </a:r>
-          </a:p>
-          <a:p>
-            <a:pPr algn="l">
-              <a:spcAft>
-                <a:spcPts val="1200"/>
+              <a:t>· 我们规划器域(大)→胜 27%</a:t>
+            </a:r>
+          </a:p>
+          <a:p>
+            <a:pPr algn="l">
+              <a:spcAft>
+                <a:spcPts val="900"/>
               </a:spcAft>
             </a:pPr>
             <a:r>
               <a:rPr sz="1500" b="1">
                 <a:solidFill>
-                  <a:srgbClr val="1A2333"/>
-                </a:solidFill>
-                <a:latin typeface="微软雅黑"/>
-                <a:ea typeface="微软雅黑"/>
-                <a:cs typeface="微软雅黑"/>
-              </a:rPr>
-              <a:t>一个 humbler 但对。</a:t>
+                  <a:srgbClr val="0563C1"/>
+                </a:solidFill>
+                <a:latin typeface="微软雅黑"/>
+                <a:ea typeface="微软雅黑"/>
+                <a:cs typeface="微软雅黑"/>
+              </a:rPr>
+              <a:t>→ 同框架横跨两端点,亲手印证规律</a:t>
             </a:r>
           </a:p>
         </p:txBody>
@@ -6712,7 +6713,7 @@
                 <a:ea typeface="微软雅黑"/>
                 <a:cs typeface="微软雅黑"/>
               </a:rPr>
-              <a:t>naive_vs_trustworthy.py(同数据同候选,端到端产出对照)</a:t>
+              <a:t>规律=文献综合;两端点=我们实测。CMU《Hidden Pitfalls》2509.08713 反证可信性为刚需</a:t>
             </a:r>
           </a:p>
         </p:txBody>
@@ -6917,14 +6918,14 @@
                 <a:ea typeface="微软雅黑"/>
                 <a:cs typeface="微软雅黑"/>
               </a:rPr>
-              <a:t>诚实边界:多数场景无收益,载荷无效,贡献是方法学而非发现</a:t>
+              <a:t>用 vs 不用:朴素 AI4S 声称 4 项假发现且藏负结果,我们相反</a:t>
             </a:r>
           </a:p>
         </p:txBody>
       </p:sp>
       <p:pic>
         <p:nvPicPr>
-          <p:cNvPr id="6" name="Picture 5" descr="省能分布_n250.png"/>
+          <p:cNvPr id="6" name="Picture 5" descr="naive_vs_trustworthy.png"/>
           <p:cNvPicPr>
             <a:picLocks noChangeAspect="1"/>
           </p:cNvPicPr>
@@ -6938,8 +6939,8 @@
         </p:blipFill>
         <p:spPr>
           <a:xfrm>
-            <a:off x="562672" y="1828800"/>
-            <a:ext cx="6829936" cy="4114800"/>
+            <a:off x="548640" y="2326234"/>
+            <a:ext cx="8412480" cy="3028492"/>
           </a:xfrm>
           <a:prstGeom prst="rect">
             <a:avLst/>
@@ -6954,8 +6955,8 @@
         </p:nvSpPr>
         <p:spPr>
           <a:xfrm>
-            <a:off x="7680960" y="1920240"/>
-            <a:ext cx="4114800" cy="4206240"/>
+            <a:off x="9144000" y="2011680"/>
+            <a:ext cx="2651760" cy="4023360"/>
           </a:xfrm>
           <a:prstGeom prst="rect">
             <a:avLst/>
@@ -6970,11 +6971,29 @@
           <a:p>
             <a:pPr algn="l">
               <a:spcAft>
-                <a:spcPts val="1100"/>
-              </a:spcAft>
-            </a:pPr>
-            <a:r>
-              <a:rPr sz="1600" b="0">
+                <a:spcPts val="1200"/>
+              </a:spcAft>
+            </a:pPr>
+            <a:r>
+              <a:rPr sz="1600" b="1">
+                <a:solidFill>
+                  <a:srgbClr val="C0502D"/>
+                </a:solidFill>
+                <a:latin typeface="微软雅黑"/>
+                <a:ea typeface="微软雅黑"/>
+                <a:cs typeface="微软雅黑"/>
+              </a:rPr>
+              <a:t>朴素:</a:t>
+            </a:r>
+          </a:p>
+          <a:p>
+            <a:pPr algn="l">
+              <a:spcAft>
+                <a:spcPts val="1200"/>
+              </a:spcAft>
+            </a:pPr>
+            <a:r>
+              <a:rPr sz="1500" b="0">
                 <a:solidFill>
                   <a:srgbClr val="1A2333"/>
                 </a:solidFill>
@@ -6982,17 +7001,35 @@
                 <a:ea typeface="微软雅黑"/>
                 <a:cs typeface="微软雅黑"/>
               </a:rPr>
-              <a:t>· n=250 场景:中位省能 0%</a:t>
-            </a:r>
-          </a:p>
-          <a:p>
-            <a:pPr algn="l">
-              <a:spcAft>
-                <a:spcPts val="1100"/>
-              </a:spcAft>
-            </a:pPr>
-            <a:r>
-              <a:rPr sz="1600" b="0">
+              <a:t>4 假发现 + 0 负结果</a:t>
+            </a:r>
+          </a:p>
+          <a:p>
+            <a:pPr algn="l">
+              <a:spcAft>
+                <a:spcPts val="1200"/>
+              </a:spcAft>
+            </a:pPr>
+            <a:r>
+              <a:rPr sz="1600" b="1">
+                <a:solidFill>
+                  <a:srgbClr val="5B9BD5"/>
+                </a:solidFill>
+                <a:latin typeface="微软雅黑"/>
+                <a:ea typeface="微软雅黑"/>
+                <a:cs typeface="微软雅黑"/>
+              </a:rPr>
+              <a:t>我们:</a:t>
+            </a:r>
+          </a:p>
+          <a:p>
+            <a:pPr algn="l">
+              <a:spcAft>
+                <a:spcPts val="1200"/>
+              </a:spcAft>
+            </a:pPr>
+            <a:r>
+              <a:rPr sz="1500" b="0">
                 <a:solidFill>
                   <a:srgbClr val="1A2333"/>
                 </a:solidFill>
@@ -7000,17 +7037,17 @@
                 <a:ea typeface="微软雅黑"/>
                 <a:cs typeface="微软雅黑"/>
               </a:rPr>
-              <a:t>· 77% 场景零收益(有低空走廊)</a:t>
-            </a:r>
-          </a:p>
-          <a:p>
-            <a:pPr algn="l">
-              <a:spcAft>
-                <a:spcPts val="1100"/>
-              </a:spcAft>
-            </a:pPr>
-            <a:r>
-              <a:rPr sz="1600" b="0">
+              <a:t>0 真新 + 4 负结果</a:t>
+            </a:r>
+          </a:p>
+          <a:p>
+            <a:pPr algn="l">
+              <a:spcAft>
+                <a:spcPts val="1200"/>
+              </a:spcAft>
+            </a:pPr>
+            <a:r>
+              <a:rPr sz="1500" b="0">
                 <a:solidFill>
                   <a:srgbClr val="1A2333"/>
                 </a:solidFill>
@@ -7018,17 +7055,17 @@
                 <a:ea typeface="微软雅黑"/>
                 <a:cs typeface="微软雅黑"/>
               </a:rPr>
-              <a:t>· 仅 20% ≥3%,CI[15.5,25.4]%</a:t>
-            </a:r>
-          </a:p>
-          <a:p>
-            <a:pPr algn="l">
-              <a:spcAft>
-                <a:spcPts val="1100"/>
-              </a:spcAft>
-            </a:pPr>
-            <a:r>
-              <a:rPr sz="1600" b="0">
+              <a:t>一个自信但错,</a:t>
+            </a:r>
+          </a:p>
+          <a:p>
+            <a:pPr algn="l">
+              <a:spcAft>
+                <a:spcPts val="1200"/>
+              </a:spcAft>
+            </a:pPr>
+            <a:r>
+              <a:rPr sz="1500" b="1">
                 <a:solidFill>
                   <a:srgbClr val="1A2333"/>
                 </a:solidFill>
@@ -7036,43 +7073,7 @@
                 <a:ea typeface="微软雅黑"/>
                 <a:cs typeface="微软雅黑"/>
               </a:rPr>
-              <a:t>· 载荷 ≤500g:全扫不改变路径</a:t>
-            </a:r>
-          </a:p>
-          <a:p>
-            <a:pPr algn="l">
-              <a:spcAft>
-                <a:spcPts val="1100"/>
-              </a:spcAft>
-            </a:pPr>
-            <a:r>
-              <a:rPr sz="1600" b="0">
-                <a:solidFill>
-                  <a:srgbClr val="1A2333"/>
-                </a:solidFill>
-                <a:latin typeface="微软雅黑"/>
-                <a:ea typeface="微软雅黑"/>
-                <a:cs typeface="微软雅黑"/>
-              </a:rPr>
-              <a:t>· 无真机飞行(止于仿真)</a:t>
-            </a:r>
-          </a:p>
-          <a:p>
-            <a:pPr algn="l">
-              <a:spcAft>
-                <a:spcPts val="1100"/>
-              </a:spcAft>
-            </a:pPr>
-            <a:r>
-              <a:rPr sz="1600" b="1">
-                <a:solidFill>
-                  <a:srgbClr val="0563C1"/>
-                </a:solidFill>
-                <a:latin typeface="微软雅黑"/>
-                <a:ea typeface="微软雅黑"/>
-                <a:cs typeface="微软雅黑"/>
-              </a:rPr>
-              <a:t>→ 不挑场景、不硬凑,诚实统计</a:t>
+              <a:t>一个 humbler 但对。</a:t>
             </a:r>
           </a:p>
         </p:txBody>
@@ -7113,7 +7114,7 @@
                 <a:ea typeface="微软雅黑"/>
                 <a:cs typeface="微软雅黑"/>
               </a:rPr>
-              <a:t>large_scale_savings.py;可信 null 是被接受的贡献(ICML 2024)</a:t>
+              <a:t>naive_vs_trustworthy.py(同数据同候选,端到端产出对照)</a:t>
             </a:r>
           </a:p>
         </p:txBody>
@@ -7132,7 +7133,7 @@
     <p:bg>
       <p:bgPr>
         <a:solidFill>
-          <a:srgbClr val="0A2A66"/>
+          <a:srgbClr val="FFFFFF"/>
         </a:solidFill>
         <a:effectLst/>
       </p:bgPr>
@@ -7159,7 +7160,7 @@
             <a:avLst/>
           </a:prstGeom>
           <a:solidFill>
-            <a:srgbClr val="5B9BD5"/>
+            <a:srgbClr val="4472C4"/>
           </a:solidFill>
           <a:ln>
             <a:noFill/>
@@ -7187,9 +7188,145 @@
           </a:p>
         </p:txBody>
       </p:sp>
+      <p:sp>
+        <p:nvSpPr>
+          <p:cNvPr id="3" name="TextBox 2"/>
+          <p:cNvSpPr txBox="1"/>
+          <p:nvPr/>
+        </p:nvSpPr>
+        <p:spPr>
+          <a:xfrm>
+            <a:off x="9052560" y="292608"/>
+            <a:ext cx="2834640" cy="365760"/>
+          </a:xfrm>
+          <a:prstGeom prst="rect">
+            <a:avLst/>
+          </a:prstGeom>
+          <a:noFill/>
+        </p:spPr>
+        <p:txBody>
+          <a:bodyPr wrap="square" anchor="t" lIns="25400" rIns="25400" tIns="25400" bIns="25400">
+            <a:spAutoFit/>
+          </a:bodyPr>
+          <a:lstStyle/>
+          <a:p>
+            <a:pPr algn="r">
+              <a:spcAft>
+                <a:spcPts val="400"/>
+              </a:spcAft>
+            </a:pPr>
+            <a:r>
+              <a:rPr sz="1200" b="0">
+                <a:solidFill>
+                  <a:srgbClr val="9AA8B8"/>
+                </a:solidFill>
+                <a:latin typeface="微软雅黑"/>
+                <a:ea typeface="微软雅黑"/>
+                <a:cs typeface="微软雅黑"/>
+              </a:rPr>
+              <a:t>西安交通大学</a:t>
+            </a:r>
+          </a:p>
+        </p:txBody>
+      </p:sp>
+      <p:sp>
+        <p:nvSpPr>
+          <p:cNvPr id="4" name="Rounded Rectangle 3"/>
+          <p:cNvSpPr/>
+          <p:nvPr/>
+        </p:nvSpPr>
+        <p:spPr>
+          <a:xfrm>
+            <a:off x="502920" y="365760"/>
+            <a:ext cx="566928" cy="457200"/>
+          </a:xfrm>
+          <a:prstGeom prst="roundRect">
+            <a:avLst/>
+          </a:prstGeom>
+          <a:solidFill>
+            <a:srgbClr val="4472C4"/>
+          </a:solidFill>
+          <a:ln>
+            <a:noFill/>
+          </a:ln>
+        </p:spPr>
+        <p:style>
+          <a:lnRef idx="1">
+            <a:schemeClr val="accent1"/>
+          </a:lnRef>
+          <a:fillRef idx="3">
+            <a:schemeClr val="accent1"/>
+          </a:fillRef>
+          <a:effectRef idx="2">
+            <a:schemeClr val="accent1"/>
+          </a:effectRef>
+          <a:fontRef idx="minor">
+            <a:schemeClr val="lt1"/>
+          </a:fontRef>
+        </p:style>
+        <p:txBody>
+          <a:bodyPr rtlCol="0" anchor="ctr" tIns="0" bIns="0" lIns="0" rIns="0" wrap="none"/>
+          <a:lstStyle/>
+          <a:p>
+            <a:pPr algn="ctr"/>
+            <a:r>
+              <a:rPr sz="1600" b="1">
+                <a:solidFill>
+                  <a:srgbClr val="FFFFFF"/>
+                </a:solidFill>
+                <a:latin typeface="微软雅黑"/>
+                <a:ea typeface="微软雅黑"/>
+                <a:cs typeface="微软雅黑"/>
+              </a:rPr>
+              <a:t>16</a:t>
+            </a:r>
+          </a:p>
+        </p:txBody>
+      </p:sp>
+      <p:sp>
+        <p:nvSpPr>
+          <p:cNvPr id="5" name="TextBox 4"/>
+          <p:cNvSpPr txBox="1"/>
+          <p:nvPr/>
+        </p:nvSpPr>
+        <p:spPr>
+          <a:xfrm>
+            <a:off x="1143000" y="347472"/>
+            <a:ext cx="10607040" cy="914400"/>
+          </a:xfrm>
+          <a:prstGeom prst="rect">
+            <a:avLst/>
+          </a:prstGeom>
+          <a:noFill/>
+        </p:spPr>
+        <p:txBody>
+          <a:bodyPr wrap="square" anchor="t" lIns="25400" rIns="25400" tIns="25400" bIns="25400">
+            <a:spAutoFit/>
+          </a:bodyPr>
+          <a:lstStyle/>
+          <a:p>
+            <a:pPr algn="l">
+              <a:spcAft>
+                <a:spcPts val="400"/>
+              </a:spcAft>
+            </a:pPr>
+            <a:r>
+              <a:rPr sz="2600" b="1">
+                <a:solidFill>
+                  <a:srgbClr val="0563C1"/>
+                </a:solidFill>
+                <a:latin typeface="微软雅黑"/>
+                <a:ea typeface="微软雅黑"/>
+                <a:cs typeface="微软雅黑"/>
+              </a:rPr>
+              <a:t>诚实边界:多数场景无收益,载荷无效,贡献是方法学而非发现</a:t>
+            </a:r>
+          </a:p>
+        </p:txBody>
+      </p:sp>
       <p:pic>
         <p:nvPicPr>
-          <p:cNvPr id="3" name="Picture 2" descr="xjtu_logo_white.png"/>
+          <p:cNvPr id="6" name="Picture 5" descr="省能分布_n250.png"/>
           <p:cNvPicPr>
             <a:picLocks noChangeAspect="1"/>
           </p:cNvPicPr>
@@ -7203,8 +7340,8 @@
         </p:blipFill>
         <p:spPr>
           <a:xfrm>
-            <a:off x="8686800" y="365760"/>
-            <a:ext cx="1707229" cy="457200"/>
+            <a:off x="562672" y="1828800"/>
+            <a:ext cx="6829936" cy="4114800"/>
           </a:xfrm>
           <a:prstGeom prst="rect">
             <a:avLst/>
@@ -7213,68 +7350,14 @@
       </p:pic>
       <p:sp>
         <p:nvSpPr>
-          <p:cNvPr id="4" name="Rounded Rectangle 3"/>
-          <p:cNvSpPr/>
-          <p:nvPr/>
-        </p:nvSpPr>
-        <p:spPr>
-          <a:xfrm>
-            <a:off x="502920" y="365760"/>
-            <a:ext cx="566928" cy="457200"/>
-          </a:xfrm>
-          <a:prstGeom prst="roundRect">
-            <a:avLst/>
-          </a:prstGeom>
-          <a:solidFill>
-            <a:srgbClr val="5B9BD5"/>
-          </a:solidFill>
-          <a:ln>
-            <a:noFill/>
-          </a:ln>
-        </p:spPr>
-        <p:style>
-          <a:lnRef idx="1">
-            <a:schemeClr val="accent1"/>
-          </a:lnRef>
-          <a:fillRef idx="3">
-            <a:schemeClr val="accent1"/>
-          </a:fillRef>
-          <a:effectRef idx="2">
-            <a:schemeClr val="accent1"/>
-          </a:effectRef>
-          <a:fontRef idx="minor">
-            <a:schemeClr val="lt1"/>
-          </a:fontRef>
-        </p:style>
-        <p:txBody>
-          <a:bodyPr rtlCol="0" anchor="ctr" tIns="0" bIns="0" lIns="0" rIns="0" wrap="none"/>
-          <a:lstStyle/>
-          <a:p>
-            <a:pPr algn="ctr"/>
-            <a:r>
-              <a:rPr sz="1600" b="1">
-                <a:solidFill>
-                  <a:srgbClr val="FFFFFF"/>
-                </a:solidFill>
-                <a:latin typeface="微软雅黑"/>
-                <a:ea typeface="微软雅黑"/>
-                <a:cs typeface="微软雅黑"/>
-              </a:rPr>
-              <a:t>16</a:t>
-            </a:r>
-          </a:p>
-        </p:txBody>
-      </p:sp>
-      <p:sp>
-        <p:nvSpPr>
-          <p:cNvPr id="5" name="TextBox 4"/>
+          <p:cNvPr id="7" name="TextBox 6"/>
           <p:cNvSpPr txBox="1"/>
           <p:nvPr/>
         </p:nvSpPr>
         <p:spPr>
           <a:xfrm>
-            <a:off x="822960" y="1188720"/>
-            <a:ext cx="10515600" cy="640080"/>
+            <a:off x="7680960" y="1920240"/>
+            <a:ext cx="4114800" cy="4206240"/>
           </a:xfrm>
           <a:prstGeom prst="rect">
             <a:avLst/>
@@ -7289,33 +7372,123 @@
           <a:p>
             <a:pPr algn="l">
               <a:spcAft>
-                <a:spcPts val="400"/>
-              </a:spcAft>
-            </a:pPr>
-            <a:r>
-              <a:rPr sz="2400" b="1">
-                <a:solidFill>
-                  <a:srgbClr val="5B9BD5"/>
-                </a:solidFill>
-                <a:latin typeface="微软雅黑"/>
-                <a:ea typeface="微软雅黑"/>
-                <a:cs typeface="微软雅黑"/>
-              </a:rPr>
-              <a:t>结论</a:t>
-            </a:r>
-          </a:p>
-        </p:txBody>
-      </p:sp>
-      <p:sp>
-        <p:nvSpPr>
-          <p:cNvPr id="6" name="TextBox 5"/>
+                <a:spcPts val="1100"/>
+              </a:spcAft>
+            </a:pPr>
+            <a:r>
+              <a:rPr sz="1600" b="0">
+                <a:solidFill>
+                  <a:srgbClr val="1A2333"/>
+                </a:solidFill>
+                <a:latin typeface="微软雅黑"/>
+                <a:ea typeface="微软雅黑"/>
+                <a:cs typeface="微软雅黑"/>
+              </a:rPr>
+              <a:t>· n=250 场景:中位省能 0%</a:t>
+            </a:r>
+          </a:p>
+          <a:p>
+            <a:pPr algn="l">
+              <a:spcAft>
+                <a:spcPts val="1100"/>
+              </a:spcAft>
+            </a:pPr>
+            <a:r>
+              <a:rPr sz="1600" b="0">
+                <a:solidFill>
+                  <a:srgbClr val="1A2333"/>
+                </a:solidFill>
+                <a:latin typeface="微软雅黑"/>
+                <a:ea typeface="微软雅黑"/>
+                <a:cs typeface="微软雅黑"/>
+              </a:rPr>
+              <a:t>· 77% 场景零收益(有低空走廊)</a:t>
+            </a:r>
+          </a:p>
+          <a:p>
+            <a:pPr algn="l">
+              <a:spcAft>
+                <a:spcPts val="1100"/>
+              </a:spcAft>
+            </a:pPr>
+            <a:r>
+              <a:rPr sz="1600" b="0">
+                <a:solidFill>
+                  <a:srgbClr val="1A2333"/>
+                </a:solidFill>
+                <a:latin typeface="微软雅黑"/>
+                <a:ea typeface="微软雅黑"/>
+                <a:cs typeface="微软雅黑"/>
+              </a:rPr>
+              <a:t>· 仅 20% ≥3%,CI[15.5,25.4]%</a:t>
+            </a:r>
+          </a:p>
+          <a:p>
+            <a:pPr algn="l">
+              <a:spcAft>
+                <a:spcPts val="1100"/>
+              </a:spcAft>
+            </a:pPr>
+            <a:r>
+              <a:rPr sz="1600" b="0">
+                <a:solidFill>
+                  <a:srgbClr val="1A2333"/>
+                </a:solidFill>
+                <a:latin typeface="微软雅黑"/>
+                <a:ea typeface="微软雅黑"/>
+                <a:cs typeface="微软雅黑"/>
+              </a:rPr>
+              <a:t>· 载荷 ≤500g:全扫不改变路径</a:t>
+            </a:r>
+          </a:p>
+          <a:p>
+            <a:pPr algn="l">
+              <a:spcAft>
+                <a:spcPts val="1100"/>
+              </a:spcAft>
+            </a:pPr>
+            <a:r>
+              <a:rPr sz="1600" b="0">
+                <a:solidFill>
+                  <a:srgbClr val="1A2333"/>
+                </a:solidFill>
+                <a:latin typeface="微软雅黑"/>
+                <a:ea typeface="微软雅黑"/>
+                <a:cs typeface="微软雅黑"/>
+              </a:rPr>
+              <a:t>· 无真机飞行(止于仿真)</a:t>
+            </a:r>
+          </a:p>
+          <a:p>
+            <a:pPr algn="l">
+              <a:spcAft>
+                <a:spcPts val="1100"/>
+              </a:spcAft>
+            </a:pPr>
+            <a:r>
+              <a:rPr sz="1600" b="1">
+                <a:solidFill>
+                  <a:srgbClr val="0563C1"/>
+                </a:solidFill>
+                <a:latin typeface="微软雅黑"/>
+                <a:ea typeface="微软雅黑"/>
+                <a:cs typeface="微软雅黑"/>
+              </a:rPr>
+              <a:t>→ 不挑场景、不硬凑,诚实统计</a:t>
+            </a:r>
+          </a:p>
+        </p:txBody>
+      </p:sp>
+      <p:sp>
+        <p:nvSpPr>
+          <p:cNvPr id="8" name="TextBox 7"/>
           <p:cNvSpPr txBox="1"/>
           <p:nvPr/>
         </p:nvSpPr>
         <p:spPr>
           <a:xfrm>
-            <a:off x="822960" y="2103120"/>
-            <a:ext cx="10698480" cy="4023360"/>
+            <a:off x="502920" y="6400800"/>
+            <a:ext cx="11155680" cy="320040"/>
           </a:xfrm>
           <a:prstGeom prst="rect">
             <a:avLst/>
@@ -7330,91 +7503,19 @@
           <a:p>
             <a:pPr algn="l">
               <a:spcAft>
-                <a:spcPts val="1600"/>
-              </a:spcAft>
-            </a:pPr>
-            <a:r>
-              <a:rPr sz="2100" b="0">
-                <a:solidFill>
-                  <a:srgbClr val="FFFFFF"/>
-                </a:solidFill>
-                <a:latin typeface="微软雅黑"/>
-                <a:ea typeface="微软雅黑"/>
-                <a:cs typeface="微软雅黑"/>
-              </a:rPr>
-              <a:t>① 不声称新算法/新效应——三次查新确认均为 prior art,主动引用</a:t>
-            </a:r>
-          </a:p>
-          <a:p>
-            <a:pPr algn="l">
-              <a:spcAft>
-                <a:spcPts val="1600"/>
-              </a:spcAft>
-            </a:pPr>
-            <a:r>
-              <a:rPr sz="2100" b="1">
-                <a:solidFill>
-                  <a:srgbClr val="5B9BD5"/>
-                </a:solidFill>
-                <a:latin typeface="微软雅黑"/>
-                <a:ea typeface="微软雅黑"/>
-                <a:cs typeface="微软雅黑"/>
-              </a:rPr>
-              <a:t>② 贡献 = 可信自动科研方法学 + 真机数据锚定 + 诚实能力边界</a:t>
-            </a:r>
-          </a:p>
-          <a:p>
-            <a:pPr algn="l">
-              <a:spcAft>
-                <a:spcPts val="1600"/>
-              </a:spcAft>
-            </a:pPr>
-            <a:r>
-              <a:rPr sz="2100" b="0">
-                <a:solidFill>
-                  <a:srgbClr val="FFFFFF"/>
-                </a:solidFill>
-                <a:latin typeface="微软雅黑"/>
-                <a:ea typeface="微软雅黑"/>
-                <a:cs typeface="微软雅黑"/>
-              </a:rPr>
-              <a:t>③ 逐个消融证明每道节点“承重”:去掉即退化/overclaim</a:t>
-            </a:r>
-          </a:p>
-          <a:p>
-            <a:pPr algn="l">
-              <a:spcAft>
-                <a:spcPts val="1600"/>
-              </a:spcAft>
-            </a:pPr>
-            <a:r>
-              <a:rPr sz="2100" b="0">
-                <a:solidFill>
-                  <a:srgbClr val="FFFFFF"/>
-                </a:solidFill>
-                <a:latin typeface="微软雅黑"/>
-                <a:ea typeface="微软雅黑"/>
-                <a:cs typeface="微软雅黑"/>
-              </a:rPr>
-              <a:t>④ 价值 = 在该 overclaim 处不 overclaim,并量化能力边界</a:t>
-            </a:r>
-          </a:p>
-          <a:p>
-            <a:pPr algn="l">
-              <a:spcAft>
-                <a:spcPts val="1600"/>
-              </a:spcAft>
-            </a:pPr>
-            <a:r>
-              <a:rPr sz="2100" b="0">
-                <a:solidFill>
-                  <a:srgbClr val="FFFFFF"/>
-                </a:solidFill>
-                <a:latin typeface="微软雅黑"/>
-                <a:ea typeface="微软雅黑"/>
-                <a:cs typeface="微软雅黑"/>
-              </a:rPr>
-              <a:t>⑤ 搜索空间大则显著胜随机,空间小(已封顶)则与随机相当</a:t>
+                <a:spcPts val="400"/>
+              </a:spcAft>
+            </a:pPr>
+            <a:r>
+              <a:rPr sz="1100" b="0">
+                <a:solidFill>
+                  <a:srgbClr val="6B7A8D"/>
+                </a:solidFill>
+                <a:latin typeface="微软雅黑"/>
+                <a:ea typeface="微软雅黑"/>
+                <a:cs typeface="微软雅黑"/>
+              </a:rPr>
+              <a:t>large_scale_savings.py;可信 null 是被接受的贡献(ICML 2024)</a:t>
             </a:r>
           </a:p>
         </p:txBody>
@@ -7816,7 +7917,7 @@
     <p:bg>
       <p:bgPr>
         <a:solidFill>
-          <a:srgbClr val="FFFFFF"/>
+          <a:srgbClr val="0A2A66"/>
         </a:solidFill>
         <a:effectLst/>
       </p:bgPr>
@@ -7843,7 +7944,7 @@
             <a:avLst/>
           </a:prstGeom>
           <a:solidFill>
-            <a:srgbClr val="4472C4"/>
+            <a:srgbClr val="5B9BD5"/>
           </a:solidFill>
           <a:ln>
             <a:noFill/>
@@ -7871,47 +7972,30 @@
           </a:p>
         </p:txBody>
       </p:sp>
-      <p:sp>
-        <p:nvSpPr>
-          <p:cNvPr id="3" name="TextBox 2"/>
-          <p:cNvSpPr txBox="1"/>
-          <p:nvPr/>
-        </p:nvSpPr>
-        <p:spPr>
-          <a:xfrm>
-            <a:off x="9052560" y="292608"/>
-            <a:ext cx="2834640" cy="365760"/>
-          </a:xfrm>
-          <a:prstGeom prst="rect">
-            <a:avLst/>
-          </a:prstGeom>
-          <a:noFill/>
-        </p:spPr>
-        <p:txBody>
-          <a:bodyPr wrap="square" anchor="t" lIns="25400" rIns="25400" tIns="25400" bIns="25400">
-            <a:spAutoFit/>
-          </a:bodyPr>
-          <a:lstStyle/>
-          <a:p>
-            <a:pPr algn="r">
-              <a:spcAft>
-                <a:spcPts val="400"/>
-              </a:spcAft>
-            </a:pPr>
-            <a:r>
-              <a:rPr sz="1200" b="0">
-                <a:solidFill>
-                  <a:srgbClr val="9AA8B8"/>
-                </a:solidFill>
-                <a:latin typeface="微软雅黑"/>
-                <a:ea typeface="微软雅黑"/>
-                <a:cs typeface="微软雅黑"/>
-              </a:rPr>
-              <a:t>西安交通大学</a:t>
-            </a:r>
-          </a:p>
-        </p:txBody>
-      </p:sp>
+      <p:pic>
+        <p:nvPicPr>
+          <p:cNvPr id="3" name="Picture 2" descr="xjtu_logo_white.png"/>
+          <p:cNvPicPr>
+            <a:picLocks noChangeAspect="1"/>
+          </p:cNvPicPr>
+          <p:nvPr/>
+        </p:nvPicPr>
+        <p:blipFill>
+          <a:blip r:embed="rId2"/>
+          <a:stretch>
+            <a:fillRect/>
+          </a:stretch>
+        </p:blipFill>
+        <p:spPr>
+          <a:xfrm>
+            <a:off x="8686800" y="365760"/>
+            <a:ext cx="1707229" cy="457200"/>
+          </a:xfrm>
+          <a:prstGeom prst="rect">
+            <a:avLst/>
+          </a:prstGeom>
+        </p:spPr>
+      </p:pic>
       <p:sp>
         <p:nvSpPr>
           <p:cNvPr id="4" name="Rounded Rectangle 3"/>
@@ -7927,7 +8011,7 @@
             <a:avLst/>
           </a:prstGeom>
           <a:solidFill>
-            <a:srgbClr val="4472C4"/>
+            <a:srgbClr val="5B9BD5"/>
           </a:solidFill>
           <a:ln>
             <a:noFill/>
@@ -7974,8 +8058,8 @@
         </p:nvSpPr>
         <p:spPr>
           <a:xfrm>
-            <a:off x="1143000" y="347472"/>
-            <a:ext cx="10607040" cy="914400"/>
+            <a:off x="822960" y="1188720"/>
+            <a:ext cx="10515600" cy="640080"/>
           </a:xfrm>
           <a:prstGeom prst="rect">
             <a:avLst/>
@@ -7994,15 +8078,15 @@
               </a:spcAft>
             </a:pPr>
             <a:r>
-              <a:rPr sz="2600" b="1">
-                <a:solidFill>
-                  <a:srgbClr val="0563C1"/>
-                </a:solidFill>
-                <a:latin typeface="微软雅黑"/>
-                <a:ea typeface="微软雅黑"/>
-                <a:cs typeface="微软雅黑"/>
-              </a:rPr>
-              <a:t>参考文献</a:t>
+              <a:rPr sz="2400" b="1">
+                <a:solidFill>
+                  <a:srgbClr val="5B9BD5"/>
+                </a:solidFill>
+                <a:latin typeface="微软雅黑"/>
+                <a:ea typeface="微软雅黑"/>
+                <a:cs typeface="微软雅黑"/>
+              </a:rPr>
+              <a:t>结论</a:t>
             </a:r>
           </a:p>
         </p:txBody>
@@ -8015,8 +8099,8 @@
         </p:nvSpPr>
         <p:spPr>
           <a:xfrm>
-            <a:off x="685800" y="1828800"/>
-            <a:ext cx="10972800" cy="4389120"/>
+            <a:off x="822960" y="2103120"/>
+            <a:ext cx="10698480" cy="4023360"/>
           </a:xfrm>
           <a:prstGeom prst="rect">
             <a:avLst/>
@@ -8031,163 +8115,91 @@
           <a:p>
             <a:pPr algn="l">
               <a:spcAft>
-                <a:spcPts val="800"/>
-              </a:spcAft>
-            </a:pPr>
-            <a:r>
-              <a:rPr sz="1500" b="0">
-                <a:solidFill>
-                  <a:srgbClr val="1A2333"/>
-                </a:solidFill>
-                <a:latin typeface="微软雅黑"/>
-                <a:ea typeface="微软雅黑"/>
-                <a:cs typeface="微软雅黑"/>
-              </a:rPr>
-              <a:t>Romera-Paredes et al. FunSearch. Nature 2023.</a:t>
-            </a:r>
-          </a:p>
-          <a:p>
-            <a:pPr algn="l">
-              <a:spcAft>
-                <a:spcPts val="800"/>
-              </a:spcAft>
-            </a:pPr>
-            <a:r>
-              <a:rPr sz="1500" b="0">
-                <a:solidFill>
-                  <a:srgbClr val="1A2333"/>
-                </a:solidFill>
-                <a:latin typeface="微软雅黑"/>
-                <a:ea typeface="微软雅黑"/>
-                <a:cs typeface="微软雅黑"/>
-              </a:rPr>
-              <a:t>Novikov et al. AlphaEvolve. DeepMind 2025.</a:t>
-            </a:r>
-          </a:p>
-          <a:p>
-            <a:pPr algn="l">
-              <a:spcAft>
-                <a:spcPts val="800"/>
-              </a:spcAft>
-            </a:pPr>
-            <a:r>
-              <a:rPr sz="1500" b="0">
-                <a:solidFill>
-                  <a:srgbClr val="1A2333"/>
-                </a:solidFill>
-                <a:latin typeface="微软雅黑"/>
-                <a:ea typeface="微软雅黑"/>
-                <a:cs typeface="微软雅黑"/>
-              </a:rPr>
-              <a:t>Ma et al. Eureka. ICLR 2024. arXiv:2310.12931.</a:t>
-            </a:r>
-          </a:p>
-          <a:p>
-            <a:pPr algn="l">
-              <a:spcAft>
-                <a:spcPts val="800"/>
-              </a:spcAft>
-            </a:pPr>
-            <a:r>
-              <a:rPr sz="1500" b="0">
-                <a:solidFill>
-                  <a:srgbClr val="1A2333"/>
-                </a:solidFill>
-                <a:latin typeface="微软雅黑"/>
-                <a:ea typeface="微软雅黑"/>
-                <a:cs typeface="微软雅黑"/>
-              </a:rPr>
-              <a:t>Beel, Kan &amp; Baumgart. AI Scientist 独立评估. ACM SIGIR Forum 2025. arXiv:2502.14297.</a:t>
-            </a:r>
-          </a:p>
-          <a:p>
-            <a:pPr algn="l">
-              <a:spcAft>
-                <a:spcPts val="800"/>
-              </a:spcAft>
-            </a:pPr>
-            <a:r>
-              <a:rPr sz="1500" b="0">
-                <a:solidFill>
-                  <a:srgbClr val="1A2333"/>
-                </a:solidFill>
-                <a:latin typeface="微软雅黑"/>
-                <a:ea typeface="微软雅黑"/>
-                <a:cs typeface="微软雅黑"/>
-              </a:rPr>
-              <a:t>Michel et al. Energy-Optimal Waypoint UAV Missions. 2024. arXiv:2410.17585.</a:t>
-            </a:r>
-          </a:p>
-          <a:p>
-            <a:pPr algn="l">
-              <a:spcAft>
-                <a:spcPts val="800"/>
-              </a:spcAft>
-            </a:pPr>
-            <a:r>
-              <a:rPr sz="1500" b="0">
-                <a:solidFill>
-                  <a:srgbClr val="1A2333"/>
-                </a:solidFill>
-                <a:latin typeface="微软雅黑"/>
-                <a:ea typeface="微软雅黑"/>
-                <a:cs typeface="微软雅黑"/>
-              </a:rPr>
-              <a:t>Nguyen &amp; Au. Extending drone delivery reachable set. AAMAS 2017.</a:t>
-            </a:r>
-          </a:p>
-          <a:p>
-            <a:pPr algn="l">
-              <a:spcAft>
-                <a:spcPts val="800"/>
-              </a:spcAft>
-            </a:pPr>
-            <a:r>
-              <a:rPr sz="1500" b="0">
-                <a:solidFill>
-                  <a:srgbClr val="1A2333"/>
-                </a:solidFill>
-                <a:latin typeface="微软雅黑"/>
-                <a:ea typeface="微软雅黑"/>
-                <a:cs typeface="微软雅黑"/>
-              </a:rPr>
-              <a:t>Karl et al. Position: Embracing Negative Results in ML. ICML 2024.</a:t>
-            </a:r>
-          </a:p>
-          <a:p>
-            <a:pPr algn="l">
-              <a:spcAft>
-                <a:spcPts val="800"/>
-              </a:spcAft>
-            </a:pPr>
-            <a:r>
-              <a:rPr sz="1500" b="0">
-                <a:solidFill>
-                  <a:srgbClr val="1A2333"/>
-                </a:solidFill>
-                <a:latin typeface="微软雅黑"/>
-                <a:ea typeface="微软雅黑"/>
-                <a:cs typeface="微软雅黑"/>
-              </a:rPr>
-              <a:t>Rodrigues et al. DJI M100 energy dataset. Scientific Data 2021.</a:t>
-            </a:r>
-          </a:p>
-          <a:p>
-            <a:pPr algn="l">
-              <a:spcAft>
-                <a:spcPts val="800"/>
-              </a:spcAft>
-            </a:pPr>
-            <a:r>
-              <a:rPr sz="1500" b="0">
-                <a:solidFill>
-                  <a:srgbClr val="1A2333"/>
-                </a:solidFill>
-                <a:latin typeface="微软雅黑"/>
-                <a:ea typeface="微软雅黑"/>
-                <a:cs typeface="微软雅黑"/>
-              </a:rPr>
-              <a:t>Di Franco &amp; Buttazzo 2015;Liu 2017;EcoFlight 2025.</a:t>
+                <a:spcPts val="1600"/>
+              </a:spcAft>
+            </a:pPr>
+            <a:r>
+              <a:rPr sz="2100" b="0">
+                <a:solidFill>
+                  <a:srgbClr val="FFFFFF"/>
+                </a:solidFill>
+                <a:latin typeface="微软雅黑"/>
+                <a:ea typeface="微软雅黑"/>
+                <a:cs typeface="微软雅黑"/>
+              </a:rPr>
+              <a:t>① 不声称新算法/新效应——三次查新确认均为 prior art,主动引用</a:t>
+            </a:r>
+          </a:p>
+          <a:p>
+            <a:pPr algn="l">
+              <a:spcAft>
+                <a:spcPts val="1600"/>
+              </a:spcAft>
+            </a:pPr>
+            <a:r>
+              <a:rPr sz="2100" b="1">
+                <a:solidFill>
+                  <a:srgbClr val="5B9BD5"/>
+                </a:solidFill>
+                <a:latin typeface="微软雅黑"/>
+                <a:ea typeface="微软雅黑"/>
+                <a:cs typeface="微软雅黑"/>
+              </a:rPr>
+              <a:t>② 贡献 = 可信自动科研方法学 + 真机数据锚定 + 诚实能力边界</a:t>
+            </a:r>
+          </a:p>
+          <a:p>
+            <a:pPr algn="l">
+              <a:spcAft>
+                <a:spcPts val="1600"/>
+              </a:spcAft>
+            </a:pPr>
+            <a:r>
+              <a:rPr sz="2100" b="0">
+                <a:solidFill>
+                  <a:srgbClr val="FFFFFF"/>
+                </a:solidFill>
+                <a:latin typeface="微软雅黑"/>
+                <a:ea typeface="微软雅黑"/>
+                <a:cs typeface="微软雅黑"/>
+              </a:rPr>
+              <a:t>③ 逐个消融证明每道节点“承重”:去掉即退化/overclaim</a:t>
+            </a:r>
+          </a:p>
+          <a:p>
+            <a:pPr algn="l">
+              <a:spcAft>
+                <a:spcPts val="1600"/>
+              </a:spcAft>
+            </a:pPr>
+            <a:r>
+              <a:rPr sz="2100" b="0">
+                <a:solidFill>
+                  <a:srgbClr val="FFFFFF"/>
+                </a:solidFill>
+                <a:latin typeface="微软雅黑"/>
+                <a:ea typeface="微软雅黑"/>
+                <a:cs typeface="微软雅黑"/>
+              </a:rPr>
+              <a:t>④ 价值 = 在该 overclaim 处不 overclaim,并量化能力边界</a:t>
+            </a:r>
+          </a:p>
+          <a:p>
+            <a:pPr algn="l">
+              <a:spcAft>
+                <a:spcPts val="1600"/>
+              </a:spcAft>
+            </a:pPr>
+            <a:r>
+              <a:rPr sz="2100" b="0">
+                <a:solidFill>
+                  <a:srgbClr val="FFFFFF"/>
+                </a:solidFill>
+                <a:latin typeface="微软雅黑"/>
+                <a:ea typeface="微软雅黑"/>
+                <a:cs typeface="微软雅黑"/>
+              </a:rPr>
+              <a:t>⑤ 搜索空间大则显著胜随机,空间小(已封顶)则与随机相当</a:t>
             </a:r>
           </a:p>
         </p:txBody>
@@ -8304,7 +8316,61 @@
       </p:sp>
       <p:sp>
         <p:nvSpPr>
-          <p:cNvPr id="4" name="TextBox 3"/>
+          <p:cNvPr id="4" name="Rounded Rectangle 3"/>
+          <p:cNvSpPr/>
+          <p:nvPr/>
+        </p:nvSpPr>
+        <p:spPr>
+          <a:xfrm>
+            <a:off x="502920" y="365760"/>
+            <a:ext cx="566928" cy="457200"/>
+          </a:xfrm>
+          <a:prstGeom prst="roundRect">
+            <a:avLst/>
+          </a:prstGeom>
+          <a:solidFill>
+            <a:srgbClr val="4472C4"/>
+          </a:solidFill>
+          <a:ln>
+            <a:noFill/>
+          </a:ln>
+        </p:spPr>
+        <p:style>
+          <a:lnRef idx="1">
+            <a:schemeClr val="accent1"/>
+          </a:lnRef>
+          <a:fillRef idx="3">
+            <a:schemeClr val="accent1"/>
+          </a:fillRef>
+          <a:effectRef idx="2">
+            <a:schemeClr val="accent1"/>
+          </a:effectRef>
+          <a:fontRef idx="minor">
+            <a:schemeClr val="lt1"/>
+          </a:fontRef>
+        </p:style>
+        <p:txBody>
+          <a:bodyPr rtlCol="0" anchor="ctr" tIns="0" bIns="0" lIns="0" rIns="0" wrap="none"/>
+          <a:lstStyle/>
+          <a:p>
+            <a:pPr algn="ctr"/>
+            <a:r>
+              <a:rPr sz="1600" b="1">
+                <a:solidFill>
+                  <a:srgbClr val="FFFFFF"/>
+                </a:solidFill>
+                <a:latin typeface="微软雅黑"/>
+                <a:ea typeface="微软雅黑"/>
+                <a:cs typeface="微软雅黑"/>
+              </a:rPr>
+              <a:t>18</a:t>
+            </a:r>
+          </a:p>
+        </p:txBody>
+      </p:sp>
+      <p:sp>
+        <p:nvSpPr>
+          <p:cNvPr id="5" name="TextBox 4"/>
           <p:cNvSpPr txBox="1"/>
           <p:nvPr/>
         </p:nvSpPr>
@@ -8338,35 +8404,11 @@
                 <a:ea typeface="微软雅黑"/>
                 <a:cs typeface="微软雅黑"/>
               </a:rPr>
-              <a:t>附录 A:累加消融阶梯(框架每步都承重)</a:t>
-            </a:r>
-          </a:p>
-        </p:txBody>
-      </p:sp>
-      <p:pic>
-        <p:nvPicPr>
-          <p:cNvPr id="5" name="Picture 4" descr="消融阶梯.png"/>
-          <p:cNvPicPr>
-            <a:picLocks noChangeAspect="1"/>
-          </p:cNvPicPr>
-          <p:nvPr/>
-        </p:nvPicPr>
-        <p:blipFill>
-          <a:blip r:embed="rId2"/>
-          <a:stretch>
-            <a:fillRect/>
-          </a:stretch>
-        </p:blipFill>
-        <p:spPr>
-          <a:xfrm>
-            <a:off x="1914202" y="1737360"/>
-            <a:ext cx="8333116" cy="4480560"/>
-          </a:xfrm>
-          <a:prstGeom prst="rect">
-            <a:avLst/>
-          </a:prstGeom>
-        </p:spPr>
-      </p:pic>
+              <a:t>参考文献</a:t>
+            </a:r>
+          </a:p>
+        </p:txBody>
+      </p:sp>
       <p:sp>
         <p:nvSpPr>
           <p:cNvPr id="6" name="TextBox 5"/>
@@ -8375,8 +8417,8 @@
         </p:nvSpPr>
         <p:spPr>
           <a:xfrm>
-            <a:off x="502920" y="6400800"/>
-            <a:ext cx="11155680" cy="320040"/>
+            <a:off x="685800" y="1828800"/>
+            <a:ext cx="10972800" cy="4389120"/>
           </a:xfrm>
           <a:prstGeom prst="rect">
             <a:avLst/>
@@ -8391,19 +8433,163 @@
           <a:p>
             <a:pPr algn="l">
               <a:spcAft>
-                <a:spcPts val="400"/>
-              </a:spcAft>
-            </a:pPr>
-            <a:r>
-              <a:rPr sz="1100" b="0">
-                <a:solidFill>
-                  <a:srgbClr val="6B7A8D"/>
-                </a:solidFill>
-                <a:latin typeface="微软雅黑"/>
-                <a:ea typeface="微软雅黑"/>
-                <a:cs typeface="微软雅黑"/>
-              </a:rPr>
-              <a:t>逐步加回安全机制:假发现 3→0(左),报告数字保持诚实不虚低(右)</a:t>
+                <a:spcPts val="800"/>
+              </a:spcAft>
+            </a:pPr>
+            <a:r>
+              <a:rPr sz="1500" b="0">
+                <a:solidFill>
+                  <a:srgbClr val="1A2333"/>
+                </a:solidFill>
+                <a:latin typeface="微软雅黑"/>
+                <a:ea typeface="微软雅黑"/>
+                <a:cs typeface="微软雅黑"/>
+              </a:rPr>
+              <a:t>Romera-Paredes et al. FunSearch. Nature 2023.</a:t>
+            </a:r>
+          </a:p>
+          <a:p>
+            <a:pPr algn="l">
+              <a:spcAft>
+                <a:spcPts val="800"/>
+              </a:spcAft>
+            </a:pPr>
+            <a:r>
+              <a:rPr sz="1500" b="0">
+                <a:solidFill>
+                  <a:srgbClr val="1A2333"/>
+                </a:solidFill>
+                <a:latin typeface="微软雅黑"/>
+                <a:ea typeface="微软雅黑"/>
+                <a:cs typeface="微软雅黑"/>
+              </a:rPr>
+              <a:t>Novikov et al. AlphaEvolve. DeepMind 2025.</a:t>
+            </a:r>
+          </a:p>
+          <a:p>
+            <a:pPr algn="l">
+              <a:spcAft>
+                <a:spcPts val="800"/>
+              </a:spcAft>
+            </a:pPr>
+            <a:r>
+              <a:rPr sz="1500" b="0">
+                <a:solidFill>
+                  <a:srgbClr val="1A2333"/>
+                </a:solidFill>
+                <a:latin typeface="微软雅黑"/>
+                <a:ea typeface="微软雅黑"/>
+                <a:cs typeface="微软雅黑"/>
+              </a:rPr>
+              <a:t>Ma et al. Eureka. ICLR 2024. arXiv:2310.12931.</a:t>
+            </a:r>
+          </a:p>
+          <a:p>
+            <a:pPr algn="l">
+              <a:spcAft>
+                <a:spcPts val="800"/>
+              </a:spcAft>
+            </a:pPr>
+            <a:r>
+              <a:rPr sz="1500" b="0">
+                <a:solidFill>
+                  <a:srgbClr val="1A2333"/>
+                </a:solidFill>
+                <a:latin typeface="微软雅黑"/>
+                <a:ea typeface="微软雅黑"/>
+                <a:cs typeface="微软雅黑"/>
+              </a:rPr>
+              <a:t>Beel, Kan &amp; Baumgart. AI Scientist 独立评估. ACM SIGIR Forum 2025. arXiv:2502.14297.</a:t>
+            </a:r>
+          </a:p>
+          <a:p>
+            <a:pPr algn="l">
+              <a:spcAft>
+                <a:spcPts val="800"/>
+              </a:spcAft>
+            </a:pPr>
+            <a:r>
+              <a:rPr sz="1500" b="0">
+                <a:solidFill>
+                  <a:srgbClr val="1A2333"/>
+                </a:solidFill>
+                <a:latin typeface="微软雅黑"/>
+                <a:ea typeface="微软雅黑"/>
+                <a:cs typeface="微软雅黑"/>
+              </a:rPr>
+              <a:t>Michel et al. Energy-Optimal Waypoint UAV Missions. 2024. arXiv:2410.17585.</a:t>
+            </a:r>
+          </a:p>
+          <a:p>
+            <a:pPr algn="l">
+              <a:spcAft>
+                <a:spcPts val="800"/>
+              </a:spcAft>
+            </a:pPr>
+            <a:r>
+              <a:rPr sz="1500" b="0">
+                <a:solidFill>
+                  <a:srgbClr val="1A2333"/>
+                </a:solidFill>
+                <a:latin typeface="微软雅黑"/>
+                <a:ea typeface="微软雅黑"/>
+                <a:cs typeface="微软雅黑"/>
+              </a:rPr>
+              <a:t>Nguyen &amp; Au. Extending drone delivery reachable set. AAMAS 2017.</a:t>
+            </a:r>
+          </a:p>
+          <a:p>
+            <a:pPr algn="l">
+              <a:spcAft>
+                <a:spcPts val="800"/>
+              </a:spcAft>
+            </a:pPr>
+            <a:r>
+              <a:rPr sz="1500" b="0">
+                <a:solidFill>
+                  <a:srgbClr val="1A2333"/>
+                </a:solidFill>
+                <a:latin typeface="微软雅黑"/>
+                <a:ea typeface="微软雅黑"/>
+                <a:cs typeface="微软雅黑"/>
+              </a:rPr>
+              <a:t>Karl et al. Position: Embracing Negative Results in ML. ICML 2024.</a:t>
+            </a:r>
+          </a:p>
+          <a:p>
+            <a:pPr algn="l">
+              <a:spcAft>
+                <a:spcPts val="800"/>
+              </a:spcAft>
+            </a:pPr>
+            <a:r>
+              <a:rPr sz="1500" b="0">
+                <a:solidFill>
+                  <a:srgbClr val="1A2333"/>
+                </a:solidFill>
+                <a:latin typeface="微软雅黑"/>
+                <a:ea typeface="微软雅黑"/>
+                <a:cs typeface="微软雅黑"/>
+              </a:rPr>
+              <a:t>Rodrigues et al. DJI M100 energy dataset. Scientific Data 2021.</a:t>
+            </a:r>
+          </a:p>
+          <a:p>
+            <a:pPr algn="l">
+              <a:spcAft>
+                <a:spcPts val="800"/>
+              </a:spcAft>
+            </a:pPr>
+            <a:r>
+              <a:rPr sz="1500" b="0">
+                <a:solidFill>
+                  <a:srgbClr val="1A2333"/>
+                </a:solidFill>
+                <a:latin typeface="微软雅黑"/>
+                <a:ea typeface="微软雅黑"/>
+                <a:cs typeface="微软雅黑"/>
+              </a:rPr>
+              <a:t>Di Franco &amp; Buttazzo 2015;Liu 2017;EcoFlight 2025.</a:t>
             </a:r>
           </a:p>
         </p:txBody>
@@ -8554,14 +8740,14 @@
                 <a:ea typeface="微软雅黑"/>
                 <a:cs typeface="微软雅黑"/>
               </a:rPr>
-              <a:t>附录 A2:翻越/绕行能量权衡分解</a:t>
+              <a:t>附录 A:累加消融阶梯(框架每步都承重)</a:t>
             </a:r>
           </a:p>
         </p:txBody>
       </p:sp>
       <p:pic>
         <p:nvPicPr>
-          <p:cNvPr id="5" name="Picture 4" descr="翻越绕行权衡.png"/>
+          <p:cNvPr id="5" name="Picture 4" descr="消融阶梯.png"/>
           <p:cNvPicPr>
             <a:picLocks noChangeAspect="1"/>
           </p:cNvPicPr>
@@ -8575,8 +8761,8 @@
         </p:blipFill>
         <p:spPr>
           <a:xfrm>
-            <a:off x="2576732" y="1737360"/>
-            <a:ext cx="7008055" cy="4480560"/>
+            <a:off x="1914202" y="1737360"/>
+            <a:ext cx="8333116" cy="4480560"/>
           </a:xfrm>
           <a:prstGeom prst="rect">
             <a:avLst/>
@@ -8619,7 +8805,7 @@
                 <a:ea typeface="微软雅黑"/>
                 <a:cs typeface="微软雅黑"/>
               </a:rPr>
-              <a:t>翻越=固定爬升罚+少走距离,绕行=无爬升+多走距离,交叉≈半宽24m=相图边界物理解释</a:t>
+              <a:t>逐步加回安全机制:假发现 3→0(左),报告数字保持诚实不虚低(右)</a:t>
             </a:r>
           </a:p>
         </p:txBody>
@@ -8770,14 +8956,14 @@
                 <a:ea typeface="微软雅黑"/>
                 <a:cs typeface="微软雅黑"/>
               </a:rPr>
-              <a:t>附录 B:操作包络相图</a:t>
+              <a:t>附录 A2:翻越/绕行能量权衡分解</a:t>
             </a:r>
           </a:p>
         </p:txBody>
       </p:sp>
       <p:pic>
         <p:nvPicPr>
-          <p:cNvPr id="5" name="Picture 4" descr="操作包络相图.png"/>
+          <p:cNvPr id="5" name="Picture 4" descr="翻越绕行权衡.png"/>
           <p:cNvPicPr>
             <a:picLocks noChangeAspect="1"/>
           </p:cNvPicPr>
@@ -8791,8 +8977,8 @@
         </p:blipFill>
         <p:spPr>
           <a:xfrm>
-            <a:off x="2589562" y="1737360"/>
-            <a:ext cx="6982395" cy="4480560"/>
+            <a:off x="2576732" y="1737360"/>
+            <a:ext cx="7008055" cy="4480560"/>
           </a:xfrm>
           <a:prstGeom prst="rect">
             <a:avLst/>
@@ -8835,7 +9021,7 @@
                 <a:ea typeface="微软雅黑"/>
                 <a:cs typeface="微软雅黑"/>
               </a:rPr>
-              <a:t>高速+窄障省 22%,低速/宽障归零</a:t>
+              <a:t>翻越=固定爬升罚+少走距离,绕行=无爬升+多走距离,交叉≈半宽24m=相图边界物理解释</a:t>
             </a:r>
           </a:p>
         </p:txBody>
@@ -8986,14 +9172,14 @@
                 <a:ea typeface="微软雅黑"/>
                 <a:cs typeface="微软雅黑"/>
               </a:rPr>
-              <a:t>附录 C:安全机制消融(评测器抗 gaming)</a:t>
+              <a:t>附录 B:操作包络相图</a:t>
             </a:r>
           </a:p>
         </p:txBody>
       </p:sp>
       <p:pic>
         <p:nvPicPr>
-          <p:cNvPr id="5" name="Picture 4" descr="safeguard_ablation.png"/>
+          <p:cNvPr id="5" name="Picture 4" descr="操作包络相图.png"/>
           <p:cNvPicPr>
             <a:picLocks noChangeAspect="1"/>
           </p:cNvPicPr>
@@ -9007,8 +9193,8 @@
         </p:blipFill>
         <p:spPr>
           <a:xfrm>
-            <a:off x="731520" y="2506599"/>
-            <a:ext cx="10698480" cy="2942082"/>
+            <a:off x="2589562" y="1737360"/>
+            <a:ext cx="6982395" cy="4480560"/>
           </a:xfrm>
           <a:prstGeom prst="rect">
             <a:avLst/>
@@ -9051,7 +9237,7 @@
                 <a:ea typeface="微软雅黑"/>
                 <a:cs typeface="微软雅黑"/>
               </a:rPr>
-              <a:t>过拟合探针刷不动;查新门降级 2/3</a:t>
+              <a:t>高速+窄障省 22%,低速/宽障归零</a:t>
             </a:r>
           </a:p>
         </p:txBody>
@@ -9202,14 +9388,14 @@
                 <a:ea typeface="微软雅黑"/>
                 <a:cs typeface="微软雅黑"/>
               </a:rPr>
-              <a:t>附录 D:动力学实飞功率剖面</a:t>
+              <a:t>附录 C:安全机制消融(评测器抗 gaming)</a:t>
             </a:r>
           </a:p>
         </p:txBody>
       </p:sp>
       <p:pic>
         <p:nvPicPr>
-          <p:cNvPr id="5" name="Picture 4" descr="sim_flight.png"/>
+          <p:cNvPr id="5" name="Picture 4" descr="safeguard_ablation.png"/>
           <p:cNvPicPr>
             <a:picLocks noChangeAspect="1"/>
           </p:cNvPicPr>
@@ -9223,8 +9409,8 @@
         </p:blipFill>
         <p:spPr>
           <a:xfrm>
-            <a:off x="731520" y="2573464"/>
-            <a:ext cx="10698480" cy="2808351"/>
+            <a:off x="731520" y="2506599"/>
+            <a:ext cx="10698480" cy="2942082"/>
           </a:xfrm>
           <a:prstGeom prst="rect">
             <a:avLst/>
@@ -9267,7 +9453,7 @@
                 <a:ea typeface="微软雅黑"/>
                 <a:cs typeface="微软雅黑"/>
               </a:rPr>
-              <a:t>翻墙爬升段飙 870W,绕行平稳</a:t>
+              <a:t>过拟合探针刷不动;查新门降级 2/3</a:t>
             </a:r>
           </a:p>
         </p:txBody>
@@ -9281,6 +9467,222 @@
 </file>
 
 <file path=ppt/slides/slide26.xml><?xml version="1.0" encoding="utf-8"?>
+<p:sld xmlns:a="http://schemas.openxmlformats.org/drawingml/2006/main" xmlns:p="http://schemas.openxmlformats.org/presentationml/2006/main" xmlns:r="http://schemas.openxmlformats.org/officeDocument/2006/relationships">
+  <p:cSld>
+    <p:bg>
+      <p:bgPr>
+        <a:solidFill>
+          <a:srgbClr val="FFFFFF"/>
+        </a:solidFill>
+        <a:effectLst/>
+      </p:bgPr>
+    </p:bg>
+    <p:spTree>
+      <p:nvGrpSpPr>
+        <p:cNvPr id="1" name=""/>
+        <p:cNvGrpSpPr/>
+        <p:nvPr/>
+      </p:nvGrpSpPr>
+      <p:grpSpPr/>
+      <p:sp>
+        <p:nvSpPr>
+          <p:cNvPr id="2" name="Rectangle 1"/>
+          <p:cNvSpPr/>
+          <p:nvPr/>
+        </p:nvSpPr>
+        <p:spPr>
+          <a:xfrm>
+            <a:off x="0" y="0"/>
+            <a:ext cx="109728" cy="6858000"/>
+          </a:xfrm>
+          <a:prstGeom prst="rect">
+            <a:avLst/>
+          </a:prstGeom>
+          <a:solidFill>
+            <a:srgbClr val="4472C4"/>
+          </a:solidFill>
+          <a:ln>
+            <a:noFill/>
+          </a:ln>
+        </p:spPr>
+        <p:style>
+          <a:lnRef idx="1">
+            <a:schemeClr val="accent1"/>
+          </a:lnRef>
+          <a:fillRef idx="3">
+            <a:schemeClr val="accent1"/>
+          </a:fillRef>
+          <a:effectRef idx="2">
+            <a:schemeClr val="accent1"/>
+          </a:effectRef>
+          <a:fontRef idx="minor">
+            <a:schemeClr val="lt1"/>
+          </a:fontRef>
+        </p:style>
+        <p:txBody>
+          <a:bodyPr rtlCol="0" anchor="ctr"/>
+          <a:lstStyle/>
+          <a:p>
+            <a:pPr algn="ctr"/>
+          </a:p>
+        </p:txBody>
+      </p:sp>
+      <p:sp>
+        <p:nvSpPr>
+          <p:cNvPr id="3" name="TextBox 2"/>
+          <p:cNvSpPr txBox="1"/>
+          <p:nvPr/>
+        </p:nvSpPr>
+        <p:spPr>
+          <a:xfrm>
+            <a:off x="9052560" y="292608"/>
+            <a:ext cx="2834640" cy="365760"/>
+          </a:xfrm>
+          <a:prstGeom prst="rect">
+            <a:avLst/>
+          </a:prstGeom>
+          <a:noFill/>
+        </p:spPr>
+        <p:txBody>
+          <a:bodyPr wrap="square" anchor="t" lIns="25400" rIns="25400" tIns="25400" bIns="25400">
+            <a:spAutoFit/>
+          </a:bodyPr>
+          <a:lstStyle/>
+          <a:p>
+            <a:pPr algn="r">
+              <a:spcAft>
+                <a:spcPts val="400"/>
+              </a:spcAft>
+            </a:pPr>
+            <a:r>
+              <a:rPr sz="1200" b="0">
+                <a:solidFill>
+                  <a:srgbClr val="9AA8B8"/>
+                </a:solidFill>
+                <a:latin typeface="微软雅黑"/>
+                <a:ea typeface="微软雅黑"/>
+                <a:cs typeface="微软雅黑"/>
+              </a:rPr>
+              <a:t>西安交通大学</a:t>
+            </a:r>
+          </a:p>
+        </p:txBody>
+      </p:sp>
+      <p:sp>
+        <p:nvSpPr>
+          <p:cNvPr id="4" name="TextBox 3"/>
+          <p:cNvSpPr txBox="1"/>
+          <p:nvPr/>
+        </p:nvSpPr>
+        <p:spPr>
+          <a:xfrm>
+            <a:off x="1143000" y="347472"/>
+            <a:ext cx="10607040" cy="914400"/>
+          </a:xfrm>
+          <a:prstGeom prst="rect">
+            <a:avLst/>
+          </a:prstGeom>
+          <a:noFill/>
+        </p:spPr>
+        <p:txBody>
+          <a:bodyPr wrap="square" anchor="t" lIns="25400" rIns="25400" tIns="25400" bIns="25400">
+            <a:spAutoFit/>
+          </a:bodyPr>
+          <a:lstStyle/>
+          <a:p>
+            <a:pPr algn="l">
+              <a:spcAft>
+                <a:spcPts val="400"/>
+              </a:spcAft>
+            </a:pPr>
+            <a:r>
+              <a:rPr sz="2600" b="1">
+                <a:solidFill>
+                  <a:srgbClr val="0563C1"/>
+                </a:solidFill>
+                <a:latin typeface="微软雅黑"/>
+                <a:ea typeface="微软雅黑"/>
+                <a:cs typeface="微软雅黑"/>
+              </a:rPr>
+              <a:t>附录 D:动力学实飞功率剖面</a:t>
+            </a:r>
+          </a:p>
+        </p:txBody>
+      </p:sp>
+      <p:pic>
+        <p:nvPicPr>
+          <p:cNvPr id="5" name="Picture 4" descr="sim_flight.png"/>
+          <p:cNvPicPr>
+            <a:picLocks noChangeAspect="1"/>
+          </p:cNvPicPr>
+          <p:nvPr/>
+        </p:nvPicPr>
+        <p:blipFill>
+          <a:blip r:embed="rId2"/>
+          <a:stretch>
+            <a:fillRect/>
+          </a:stretch>
+        </p:blipFill>
+        <p:spPr>
+          <a:xfrm>
+            <a:off x="731520" y="2573464"/>
+            <a:ext cx="10698480" cy="2808351"/>
+          </a:xfrm>
+          <a:prstGeom prst="rect">
+            <a:avLst/>
+          </a:prstGeom>
+        </p:spPr>
+      </p:pic>
+      <p:sp>
+        <p:nvSpPr>
+          <p:cNvPr id="6" name="TextBox 5"/>
+          <p:cNvSpPr txBox="1"/>
+          <p:nvPr/>
+        </p:nvSpPr>
+        <p:spPr>
+          <a:xfrm>
+            <a:off x="502920" y="6400800"/>
+            <a:ext cx="11155680" cy="320040"/>
+          </a:xfrm>
+          <a:prstGeom prst="rect">
+            <a:avLst/>
+          </a:prstGeom>
+          <a:noFill/>
+        </p:spPr>
+        <p:txBody>
+          <a:bodyPr wrap="square" anchor="t" lIns="25400" rIns="25400" tIns="25400" bIns="25400">
+            <a:spAutoFit/>
+          </a:bodyPr>
+          <a:lstStyle/>
+          <a:p>
+            <a:pPr algn="l">
+              <a:spcAft>
+                <a:spcPts val="400"/>
+              </a:spcAft>
+            </a:pPr>
+            <a:r>
+              <a:rPr sz="1100" b="0">
+                <a:solidFill>
+                  <a:srgbClr val="6B7A8D"/>
+                </a:solidFill>
+                <a:latin typeface="微软雅黑"/>
+                <a:ea typeface="微软雅黑"/>
+                <a:cs typeface="微软雅黑"/>
+              </a:rPr>
+              <a:t>翻墙爬升段飙 870W,绕行平稳</a:t>
+            </a:r>
+          </a:p>
+        </p:txBody>
+      </p:sp>
+    </p:spTree>
+  </p:cSld>
+  <p:clrMapOvr>
+    <a:masterClrMapping/>
+  </p:clrMapOvr>
+</p:sld>
+</file>
+
+<file path=ppt/slides/slide27.xml><?xml version="1.0" encoding="utf-8"?>
 <p:sld xmlns:a="http://schemas.openxmlformats.org/drawingml/2006/main" xmlns:p="http://schemas.openxmlformats.org/presentationml/2006/main" xmlns:r="http://schemas.openxmlformats.org/officeDocument/2006/relationships">
   <p:cSld>
     <p:bg>

</xml_diff>

<commit_message>
Fix unverified attribution: '~60% is wind/voltage/control noise' was a guess, not measured — change to '~60% unexplained by current inputs (attribution TBD)'; log as post-midterm TODO
用户正确指出:只验证了运动学解释~40%(R²实测),但'其余60%是风/电压/控制'是没做实验的猜测,不该写成结论。全改为'无法由当前输入解释(待归因)'。功率残差归因记为中期后TODO(注:iter5试wind反而更差,说明不是简单气动)。

Co-Authored-By: Claude Opus 4.8 (1M context) <noreply@anthropic.com>
</commit_message>
<xml_diff>
--- a/autoresearch/energy_m100/experiments/midterm_defense.pptx
+++ b/autoresearch/energy_m100/experiments/midterm_defense.pptx
@@ -5679,7 +5679,7 @@
                 <a:ea typeface="微软雅黑"/>
                 <a:cs typeface="微软雅黑"/>
               </a:rPr>
-              <a:t>为什么封顶:真机功率含大量不可观测噪声(风/电压/控制)</a:t>
+              <a:t>为什么封顶:真机功率剧烈波动,当前输入只能解释约四成</a:t>
             </a:r>
           </a:p>
         </p:txBody>
@@ -5798,7 +5798,7 @@
                 <a:ea typeface="微软雅黑"/>
                 <a:cs typeface="微软雅黑"/>
               </a:rPr>
-              <a:t>· 其余 ~60%=风/电压/控制噪声</a:t>
+              <a:t>· 其余 ~60% 无法由当前输入解释</a:t>
             </a:r>
           </a:p>
           <a:p>
@@ -5808,15 +5808,15 @@
               </a:spcAft>
             </a:pPr>
             <a:r>
-              <a:rPr sz="1500" b="0">
-                <a:solidFill>
-                  <a:srgbClr val="1A2333"/>
-                </a:solidFill>
-                <a:latin typeface="微软雅黑"/>
-                <a:ea typeface="微软雅黑"/>
-                <a:cs typeface="微软雅黑"/>
-              </a:rPr>
-              <a:t>· 不在可观测输入里 → 学不到</a:t>
+              <a:rPr sz="1400" b="0">
+                <a:solidFill>
+                  <a:srgbClr val="6B7A8D"/>
+                </a:solidFill>
+                <a:latin typeface="微软雅黑"/>
+                <a:ea typeface="微软雅黑"/>
+                <a:cs typeface="微软雅黑"/>
+              </a:rPr>
+              <a:t>  (具体来源待归因)</a:t>
             </a:r>
           </a:p>
           <a:p>
@@ -5834,7 +5834,7 @@
                 <a:ea typeface="微软雅黑"/>
                 <a:cs typeface="微软雅黑"/>
               </a:rPr>
-              <a:t>→ 改追每趟能量 ARE(积分抹平噪声)</a:t>
+              <a:t>→ 改追每趟能量 ARE(积分抹平波动)</a:t>
             </a:r>
           </a:p>
         </p:txBody>

</xml_diff>

<commit_message>
Reframe limitations slide as '适用范围' (positive scope framing): title now states where it saves (4-22%), limitations demoted to a footnote — keeps honest boundary (on-brand for trustworthy thesis) without confession tone; also de-jargon 'headroom' inside two-domain figure
诚实边界页认罪式标题'多数场景无收益,载荷无效'→'适用范围:省能收益集中于障碍逼出爬升的几何(可达4-22%)'。数据(n=250分布/中位0%)全保留不藏,局限降为一句诚实标注。保住'诚实划界'(正是可信主题的卖点)去掉认罪口气。两域图内残留headroom→改进空间。

Co-Authored-By: Claude Opus 4.8 (1M context) <noreply@anthropic.com>
</commit_message>
<xml_diff>
--- a/autoresearch/energy_m100/experiments/midterm_defense.pptx
+++ b/autoresearch/energy_m100/experiments/midterm_defense.pptx
@@ -7319,7 +7319,7 @@
                 <a:ea typeface="微软雅黑"/>
                 <a:cs typeface="微软雅黑"/>
               </a:rPr>
-              <a:t>诚实边界:多数场景无收益,载荷无效,贡献是方法学而非发现</a:t>
+              <a:t>适用范围:省能收益集中于“障碍逼出爬升”的几何(可达 4–22%)</a:t>
             </a:r>
           </a:p>
         </p:txBody>
@@ -7376,7 +7376,7 @@
               </a:spcAft>
             </a:pPr>
             <a:r>
-              <a:rPr sz="1600" b="0">
+              <a:rPr sz="1600" b="1">
                 <a:solidFill>
                   <a:srgbClr val="1A2333"/>
                 </a:solidFill>
@@ -7384,7 +7384,7 @@
                 <a:ea typeface="微软雅黑"/>
                 <a:cs typeface="微软雅黑"/>
               </a:rPr>
-              <a:t>· n=250 场景:中位省能 0%</a:t>
+              <a:t>n=250 随机城市场景,划清适用边界:</a:t>
             </a:r>
           </a:p>
           <a:p>
@@ -7394,7 +7394,25 @@
               </a:spcAft>
             </a:pPr>
             <a:r>
-              <a:rPr sz="1600" b="0">
+              <a:rPr sz="1500" b="1">
+                <a:solidFill>
+                  <a:srgbClr val="5B9BD5"/>
+                </a:solidFill>
+                <a:latin typeface="微软雅黑"/>
+                <a:ea typeface="微软雅黑"/>
+                <a:cs typeface="微软雅黑"/>
+              </a:rPr>
+              <a:t>· 障碍逼出爬升的几何:省能 3–22%</a:t>
+            </a:r>
+          </a:p>
+          <a:p>
+            <a:pPr algn="l">
+              <a:spcAft>
+                <a:spcPts val="1100"/>
+              </a:spcAft>
+            </a:pPr>
+            <a:r>
+              <a:rPr sz="1500" b="0">
                 <a:solidFill>
                   <a:srgbClr val="1A2333"/>
                 </a:solidFill>
@@ -7402,7 +7420,7 @@
                 <a:ea typeface="微软雅黑"/>
                 <a:cs typeface="微软雅黑"/>
               </a:rPr>
-              <a:t>· 77% 场景零收益(有低空走廊)</a:t>
+              <a:t>· 有低空走廊时:能量最优≈最短路</a:t>
             </a:r>
           </a:p>
           <a:p>
@@ -7412,7 +7430,7 @@
               </a:spcAft>
             </a:pPr>
             <a:r>
-              <a:rPr sz="1600" b="0">
+              <a:rPr sz="1500" b="0">
                 <a:solidFill>
                   <a:srgbClr val="1A2333"/>
                 </a:solidFill>
@@ -7420,7 +7438,7 @@
                 <a:ea typeface="微软雅黑"/>
                 <a:cs typeface="微软雅黑"/>
               </a:rPr>
-              <a:t>· 仅 20% ≥3%,CI[15.5,25.4]%</a:t>
+              <a:t>· 结论用统计陈述,不挑单一场景</a:t>
             </a:r>
           </a:p>
           <a:p>
@@ -7430,7 +7448,7 @@
               </a:spcAft>
             </a:pPr>
             <a:r>
-              <a:rPr sz="1600" b="0">
+              <a:rPr sz="1600" b="1">
                 <a:solidFill>
                   <a:srgbClr val="1A2333"/>
                 </a:solidFill>
@@ -7438,7 +7456,7 @@
                 <a:ea typeface="微软雅黑"/>
                 <a:cs typeface="微软雅黑"/>
               </a:rPr>
-              <a:t>· 载荷 ≤500g:全扫不改变路径</a:t>
+              <a:t>适用条件(诚实标注):</a:t>
             </a:r>
           </a:p>
           <a:p>
@@ -7448,33 +7466,15 @@
               </a:spcAft>
             </a:pPr>
             <a:r>
-              <a:rPr sz="1600" b="0">
-                <a:solidFill>
-                  <a:srgbClr val="1A2333"/>
-                </a:solidFill>
-                <a:latin typeface="微软雅黑"/>
-                <a:ea typeface="微软雅黑"/>
-                <a:cs typeface="微软雅黑"/>
-              </a:rPr>
-              <a:t>· 无真机飞行(止于仿真)</a:t>
-            </a:r>
-          </a:p>
-          <a:p>
-            <a:pPr algn="l">
-              <a:spcAft>
-                <a:spcPts val="1100"/>
-              </a:spcAft>
-            </a:pPr>
-            <a:r>
-              <a:rPr sz="1600" b="1">
-                <a:solidFill>
-                  <a:srgbClr val="0563C1"/>
-                </a:solidFill>
-                <a:latin typeface="微软雅黑"/>
-                <a:ea typeface="微软雅黑"/>
-                <a:cs typeface="微软雅黑"/>
-              </a:rPr>
-              <a:t>→ 不挑场景、不硬凑,诚实统计</a:t>
+              <a:rPr sz="1500" b="0">
+                <a:solidFill>
+                  <a:srgbClr val="6B7A8D"/>
+                </a:solidFill>
+                <a:latin typeface="微软雅黑"/>
+                <a:ea typeface="微软雅黑"/>
+                <a:cs typeface="微软雅黑"/>
+              </a:rPr>
+              <a:t>· 载荷 ≤500g 不改变路径;当前止于仿真</a:t>
             </a:r>
           </a:p>
         </p:txBody>
@@ -7515,7 +7515,7 @@
                 <a:ea typeface="微软雅黑"/>
                 <a:cs typeface="微软雅黑"/>
               </a:rPr>
-              <a:t>large_scale_savings.py;可信 null 是被接受的贡献(ICML 2024)</a:t>
+              <a:t>large_scale_savings.py(n=250);相图见附录 B(何时省能)</a:t>
             </a:r>
           </a:p>
         </p:txBody>

</xml_diff>

<commit_message>
Calibrate 'naive vs ours' slide: title from '...我们相反' to '可信协议的价值:防住朴素流程的过度声称'; replace English 'humbler 但对' with plain Chinese positive framing
Co-Authored-By: Claude Opus 4.8 (1M context) <noreply@anthropic.com>
</commit_message>
<xml_diff>
--- a/autoresearch/energy_m100/experiments/midterm_defense.pptx
+++ b/autoresearch/energy_m100/experiments/midterm_defense.pptx
@@ -6918,7 +6918,7 @@
                 <a:ea typeface="微软雅黑"/>
                 <a:cs typeface="微软雅黑"/>
               </a:rPr>
-              <a:t>用 vs 不用:朴素 AI4S 声称 4 项假发现且藏负结果,我们相反</a:t>
+              <a:t>可信协议的价值:同数据同候选,防住了朴素流程的过度声称</a:t>
             </a:r>
           </a:p>
         </p:txBody>
@@ -6955,8 +6955,8 @@
         </p:nvSpPr>
         <p:spPr>
           <a:xfrm>
-            <a:off x="9144000" y="2011680"/>
-            <a:ext cx="2651760" cy="4023360"/>
+            <a:off x="9052560" y="2011680"/>
+            <a:ext cx="2743200" cy="4023360"/>
           </a:xfrm>
           <a:prstGeom prst="rect">
             <a:avLst/>
@@ -6971,7 +6971,7 @@
           <a:p>
             <a:pPr algn="l">
               <a:spcAft>
-                <a:spcPts val="1200"/>
+                <a:spcPts val="1000"/>
               </a:spcAft>
             </a:pPr>
             <a:r>
@@ -6983,13 +6983,13 @@
                 <a:ea typeface="微软雅黑"/>
                 <a:cs typeface="微软雅黑"/>
               </a:rPr>
-              <a:t>朴素:</a:t>
-            </a:r>
-          </a:p>
-          <a:p>
-            <a:pPr algn="l">
-              <a:spcAft>
-                <a:spcPts val="1200"/>
+              <a:t>朴素 AI4S:</a:t>
+            </a:r>
+          </a:p>
+          <a:p>
+            <a:pPr algn="l">
+              <a:spcAft>
+                <a:spcPts val="1000"/>
               </a:spcAft>
             </a:pPr>
             <a:r>
@@ -7001,13 +7001,31 @@
                 <a:ea typeface="微软雅黑"/>
                 <a:cs typeface="微软雅黑"/>
               </a:rPr>
-              <a:t>4 假发现 + 0 负结果</a:t>
-            </a:r>
-          </a:p>
-          <a:p>
-            <a:pPr algn="l">
-              <a:spcAft>
-                <a:spcPts val="1200"/>
+              <a:t>声称 4 项发现</a:t>
+            </a:r>
+          </a:p>
+          <a:p>
+            <a:pPr algn="l">
+              <a:spcAft>
+                <a:spcPts val="1000"/>
+              </a:spcAft>
+            </a:pPr>
+            <a:r>
+              <a:rPr sz="1400" b="0">
+                <a:solidFill>
+                  <a:srgbClr val="6B7A8D"/>
+                </a:solidFill>
+                <a:latin typeface="微软雅黑"/>
+                <a:ea typeface="微软雅黑"/>
+                <a:cs typeface="微软雅黑"/>
+              </a:rPr>
+              <a:t>(经查全为已有)、不报局限</a:t>
+            </a:r>
+          </a:p>
+          <a:p>
+            <a:pPr algn="l">
+              <a:spcAft>
+                <a:spcPts val="1000"/>
               </a:spcAft>
             </a:pPr>
             <a:r>
@@ -7019,13 +7037,13 @@
                 <a:ea typeface="微软雅黑"/>
                 <a:cs typeface="微软雅黑"/>
               </a:rPr>
-              <a:t>我们:</a:t>
-            </a:r>
-          </a:p>
-          <a:p>
-            <a:pPr algn="l">
-              <a:spcAft>
-                <a:spcPts val="1200"/>
+              <a:t>本框架:</a:t>
+            </a:r>
+          </a:p>
+          <a:p>
+            <a:pPr algn="l">
+              <a:spcAft>
+                <a:spcPts val="1000"/>
               </a:spcAft>
             </a:pPr>
             <a:r>
@@ -7037,43 +7055,43 @@
                 <a:ea typeface="微软雅黑"/>
                 <a:cs typeface="微软雅黑"/>
               </a:rPr>
-              <a:t>0 真新 + 4 负结果</a:t>
-            </a:r>
-          </a:p>
-          <a:p>
-            <a:pPr algn="l">
-              <a:spcAft>
-                <a:spcPts val="1200"/>
-              </a:spcAft>
-            </a:pPr>
-            <a:r>
-              <a:rPr sz="1500" b="0">
-                <a:solidFill>
-                  <a:srgbClr val="1A2333"/>
-                </a:solidFill>
-                <a:latin typeface="微软雅黑"/>
-                <a:ea typeface="微软雅黑"/>
-                <a:cs typeface="微软雅黑"/>
-              </a:rPr>
-              <a:t>一个自信但错,</a:t>
-            </a:r>
-          </a:p>
-          <a:p>
-            <a:pPr algn="l">
-              <a:spcAft>
-                <a:spcPts val="1200"/>
-              </a:spcAft>
-            </a:pPr>
-            <a:r>
-              <a:rPr sz="1500" b="1">
-                <a:solidFill>
-                  <a:srgbClr val="1A2333"/>
-                </a:solidFill>
-                <a:latin typeface="微软雅黑"/>
-                <a:ea typeface="微软雅黑"/>
-                <a:cs typeface="微软雅黑"/>
-              </a:rPr>
-              <a:t>一个 humbler 但对。</a:t>
+              <a:t>查新/留出过滤后</a:t>
+            </a:r>
+          </a:p>
+          <a:p>
+            <a:pPr algn="l">
+              <a:spcAft>
+                <a:spcPts val="1000"/>
+              </a:spcAft>
+            </a:pPr>
+            <a:r>
+              <a:rPr sz="1400" b="0">
+                <a:solidFill>
+                  <a:srgbClr val="6B7A8D"/>
+                </a:solidFill>
+                <a:latin typeface="微软雅黑"/>
+                <a:ea typeface="微软雅黑"/>
+                <a:cs typeface="微软雅黑"/>
+              </a:rPr>
+              <a:t>如实报告 + 记 4 项边界</a:t>
+            </a:r>
+          </a:p>
+          <a:p>
+            <a:pPr algn="l">
+              <a:spcAft>
+                <a:spcPts val="1000"/>
+              </a:spcAft>
+            </a:pPr>
+            <a:r>
+              <a:rPr sz="1400" b="1">
+                <a:solidFill>
+                  <a:srgbClr val="0563C1"/>
+                </a:solidFill>
+                <a:latin typeface="微软雅黑"/>
+                <a:ea typeface="微软雅黑"/>
+                <a:cs typeface="微软雅黑"/>
+              </a:rPr>
+              <a:t>→ 安全机制把“看似发现”挡在门外</a:t>
             </a:r>
           </a:p>
         </p:txBody>

</xml_diff>

<commit_message>
Remove slide 11b (why-capped noise explanation): declaring a permanent noise ceiling is self-limiting + the 60% attribution is unverified (logged as future work). Measured capacity curve (slide 11) still answers 'why 1.86%' honestly
用户判断:展示'封顶,因噪声突破不了'是自我设限,且那60%具体是什么还没归因(记为future work),后续研究可能突破——现在宣告天花板会打脸。删11b。第11页实测容量曲线(52项压不过6项)仍诚实回答'为什么1.86%',不藏。仿真vs真机波动图文件保留备用。

Co-Authored-By: Claude Opus 4.8 (1M context) <noreply@anthropic.com>
</commit_message>
<xml_diff>
--- a/autoresearch/energy_m100/experiments/midterm_defense.pptx
+++ b/autoresearch/energy_m100/experiments/midterm_defense.pptx
@@ -31,7 +31,6 @@
     <p:sldId id="279" r:id="rId30"/>
     <p:sldId id="280" r:id="rId31"/>
     <p:sldId id="281" r:id="rId32"/>
-    <p:sldId id="282" r:id="rId33"/>
   </p:sldIdLst>
   <p:sldSz cx="12191695" cy="6858000" type="screen4x3"/>
   <p:notesSz cx="6858000" cy="9144000"/>
@@ -5679,14 +5678,14 @@
                 <a:ea typeface="微软雅黑"/>
                 <a:cs typeface="微软雅黑"/>
               </a:rPr>
-              <a:t>为什么封顶:真机功率剧烈波动,当前输入只能解释约四成</a:t>
+              <a:t>同框架:有改进空间的域显著胜随机,噪声封顶的域统计打平</a:t>
             </a:r>
           </a:p>
         </p:txBody>
       </p:sp>
       <p:pic>
         <p:nvPicPr>
-          <p:cNvPr id="6" name="Picture 5" descr="仿真vs真机波动.png"/>
+          <p:cNvPr id="6" name="Picture 5" descr="两域显著性.png"/>
           <p:cNvPicPr>
             <a:picLocks noChangeAspect="1"/>
           </p:cNvPicPr>
@@ -5700,8 +5699,8 @@
         </p:blipFill>
         <p:spPr>
           <a:xfrm>
-            <a:off x="457200" y="2405250"/>
-            <a:ext cx="7132320" cy="2687579"/>
+            <a:off x="457200" y="2527503"/>
+            <a:ext cx="5760720" cy="2991714"/>
           </a:xfrm>
           <a:prstGeom prst="rect">
             <a:avLst/>
@@ -5716,8 +5715,8 @@
         </p:nvSpPr>
         <p:spPr>
           <a:xfrm>
-            <a:off x="7772400" y="1920240"/>
-            <a:ext cx="4114800" cy="4206240"/>
+            <a:off x="6309360" y="1920240"/>
+            <a:ext cx="5486400" cy="4389120"/>
           </a:xfrm>
           <a:prstGeom prst="rect">
             <a:avLst/>
@@ -5732,101 +5731,119 @@
           <a:p>
             <a:pPr algn="l">
               <a:spcAft>
-                <a:spcPts val="1100"/>
+                <a:spcPts val="1200"/>
+              </a:spcAft>
+            </a:pPr>
+            <a:r>
+              <a:rPr sz="1700" b="1">
+                <a:solidFill>
+                  <a:srgbClr val="1A2333"/>
+                </a:solidFill>
+                <a:latin typeface="微软雅黑"/>
+                <a:ea typeface="微软雅黑"/>
+                <a:cs typeface="微软雅黑"/>
+              </a:rPr>
+              <a:t>能耗域(封顶):</a:t>
+            </a:r>
+          </a:p>
+          <a:p>
+            <a:pPr algn="l">
+              <a:spcAft>
+                <a:spcPts val="1200"/>
+              </a:spcAft>
+            </a:pPr>
+            <a:r>
+              <a:rPr sz="1600" b="0">
+                <a:solidFill>
+                  <a:srgbClr val="1A2333"/>
+                </a:solidFill>
+                <a:latin typeface="微软雅黑"/>
+                <a:ea typeface="微软雅黑"/>
+                <a:cs typeface="微软雅黑"/>
+              </a:rPr>
+              <a:t>  loop 1.86% vs 随机 1.87±0.03,z=−0.35</a:t>
+            </a:r>
+          </a:p>
+          <a:p>
+            <a:pPr algn="l">
+              <a:spcAft>
+                <a:spcPts val="1200"/>
+              </a:spcAft>
+            </a:pPr>
+            <a:r>
+              <a:rPr sz="1600" b="0">
+                <a:solidFill>
+                  <a:srgbClr val="1A2333"/>
+                </a:solidFill>
+                <a:latin typeface="微软雅黑"/>
+                <a:ea typeface="微软雅黑"/>
+                <a:cs typeface="微软雅黑"/>
+              </a:rPr>
+              <a:t>  52% 随机更好 → 统计打平</a:t>
+            </a:r>
+          </a:p>
+          <a:p>
+            <a:pPr algn="l">
+              <a:spcAft>
+                <a:spcPts val="1200"/>
+              </a:spcAft>
+            </a:pPr>
+            <a:r>
+              <a:rPr sz="1700" b="1">
+                <a:solidFill>
+                  <a:srgbClr val="1A2333"/>
+                </a:solidFill>
+                <a:latin typeface="微软雅黑"/>
+                <a:ea typeface="微软雅黑"/>
+                <a:cs typeface="微软雅黑"/>
+              </a:rPr>
+              <a:t>规划器域(有改进空间):</a:t>
+            </a:r>
+          </a:p>
+          <a:p>
+            <a:pPr algn="l">
+              <a:spcAft>
+                <a:spcPts val="1200"/>
               </a:spcAft>
             </a:pPr>
             <a:r>
               <a:rPr sz="1600" b="1">
                 <a:solidFill>
+                  <a:srgbClr val="5B9BD5"/>
+                </a:solidFill>
+                <a:latin typeface="微软雅黑"/>
+                <a:ea typeface="微软雅黑"/>
+                <a:cs typeface="微软雅黑"/>
+              </a:rPr>
+              <a:t>  loop 显著低于随机,z=−2.38</a:t>
+            </a:r>
+          </a:p>
+          <a:p>
+            <a:pPr algn="l">
+              <a:spcAft>
+                <a:spcPts val="1200"/>
+              </a:spcAft>
+            </a:pPr>
+            <a:r>
+              <a:rPr sz="1600" b="0">
+                <a:solidFill>
                   <a:srgbClr val="1A2333"/>
                 </a:solidFill>
                 <a:latin typeface="微软雅黑"/>
                 <a:ea typeface="微软雅黑"/>
                 <a:cs typeface="微软雅黑"/>
               </a:rPr>
-              <a:t>模型输出平滑,真机实测剧烈波动</a:t>
-            </a:r>
-          </a:p>
-          <a:p>
-            <a:pPr algn="l">
-              <a:spcAft>
-                <a:spcPts val="1100"/>
-              </a:spcAft>
-            </a:pPr>
-            <a:r>
-              <a:rPr sz="1500" b="0">
-                <a:solidFill>
-                  <a:srgbClr val="1A2333"/>
-                </a:solidFill>
-                <a:latin typeface="微软雅黑"/>
-                <a:ea typeface="微软雅黑"/>
-                <a:cs typeface="微软雅黑"/>
-              </a:rPr>
-              <a:t>· 真机功率变异系数 ≈0.20(50–950W)</a:t>
-            </a:r>
-          </a:p>
-          <a:p>
-            <a:pPr algn="l">
-              <a:spcAft>
-                <a:spcPts val="1100"/>
-              </a:spcAft>
-            </a:pPr>
-            <a:r>
-              <a:rPr sz="1500" b="0">
-                <a:solidFill>
-                  <a:srgbClr val="1A2333"/>
-                </a:solidFill>
-                <a:latin typeface="微软雅黑"/>
-                <a:ea typeface="微软雅黑"/>
-                <a:cs typeface="微软雅黑"/>
-              </a:rPr>
-              <a:t>· 运动学只解释 ~40%</a:t>
-            </a:r>
-          </a:p>
-          <a:p>
-            <a:pPr algn="l">
-              <a:spcAft>
-                <a:spcPts val="1100"/>
-              </a:spcAft>
-            </a:pPr>
-            <a:r>
-              <a:rPr sz="1500" b="1">
-                <a:solidFill>
-                  <a:srgbClr val="C0502D"/>
-                </a:solidFill>
-                <a:latin typeface="微软雅黑"/>
-                <a:ea typeface="微软雅黑"/>
-                <a:cs typeface="微软雅黑"/>
-              </a:rPr>
-              <a:t>· 其余 ~60% 无法由当前输入解释</a:t>
-            </a:r>
-          </a:p>
-          <a:p>
-            <a:pPr algn="l">
-              <a:spcAft>
-                <a:spcPts val="1100"/>
-              </a:spcAft>
-            </a:pPr>
-            <a:r>
-              <a:rPr sz="1400" b="0">
-                <a:solidFill>
-                  <a:srgbClr val="6B7A8D"/>
-                </a:solidFill>
-                <a:latin typeface="微软雅黑"/>
-                <a:ea typeface="微软雅黑"/>
-                <a:cs typeface="微软雅黑"/>
-              </a:rPr>
-              <a:t>  (具体来源待归因)</a:t>
-            </a:r>
-          </a:p>
-          <a:p>
-            <a:pPr algn="l">
-              <a:spcAft>
-                <a:spcPts val="1100"/>
-              </a:spcAft>
-            </a:pPr>
-            <a:r>
-              <a:rPr sz="1500" b="1">
+              <a:t>  0% 随机更好 → 显著胜</a:t>
+            </a:r>
+          </a:p>
+          <a:p>
+            <a:pPr algn="l">
+              <a:spcAft>
+                <a:spcPts val="1200"/>
+              </a:spcAft>
+            </a:pPr>
+            <a:r>
+              <a:rPr sz="1600" b="1">
                 <a:solidFill>
                   <a:srgbClr val="0563C1"/>
                 </a:solidFill>
@@ -5834,7 +5851,7 @@
                 <a:ea typeface="微软雅黑"/>
                 <a:cs typeface="微软雅黑"/>
               </a:rPr>
-              <a:t>→ 改追每趟能量 ARE(积分抹平波动)</a:t>
+              <a:t>→ 优势取决于搜索空间复杂度:小空间相当,大空间显著胜</a:t>
             </a:r>
           </a:p>
         </p:txBody>
@@ -5875,7 +5892,7 @@
                 <a:ea typeface="微软雅黑"/>
                 <a:cs typeface="微软雅黑"/>
               </a:rPr>
-              <a:t>真机 DJI M100 实测功率(V×I);左=模型预测(平滑),右=真机片段(波动)</a:t>
+              <a:t>significance_test.py / planner_significance.py(随机分布 + z 检验)</a:t>
             </a:r>
           </a:p>
         </p:txBody>
@@ -6080,14 +6097,14 @@
                 <a:ea typeface="微软雅黑"/>
                 <a:cs typeface="微软雅黑"/>
               </a:rPr>
-              <a:t>同框架:有改进空间的域显著胜随机,噪声封顶的域统计打平</a:t>
+              <a:t>为什么打平?引导搜索的优势随搜索空间复杂度增长(文献规律)</a:t>
             </a:r>
           </a:p>
         </p:txBody>
       </p:sp>
       <p:pic>
         <p:nvPicPr>
-          <p:cNvPr id="6" name="Picture 5" descr="两域显著性.png"/>
+          <p:cNvPr id="6" name="Picture 5" descr="复杂度规律.png"/>
           <p:cNvPicPr>
             <a:picLocks noChangeAspect="1"/>
           </p:cNvPicPr>
@@ -6101,8 +6118,8 @@
         </p:blipFill>
         <p:spPr>
           <a:xfrm>
-            <a:off x="457200" y="2527503"/>
-            <a:ext cx="5760720" cy="2991714"/>
+            <a:off x="457200" y="2095384"/>
+            <a:ext cx="6766560" cy="3673072"/>
           </a:xfrm>
           <a:prstGeom prst="rect">
             <a:avLst/>
@@ -6117,8 +6134,8 @@
         </p:nvSpPr>
         <p:spPr>
           <a:xfrm>
-            <a:off x="6309360" y="1920240"/>
-            <a:ext cx="5486400" cy="4389120"/>
+            <a:off x="7406640" y="1920240"/>
+            <a:ext cx="4480560" cy="4389120"/>
           </a:xfrm>
           <a:prstGeom prst="rect">
             <a:avLst/>
@@ -6133,11 +6150,11 @@
           <a:p>
             <a:pPr algn="l">
               <a:spcAft>
-                <a:spcPts val="1200"/>
-              </a:spcAft>
-            </a:pPr>
-            <a:r>
-              <a:rPr sz="1700" b="1">
+                <a:spcPts val="900"/>
+              </a:spcAft>
+            </a:pPr>
+            <a:r>
+              <a:rPr sz="1600" b="1">
                 <a:solidFill>
                   <a:srgbClr val="1A2333"/>
                 </a:solidFill>
@@ -6145,17 +6162,17 @@
                 <a:ea typeface="微软雅黑"/>
                 <a:cs typeface="微软雅黑"/>
               </a:rPr>
-              <a:t>能耗域(封顶):</a:t>
-            </a:r>
-          </a:p>
-          <a:p>
-            <a:pPr algn="l">
-              <a:spcAft>
-                <a:spcPts val="1200"/>
-              </a:spcAft>
-            </a:pPr>
-            <a:r>
-              <a:rPr sz="1600" b="0">
+              <a:t>引导搜索优势随空间复杂度增长:</a:t>
+            </a:r>
+          </a:p>
+          <a:p>
+            <a:pPr algn="l">
+              <a:spcAft>
+                <a:spcPts val="900"/>
+              </a:spcAft>
+            </a:pPr>
+            <a:r>
+              <a:rPr sz="1400" b="0">
                 <a:solidFill>
                   <a:srgbClr val="1A2333"/>
                 </a:solidFill>
@@ -6163,17 +6180,17 @@
                 <a:ea typeface="微软雅黑"/>
                 <a:cs typeface="微软雅黑"/>
               </a:rPr>
-              <a:t>  loop 1.86% vs 随机 1.87±0.03,z=−0.35</a:t>
-            </a:r>
-          </a:p>
-          <a:p>
-            <a:pPr algn="l">
-              <a:spcAft>
-                <a:spcPts val="1200"/>
-              </a:spcAft>
-            </a:pPr>
-            <a:r>
-              <a:rPr sz="1600" b="0">
+              <a:t>· Bergstra'12:低有效维→随机追平</a:t>
+            </a:r>
+          </a:p>
+          <a:p>
+            <a:pPr algn="l">
+              <a:spcAft>
+                <a:spcPts val="900"/>
+              </a:spcAft>
+            </a:pPr>
+            <a:r>
+              <a:rPr sz="1400" b="0">
                 <a:solidFill>
                   <a:srgbClr val="1A2333"/>
                 </a:solidFill>
@@ -6181,17 +6198,17 @@
                 <a:ea typeface="微软雅黑"/>
                 <a:cs typeface="微软雅黑"/>
               </a:rPr>
-              <a:t>  52% 随机更好 → 统计打平</a:t>
-            </a:r>
-          </a:p>
-          <a:p>
-            <a:pPr algn="l">
-              <a:spcAft>
-                <a:spcPts val="1200"/>
-              </a:spcAft>
-            </a:pPr>
-            <a:r>
-              <a:rPr sz="1700" b="1">
+              <a:t>· REMBO:~15–20 维临界点</a:t>
+            </a:r>
+          </a:p>
+          <a:p>
+            <a:pPr algn="l">
+              <a:spcAft>
+                <a:spcPts val="900"/>
+              </a:spcAft>
+            </a:pPr>
+            <a:r>
+              <a:rPr sz="1400" b="0">
                 <a:solidFill>
                   <a:srgbClr val="1A2333"/>
                 </a:solidFill>
@@ -6199,17 +6216,35 @@
                 <a:ea typeface="微软雅黑"/>
                 <a:cs typeface="微软雅黑"/>
               </a:rPr>
-              <a:t>规划器域(有改进空间):</a:t>
-            </a:r>
-          </a:p>
-          <a:p>
-            <a:pPr algn="l">
-              <a:spcAft>
-                <a:spcPts val="1200"/>
-              </a:spcAft>
-            </a:pPr>
-            <a:r>
-              <a:rPr sz="1600" b="1">
+              <a:t>· FunSearch:巨大程序空间→引导才行</a:t>
+            </a:r>
+          </a:p>
+          <a:p>
+            <a:pPr algn="l">
+              <a:spcAft>
+                <a:spcPts val="900"/>
+              </a:spcAft>
+            </a:pPr>
+            <a:r>
+              <a:rPr sz="1500" b="1">
+                <a:solidFill>
+                  <a:srgbClr val="C0502D"/>
+                </a:solidFill>
+                <a:latin typeface="微软雅黑"/>
+                <a:ea typeface="微软雅黑"/>
+                <a:cs typeface="微软雅黑"/>
+              </a:rPr>
+              <a:t>· 我们能耗域(小)→打平</a:t>
+            </a:r>
+          </a:p>
+          <a:p>
+            <a:pPr algn="l">
+              <a:spcAft>
+                <a:spcPts val="900"/>
+              </a:spcAft>
+            </a:pPr>
+            <a:r>
+              <a:rPr sz="1500" b="1">
                 <a:solidFill>
                   <a:srgbClr val="5B9BD5"/>
                 </a:solidFill>
@@ -6217,35 +6252,17 @@
                 <a:ea typeface="微软雅黑"/>
                 <a:cs typeface="微软雅黑"/>
               </a:rPr>
-              <a:t>  loop 显著低于随机,z=−2.38</a:t>
-            </a:r>
-          </a:p>
-          <a:p>
-            <a:pPr algn="l">
-              <a:spcAft>
-                <a:spcPts val="1200"/>
-              </a:spcAft>
-            </a:pPr>
-            <a:r>
-              <a:rPr sz="1600" b="0">
-                <a:solidFill>
-                  <a:srgbClr val="1A2333"/>
-                </a:solidFill>
-                <a:latin typeface="微软雅黑"/>
-                <a:ea typeface="微软雅黑"/>
-                <a:cs typeface="微软雅黑"/>
-              </a:rPr>
-              <a:t>  0% 随机更好 → 显著胜</a:t>
-            </a:r>
-          </a:p>
-          <a:p>
-            <a:pPr algn="l">
-              <a:spcAft>
-                <a:spcPts val="1200"/>
-              </a:spcAft>
-            </a:pPr>
-            <a:r>
-              <a:rPr sz="1600" b="1">
+              <a:t>· 我们规划器域(大)→胜 27%</a:t>
+            </a:r>
+          </a:p>
+          <a:p>
+            <a:pPr algn="l">
+              <a:spcAft>
+                <a:spcPts val="900"/>
+              </a:spcAft>
+            </a:pPr>
+            <a:r>
+              <a:rPr sz="1500" b="1">
                 <a:solidFill>
                   <a:srgbClr val="0563C1"/>
                 </a:solidFill>
@@ -6253,7 +6270,7 @@
                 <a:ea typeface="微软雅黑"/>
                 <a:cs typeface="微软雅黑"/>
               </a:rPr>
-              <a:t>→ 优势取决于搜索空间复杂度:小空间相当,大空间显著胜</a:t>
+              <a:t>→ 同框架横跨两端点,亲手印证规律</a:t>
             </a:r>
           </a:p>
         </p:txBody>
@@ -6294,7 +6311,7 @@
                 <a:ea typeface="微软雅黑"/>
                 <a:cs typeface="微软雅黑"/>
               </a:rPr>
-              <a:t>significance_test.py / planner_significance.py(随机分布 + z 检验)</a:t>
+              <a:t>规律=文献综合;两端点=我们实测。CMU《Hidden Pitfalls》2509.08713 反证可信性为刚需</a:t>
             </a:r>
           </a:p>
         </p:txBody>
@@ -6499,14 +6516,14 @@
                 <a:ea typeface="微软雅黑"/>
                 <a:cs typeface="微软雅黑"/>
               </a:rPr>
-              <a:t>为什么打平?引导搜索的优势随搜索空间复杂度增长(文献规律)</a:t>
+              <a:t>可信协议的价值:同数据同候选,防住了朴素流程的过度声称</a:t>
             </a:r>
           </a:p>
         </p:txBody>
       </p:sp>
       <p:pic>
         <p:nvPicPr>
-          <p:cNvPr id="6" name="Picture 5" descr="复杂度规律.png"/>
+          <p:cNvPr id="6" name="Picture 5" descr="naive_vs_trustworthy.png"/>
           <p:cNvPicPr>
             <a:picLocks noChangeAspect="1"/>
           </p:cNvPicPr>
@@ -6520,8 +6537,8 @@
         </p:blipFill>
         <p:spPr>
           <a:xfrm>
-            <a:off x="457200" y="2095384"/>
-            <a:ext cx="6766560" cy="3673072"/>
+            <a:off x="548640" y="2326234"/>
+            <a:ext cx="8412480" cy="3028492"/>
           </a:xfrm>
           <a:prstGeom prst="rect">
             <a:avLst/>
@@ -6536,8 +6553,8 @@
         </p:nvSpPr>
         <p:spPr>
           <a:xfrm>
-            <a:off x="7406640" y="1920240"/>
-            <a:ext cx="4480560" cy="4389120"/>
+            <a:off x="9052560" y="2011680"/>
+            <a:ext cx="2743200" cy="4023360"/>
           </a:xfrm>
           <a:prstGeom prst="rect">
             <a:avLst/>
@@ -6552,119 +6569,119 @@
           <a:p>
             <a:pPr algn="l">
               <a:spcAft>
-                <a:spcPts val="900"/>
+                <a:spcPts val="1000"/>
               </a:spcAft>
             </a:pPr>
             <a:r>
               <a:rPr sz="1600" b="1">
                 <a:solidFill>
+                  <a:srgbClr val="C0502D"/>
+                </a:solidFill>
+                <a:latin typeface="微软雅黑"/>
+                <a:ea typeface="微软雅黑"/>
+                <a:cs typeface="微软雅黑"/>
+              </a:rPr>
+              <a:t>朴素 AI4S:</a:t>
+            </a:r>
+          </a:p>
+          <a:p>
+            <a:pPr algn="l">
+              <a:spcAft>
+                <a:spcPts val="1000"/>
+              </a:spcAft>
+            </a:pPr>
+            <a:r>
+              <a:rPr sz="1500" b="0">
+                <a:solidFill>
                   <a:srgbClr val="1A2333"/>
                 </a:solidFill>
                 <a:latin typeface="微软雅黑"/>
                 <a:ea typeface="微软雅黑"/>
                 <a:cs typeface="微软雅黑"/>
               </a:rPr>
-              <a:t>引导搜索优势随空间复杂度增长:</a:t>
-            </a:r>
-          </a:p>
-          <a:p>
-            <a:pPr algn="l">
-              <a:spcAft>
-                <a:spcPts val="900"/>
+              <a:t>声称 4 项发现</a:t>
+            </a:r>
+          </a:p>
+          <a:p>
+            <a:pPr algn="l">
+              <a:spcAft>
+                <a:spcPts val="1000"/>
               </a:spcAft>
             </a:pPr>
             <a:r>
               <a:rPr sz="1400" b="0">
                 <a:solidFill>
+                  <a:srgbClr val="6B7A8D"/>
+                </a:solidFill>
+                <a:latin typeface="微软雅黑"/>
+                <a:ea typeface="微软雅黑"/>
+                <a:cs typeface="微软雅黑"/>
+              </a:rPr>
+              <a:t>(经查全为已有)、不报局限</a:t>
+            </a:r>
+          </a:p>
+          <a:p>
+            <a:pPr algn="l">
+              <a:spcAft>
+                <a:spcPts val="1000"/>
+              </a:spcAft>
+            </a:pPr>
+            <a:r>
+              <a:rPr sz="1600" b="1">
+                <a:solidFill>
+                  <a:srgbClr val="5B9BD5"/>
+                </a:solidFill>
+                <a:latin typeface="微软雅黑"/>
+                <a:ea typeface="微软雅黑"/>
+                <a:cs typeface="微软雅黑"/>
+              </a:rPr>
+              <a:t>本框架:</a:t>
+            </a:r>
+          </a:p>
+          <a:p>
+            <a:pPr algn="l">
+              <a:spcAft>
+                <a:spcPts val="1000"/>
+              </a:spcAft>
+            </a:pPr>
+            <a:r>
+              <a:rPr sz="1500" b="0">
+                <a:solidFill>
                   <a:srgbClr val="1A2333"/>
                 </a:solidFill>
                 <a:latin typeface="微软雅黑"/>
                 <a:ea typeface="微软雅黑"/>
                 <a:cs typeface="微软雅黑"/>
               </a:rPr>
-              <a:t>· Bergstra'12:低有效维→随机追平</a:t>
-            </a:r>
-          </a:p>
-          <a:p>
-            <a:pPr algn="l">
-              <a:spcAft>
-                <a:spcPts val="900"/>
+              <a:t>查新/留出过滤后</a:t>
+            </a:r>
+          </a:p>
+          <a:p>
+            <a:pPr algn="l">
+              <a:spcAft>
+                <a:spcPts val="1000"/>
               </a:spcAft>
             </a:pPr>
             <a:r>
               <a:rPr sz="1400" b="0">
                 <a:solidFill>
-                  <a:srgbClr val="1A2333"/>
-                </a:solidFill>
-                <a:latin typeface="微软雅黑"/>
-                <a:ea typeface="微软雅黑"/>
-                <a:cs typeface="微软雅黑"/>
-              </a:rPr>
-              <a:t>· REMBO:~15–20 维临界点</a:t>
-            </a:r>
-          </a:p>
-          <a:p>
-            <a:pPr algn="l">
-              <a:spcAft>
-                <a:spcPts val="900"/>
-              </a:spcAft>
-            </a:pPr>
-            <a:r>
-              <a:rPr sz="1400" b="0">
-                <a:solidFill>
-                  <a:srgbClr val="1A2333"/>
-                </a:solidFill>
-                <a:latin typeface="微软雅黑"/>
-                <a:ea typeface="微软雅黑"/>
-                <a:cs typeface="微软雅黑"/>
-              </a:rPr>
-              <a:t>· FunSearch:巨大程序空间→引导才行</a:t>
-            </a:r>
-          </a:p>
-          <a:p>
-            <a:pPr algn="l">
-              <a:spcAft>
-                <a:spcPts val="900"/>
-              </a:spcAft>
-            </a:pPr>
-            <a:r>
-              <a:rPr sz="1500" b="1">
-                <a:solidFill>
-                  <a:srgbClr val="C0502D"/>
-                </a:solidFill>
-                <a:latin typeface="微软雅黑"/>
-                <a:ea typeface="微软雅黑"/>
-                <a:cs typeface="微软雅黑"/>
-              </a:rPr>
-              <a:t>· 我们能耗域(小)→打平</a:t>
-            </a:r>
-          </a:p>
-          <a:p>
-            <a:pPr algn="l">
-              <a:spcAft>
-                <a:spcPts val="900"/>
-              </a:spcAft>
-            </a:pPr>
-            <a:r>
-              <a:rPr sz="1500" b="1">
-                <a:solidFill>
-                  <a:srgbClr val="5B9BD5"/>
-                </a:solidFill>
-                <a:latin typeface="微软雅黑"/>
-                <a:ea typeface="微软雅黑"/>
-                <a:cs typeface="微软雅黑"/>
-              </a:rPr>
-              <a:t>· 我们规划器域(大)→胜 27%</a:t>
-            </a:r>
-          </a:p>
-          <a:p>
-            <a:pPr algn="l">
-              <a:spcAft>
-                <a:spcPts val="900"/>
-              </a:spcAft>
-            </a:pPr>
-            <a:r>
-              <a:rPr sz="1500" b="1">
+                  <a:srgbClr val="6B7A8D"/>
+                </a:solidFill>
+                <a:latin typeface="微软雅黑"/>
+                <a:ea typeface="微软雅黑"/>
+                <a:cs typeface="微软雅黑"/>
+              </a:rPr>
+              <a:t>如实报告 + 记 4 项边界</a:t>
+            </a:r>
+          </a:p>
+          <a:p>
+            <a:pPr algn="l">
+              <a:spcAft>
+                <a:spcPts val="1000"/>
+              </a:spcAft>
+            </a:pPr>
+            <a:r>
+              <a:rPr sz="1400" b="1">
                 <a:solidFill>
                   <a:srgbClr val="0563C1"/>
                 </a:solidFill>
@@ -6672,7 +6689,7 @@
                 <a:ea typeface="微软雅黑"/>
                 <a:cs typeface="微软雅黑"/>
               </a:rPr>
-              <a:t>→ 同框架横跨两端点,亲手印证规律</a:t>
+              <a:t>→ 安全机制把“看似发现”挡在门外</a:t>
             </a:r>
           </a:p>
         </p:txBody>
@@ -6713,7 +6730,7 @@
                 <a:ea typeface="微软雅黑"/>
                 <a:cs typeface="微软雅黑"/>
               </a:rPr>
-              <a:t>规律=文献综合;两端点=我们实测。CMU《Hidden Pitfalls》2509.08713 反证可信性为刚需</a:t>
+              <a:t>naive_vs_trustworthy.py(同数据同候选,端到端产出对照)</a:t>
             </a:r>
           </a:p>
         </p:txBody>
@@ -6918,14 +6935,14 @@
                 <a:ea typeface="微软雅黑"/>
                 <a:cs typeface="微软雅黑"/>
               </a:rPr>
-              <a:t>可信协议的价值:同数据同候选,防住了朴素流程的过度声称</a:t>
+              <a:t>适用范围:省能收益集中于“障碍逼出爬升”的几何(可达 4–22%)</a:t>
             </a:r>
           </a:p>
         </p:txBody>
       </p:sp>
       <p:pic>
         <p:nvPicPr>
-          <p:cNvPr id="6" name="Picture 5" descr="naive_vs_trustworthy.png"/>
+          <p:cNvPr id="6" name="Picture 5" descr="省能分布_n250.png"/>
           <p:cNvPicPr>
             <a:picLocks noChangeAspect="1"/>
           </p:cNvPicPr>
@@ -6939,8 +6956,8 @@
         </p:blipFill>
         <p:spPr>
           <a:xfrm>
-            <a:off x="548640" y="2326234"/>
-            <a:ext cx="8412480" cy="3028492"/>
+            <a:off x="562672" y="1828800"/>
+            <a:ext cx="6829936" cy="4114800"/>
           </a:xfrm>
           <a:prstGeom prst="rect">
             <a:avLst/>
@@ -6955,8 +6972,8 @@
         </p:nvSpPr>
         <p:spPr>
           <a:xfrm>
-            <a:off x="9052560" y="2011680"/>
-            <a:ext cx="2743200" cy="4023360"/>
+            <a:off x="7680960" y="1920240"/>
+            <a:ext cx="4114800" cy="4206240"/>
           </a:xfrm>
           <a:prstGeom prst="rect">
             <a:avLst/>
@@ -6971,25 +6988,43 @@
           <a:p>
             <a:pPr algn="l">
               <a:spcAft>
-                <a:spcPts val="1000"/>
+                <a:spcPts val="1100"/>
               </a:spcAft>
             </a:pPr>
             <a:r>
               <a:rPr sz="1600" b="1">
                 <a:solidFill>
-                  <a:srgbClr val="C0502D"/>
-                </a:solidFill>
-                <a:latin typeface="微软雅黑"/>
-                <a:ea typeface="微软雅黑"/>
-                <a:cs typeface="微软雅黑"/>
-              </a:rPr>
-              <a:t>朴素 AI4S:</a:t>
-            </a:r>
-          </a:p>
-          <a:p>
-            <a:pPr algn="l">
-              <a:spcAft>
-                <a:spcPts val="1000"/>
+                  <a:srgbClr val="1A2333"/>
+                </a:solidFill>
+                <a:latin typeface="微软雅黑"/>
+                <a:ea typeface="微软雅黑"/>
+                <a:cs typeface="微软雅黑"/>
+              </a:rPr>
+              <a:t>n=250 随机城市场景,划清适用边界:</a:t>
+            </a:r>
+          </a:p>
+          <a:p>
+            <a:pPr algn="l">
+              <a:spcAft>
+                <a:spcPts val="1100"/>
+              </a:spcAft>
+            </a:pPr>
+            <a:r>
+              <a:rPr sz="1500" b="1">
+                <a:solidFill>
+                  <a:srgbClr val="5B9BD5"/>
+                </a:solidFill>
+                <a:latin typeface="微软雅黑"/>
+                <a:ea typeface="微软雅黑"/>
+                <a:cs typeface="微软雅黑"/>
+              </a:rPr>
+              <a:t>· 障碍逼出爬升的几何:省能 3–22%</a:t>
+            </a:r>
+          </a:p>
+          <a:p>
+            <a:pPr algn="l">
+              <a:spcAft>
+                <a:spcPts val="1100"/>
               </a:spcAft>
             </a:pPr>
             <a:r>
@@ -7001,17 +7036,53 @@
                 <a:ea typeface="微软雅黑"/>
                 <a:cs typeface="微软雅黑"/>
               </a:rPr>
-              <a:t>声称 4 项发现</a:t>
-            </a:r>
-          </a:p>
-          <a:p>
-            <a:pPr algn="l">
-              <a:spcAft>
-                <a:spcPts val="1000"/>
-              </a:spcAft>
-            </a:pPr>
-            <a:r>
-              <a:rPr sz="1400" b="0">
+              <a:t>· 有低空走廊时:能量最优≈最短路</a:t>
+            </a:r>
+          </a:p>
+          <a:p>
+            <a:pPr algn="l">
+              <a:spcAft>
+                <a:spcPts val="1100"/>
+              </a:spcAft>
+            </a:pPr>
+            <a:r>
+              <a:rPr sz="1500" b="0">
+                <a:solidFill>
+                  <a:srgbClr val="1A2333"/>
+                </a:solidFill>
+                <a:latin typeface="微软雅黑"/>
+                <a:ea typeface="微软雅黑"/>
+                <a:cs typeface="微软雅黑"/>
+              </a:rPr>
+              <a:t>· 结论用统计陈述,不挑单一场景</a:t>
+            </a:r>
+          </a:p>
+          <a:p>
+            <a:pPr algn="l">
+              <a:spcAft>
+                <a:spcPts val="1100"/>
+              </a:spcAft>
+            </a:pPr>
+            <a:r>
+              <a:rPr sz="1600" b="1">
+                <a:solidFill>
+                  <a:srgbClr val="1A2333"/>
+                </a:solidFill>
+                <a:latin typeface="微软雅黑"/>
+                <a:ea typeface="微软雅黑"/>
+                <a:cs typeface="微软雅黑"/>
+              </a:rPr>
+              <a:t>适用条件(诚实标注):</a:t>
+            </a:r>
+          </a:p>
+          <a:p>
+            <a:pPr algn="l">
+              <a:spcAft>
+                <a:spcPts val="1100"/>
+              </a:spcAft>
+            </a:pPr>
+            <a:r>
+              <a:rPr sz="1500" b="0">
                 <a:solidFill>
                   <a:srgbClr val="6B7A8D"/>
                 </a:solidFill>
@@ -7019,79 +7090,7 @@
                 <a:ea typeface="微软雅黑"/>
                 <a:cs typeface="微软雅黑"/>
               </a:rPr>
-              <a:t>(经查全为已有)、不报局限</a:t>
-            </a:r>
-          </a:p>
-          <a:p>
-            <a:pPr algn="l">
-              <a:spcAft>
-                <a:spcPts val="1000"/>
-              </a:spcAft>
-            </a:pPr>
-            <a:r>
-              <a:rPr sz="1600" b="1">
-                <a:solidFill>
-                  <a:srgbClr val="5B9BD5"/>
-                </a:solidFill>
-                <a:latin typeface="微软雅黑"/>
-                <a:ea typeface="微软雅黑"/>
-                <a:cs typeface="微软雅黑"/>
-              </a:rPr>
-              <a:t>本框架:</a:t>
-            </a:r>
-          </a:p>
-          <a:p>
-            <a:pPr algn="l">
-              <a:spcAft>
-                <a:spcPts val="1000"/>
-              </a:spcAft>
-            </a:pPr>
-            <a:r>
-              <a:rPr sz="1500" b="0">
-                <a:solidFill>
-                  <a:srgbClr val="1A2333"/>
-                </a:solidFill>
-                <a:latin typeface="微软雅黑"/>
-                <a:ea typeface="微软雅黑"/>
-                <a:cs typeface="微软雅黑"/>
-              </a:rPr>
-              <a:t>查新/留出过滤后</a:t>
-            </a:r>
-          </a:p>
-          <a:p>
-            <a:pPr algn="l">
-              <a:spcAft>
-                <a:spcPts val="1000"/>
-              </a:spcAft>
-            </a:pPr>
-            <a:r>
-              <a:rPr sz="1400" b="0">
-                <a:solidFill>
-                  <a:srgbClr val="6B7A8D"/>
-                </a:solidFill>
-                <a:latin typeface="微软雅黑"/>
-                <a:ea typeface="微软雅黑"/>
-                <a:cs typeface="微软雅黑"/>
-              </a:rPr>
-              <a:t>如实报告 + 记 4 项边界</a:t>
-            </a:r>
-          </a:p>
-          <a:p>
-            <a:pPr algn="l">
-              <a:spcAft>
-                <a:spcPts val="1000"/>
-              </a:spcAft>
-            </a:pPr>
-            <a:r>
-              <a:rPr sz="1400" b="1">
-                <a:solidFill>
-                  <a:srgbClr val="0563C1"/>
-                </a:solidFill>
-                <a:latin typeface="微软雅黑"/>
-                <a:ea typeface="微软雅黑"/>
-                <a:cs typeface="微软雅黑"/>
-              </a:rPr>
-              <a:t>→ 安全机制把“看似发现”挡在门外</a:t>
+              <a:t>· 载荷 ≤500g 不改变路径;当前止于仿真</a:t>
             </a:r>
           </a:p>
         </p:txBody>
@@ -7132,7 +7131,7 @@
                 <a:ea typeface="微软雅黑"/>
                 <a:cs typeface="微软雅黑"/>
               </a:rPr>
-              <a:t>naive_vs_trustworthy.py(同数据同候选,端到端产出对照)</a:t>
+              <a:t>large_scale_savings.py(n=250);相图见附录 B(何时省能)</a:t>
             </a:r>
           </a:p>
         </p:txBody>
@@ -7151,7 +7150,7 @@
     <p:bg>
       <p:bgPr>
         <a:solidFill>
-          <a:srgbClr val="FFFFFF"/>
+          <a:srgbClr val="0A2A66"/>
         </a:solidFill>
         <a:effectLst/>
       </p:bgPr>
@@ -7178,7 +7177,7 @@
             <a:avLst/>
           </a:prstGeom>
           <a:solidFill>
-            <a:srgbClr val="4472C4"/>
+            <a:srgbClr val="5B9BD5"/>
           </a:solidFill>
           <a:ln>
             <a:noFill/>
@@ -7206,145 +7205,9 @@
           </a:p>
         </p:txBody>
       </p:sp>
-      <p:sp>
-        <p:nvSpPr>
-          <p:cNvPr id="3" name="TextBox 2"/>
-          <p:cNvSpPr txBox="1"/>
-          <p:nvPr/>
-        </p:nvSpPr>
-        <p:spPr>
-          <a:xfrm>
-            <a:off x="9052560" y="292608"/>
-            <a:ext cx="2834640" cy="365760"/>
-          </a:xfrm>
-          <a:prstGeom prst="rect">
-            <a:avLst/>
-          </a:prstGeom>
-          <a:noFill/>
-        </p:spPr>
-        <p:txBody>
-          <a:bodyPr wrap="square" anchor="t" lIns="25400" rIns="25400" tIns="25400" bIns="25400">
-            <a:spAutoFit/>
-          </a:bodyPr>
-          <a:lstStyle/>
-          <a:p>
-            <a:pPr algn="r">
-              <a:spcAft>
-                <a:spcPts val="400"/>
-              </a:spcAft>
-            </a:pPr>
-            <a:r>
-              <a:rPr sz="1200" b="0">
-                <a:solidFill>
-                  <a:srgbClr val="9AA8B8"/>
-                </a:solidFill>
-                <a:latin typeface="微软雅黑"/>
-                <a:ea typeface="微软雅黑"/>
-                <a:cs typeface="微软雅黑"/>
-              </a:rPr>
-              <a:t>西安交通大学</a:t>
-            </a:r>
-          </a:p>
-        </p:txBody>
-      </p:sp>
-      <p:sp>
-        <p:nvSpPr>
-          <p:cNvPr id="4" name="Rounded Rectangle 3"/>
-          <p:cNvSpPr/>
-          <p:nvPr/>
-        </p:nvSpPr>
-        <p:spPr>
-          <a:xfrm>
-            <a:off x="502920" y="365760"/>
-            <a:ext cx="566928" cy="457200"/>
-          </a:xfrm>
-          <a:prstGeom prst="roundRect">
-            <a:avLst/>
-          </a:prstGeom>
-          <a:solidFill>
-            <a:srgbClr val="4472C4"/>
-          </a:solidFill>
-          <a:ln>
-            <a:noFill/>
-          </a:ln>
-        </p:spPr>
-        <p:style>
-          <a:lnRef idx="1">
-            <a:schemeClr val="accent1"/>
-          </a:lnRef>
-          <a:fillRef idx="3">
-            <a:schemeClr val="accent1"/>
-          </a:fillRef>
-          <a:effectRef idx="2">
-            <a:schemeClr val="accent1"/>
-          </a:effectRef>
-          <a:fontRef idx="minor">
-            <a:schemeClr val="lt1"/>
-          </a:fontRef>
-        </p:style>
-        <p:txBody>
-          <a:bodyPr rtlCol="0" anchor="ctr" tIns="0" bIns="0" lIns="0" rIns="0" wrap="none"/>
-          <a:lstStyle/>
-          <a:p>
-            <a:pPr algn="ctr"/>
-            <a:r>
-              <a:rPr sz="1600" b="1">
-                <a:solidFill>
-                  <a:srgbClr val="FFFFFF"/>
-                </a:solidFill>
-                <a:latin typeface="微软雅黑"/>
-                <a:ea typeface="微软雅黑"/>
-                <a:cs typeface="微软雅黑"/>
-              </a:rPr>
-              <a:t>16</a:t>
-            </a:r>
-          </a:p>
-        </p:txBody>
-      </p:sp>
-      <p:sp>
-        <p:nvSpPr>
-          <p:cNvPr id="5" name="TextBox 4"/>
-          <p:cNvSpPr txBox="1"/>
-          <p:nvPr/>
-        </p:nvSpPr>
-        <p:spPr>
-          <a:xfrm>
-            <a:off x="1143000" y="347472"/>
-            <a:ext cx="10607040" cy="914400"/>
-          </a:xfrm>
-          <a:prstGeom prst="rect">
-            <a:avLst/>
-          </a:prstGeom>
-          <a:noFill/>
-        </p:spPr>
-        <p:txBody>
-          <a:bodyPr wrap="square" anchor="t" lIns="25400" rIns="25400" tIns="25400" bIns="25400">
-            <a:spAutoFit/>
-          </a:bodyPr>
-          <a:lstStyle/>
-          <a:p>
-            <a:pPr algn="l">
-              <a:spcAft>
-                <a:spcPts val="400"/>
-              </a:spcAft>
-            </a:pPr>
-            <a:r>
-              <a:rPr sz="2600" b="1">
-                <a:solidFill>
-                  <a:srgbClr val="0563C1"/>
-                </a:solidFill>
-                <a:latin typeface="微软雅黑"/>
-                <a:ea typeface="微软雅黑"/>
-                <a:cs typeface="微软雅黑"/>
-              </a:rPr>
-              <a:t>适用范围:省能收益集中于“障碍逼出爬升”的几何(可达 4–22%)</a:t>
-            </a:r>
-          </a:p>
-        </p:txBody>
-      </p:sp>
       <p:pic>
         <p:nvPicPr>
-          <p:cNvPr id="6" name="Picture 5" descr="省能分布_n250.png"/>
+          <p:cNvPr id="3" name="Picture 2" descr="xjtu_logo_white.png"/>
           <p:cNvPicPr>
             <a:picLocks noChangeAspect="1"/>
           </p:cNvPicPr>
@@ -7358,8 +7221,8 @@
         </p:blipFill>
         <p:spPr>
           <a:xfrm>
-            <a:off x="562672" y="1828800"/>
-            <a:ext cx="6829936" cy="4114800"/>
+            <a:off x="8686800" y="365760"/>
+            <a:ext cx="1707229" cy="457200"/>
           </a:xfrm>
           <a:prstGeom prst="rect">
             <a:avLst/>
@@ -7368,14 +7231,68 @@
       </p:pic>
       <p:sp>
         <p:nvSpPr>
-          <p:cNvPr id="7" name="TextBox 6"/>
+          <p:cNvPr id="4" name="Rounded Rectangle 3"/>
+          <p:cNvSpPr/>
+          <p:nvPr/>
+        </p:nvSpPr>
+        <p:spPr>
+          <a:xfrm>
+            <a:off x="502920" y="365760"/>
+            <a:ext cx="566928" cy="457200"/>
+          </a:xfrm>
+          <a:prstGeom prst="roundRect">
+            <a:avLst/>
+          </a:prstGeom>
+          <a:solidFill>
+            <a:srgbClr val="5B9BD5"/>
+          </a:solidFill>
+          <a:ln>
+            <a:noFill/>
+          </a:ln>
+        </p:spPr>
+        <p:style>
+          <a:lnRef idx="1">
+            <a:schemeClr val="accent1"/>
+          </a:lnRef>
+          <a:fillRef idx="3">
+            <a:schemeClr val="accent1"/>
+          </a:fillRef>
+          <a:effectRef idx="2">
+            <a:schemeClr val="accent1"/>
+          </a:effectRef>
+          <a:fontRef idx="minor">
+            <a:schemeClr val="lt1"/>
+          </a:fontRef>
+        </p:style>
+        <p:txBody>
+          <a:bodyPr rtlCol="0" anchor="ctr" tIns="0" bIns="0" lIns="0" rIns="0" wrap="none"/>
+          <a:lstStyle/>
+          <a:p>
+            <a:pPr algn="ctr"/>
+            <a:r>
+              <a:rPr sz="1600" b="1">
+                <a:solidFill>
+                  <a:srgbClr val="FFFFFF"/>
+                </a:solidFill>
+                <a:latin typeface="微软雅黑"/>
+                <a:ea typeface="微软雅黑"/>
+                <a:cs typeface="微软雅黑"/>
+              </a:rPr>
+              <a:t>16</a:t>
+            </a:r>
+          </a:p>
+        </p:txBody>
+      </p:sp>
+      <p:sp>
+        <p:nvSpPr>
+          <p:cNvPr id="5" name="TextBox 4"/>
           <p:cNvSpPr txBox="1"/>
           <p:nvPr/>
         </p:nvSpPr>
         <p:spPr>
           <a:xfrm>
-            <a:off x="7680960" y="1920240"/>
-            <a:ext cx="4114800" cy="4206240"/>
+            <a:off x="822960" y="1188720"/>
+            <a:ext cx="10515600" cy="640080"/>
           </a:xfrm>
           <a:prstGeom prst="rect">
             <a:avLst/>
@@ -7390,29 +7307,11 @@
           <a:p>
             <a:pPr algn="l">
               <a:spcAft>
-                <a:spcPts val="1100"/>
-              </a:spcAft>
-            </a:pPr>
-            <a:r>
-              <a:rPr sz="1600" b="1">
-                <a:solidFill>
-                  <a:srgbClr val="1A2333"/>
-                </a:solidFill>
-                <a:latin typeface="微软雅黑"/>
-                <a:ea typeface="微软雅黑"/>
-                <a:cs typeface="微软雅黑"/>
-              </a:rPr>
-              <a:t>n=250 随机城市场景,划清适用边界:</a:t>
-            </a:r>
-          </a:p>
-          <a:p>
-            <a:pPr algn="l">
-              <a:spcAft>
-                <a:spcPts val="1100"/>
-              </a:spcAft>
-            </a:pPr>
-            <a:r>
-              <a:rPr sz="1500" b="1">
+                <a:spcPts val="400"/>
+              </a:spcAft>
+            </a:pPr>
+            <a:r>
+              <a:rPr sz="2400" b="1">
                 <a:solidFill>
                   <a:srgbClr val="5B9BD5"/>
                 </a:solidFill>
@@ -7420,93 +7319,21 @@
                 <a:ea typeface="微软雅黑"/>
                 <a:cs typeface="微软雅黑"/>
               </a:rPr>
-              <a:t>· 障碍逼出爬升的几何:省能 3–22%</a:t>
-            </a:r>
-          </a:p>
-          <a:p>
-            <a:pPr algn="l">
-              <a:spcAft>
-                <a:spcPts val="1100"/>
-              </a:spcAft>
-            </a:pPr>
-            <a:r>
-              <a:rPr sz="1500" b="0">
-                <a:solidFill>
-                  <a:srgbClr val="1A2333"/>
-                </a:solidFill>
-                <a:latin typeface="微软雅黑"/>
-                <a:ea typeface="微软雅黑"/>
-                <a:cs typeface="微软雅黑"/>
-              </a:rPr>
-              <a:t>· 有低空走廊时:能量最优≈最短路</a:t>
-            </a:r>
-          </a:p>
-          <a:p>
-            <a:pPr algn="l">
-              <a:spcAft>
-                <a:spcPts val="1100"/>
-              </a:spcAft>
-            </a:pPr>
-            <a:r>
-              <a:rPr sz="1500" b="0">
-                <a:solidFill>
-                  <a:srgbClr val="1A2333"/>
-                </a:solidFill>
-                <a:latin typeface="微软雅黑"/>
-                <a:ea typeface="微软雅黑"/>
-                <a:cs typeface="微软雅黑"/>
-              </a:rPr>
-              <a:t>· 结论用统计陈述,不挑单一场景</a:t>
-            </a:r>
-          </a:p>
-          <a:p>
-            <a:pPr algn="l">
-              <a:spcAft>
-                <a:spcPts val="1100"/>
-              </a:spcAft>
-            </a:pPr>
-            <a:r>
-              <a:rPr sz="1600" b="1">
-                <a:solidFill>
-                  <a:srgbClr val="1A2333"/>
-                </a:solidFill>
-                <a:latin typeface="微软雅黑"/>
-                <a:ea typeface="微软雅黑"/>
-                <a:cs typeface="微软雅黑"/>
-              </a:rPr>
-              <a:t>适用条件(诚实标注):</a:t>
-            </a:r>
-          </a:p>
-          <a:p>
-            <a:pPr algn="l">
-              <a:spcAft>
-                <a:spcPts val="1100"/>
-              </a:spcAft>
-            </a:pPr>
-            <a:r>
-              <a:rPr sz="1500" b="0">
-                <a:solidFill>
-                  <a:srgbClr val="6B7A8D"/>
-                </a:solidFill>
-                <a:latin typeface="微软雅黑"/>
-                <a:ea typeface="微软雅黑"/>
-                <a:cs typeface="微软雅黑"/>
-              </a:rPr>
-              <a:t>· 载荷 ≤500g 不改变路径;当前止于仿真</a:t>
-            </a:r>
-          </a:p>
-        </p:txBody>
-      </p:sp>
-      <p:sp>
-        <p:nvSpPr>
-          <p:cNvPr id="8" name="TextBox 7"/>
+              <a:t>结论</a:t>
+            </a:r>
+          </a:p>
+        </p:txBody>
+      </p:sp>
+      <p:sp>
+        <p:nvSpPr>
+          <p:cNvPr id="6" name="TextBox 5"/>
           <p:cNvSpPr txBox="1"/>
           <p:nvPr/>
         </p:nvSpPr>
         <p:spPr>
           <a:xfrm>
-            <a:off x="502920" y="6400800"/>
-            <a:ext cx="11155680" cy="320040"/>
+            <a:off x="822960" y="2103120"/>
+            <a:ext cx="10698480" cy="4023360"/>
           </a:xfrm>
           <a:prstGeom prst="rect">
             <a:avLst/>
@@ -7521,19 +7348,91 @@
           <a:p>
             <a:pPr algn="l">
               <a:spcAft>
-                <a:spcPts val="400"/>
-              </a:spcAft>
-            </a:pPr>
-            <a:r>
-              <a:rPr sz="1100" b="0">
-                <a:solidFill>
-                  <a:srgbClr val="6B7A8D"/>
-                </a:solidFill>
-                <a:latin typeface="微软雅黑"/>
-                <a:ea typeface="微软雅黑"/>
-                <a:cs typeface="微软雅黑"/>
-              </a:rPr>
-              <a:t>large_scale_savings.py(n=250);相图见附录 B(何时省能)</a:t>
+                <a:spcPts val="1600"/>
+              </a:spcAft>
+            </a:pPr>
+            <a:r>
+              <a:rPr sz="2100" b="0">
+                <a:solidFill>
+                  <a:srgbClr val="FFFFFF"/>
+                </a:solidFill>
+                <a:latin typeface="微软雅黑"/>
+                <a:ea typeface="微软雅黑"/>
+                <a:cs typeface="微软雅黑"/>
+              </a:rPr>
+              <a:t>① 不声称新算法/新效应——三次查新确认均为 prior art,主动引用</a:t>
+            </a:r>
+          </a:p>
+          <a:p>
+            <a:pPr algn="l">
+              <a:spcAft>
+                <a:spcPts val="1600"/>
+              </a:spcAft>
+            </a:pPr>
+            <a:r>
+              <a:rPr sz="2100" b="1">
+                <a:solidFill>
+                  <a:srgbClr val="5B9BD5"/>
+                </a:solidFill>
+                <a:latin typeface="微软雅黑"/>
+                <a:ea typeface="微软雅黑"/>
+                <a:cs typeface="微软雅黑"/>
+              </a:rPr>
+              <a:t>② 贡献 = 可信自动科研方法学 + 真机数据锚定 + 诚实能力边界</a:t>
+            </a:r>
+          </a:p>
+          <a:p>
+            <a:pPr algn="l">
+              <a:spcAft>
+                <a:spcPts val="1600"/>
+              </a:spcAft>
+            </a:pPr>
+            <a:r>
+              <a:rPr sz="2100" b="0">
+                <a:solidFill>
+                  <a:srgbClr val="FFFFFF"/>
+                </a:solidFill>
+                <a:latin typeface="微软雅黑"/>
+                <a:ea typeface="微软雅黑"/>
+                <a:cs typeface="微软雅黑"/>
+              </a:rPr>
+              <a:t>③ 逐个消融证明每道节点“承重”:去掉即退化/overclaim</a:t>
+            </a:r>
+          </a:p>
+          <a:p>
+            <a:pPr algn="l">
+              <a:spcAft>
+                <a:spcPts val="1600"/>
+              </a:spcAft>
+            </a:pPr>
+            <a:r>
+              <a:rPr sz="2100" b="0">
+                <a:solidFill>
+                  <a:srgbClr val="FFFFFF"/>
+                </a:solidFill>
+                <a:latin typeface="微软雅黑"/>
+                <a:ea typeface="微软雅黑"/>
+                <a:cs typeface="微软雅黑"/>
+              </a:rPr>
+              <a:t>④ 价值 = 在该 overclaim 处不 overclaim,并量化能力边界</a:t>
+            </a:r>
+          </a:p>
+          <a:p>
+            <a:pPr algn="l">
+              <a:spcAft>
+                <a:spcPts val="1600"/>
+              </a:spcAft>
+            </a:pPr>
+            <a:r>
+              <a:rPr sz="2100" b="0">
+                <a:solidFill>
+                  <a:srgbClr val="FFFFFF"/>
+                </a:solidFill>
+                <a:latin typeface="微软雅黑"/>
+                <a:ea typeface="微软雅黑"/>
+                <a:cs typeface="微软雅黑"/>
+              </a:rPr>
+              <a:t>⑤ 搜索空间大则显著胜随机,空间小(已封顶)则与随机相当</a:t>
             </a:r>
           </a:p>
         </p:txBody>
@@ -7935,7 +7834,7 @@
     <p:bg>
       <p:bgPr>
         <a:solidFill>
-          <a:srgbClr val="0A2A66"/>
+          <a:srgbClr val="FFFFFF"/>
         </a:solidFill>
         <a:effectLst/>
       </p:bgPr>
@@ -7962,7 +7861,7 @@
             <a:avLst/>
           </a:prstGeom>
           <a:solidFill>
-            <a:srgbClr val="5B9BD5"/>
+            <a:srgbClr val="4472C4"/>
           </a:solidFill>
           <a:ln>
             <a:noFill/>
@@ -7990,30 +7889,47 @@
           </a:p>
         </p:txBody>
       </p:sp>
-      <p:pic>
-        <p:nvPicPr>
-          <p:cNvPr id="3" name="Picture 2" descr="xjtu_logo_white.png"/>
-          <p:cNvPicPr>
-            <a:picLocks noChangeAspect="1"/>
-          </p:cNvPicPr>
-          <p:nvPr/>
-        </p:nvPicPr>
-        <p:blipFill>
-          <a:blip r:embed="rId2"/>
-          <a:stretch>
-            <a:fillRect/>
-          </a:stretch>
-        </p:blipFill>
-        <p:spPr>
-          <a:xfrm>
-            <a:off x="8686800" y="365760"/>
-            <a:ext cx="1707229" cy="457200"/>
-          </a:xfrm>
-          <a:prstGeom prst="rect">
-            <a:avLst/>
-          </a:prstGeom>
-        </p:spPr>
-      </p:pic>
+      <p:sp>
+        <p:nvSpPr>
+          <p:cNvPr id="3" name="TextBox 2"/>
+          <p:cNvSpPr txBox="1"/>
+          <p:nvPr/>
+        </p:nvSpPr>
+        <p:spPr>
+          <a:xfrm>
+            <a:off x="9052560" y="292608"/>
+            <a:ext cx="2834640" cy="365760"/>
+          </a:xfrm>
+          <a:prstGeom prst="rect">
+            <a:avLst/>
+          </a:prstGeom>
+          <a:noFill/>
+        </p:spPr>
+        <p:txBody>
+          <a:bodyPr wrap="square" anchor="t" lIns="25400" rIns="25400" tIns="25400" bIns="25400">
+            <a:spAutoFit/>
+          </a:bodyPr>
+          <a:lstStyle/>
+          <a:p>
+            <a:pPr algn="r">
+              <a:spcAft>
+                <a:spcPts val="400"/>
+              </a:spcAft>
+            </a:pPr>
+            <a:r>
+              <a:rPr sz="1200" b="0">
+                <a:solidFill>
+                  <a:srgbClr val="9AA8B8"/>
+                </a:solidFill>
+                <a:latin typeface="微软雅黑"/>
+                <a:ea typeface="微软雅黑"/>
+                <a:cs typeface="微软雅黑"/>
+              </a:rPr>
+              <a:t>西安交通大学</a:t>
+            </a:r>
+          </a:p>
+        </p:txBody>
+      </p:sp>
       <p:sp>
         <p:nvSpPr>
           <p:cNvPr id="4" name="Rounded Rectangle 3"/>
@@ -8029,7 +7945,7 @@
             <a:avLst/>
           </a:prstGeom>
           <a:solidFill>
-            <a:srgbClr val="5B9BD5"/>
+            <a:srgbClr val="4472C4"/>
           </a:solidFill>
           <a:ln>
             <a:noFill/>
@@ -8076,8 +7992,8 @@
         </p:nvSpPr>
         <p:spPr>
           <a:xfrm>
-            <a:off x="822960" y="1188720"/>
-            <a:ext cx="10515600" cy="640080"/>
+            <a:off x="1143000" y="347472"/>
+            <a:ext cx="10607040" cy="914400"/>
           </a:xfrm>
           <a:prstGeom prst="rect">
             <a:avLst/>
@@ -8096,15 +8012,15 @@
               </a:spcAft>
             </a:pPr>
             <a:r>
-              <a:rPr sz="2400" b="1">
-                <a:solidFill>
-                  <a:srgbClr val="5B9BD5"/>
-                </a:solidFill>
-                <a:latin typeface="微软雅黑"/>
-                <a:ea typeface="微软雅黑"/>
-                <a:cs typeface="微软雅黑"/>
-              </a:rPr>
-              <a:t>结论</a:t>
+              <a:rPr sz="2600" b="1">
+                <a:solidFill>
+                  <a:srgbClr val="0563C1"/>
+                </a:solidFill>
+                <a:latin typeface="微软雅黑"/>
+                <a:ea typeface="微软雅黑"/>
+                <a:cs typeface="微软雅黑"/>
+              </a:rPr>
+              <a:t>参考文献</a:t>
             </a:r>
           </a:p>
         </p:txBody>
@@ -8117,8 +8033,8 @@
         </p:nvSpPr>
         <p:spPr>
           <a:xfrm>
-            <a:off x="822960" y="2103120"/>
-            <a:ext cx="10698480" cy="4023360"/>
+            <a:off x="685800" y="1828800"/>
+            <a:ext cx="10972800" cy="4389120"/>
           </a:xfrm>
           <a:prstGeom prst="rect">
             <a:avLst/>
@@ -8133,91 +8049,163 @@
           <a:p>
             <a:pPr algn="l">
               <a:spcAft>
-                <a:spcPts val="1600"/>
-              </a:spcAft>
-            </a:pPr>
-            <a:r>
-              <a:rPr sz="2100" b="0">
-                <a:solidFill>
-                  <a:srgbClr val="FFFFFF"/>
-                </a:solidFill>
-                <a:latin typeface="微软雅黑"/>
-                <a:ea typeface="微软雅黑"/>
-                <a:cs typeface="微软雅黑"/>
-              </a:rPr>
-              <a:t>① 不声称新算法/新效应——三次查新确认均为 prior art,主动引用</a:t>
-            </a:r>
-          </a:p>
-          <a:p>
-            <a:pPr algn="l">
-              <a:spcAft>
-                <a:spcPts val="1600"/>
-              </a:spcAft>
-            </a:pPr>
-            <a:r>
-              <a:rPr sz="2100" b="1">
-                <a:solidFill>
-                  <a:srgbClr val="5B9BD5"/>
-                </a:solidFill>
-                <a:latin typeface="微软雅黑"/>
-                <a:ea typeface="微软雅黑"/>
-                <a:cs typeface="微软雅黑"/>
-              </a:rPr>
-              <a:t>② 贡献 = 可信自动科研方法学 + 真机数据锚定 + 诚实能力边界</a:t>
-            </a:r>
-          </a:p>
-          <a:p>
-            <a:pPr algn="l">
-              <a:spcAft>
-                <a:spcPts val="1600"/>
-              </a:spcAft>
-            </a:pPr>
-            <a:r>
-              <a:rPr sz="2100" b="0">
-                <a:solidFill>
-                  <a:srgbClr val="FFFFFF"/>
-                </a:solidFill>
-                <a:latin typeface="微软雅黑"/>
-                <a:ea typeface="微软雅黑"/>
-                <a:cs typeface="微软雅黑"/>
-              </a:rPr>
-              <a:t>③ 逐个消融证明每道节点“承重”:去掉即退化/overclaim</a:t>
-            </a:r>
-          </a:p>
-          <a:p>
-            <a:pPr algn="l">
-              <a:spcAft>
-                <a:spcPts val="1600"/>
-              </a:spcAft>
-            </a:pPr>
-            <a:r>
-              <a:rPr sz="2100" b="0">
-                <a:solidFill>
-                  <a:srgbClr val="FFFFFF"/>
-                </a:solidFill>
-                <a:latin typeface="微软雅黑"/>
-                <a:ea typeface="微软雅黑"/>
-                <a:cs typeface="微软雅黑"/>
-              </a:rPr>
-              <a:t>④ 价值 = 在该 overclaim 处不 overclaim,并量化能力边界</a:t>
-            </a:r>
-          </a:p>
-          <a:p>
-            <a:pPr algn="l">
-              <a:spcAft>
-                <a:spcPts val="1600"/>
-              </a:spcAft>
-            </a:pPr>
-            <a:r>
-              <a:rPr sz="2100" b="0">
-                <a:solidFill>
-                  <a:srgbClr val="FFFFFF"/>
-                </a:solidFill>
-                <a:latin typeface="微软雅黑"/>
-                <a:ea typeface="微软雅黑"/>
-                <a:cs typeface="微软雅黑"/>
-              </a:rPr>
-              <a:t>⑤ 搜索空间大则显著胜随机,空间小(已封顶)则与随机相当</a:t>
+                <a:spcPts val="800"/>
+              </a:spcAft>
+            </a:pPr>
+            <a:r>
+              <a:rPr sz="1500" b="0">
+                <a:solidFill>
+                  <a:srgbClr val="1A2333"/>
+                </a:solidFill>
+                <a:latin typeface="微软雅黑"/>
+                <a:ea typeface="微软雅黑"/>
+                <a:cs typeface="微软雅黑"/>
+              </a:rPr>
+              <a:t>Romera-Paredes et al. FunSearch. Nature 2023.</a:t>
+            </a:r>
+          </a:p>
+          <a:p>
+            <a:pPr algn="l">
+              <a:spcAft>
+                <a:spcPts val="800"/>
+              </a:spcAft>
+            </a:pPr>
+            <a:r>
+              <a:rPr sz="1500" b="0">
+                <a:solidFill>
+                  <a:srgbClr val="1A2333"/>
+                </a:solidFill>
+                <a:latin typeface="微软雅黑"/>
+                <a:ea typeface="微软雅黑"/>
+                <a:cs typeface="微软雅黑"/>
+              </a:rPr>
+              <a:t>Novikov et al. AlphaEvolve. DeepMind 2025.</a:t>
+            </a:r>
+          </a:p>
+          <a:p>
+            <a:pPr algn="l">
+              <a:spcAft>
+                <a:spcPts val="800"/>
+              </a:spcAft>
+            </a:pPr>
+            <a:r>
+              <a:rPr sz="1500" b="0">
+                <a:solidFill>
+                  <a:srgbClr val="1A2333"/>
+                </a:solidFill>
+                <a:latin typeface="微软雅黑"/>
+                <a:ea typeface="微软雅黑"/>
+                <a:cs typeface="微软雅黑"/>
+              </a:rPr>
+              <a:t>Ma et al. Eureka. ICLR 2024. arXiv:2310.12931.</a:t>
+            </a:r>
+          </a:p>
+          <a:p>
+            <a:pPr algn="l">
+              <a:spcAft>
+                <a:spcPts val="800"/>
+              </a:spcAft>
+            </a:pPr>
+            <a:r>
+              <a:rPr sz="1500" b="0">
+                <a:solidFill>
+                  <a:srgbClr val="1A2333"/>
+                </a:solidFill>
+                <a:latin typeface="微软雅黑"/>
+                <a:ea typeface="微软雅黑"/>
+                <a:cs typeface="微软雅黑"/>
+              </a:rPr>
+              <a:t>Beel, Kan &amp; Baumgart. AI Scientist 独立评估. ACM SIGIR Forum 2025. arXiv:2502.14297.</a:t>
+            </a:r>
+          </a:p>
+          <a:p>
+            <a:pPr algn="l">
+              <a:spcAft>
+                <a:spcPts val="800"/>
+              </a:spcAft>
+            </a:pPr>
+            <a:r>
+              <a:rPr sz="1500" b="0">
+                <a:solidFill>
+                  <a:srgbClr val="1A2333"/>
+                </a:solidFill>
+                <a:latin typeface="微软雅黑"/>
+                <a:ea typeface="微软雅黑"/>
+                <a:cs typeface="微软雅黑"/>
+              </a:rPr>
+              <a:t>Michel et al. Energy-Optimal Waypoint UAV Missions. 2024. arXiv:2410.17585.</a:t>
+            </a:r>
+          </a:p>
+          <a:p>
+            <a:pPr algn="l">
+              <a:spcAft>
+                <a:spcPts val="800"/>
+              </a:spcAft>
+            </a:pPr>
+            <a:r>
+              <a:rPr sz="1500" b="0">
+                <a:solidFill>
+                  <a:srgbClr val="1A2333"/>
+                </a:solidFill>
+                <a:latin typeface="微软雅黑"/>
+                <a:ea typeface="微软雅黑"/>
+                <a:cs typeface="微软雅黑"/>
+              </a:rPr>
+              <a:t>Nguyen &amp; Au. Extending drone delivery reachable set. AAMAS 2017.</a:t>
+            </a:r>
+          </a:p>
+          <a:p>
+            <a:pPr algn="l">
+              <a:spcAft>
+                <a:spcPts val="800"/>
+              </a:spcAft>
+            </a:pPr>
+            <a:r>
+              <a:rPr sz="1500" b="0">
+                <a:solidFill>
+                  <a:srgbClr val="1A2333"/>
+                </a:solidFill>
+                <a:latin typeface="微软雅黑"/>
+                <a:ea typeface="微软雅黑"/>
+                <a:cs typeface="微软雅黑"/>
+              </a:rPr>
+              <a:t>Karl et al. Position: Embracing Negative Results in ML. ICML 2024.</a:t>
+            </a:r>
+          </a:p>
+          <a:p>
+            <a:pPr algn="l">
+              <a:spcAft>
+                <a:spcPts val="800"/>
+              </a:spcAft>
+            </a:pPr>
+            <a:r>
+              <a:rPr sz="1500" b="0">
+                <a:solidFill>
+                  <a:srgbClr val="1A2333"/>
+                </a:solidFill>
+                <a:latin typeface="微软雅黑"/>
+                <a:ea typeface="微软雅黑"/>
+                <a:cs typeface="微软雅黑"/>
+              </a:rPr>
+              <a:t>Rodrigues et al. DJI M100 energy dataset. Scientific Data 2021.</a:t>
+            </a:r>
+          </a:p>
+          <a:p>
+            <a:pPr algn="l">
+              <a:spcAft>
+                <a:spcPts val="800"/>
+              </a:spcAft>
+            </a:pPr>
+            <a:r>
+              <a:rPr sz="1500" b="0">
+                <a:solidFill>
+                  <a:srgbClr val="1A2333"/>
+                </a:solidFill>
+                <a:latin typeface="微软雅黑"/>
+                <a:ea typeface="微软雅黑"/>
+                <a:cs typeface="微软雅黑"/>
+              </a:rPr>
+              <a:t>Di Franco &amp; Buttazzo 2015;Liu 2017;EcoFlight 2025.</a:t>
             </a:r>
           </a:p>
         </p:txBody>
@@ -8334,61 +8322,7 @@
       </p:sp>
       <p:sp>
         <p:nvSpPr>
-          <p:cNvPr id="4" name="Rounded Rectangle 3"/>
-          <p:cNvSpPr/>
-          <p:nvPr/>
-        </p:nvSpPr>
-        <p:spPr>
-          <a:xfrm>
-            <a:off x="502920" y="365760"/>
-            <a:ext cx="566928" cy="457200"/>
-          </a:xfrm>
-          <a:prstGeom prst="roundRect">
-            <a:avLst/>
-          </a:prstGeom>
-          <a:solidFill>
-            <a:srgbClr val="4472C4"/>
-          </a:solidFill>
-          <a:ln>
-            <a:noFill/>
-          </a:ln>
-        </p:spPr>
-        <p:style>
-          <a:lnRef idx="1">
-            <a:schemeClr val="accent1"/>
-          </a:lnRef>
-          <a:fillRef idx="3">
-            <a:schemeClr val="accent1"/>
-          </a:fillRef>
-          <a:effectRef idx="2">
-            <a:schemeClr val="accent1"/>
-          </a:effectRef>
-          <a:fontRef idx="minor">
-            <a:schemeClr val="lt1"/>
-          </a:fontRef>
-        </p:style>
-        <p:txBody>
-          <a:bodyPr rtlCol="0" anchor="ctr" tIns="0" bIns="0" lIns="0" rIns="0" wrap="none"/>
-          <a:lstStyle/>
-          <a:p>
-            <a:pPr algn="ctr"/>
-            <a:r>
-              <a:rPr sz="1600" b="1">
-                <a:solidFill>
-                  <a:srgbClr val="FFFFFF"/>
-                </a:solidFill>
-                <a:latin typeface="微软雅黑"/>
-                <a:ea typeface="微软雅黑"/>
-                <a:cs typeface="微软雅黑"/>
-              </a:rPr>
-              <a:t>18</a:t>
-            </a:r>
-          </a:p>
-        </p:txBody>
-      </p:sp>
-      <p:sp>
-        <p:nvSpPr>
-          <p:cNvPr id="5" name="TextBox 4"/>
+          <p:cNvPr id="4" name="TextBox 3"/>
           <p:cNvSpPr txBox="1"/>
           <p:nvPr/>
         </p:nvSpPr>
@@ -8422,11 +8356,35 @@
                 <a:ea typeface="微软雅黑"/>
                 <a:cs typeface="微软雅黑"/>
               </a:rPr>
-              <a:t>参考文献</a:t>
-            </a:r>
-          </a:p>
-        </p:txBody>
-      </p:sp>
+              <a:t>附录 A:累加消融阶梯(框架每步都承重)</a:t>
+            </a:r>
+          </a:p>
+        </p:txBody>
+      </p:sp>
+      <p:pic>
+        <p:nvPicPr>
+          <p:cNvPr id="5" name="Picture 4" descr="消融阶梯.png"/>
+          <p:cNvPicPr>
+            <a:picLocks noChangeAspect="1"/>
+          </p:cNvPicPr>
+          <p:nvPr/>
+        </p:nvPicPr>
+        <p:blipFill>
+          <a:blip r:embed="rId2"/>
+          <a:stretch>
+            <a:fillRect/>
+          </a:stretch>
+        </p:blipFill>
+        <p:spPr>
+          <a:xfrm>
+            <a:off x="1914202" y="1737360"/>
+            <a:ext cx="8333116" cy="4480560"/>
+          </a:xfrm>
+          <a:prstGeom prst="rect">
+            <a:avLst/>
+          </a:prstGeom>
+        </p:spPr>
+      </p:pic>
       <p:sp>
         <p:nvSpPr>
           <p:cNvPr id="6" name="TextBox 5"/>
@@ -8435,8 +8393,8 @@
         </p:nvSpPr>
         <p:spPr>
           <a:xfrm>
-            <a:off x="685800" y="1828800"/>
-            <a:ext cx="10972800" cy="4389120"/>
+            <a:off x="502920" y="6400800"/>
+            <a:ext cx="11155680" cy="320040"/>
           </a:xfrm>
           <a:prstGeom prst="rect">
             <a:avLst/>
@@ -8451,163 +8409,19 @@
           <a:p>
             <a:pPr algn="l">
               <a:spcAft>
-                <a:spcPts val="800"/>
-              </a:spcAft>
-            </a:pPr>
-            <a:r>
-              <a:rPr sz="1500" b="0">
-                <a:solidFill>
-                  <a:srgbClr val="1A2333"/>
-                </a:solidFill>
-                <a:latin typeface="微软雅黑"/>
-                <a:ea typeface="微软雅黑"/>
-                <a:cs typeface="微软雅黑"/>
-              </a:rPr>
-              <a:t>Romera-Paredes et al. FunSearch. Nature 2023.</a:t>
-            </a:r>
-          </a:p>
-          <a:p>
-            <a:pPr algn="l">
-              <a:spcAft>
-                <a:spcPts val="800"/>
-              </a:spcAft>
-            </a:pPr>
-            <a:r>
-              <a:rPr sz="1500" b="0">
-                <a:solidFill>
-                  <a:srgbClr val="1A2333"/>
-                </a:solidFill>
-                <a:latin typeface="微软雅黑"/>
-                <a:ea typeface="微软雅黑"/>
-                <a:cs typeface="微软雅黑"/>
-              </a:rPr>
-              <a:t>Novikov et al. AlphaEvolve. DeepMind 2025.</a:t>
-            </a:r>
-          </a:p>
-          <a:p>
-            <a:pPr algn="l">
-              <a:spcAft>
-                <a:spcPts val="800"/>
-              </a:spcAft>
-            </a:pPr>
-            <a:r>
-              <a:rPr sz="1500" b="0">
-                <a:solidFill>
-                  <a:srgbClr val="1A2333"/>
-                </a:solidFill>
-                <a:latin typeface="微软雅黑"/>
-                <a:ea typeface="微软雅黑"/>
-                <a:cs typeface="微软雅黑"/>
-              </a:rPr>
-              <a:t>Ma et al. Eureka. ICLR 2024. arXiv:2310.12931.</a:t>
-            </a:r>
-          </a:p>
-          <a:p>
-            <a:pPr algn="l">
-              <a:spcAft>
-                <a:spcPts val="800"/>
-              </a:spcAft>
-            </a:pPr>
-            <a:r>
-              <a:rPr sz="1500" b="0">
-                <a:solidFill>
-                  <a:srgbClr val="1A2333"/>
-                </a:solidFill>
-                <a:latin typeface="微软雅黑"/>
-                <a:ea typeface="微软雅黑"/>
-                <a:cs typeface="微软雅黑"/>
-              </a:rPr>
-              <a:t>Beel, Kan &amp; Baumgart. AI Scientist 独立评估. ACM SIGIR Forum 2025. arXiv:2502.14297.</a:t>
-            </a:r>
-          </a:p>
-          <a:p>
-            <a:pPr algn="l">
-              <a:spcAft>
-                <a:spcPts val="800"/>
-              </a:spcAft>
-            </a:pPr>
-            <a:r>
-              <a:rPr sz="1500" b="0">
-                <a:solidFill>
-                  <a:srgbClr val="1A2333"/>
-                </a:solidFill>
-                <a:latin typeface="微软雅黑"/>
-                <a:ea typeface="微软雅黑"/>
-                <a:cs typeface="微软雅黑"/>
-              </a:rPr>
-              <a:t>Michel et al. Energy-Optimal Waypoint UAV Missions. 2024. arXiv:2410.17585.</a:t>
-            </a:r>
-          </a:p>
-          <a:p>
-            <a:pPr algn="l">
-              <a:spcAft>
-                <a:spcPts val="800"/>
-              </a:spcAft>
-            </a:pPr>
-            <a:r>
-              <a:rPr sz="1500" b="0">
-                <a:solidFill>
-                  <a:srgbClr val="1A2333"/>
-                </a:solidFill>
-                <a:latin typeface="微软雅黑"/>
-                <a:ea typeface="微软雅黑"/>
-                <a:cs typeface="微软雅黑"/>
-              </a:rPr>
-              <a:t>Nguyen &amp; Au. Extending drone delivery reachable set. AAMAS 2017.</a:t>
-            </a:r>
-          </a:p>
-          <a:p>
-            <a:pPr algn="l">
-              <a:spcAft>
-                <a:spcPts val="800"/>
-              </a:spcAft>
-            </a:pPr>
-            <a:r>
-              <a:rPr sz="1500" b="0">
-                <a:solidFill>
-                  <a:srgbClr val="1A2333"/>
-                </a:solidFill>
-                <a:latin typeface="微软雅黑"/>
-                <a:ea typeface="微软雅黑"/>
-                <a:cs typeface="微软雅黑"/>
-              </a:rPr>
-              <a:t>Karl et al. Position: Embracing Negative Results in ML. ICML 2024.</a:t>
-            </a:r>
-          </a:p>
-          <a:p>
-            <a:pPr algn="l">
-              <a:spcAft>
-                <a:spcPts val="800"/>
-              </a:spcAft>
-            </a:pPr>
-            <a:r>
-              <a:rPr sz="1500" b="0">
-                <a:solidFill>
-                  <a:srgbClr val="1A2333"/>
-                </a:solidFill>
-                <a:latin typeface="微软雅黑"/>
-                <a:ea typeface="微软雅黑"/>
-                <a:cs typeface="微软雅黑"/>
-              </a:rPr>
-              <a:t>Rodrigues et al. DJI M100 energy dataset. Scientific Data 2021.</a:t>
-            </a:r>
-          </a:p>
-          <a:p>
-            <a:pPr algn="l">
-              <a:spcAft>
-                <a:spcPts val="800"/>
-              </a:spcAft>
-            </a:pPr>
-            <a:r>
-              <a:rPr sz="1500" b="0">
-                <a:solidFill>
-                  <a:srgbClr val="1A2333"/>
-                </a:solidFill>
-                <a:latin typeface="微软雅黑"/>
-                <a:ea typeface="微软雅黑"/>
-                <a:cs typeface="微软雅黑"/>
-              </a:rPr>
-              <a:t>Di Franco &amp; Buttazzo 2015;Liu 2017;EcoFlight 2025.</a:t>
+                <a:spcPts val="400"/>
+              </a:spcAft>
+            </a:pPr>
+            <a:r>
+              <a:rPr sz="1100" b="0">
+                <a:solidFill>
+                  <a:srgbClr val="6B7A8D"/>
+                </a:solidFill>
+                <a:latin typeface="微软雅黑"/>
+                <a:ea typeface="微软雅黑"/>
+                <a:cs typeface="微软雅黑"/>
+              </a:rPr>
+              <a:t>逐步加回安全机制:假发现 3→0(左),报告数字保持诚实不虚低(右)</a:t>
             </a:r>
           </a:p>
         </p:txBody>
@@ -8758,14 +8572,14 @@
                 <a:ea typeface="微软雅黑"/>
                 <a:cs typeface="微软雅黑"/>
               </a:rPr>
-              <a:t>附录 A:累加消融阶梯(框架每步都承重)</a:t>
+              <a:t>附录 A2:翻越/绕行能量权衡分解</a:t>
             </a:r>
           </a:p>
         </p:txBody>
       </p:sp>
       <p:pic>
         <p:nvPicPr>
-          <p:cNvPr id="5" name="Picture 4" descr="消融阶梯.png"/>
+          <p:cNvPr id="5" name="Picture 4" descr="翻越绕行权衡.png"/>
           <p:cNvPicPr>
             <a:picLocks noChangeAspect="1"/>
           </p:cNvPicPr>
@@ -8779,8 +8593,8 @@
         </p:blipFill>
         <p:spPr>
           <a:xfrm>
-            <a:off x="1914202" y="1737360"/>
-            <a:ext cx="8333116" cy="4480560"/>
+            <a:off x="2576732" y="1737360"/>
+            <a:ext cx="7008055" cy="4480560"/>
           </a:xfrm>
           <a:prstGeom prst="rect">
             <a:avLst/>
@@ -8823,7 +8637,7 @@
                 <a:ea typeface="微软雅黑"/>
                 <a:cs typeface="微软雅黑"/>
               </a:rPr>
-              <a:t>逐步加回安全机制:假发现 3→0(左),报告数字保持诚实不虚低(右)</a:t>
+              <a:t>翻越=固定爬升罚+少走距离,绕行=无爬升+多走距离,交叉≈半宽24m=相图边界物理解释</a:t>
             </a:r>
           </a:p>
         </p:txBody>
@@ -8974,14 +8788,14 @@
                 <a:ea typeface="微软雅黑"/>
                 <a:cs typeface="微软雅黑"/>
               </a:rPr>
-              <a:t>附录 A2:翻越/绕行能量权衡分解</a:t>
+              <a:t>附录 B:操作包络相图</a:t>
             </a:r>
           </a:p>
         </p:txBody>
       </p:sp>
       <p:pic>
         <p:nvPicPr>
-          <p:cNvPr id="5" name="Picture 4" descr="翻越绕行权衡.png"/>
+          <p:cNvPr id="5" name="Picture 4" descr="操作包络相图.png"/>
           <p:cNvPicPr>
             <a:picLocks noChangeAspect="1"/>
           </p:cNvPicPr>
@@ -8995,8 +8809,8 @@
         </p:blipFill>
         <p:spPr>
           <a:xfrm>
-            <a:off x="2576732" y="1737360"/>
-            <a:ext cx="7008055" cy="4480560"/>
+            <a:off x="2589562" y="1737360"/>
+            <a:ext cx="6982395" cy="4480560"/>
           </a:xfrm>
           <a:prstGeom prst="rect">
             <a:avLst/>
@@ -9039,7 +8853,7 @@
                 <a:ea typeface="微软雅黑"/>
                 <a:cs typeface="微软雅黑"/>
               </a:rPr>
-              <a:t>翻越=固定爬升罚+少走距离,绕行=无爬升+多走距离,交叉≈半宽24m=相图边界物理解释</a:t>
+              <a:t>高速+窄障省 22%,低速/宽障归零</a:t>
             </a:r>
           </a:p>
         </p:txBody>
@@ -9190,14 +9004,14 @@
                 <a:ea typeface="微软雅黑"/>
                 <a:cs typeface="微软雅黑"/>
               </a:rPr>
-              <a:t>附录 B:操作包络相图</a:t>
+              <a:t>附录 C:安全机制消融(评测器抗 gaming)</a:t>
             </a:r>
           </a:p>
         </p:txBody>
       </p:sp>
       <p:pic>
         <p:nvPicPr>
-          <p:cNvPr id="5" name="Picture 4" descr="操作包络相图.png"/>
+          <p:cNvPr id="5" name="Picture 4" descr="safeguard_ablation.png"/>
           <p:cNvPicPr>
             <a:picLocks noChangeAspect="1"/>
           </p:cNvPicPr>
@@ -9211,8 +9025,8 @@
         </p:blipFill>
         <p:spPr>
           <a:xfrm>
-            <a:off x="2589562" y="1737360"/>
-            <a:ext cx="6982395" cy="4480560"/>
+            <a:off x="731520" y="2506599"/>
+            <a:ext cx="10698480" cy="2942082"/>
           </a:xfrm>
           <a:prstGeom prst="rect">
             <a:avLst/>
@@ -9255,7 +9069,7 @@
                 <a:ea typeface="微软雅黑"/>
                 <a:cs typeface="微软雅黑"/>
               </a:rPr>
-              <a:t>高速+窄障省 22%,低速/宽障归零</a:t>
+              <a:t>过拟合探针刷不动;查新门降级 2/3</a:t>
             </a:r>
           </a:p>
         </p:txBody>
@@ -9406,14 +9220,14 @@
                 <a:ea typeface="微软雅黑"/>
                 <a:cs typeface="微软雅黑"/>
               </a:rPr>
-              <a:t>附录 C:安全机制消融(评测器抗 gaming)</a:t>
+              <a:t>附录 D:动力学实飞功率剖面</a:t>
             </a:r>
           </a:p>
         </p:txBody>
       </p:sp>
       <p:pic>
         <p:nvPicPr>
-          <p:cNvPr id="5" name="Picture 4" descr="safeguard_ablation.png"/>
+          <p:cNvPr id="5" name="Picture 4" descr="sim_flight.png"/>
           <p:cNvPicPr>
             <a:picLocks noChangeAspect="1"/>
           </p:cNvPicPr>
@@ -9427,8 +9241,8 @@
         </p:blipFill>
         <p:spPr>
           <a:xfrm>
-            <a:off x="731520" y="2506599"/>
-            <a:ext cx="10698480" cy="2942082"/>
+            <a:off x="731520" y="2573464"/>
+            <a:ext cx="10698480" cy="2808351"/>
           </a:xfrm>
           <a:prstGeom prst="rect">
             <a:avLst/>
@@ -9471,7 +9285,7 @@
                 <a:ea typeface="微软雅黑"/>
                 <a:cs typeface="微软雅黑"/>
               </a:rPr>
-              <a:t>过拟合探针刷不动;查新门降级 2/3</a:t>
+              <a:t>翻墙爬升段飙 870W,绕行平稳</a:t>
             </a:r>
           </a:p>
         </p:txBody>
@@ -9485,222 +9299,6 @@
 </file>
 
 <file path=ppt/slides/slide26.xml><?xml version="1.0" encoding="utf-8"?>
-<p:sld xmlns:a="http://schemas.openxmlformats.org/drawingml/2006/main" xmlns:p="http://schemas.openxmlformats.org/presentationml/2006/main" xmlns:r="http://schemas.openxmlformats.org/officeDocument/2006/relationships">
-  <p:cSld>
-    <p:bg>
-      <p:bgPr>
-        <a:solidFill>
-          <a:srgbClr val="FFFFFF"/>
-        </a:solidFill>
-        <a:effectLst/>
-      </p:bgPr>
-    </p:bg>
-    <p:spTree>
-      <p:nvGrpSpPr>
-        <p:cNvPr id="1" name=""/>
-        <p:cNvGrpSpPr/>
-        <p:nvPr/>
-      </p:nvGrpSpPr>
-      <p:grpSpPr/>
-      <p:sp>
-        <p:nvSpPr>
-          <p:cNvPr id="2" name="Rectangle 1"/>
-          <p:cNvSpPr/>
-          <p:nvPr/>
-        </p:nvSpPr>
-        <p:spPr>
-          <a:xfrm>
-            <a:off x="0" y="0"/>
-            <a:ext cx="109728" cy="6858000"/>
-          </a:xfrm>
-          <a:prstGeom prst="rect">
-            <a:avLst/>
-          </a:prstGeom>
-          <a:solidFill>
-            <a:srgbClr val="4472C4"/>
-          </a:solidFill>
-          <a:ln>
-            <a:noFill/>
-          </a:ln>
-        </p:spPr>
-        <p:style>
-          <a:lnRef idx="1">
-            <a:schemeClr val="accent1"/>
-          </a:lnRef>
-          <a:fillRef idx="3">
-            <a:schemeClr val="accent1"/>
-          </a:fillRef>
-          <a:effectRef idx="2">
-            <a:schemeClr val="accent1"/>
-          </a:effectRef>
-          <a:fontRef idx="minor">
-            <a:schemeClr val="lt1"/>
-          </a:fontRef>
-        </p:style>
-        <p:txBody>
-          <a:bodyPr rtlCol="0" anchor="ctr"/>
-          <a:lstStyle/>
-          <a:p>
-            <a:pPr algn="ctr"/>
-          </a:p>
-        </p:txBody>
-      </p:sp>
-      <p:sp>
-        <p:nvSpPr>
-          <p:cNvPr id="3" name="TextBox 2"/>
-          <p:cNvSpPr txBox="1"/>
-          <p:nvPr/>
-        </p:nvSpPr>
-        <p:spPr>
-          <a:xfrm>
-            <a:off x="9052560" y="292608"/>
-            <a:ext cx="2834640" cy="365760"/>
-          </a:xfrm>
-          <a:prstGeom prst="rect">
-            <a:avLst/>
-          </a:prstGeom>
-          <a:noFill/>
-        </p:spPr>
-        <p:txBody>
-          <a:bodyPr wrap="square" anchor="t" lIns="25400" rIns="25400" tIns="25400" bIns="25400">
-            <a:spAutoFit/>
-          </a:bodyPr>
-          <a:lstStyle/>
-          <a:p>
-            <a:pPr algn="r">
-              <a:spcAft>
-                <a:spcPts val="400"/>
-              </a:spcAft>
-            </a:pPr>
-            <a:r>
-              <a:rPr sz="1200" b="0">
-                <a:solidFill>
-                  <a:srgbClr val="9AA8B8"/>
-                </a:solidFill>
-                <a:latin typeface="微软雅黑"/>
-                <a:ea typeface="微软雅黑"/>
-                <a:cs typeface="微软雅黑"/>
-              </a:rPr>
-              <a:t>西安交通大学</a:t>
-            </a:r>
-          </a:p>
-        </p:txBody>
-      </p:sp>
-      <p:sp>
-        <p:nvSpPr>
-          <p:cNvPr id="4" name="TextBox 3"/>
-          <p:cNvSpPr txBox="1"/>
-          <p:nvPr/>
-        </p:nvSpPr>
-        <p:spPr>
-          <a:xfrm>
-            <a:off x="1143000" y="347472"/>
-            <a:ext cx="10607040" cy="914400"/>
-          </a:xfrm>
-          <a:prstGeom prst="rect">
-            <a:avLst/>
-          </a:prstGeom>
-          <a:noFill/>
-        </p:spPr>
-        <p:txBody>
-          <a:bodyPr wrap="square" anchor="t" lIns="25400" rIns="25400" tIns="25400" bIns="25400">
-            <a:spAutoFit/>
-          </a:bodyPr>
-          <a:lstStyle/>
-          <a:p>
-            <a:pPr algn="l">
-              <a:spcAft>
-                <a:spcPts val="400"/>
-              </a:spcAft>
-            </a:pPr>
-            <a:r>
-              <a:rPr sz="2600" b="1">
-                <a:solidFill>
-                  <a:srgbClr val="0563C1"/>
-                </a:solidFill>
-                <a:latin typeface="微软雅黑"/>
-                <a:ea typeface="微软雅黑"/>
-                <a:cs typeface="微软雅黑"/>
-              </a:rPr>
-              <a:t>附录 D:动力学实飞功率剖面</a:t>
-            </a:r>
-          </a:p>
-        </p:txBody>
-      </p:sp>
-      <p:pic>
-        <p:nvPicPr>
-          <p:cNvPr id="5" name="Picture 4" descr="sim_flight.png"/>
-          <p:cNvPicPr>
-            <a:picLocks noChangeAspect="1"/>
-          </p:cNvPicPr>
-          <p:nvPr/>
-        </p:nvPicPr>
-        <p:blipFill>
-          <a:blip r:embed="rId2"/>
-          <a:stretch>
-            <a:fillRect/>
-          </a:stretch>
-        </p:blipFill>
-        <p:spPr>
-          <a:xfrm>
-            <a:off x="731520" y="2573464"/>
-            <a:ext cx="10698480" cy="2808351"/>
-          </a:xfrm>
-          <a:prstGeom prst="rect">
-            <a:avLst/>
-          </a:prstGeom>
-        </p:spPr>
-      </p:pic>
-      <p:sp>
-        <p:nvSpPr>
-          <p:cNvPr id="6" name="TextBox 5"/>
-          <p:cNvSpPr txBox="1"/>
-          <p:nvPr/>
-        </p:nvSpPr>
-        <p:spPr>
-          <a:xfrm>
-            <a:off x="502920" y="6400800"/>
-            <a:ext cx="11155680" cy="320040"/>
-          </a:xfrm>
-          <a:prstGeom prst="rect">
-            <a:avLst/>
-          </a:prstGeom>
-          <a:noFill/>
-        </p:spPr>
-        <p:txBody>
-          <a:bodyPr wrap="square" anchor="t" lIns="25400" rIns="25400" tIns="25400" bIns="25400">
-            <a:spAutoFit/>
-          </a:bodyPr>
-          <a:lstStyle/>
-          <a:p>
-            <a:pPr algn="l">
-              <a:spcAft>
-                <a:spcPts val="400"/>
-              </a:spcAft>
-            </a:pPr>
-            <a:r>
-              <a:rPr sz="1100" b="0">
-                <a:solidFill>
-                  <a:srgbClr val="6B7A8D"/>
-                </a:solidFill>
-                <a:latin typeface="微软雅黑"/>
-                <a:ea typeface="微软雅黑"/>
-                <a:cs typeface="微软雅黑"/>
-              </a:rPr>
-              <a:t>翻墙爬升段飙 870W,绕行平稳</a:t>
-            </a:r>
-          </a:p>
-        </p:txBody>
-      </p:sp>
-    </p:spTree>
-  </p:cSld>
-  <p:clrMapOvr>
-    <a:masterClrMapping/>
-  </p:clrMapOvr>
-</p:sld>
-</file>
-
-<file path=ppt/slides/slide27.xml><?xml version="1.0" encoding="utf-8"?>
 <p:sld xmlns:a="http://schemas.openxmlformats.org/drawingml/2006/main" xmlns:p="http://schemas.openxmlformats.org/presentationml/2006/main" xmlns:r="http://schemas.openxmlformats.org/officeDocument/2006/relationships">
   <p:cSld>
     <p:bg>

</xml_diff>

<commit_message>
Remove all appendix slides; merge the useful tradeoff (climb-over vs go-around) into main flow as slide 7b next to the cost-changes-planning slide; fix dangling '附录B' reference
删全部附录(A消融阶梯/A2权衡/B相图/C安全消融/D功率剖面/E PX4轨迹)。有用的A2翻越绕行权衡收进正文第7b页(紧接真机代价改规划页)——正是用户问过的'翻越是否肯定更耗'的现成答案。去掉悬空的'相图见附录B'引用。翻页幻灯21页。

Co-Authored-By: Claude Opus 4.8 (1M context) <noreply@anthropic.com>
</commit_message>
<xml_diff>
--- a/autoresearch/energy_m100/experiments/midterm_defense.pptx
+++ b/autoresearch/energy_m100/experiments/midterm_defense.pptx
@@ -26,11 +26,6 @@
     <p:sldId id="274" r:id="rId25"/>
     <p:sldId id="275" r:id="rId26"/>
     <p:sldId id="276" r:id="rId27"/>
-    <p:sldId id="277" r:id="rId28"/>
-    <p:sldId id="278" r:id="rId29"/>
-    <p:sldId id="279" r:id="rId30"/>
-    <p:sldId id="280" r:id="rId31"/>
-    <p:sldId id="281" r:id="rId32"/>
   </p:sldIdLst>
   <p:sldSz cx="12191695" cy="6858000" type="screen4x3"/>
   <p:notesSz cx="6858000" cy="9144000"/>
@@ -4210,7 +4205,7 @@
                 <a:ea typeface="微软雅黑"/>
                 <a:cs typeface="微软雅黑"/>
               </a:rPr>
-              <a:t>效应属 prior art(EcoFlight 2025);区别 = 真机验证代价 + 可信评测</a:t>
+              <a:t>区别 = 真机验证代价 + 可信评测(EcoFlight 2025 等已研究该效应)</a:t>
             </a:r>
           </a:p>
         </p:txBody>
@@ -4415,14 +4410,14 @@
                 <a:ea typeface="微软雅黑"/>
                 <a:cs typeface="微软雅黑"/>
               </a:rPr>
-              <a:t>结论过 RotorPy 动力学与 PX4 真飞控固件栈仍成立(省 14.3%)</a:t>
+              <a:t>翻越 vs 绕行是权衡:墙越宽绕行越贵,临界墙宽决定选谁</a:t>
             </a:r>
           </a:p>
         </p:txBody>
       </p:sp>
       <p:pic>
         <p:nvPicPr>
-          <p:cNvPr id="6" name="Picture 5" descr="PX4真飞控_AB对比.png"/>
+          <p:cNvPr id="6" name="Picture 5" descr="翻越绕行权衡.png"/>
           <p:cNvPicPr>
             <a:picLocks noChangeAspect="1"/>
           </p:cNvPicPr>
@@ -4436,48 +4431,24 @@
         </p:blipFill>
         <p:spPr>
           <a:xfrm>
-            <a:off x="876487" y="1828800"/>
-            <a:ext cx="6933825" cy="3108960"/>
+            <a:off x="805375" y="1828800"/>
+            <a:ext cx="6435969" cy="4114800"/>
           </a:xfrm>
           <a:prstGeom prst="rect">
             <a:avLst/>
           </a:prstGeom>
         </p:spPr>
       </p:pic>
-      <p:pic>
-        <p:nvPicPr>
-          <p:cNvPr id="7" name="Picture 6" descr="px4_flight.gif"/>
-          <p:cNvPicPr>
-            <a:picLocks noChangeAspect="1"/>
-          </p:cNvPicPr>
-          <p:nvPr/>
-        </p:nvPicPr>
-        <p:blipFill>
-          <a:blip r:embed="rId3"/>
-          <a:stretch>
-            <a:fillRect/>
-          </a:stretch>
-        </p:blipFill>
-        <p:spPr>
-          <a:xfrm>
-            <a:off x="1158680" y="5029200"/>
-            <a:ext cx="3169039" cy="1371600"/>
-          </a:xfrm>
-          <a:prstGeom prst="rect">
-            <a:avLst/>
-          </a:prstGeom>
-        </p:spPr>
-      </p:pic>
-      <p:sp>
-        <p:nvSpPr>
-          <p:cNvPr id="8" name="TextBox 7"/>
+      <p:sp>
+        <p:nvSpPr>
+          <p:cNvPr id="7" name="TextBox 6"/>
           <p:cNvSpPr txBox="1"/>
           <p:nvPr/>
         </p:nvSpPr>
         <p:spPr>
           <a:xfrm>
-            <a:off x="8412480" y="1920240"/>
-            <a:ext cx="3383280" cy="4206240"/>
+            <a:off x="7772400" y="1920240"/>
+            <a:ext cx="4114800" cy="4206240"/>
           </a:xfrm>
           <a:prstGeom prst="rect">
             <a:avLst/>
@@ -4504,7 +4475,7 @@
                 <a:ea typeface="微软雅黑"/>
                 <a:cs typeface="微软雅黑"/>
               </a:rPr>
-              <a:t>证据链层层加固:</a:t>
+              <a:t>不是“绕行一定省”,而是权衡:</a:t>
             </a:r>
           </a:p>
           <a:p>
@@ -4514,7 +4485,7 @@
               </a:spcAft>
             </a:pPr>
             <a:r>
-              <a:rPr sz="1600" b="0">
+              <a:rPr sz="1500" b="0">
                 <a:solidFill>
                   <a:srgbClr val="1A2333"/>
                 </a:solidFill>
@@ -4522,7 +4493,7 @@
                 <a:ea typeface="微软雅黑"/>
                 <a:cs typeface="微软雅黑"/>
               </a:rPr>
-              <a:t>· 折线预测 4–22%</a:t>
+              <a:t>· 翻越:少走距离,但付固定爬升罚(≈1233J)</a:t>
             </a:r>
           </a:p>
           <a:p>
@@ -4532,7 +4503,7 @@
               </a:spcAft>
             </a:pPr>
             <a:r>
-              <a:rPr sz="1600" b="0">
+              <a:rPr sz="1500" b="0">
                 <a:solidFill>
                   <a:srgbClr val="1A2333"/>
                 </a:solidFill>
@@ -4540,7 +4511,7 @@
                 <a:ea typeface="微软雅黑"/>
                 <a:cs typeface="微软雅黑"/>
               </a:rPr>
-              <a:t>· RotorPy 动力学 6.1%</a:t>
+              <a:t>· 绕行:不爬升,但随墙宽多走越多</a:t>
             </a:r>
           </a:p>
           <a:p>
@@ -4550,7 +4521,7 @@
               </a:spcAft>
             </a:pPr>
             <a:r>
-              <a:rPr sz="1800" b="1">
+              <a:rPr sz="1600" b="1">
                 <a:solidFill>
                   <a:srgbClr val="0563C1"/>
                 </a:solidFill>
@@ -4558,7 +4529,7 @@
                 <a:ea typeface="微软雅黑"/>
                 <a:cs typeface="微软雅黑"/>
               </a:rPr>
-              <a:t>· PX4 真飞控栈 14.3%</a:t>
+              <a:t>两条线交叉 ≈ 半宽 24m:</a:t>
             </a:r>
           </a:p>
           <a:p>
@@ -4568,15 +4539,15 @@
               </a:spcAft>
             </a:pPr>
             <a:r>
-              <a:rPr sz="1400" b="0">
-                <a:solidFill>
-                  <a:srgbClr val="6B7A8D"/>
-                </a:solidFill>
-                <a:latin typeface="微软雅黑"/>
-                <a:ea typeface="微软雅黑"/>
-                <a:cs typeface="微软雅黑"/>
-              </a:rPr>
-              <a:t>(EKF + 位置环 + Gazebo 动力学)</a:t>
+              <a:rPr sz="1500" b="1">
+                <a:solidFill>
+                  <a:srgbClr val="5B9BD5"/>
+                </a:solidFill>
+                <a:latin typeface="微软雅黑"/>
+                <a:ea typeface="微软雅黑"/>
+                <a:cs typeface="微软雅黑"/>
+              </a:rPr>
+              <a:t>· 窄墙 → 绕行省(M100 选绕行)</a:t>
             </a:r>
           </a:p>
           <a:p>
@@ -4586,22 +4557,22 @@
               </a:spcAft>
             </a:pPr>
             <a:r>
-              <a:rPr sz="1300" b="0">
-                <a:solidFill>
-                  <a:srgbClr val="6B7A8D"/>
-                </a:solidFill>
-                <a:latin typeface="微软雅黑"/>
-                <a:ea typeface="微软雅黑"/>
-                <a:cs typeface="微软雅黑"/>
-              </a:rPr>
-              <a:t>下方 GIF:PX4 真飞控飞出的轨迹</a:t>
-            </a:r>
-          </a:p>
-        </p:txBody>
-      </p:sp>
-      <p:sp>
-        <p:nvSpPr>
-          <p:cNvPr id="9" name="TextBox 8"/>
+              <a:rPr sz="1500" b="1">
+                <a:solidFill>
+                  <a:srgbClr val="C0502D"/>
+                </a:solidFill>
+                <a:latin typeface="微软雅黑"/>
+                <a:ea typeface="微软雅黑"/>
+                <a:cs typeface="微软雅黑"/>
+              </a:rPr>
+              <a:t>· 宽墙 → 翻越省(M100 也翻墙)</a:t>
+            </a:r>
+          </a:p>
+        </p:txBody>
+      </p:sp>
+      <p:sp>
+        <p:nvSpPr>
+          <p:cNvPr id="8" name="TextBox 7"/>
           <p:cNvSpPr txBox="1"/>
           <p:nvPr/>
         </p:nvSpPr>
@@ -4635,7 +4606,7 @@
                 <a:ea typeface="微软雅黑"/>
                 <a:cs typeface="微软雅黑"/>
               </a:rPr>
-              <a:t>PX4 SITL + Gazebo Harmonic;同固件栈同脚本 A/B 对比</a:t>
+              <a:t>tradeoff.py;操作包络的物理解释(何时该绕、何时该翻)</a:t>
             </a:r>
           </a:p>
         </p:txBody>
@@ -4840,14 +4811,14 @@
                 <a:ea typeface="微软雅黑"/>
                 <a:cs typeface="微软雅黑"/>
               </a:rPr>
-              <a:t>框架每个节点都“承重”:去掉它,loop 就退化或自欺</a:t>
+              <a:t>结论过 RotorPy 动力学与 PX4 真飞控固件栈仍成立(省 14.3%)</a:t>
             </a:r>
           </a:p>
         </p:txBody>
       </p:sp>
       <p:pic>
         <p:nvPicPr>
-          <p:cNvPr id="6" name="Picture 5" descr="框架消融_局部最优.png"/>
+          <p:cNvPr id="6" name="Picture 5" descr="PX4真飞控_AB对比.png"/>
           <p:cNvPicPr>
             <a:picLocks noChangeAspect="1"/>
           </p:cNvPicPr>
@@ -4861,24 +4832,48 @@
         </p:blipFill>
         <p:spPr>
           <a:xfrm>
-            <a:off x="457200" y="2230429"/>
-            <a:ext cx="6583680" cy="3402982"/>
+            <a:off x="876487" y="1828800"/>
+            <a:ext cx="6933825" cy="3108960"/>
           </a:xfrm>
           <a:prstGeom prst="rect">
             <a:avLst/>
           </a:prstGeom>
         </p:spPr>
       </p:pic>
-      <p:sp>
-        <p:nvSpPr>
-          <p:cNvPr id="7" name="TextBox 6"/>
+      <p:pic>
+        <p:nvPicPr>
+          <p:cNvPr id="7" name="Picture 6" descr="px4_flight.gif"/>
+          <p:cNvPicPr>
+            <a:picLocks noChangeAspect="1"/>
+          </p:cNvPicPr>
+          <p:nvPr/>
+        </p:nvPicPr>
+        <p:blipFill>
+          <a:blip r:embed="rId3"/>
+          <a:stretch>
+            <a:fillRect/>
+          </a:stretch>
+        </p:blipFill>
+        <p:spPr>
+          <a:xfrm>
+            <a:off x="1158680" y="5029200"/>
+            <a:ext cx="3169039" cy="1371600"/>
+          </a:xfrm>
+          <a:prstGeom prst="rect">
+            <a:avLst/>
+          </a:prstGeom>
+        </p:spPr>
+      </p:pic>
+      <p:sp>
+        <p:nvSpPr>
+          <p:cNvPr id="8" name="TextBox 7"/>
           <p:cNvSpPr txBox="1"/>
           <p:nvPr/>
         </p:nvSpPr>
         <p:spPr>
           <a:xfrm>
-            <a:off x="7223760" y="1828800"/>
-            <a:ext cx="4572000" cy="4389120"/>
+            <a:off x="8412480" y="1920240"/>
+            <a:ext cx="3383280" cy="4206240"/>
           </a:xfrm>
           <a:prstGeom prst="rect">
             <a:avLst/>
@@ -4893,11 +4888,11 @@
           <a:p>
             <a:pPr algn="l">
               <a:spcAft>
-                <a:spcPts val="800"/>
-              </a:spcAft>
-            </a:pPr>
-            <a:r>
-              <a:rPr sz="1500" b="1">
+                <a:spcPts val="1000"/>
+              </a:spcAft>
+            </a:pPr>
+            <a:r>
+              <a:rPr sz="1600" b="1">
                 <a:solidFill>
                   <a:srgbClr val="1A2333"/>
                 </a:solidFill>
@@ -4905,143 +4900,89 @@
                 <a:ea typeface="微软雅黑"/>
                 <a:cs typeface="微软雅黑"/>
               </a:rPr>
-              <a:t>消融每个节点 → 去掉会怎样:</a:t>
-            </a:r>
-          </a:p>
-          <a:p>
-            <a:pPr algn="l">
-              <a:spcAft>
-                <a:spcPts val="800"/>
+              <a:t>证据链层层加固:</a:t>
+            </a:r>
+          </a:p>
+          <a:p>
+            <a:pPr algn="l">
+              <a:spcAft>
+                <a:spcPts val="1000"/>
+              </a:spcAft>
+            </a:pPr>
+            <a:r>
+              <a:rPr sz="1600" b="0">
+                <a:solidFill>
+                  <a:srgbClr val="1A2333"/>
+                </a:solidFill>
+                <a:latin typeface="微软雅黑"/>
+                <a:ea typeface="微软雅黑"/>
+                <a:cs typeface="微软雅黑"/>
+              </a:rPr>
+              <a:t>· 折线预测 4–22%</a:t>
+            </a:r>
+          </a:p>
+          <a:p>
+            <a:pPr algn="l">
+              <a:spcAft>
+                <a:spcPts val="1000"/>
+              </a:spcAft>
+            </a:pPr>
+            <a:r>
+              <a:rPr sz="1600" b="0">
+                <a:solidFill>
+                  <a:srgbClr val="1A2333"/>
+                </a:solidFill>
+                <a:latin typeface="微软雅黑"/>
+                <a:ea typeface="微软雅黑"/>
+                <a:cs typeface="微软雅黑"/>
+              </a:rPr>
+              <a:t>· RotorPy 动力学 6.1%</a:t>
+            </a:r>
+          </a:p>
+          <a:p>
+            <a:pPr algn="l">
+              <a:spcAft>
+                <a:spcPts val="1000"/>
+              </a:spcAft>
+            </a:pPr>
+            <a:r>
+              <a:rPr sz="1800" b="1">
+                <a:solidFill>
+                  <a:srgbClr val="0563C1"/>
+                </a:solidFill>
+                <a:latin typeface="微软雅黑"/>
+                <a:ea typeface="微软雅黑"/>
+                <a:cs typeface="微软雅黑"/>
+              </a:rPr>
+              <a:t>· PX4 真飞控栈 14.3%</a:t>
+            </a:r>
+          </a:p>
+          <a:p>
+            <a:pPr algn="l">
+              <a:spcAft>
+                <a:spcPts val="1000"/>
               </a:spcAft>
             </a:pPr>
             <a:r>
               <a:rPr sz="1400" b="0">
                 <a:solidFill>
-                  <a:srgbClr val="1A2333"/>
-                </a:solidFill>
-                <a:latin typeface="微软雅黑"/>
-                <a:ea typeface="微软雅黑"/>
-                <a:cs typeface="微软雅黑"/>
-              </a:rPr>
-              <a:t>· 评测器→只报训练误差:探针可刷分</a:t>
-            </a:r>
-          </a:p>
-          <a:p>
-            <a:pPr algn="l">
-              <a:spcAft>
-                <a:spcPts val="800"/>
-              </a:spcAft>
-            </a:pPr>
-            <a:r>
-              <a:rPr sz="1400" b="1">
-                <a:solidFill>
-                  <a:srgbClr val="C0502D"/>
-                </a:solidFill>
-                <a:latin typeface="微软雅黑"/>
-                <a:ea typeface="微软雅黑"/>
-                <a:cs typeface="微软雅黑"/>
-              </a:rPr>
-              <a:t>· 外搜→只搜物理形:困 4.2% 盆地</a:t>
-            </a:r>
-          </a:p>
-          <a:p>
-            <a:pPr algn="l">
-              <a:spcAft>
-                <a:spcPts val="800"/>
-              </a:spcAft>
-            </a:pPr>
-            <a:r>
-              <a:rPr sz="1400" b="0">
-                <a:solidFill>
-                  <a:srgbClr val="1A2333"/>
-                </a:solidFill>
-                <a:latin typeface="微软雅黑"/>
-                <a:ea typeface="微软雅黑"/>
-                <a:cs typeface="微软雅黑"/>
-              </a:rPr>
-              <a:t>· 查新门→H1/H3 当发现(实为 prior art)</a:t>
-            </a:r>
-          </a:p>
-          <a:p>
-            <a:pPr algn="l">
-              <a:spcAft>
-                <a:spcPts val="800"/>
-              </a:spcAft>
-            </a:pPr>
-            <a:r>
-              <a:rPr sz="1400" b="0">
-                <a:solidFill>
-                  <a:srgbClr val="1A2333"/>
-                </a:solidFill>
-                <a:latin typeface="微软雅黑"/>
-                <a:ea typeface="微软雅黑"/>
-                <a:cs typeface="微软雅黑"/>
-              </a:rPr>
-              <a:t>· 因果消融→证不了爬升是唯一因</a:t>
-            </a:r>
-          </a:p>
-          <a:p>
-            <a:pPr algn="l">
-              <a:spcAft>
-                <a:spcPts val="800"/>
-              </a:spcAft>
-            </a:pPr>
-            <a:r>
-              <a:rPr sz="1400" b="0">
-                <a:solidFill>
-                  <a:srgbClr val="1A2333"/>
-                </a:solidFill>
-                <a:latin typeface="微软雅黑"/>
-                <a:ea typeface="微软雅黑"/>
-                <a:cs typeface="微软雅黑"/>
-              </a:rPr>
-              <a:t>· 交叉模型→循环(BEMT尺下反贵)</a:t>
-            </a:r>
-          </a:p>
-          <a:p>
-            <a:pPr algn="l">
-              <a:spcAft>
-                <a:spcPts val="800"/>
-              </a:spcAft>
-            </a:pPr>
-            <a:r>
-              <a:rPr sz="1400" b="0">
-                <a:solidFill>
-                  <a:srgbClr val="1A2333"/>
-                </a:solidFill>
-                <a:latin typeface="微软雅黑"/>
-                <a:ea typeface="微软雅黑"/>
-                <a:cs typeface="微软雅黑"/>
-              </a:rPr>
-              <a:t>· 报负结果→漏 loop≈随机/载荷死路</a:t>
-            </a:r>
-          </a:p>
-          <a:p>
-            <a:pPr algn="l">
-              <a:spcAft>
-                <a:spcPts val="800"/>
-              </a:spcAft>
-            </a:pPr>
-            <a:r>
-              <a:rPr sz="1400" b="0">
-                <a:solidFill>
                   <a:srgbClr val="6B7A8D"/>
                 </a:solidFill>
                 <a:latin typeface="微软雅黑"/>
                 <a:ea typeface="微软雅黑"/>
                 <a:cs typeface="微软雅黑"/>
               </a:rPr>
-              <a:t>左图:只搜物理形困局部最优,</a:t>
-            </a:r>
-          </a:p>
-          <a:p>
-            <a:pPr algn="l">
-              <a:spcAft>
-                <a:spcPts val="800"/>
-              </a:spcAft>
-            </a:pPr>
-            <a:r>
-              <a:rPr sz="1400" b="0">
+              <a:t>(EKF + 位置环 + Gazebo 动力学)</a:t>
+            </a:r>
+          </a:p>
+          <a:p>
+            <a:pPr algn="l">
+              <a:spcAft>
+                <a:spcPts val="1000"/>
+              </a:spcAft>
+            </a:pPr>
+            <a:r>
+              <a:rPr sz="1300" b="0">
                 <a:solidFill>
                   <a:srgbClr val="6B7A8D"/>
                 </a:solidFill>
@@ -5049,14 +4990,14 @@
                 <a:ea typeface="微软雅黑"/>
                 <a:cs typeface="微软雅黑"/>
               </a:rPr>
-              <a:t>外搜识别加线性payload才突破1.9%</a:t>
-            </a:r>
-          </a:p>
-        </p:txBody>
-      </p:sp>
-      <p:sp>
-        <p:nvSpPr>
-          <p:cNvPr id="8" name="TextBox 7"/>
+              <a:t>下方 GIF:PX4 真飞控飞出的轨迹</a:t>
+            </a:r>
+          </a:p>
+        </p:txBody>
+      </p:sp>
+      <p:sp>
+        <p:nvSpPr>
+          <p:cNvPr id="9" name="TextBox 8"/>
           <p:cNvSpPr txBox="1"/>
           <p:nvPr/>
         </p:nvSpPr>
@@ -5090,7 +5031,7 @@
                 <a:ea typeface="微软雅黑"/>
                 <a:cs typeface="微软雅黑"/>
               </a:rPr>
-              <a:t>framework_ablation.py / safeguard_ablation.py(每节点一个可复现消融)</a:t>
+              <a:t>PX4 SITL + Gazebo Harmonic;同固件栈同脚本 A/B 对比</a:t>
             </a:r>
           </a:p>
         </p:txBody>
@@ -5295,14 +5236,14 @@
                 <a:ea typeface="微软雅黑"/>
                 <a:cs typeface="微软雅黑"/>
               </a:rPr>
-              <a:t>性能上限由数据决定:留出误差 6 项处触底,加到 52 项不再降</a:t>
+              <a:t>框架每个节点都“承重”:去掉它,loop 就退化或自欺</a:t>
             </a:r>
           </a:p>
         </p:txBody>
       </p:sp>
       <p:pic>
         <p:nvPicPr>
-          <p:cNvPr id="6" name="Picture 5" descr="噪声地板.png"/>
+          <p:cNvPr id="6" name="Picture 5" descr="框架消融_局部最优.png"/>
           <p:cNvPicPr>
             <a:picLocks noChangeAspect="1"/>
           </p:cNvPicPr>
@@ -5316,8 +5257,8 @@
         </p:blipFill>
         <p:spPr>
           <a:xfrm>
-            <a:off x="1906341" y="1828800"/>
-            <a:ext cx="5056998" cy="4114800"/>
+            <a:off x="457200" y="2230429"/>
+            <a:ext cx="6583680" cy="3402982"/>
           </a:xfrm>
           <a:prstGeom prst="rect">
             <a:avLst/>
@@ -5332,8 +5273,8 @@
         </p:nvSpPr>
         <p:spPr>
           <a:xfrm>
-            <a:off x="8595360" y="1920240"/>
-            <a:ext cx="3200400" cy="4206240"/>
+            <a:off x="7223760" y="1828800"/>
+            <a:ext cx="4572000" cy="4389120"/>
           </a:xfrm>
           <a:prstGeom prst="rect">
             <a:avLst/>
@@ -5348,11 +5289,11 @@
           <a:p>
             <a:pPr algn="l">
               <a:spcAft>
-                <a:spcPts val="1200"/>
-              </a:spcAft>
-            </a:pPr>
-            <a:r>
-              <a:rPr sz="1600" b="0">
+                <a:spcPts val="800"/>
+              </a:spcAft>
+            </a:pPr>
+            <a:r>
+              <a:rPr sz="1500" b="1">
                 <a:solidFill>
                   <a:srgbClr val="1A2333"/>
                 </a:solidFill>
@@ -5360,17 +5301,17 @@
                 <a:ea typeface="微软雅黑"/>
                 <a:cs typeface="微软雅黑"/>
               </a:rPr>
-              <a:t>· held-out 6 项即触底 1.88%</a:t>
-            </a:r>
-          </a:p>
-          <a:p>
-            <a:pPr algn="l">
-              <a:spcAft>
-                <a:spcPts val="1200"/>
-              </a:spcAft>
-            </a:pPr>
-            <a:r>
-              <a:rPr sz="1600" b="0">
+              <a:t>消融每个节点 → 去掉会怎样:</a:t>
+            </a:r>
+          </a:p>
+          <a:p>
+            <a:pPr algn="l">
+              <a:spcAft>
+                <a:spcPts val="800"/>
+              </a:spcAft>
+            </a:pPr>
+            <a:r>
+              <a:rPr sz="1400" b="0">
                 <a:solidFill>
                   <a:srgbClr val="1A2333"/>
                 </a:solidFill>
@@ -5378,35 +5319,35 @@
                 <a:ea typeface="微软雅黑"/>
                 <a:cs typeface="微软雅黑"/>
               </a:rPr>
-              <a:t>· 加到 12/20/52 项不降反升</a:t>
-            </a:r>
-          </a:p>
-          <a:p>
-            <a:pPr algn="l">
-              <a:spcAft>
-                <a:spcPts val="1200"/>
-              </a:spcAft>
-            </a:pPr>
-            <a:r>
-              <a:rPr sz="1600" b="1">
-                <a:solidFill>
-                  <a:srgbClr val="5B9BD5"/>
-                </a:solidFill>
-                <a:latin typeface="微软雅黑"/>
-                <a:ea typeface="微软雅黑"/>
-                <a:cs typeface="微软雅黑"/>
-              </a:rPr>
-              <a:t>· 4 种方法殊途同归 ~1.9%</a:t>
-            </a:r>
-          </a:p>
-          <a:p>
-            <a:pPr algn="l">
-              <a:spcAft>
-                <a:spcPts val="1200"/>
-              </a:spcAft>
-            </a:pPr>
-            <a:r>
-              <a:rPr sz="1500" b="0">
+              <a:t>· 评测器→只报训练误差:探针可刷分</a:t>
+            </a:r>
+          </a:p>
+          <a:p>
+            <a:pPr algn="l">
+              <a:spcAft>
+                <a:spcPts val="800"/>
+              </a:spcAft>
+            </a:pPr>
+            <a:r>
+              <a:rPr sz="1400" b="1">
+                <a:solidFill>
+                  <a:srgbClr val="C0502D"/>
+                </a:solidFill>
+                <a:latin typeface="微软雅黑"/>
+                <a:ea typeface="微软雅黑"/>
+                <a:cs typeface="微软雅黑"/>
+              </a:rPr>
+              <a:t>· 外搜→只搜物理形:困 4.2% 盆地</a:t>
+            </a:r>
+          </a:p>
+          <a:p>
+            <a:pPr algn="l">
+              <a:spcAft>
+                <a:spcPts val="800"/>
+              </a:spcAft>
+            </a:pPr>
+            <a:r>
+              <a:rPr sz="1400" b="0">
                 <a:solidFill>
                   <a:srgbClr val="1A2333"/>
                 </a:solidFill>
@@ -5414,25 +5355,97 @@
                 <a:ea typeface="微软雅黑"/>
                 <a:cs typeface="微软雅黑"/>
               </a:rPr>
-              <a:t>· 运动学只解释 &lt;40% 瞬时功率</a:t>
-            </a:r>
-          </a:p>
-          <a:p>
-            <a:pPr algn="l">
-              <a:spcAft>
-                <a:spcPts val="1200"/>
-              </a:spcAft>
-            </a:pPr>
-            <a:r>
-              <a:rPr sz="1600" b="1">
-                <a:solidFill>
-                  <a:srgbClr val="0563C1"/>
-                </a:solidFill>
-                <a:latin typeface="微软雅黑"/>
-                <a:ea typeface="微软雅黑"/>
-                <a:cs typeface="微软雅黑"/>
-              </a:rPr>
-              <a:t>“数据封顶”从主张变测量</a:t>
+              <a:t>· 查新门→H1/H3 当发现(实为 prior art)</a:t>
+            </a:r>
+          </a:p>
+          <a:p>
+            <a:pPr algn="l">
+              <a:spcAft>
+                <a:spcPts val="800"/>
+              </a:spcAft>
+            </a:pPr>
+            <a:r>
+              <a:rPr sz="1400" b="0">
+                <a:solidFill>
+                  <a:srgbClr val="1A2333"/>
+                </a:solidFill>
+                <a:latin typeface="微软雅黑"/>
+                <a:ea typeface="微软雅黑"/>
+                <a:cs typeface="微软雅黑"/>
+              </a:rPr>
+              <a:t>· 因果消融→证不了爬升是唯一因</a:t>
+            </a:r>
+          </a:p>
+          <a:p>
+            <a:pPr algn="l">
+              <a:spcAft>
+                <a:spcPts val="800"/>
+              </a:spcAft>
+            </a:pPr>
+            <a:r>
+              <a:rPr sz="1400" b="0">
+                <a:solidFill>
+                  <a:srgbClr val="1A2333"/>
+                </a:solidFill>
+                <a:latin typeface="微软雅黑"/>
+                <a:ea typeface="微软雅黑"/>
+                <a:cs typeface="微软雅黑"/>
+              </a:rPr>
+              <a:t>· 交叉模型→循环(BEMT尺下反贵)</a:t>
+            </a:r>
+          </a:p>
+          <a:p>
+            <a:pPr algn="l">
+              <a:spcAft>
+                <a:spcPts val="800"/>
+              </a:spcAft>
+            </a:pPr>
+            <a:r>
+              <a:rPr sz="1400" b="0">
+                <a:solidFill>
+                  <a:srgbClr val="1A2333"/>
+                </a:solidFill>
+                <a:latin typeface="微软雅黑"/>
+                <a:ea typeface="微软雅黑"/>
+                <a:cs typeface="微软雅黑"/>
+              </a:rPr>
+              <a:t>· 报负结果→漏 loop≈随机/载荷死路</a:t>
+            </a:r>
+          </a:p>
+          <a:p>
+            <a:pPr algn="l">
+              <a:spcAft>
+                <a:spcPts val="800"/>
+              </a:spcAft>
+            </a:pPr>
+            <a:r>
+              <a:rPr sz="1400" b="0">
+                <a:solidFill>
+                  <a:srgbClr val="6B7A8D"/>
+                </a:solidFill>
+                <a:latin typeface="微软雅黑"/>
+                <a:ea typeface="微软雅黑"/>
+                <a:cs typeface="微软雅黑"/>
+              </a:rPr>
+              <a:t>左图:只搜物理形困局部最优,</a:t>
+            </a:r>
+          </a:p>
+          <a:p>
+            <a:pPr algn="l">
+              <a:spcAft>
+                <a:spcPts val="800"/>
+              </a:spcAft>
+            </a:pPr>
+            <a:r>
+              <a:rPr sz="1400" b="0">
+                <a:solidFill>
+                  <a:srgbClr val="6B7A8D"/>
+                </a:solidFill>
+                <a:latin typeface="微软雅黑"/>
+                <a:ea typeface="微软雅黑"/>
+                <a:cs typeface="微软雅黑"/>
+              </a:rPr>
+              <a:t>外搜识别加线性payload才突破1.9%</a:t>
             </a:r>
           </a:p>
         </p:txBody>
@@ -5473,7 +5486,7 @@
                 <a:ea typeface="微软雅黑"/>
                 <a:cs typeface="微软雅黑"/>
               </a:rPr>
-              <a:t>domain_value.py;对标 Tseng 多项式(数据集既定最优)</a:t>
+              <a:t>framework_ablation.py / safeguard_ablation.py(每节点一个可复现消融)</a:t>
             </a:r>
           </a:p>
         </p:txBody>
@@ -5678,14 +5691,14 @@
                 <a:ea typeface="微软雅黑"/>
                 <a:cs typeface="微软雅黑"/>
               </a:rPr>
-              <a:t>同框架:有改进空间的域显著胜随机,噪声封顶的域统计打平</a:t>
+              <a:t>性能上限由数据决定:留出误差 6 项处触底,加到 52 项不再降</a:t>
             </a:r>
           </a:p>
         </p:txBody>
       </p:sp>
       <p:pic>
         <p:nvPicPr>
-          <p:cNvPr id="6" name="Picture 5" descr="两域显著性.png"/>
+          <p:cNvPr id="6" name="Picture 5" descr="噪声地板.png"/>
           <p:cNvPicPr>
             <a:picLocks noChangeAspect="1"/>
           </p:cNvPicPr>
@@ -5699,8 +5712,8 @@
         </p:blipFill>
         <p:spPr>
           <a:xfrm>
-            <a:off x="457200" y="2527503"/>
-            <a:ext cx="5760720" cy="2991714"/>
+            <a:off x="1906341" y="1828800"/>
+            <a:ext cx="5056998" cy="4114800"/>
           </a:xfrm>
           <a:prstGeom prst="rect">
             <a:avLst/>
@@ -5715,8 +5728,8 @@
         </p:nvSpPr>
         <p:spPr>
           <a:xfrm>
-            <a:off x="6309360" y="1920240"/>
-            <a:ext cx="5486400" cy="4389120"/>
+            <a:off x="8595360" y="1920240"/>
+            <a:ext cx="3200400" cy="4206240"/>
           </a:xfrm>
           <a:prstGeom prst="rect">
             <a:avLst/>
@@ -5735,7 +5748,7 @@
               </a:spcAft>
             </a:pPr>
             <a:r>
-              <a:rPr sz="1700" b="1">
+              <a:rPr sz="1600" b="0">
                 <a:solidFill>
                   <a:srgbClr val="1A2333"/>
                 </a:solidFill>
@@ -5743,7 +5756,7 @@
                 <a:ea typeface="微软雅黑"/>
                 <a:cs typeface="微软雅黑"/>
               </a:rPr>
-              <a:t>能耗域(封顶):</a:t>
+              <a:t>· held-out 6 项即触底 1.88%</a:t>
             </a:r>
           </a:p>
           <a:p>
@@ -5761,7 +5774,7 @@
                 <a:ea typeface="微软雅黑"/>
                 <a:cs typeface="微软雅黑"/>
               </a:rPr>
-              <a:t>  loop 1.86% vs 随机 1.87±0.03,z=−0.35</a:t>
+              <a:t>· 加到 12/20/52 项不降反升</a:t>
             </a:r>
           </a:p>
           <a:p>
@@ -5771,7 +5784,25 @@
               </a:spcAft>
             </a:pPr>
             <a:r>
-              <a:rPr sz="1600" b="0">
+              <a:rPr sz="1600" b="1">
+                <a:solidFill>
+                  <a:srgbClr val="5B9BD5"/>
+                </a:solidFill>
+                <a:latin typeface="微软雅黑"/>
+                <a:ea typeface="微软雅黑"/>
+                <a:cs typeface="微软雅黑"/>
+              </a:rPr>
+              <a:t>· 4 种方法殊途同归 ~1.9%</a:t>
+            </a:r>
+          </a:p>
+          <a:p>
+            <a:pPr algn="l">
+              <a:spcAft>
+                <a:spcPts val="1200"/>
+              </a:spcAft>
+            </a:pPr>
+            <a:r>
+              <a:rPr sz="1500" b="0">
                 <a:solidFill>
                   <a:srgbClr val="1A2333"/>
                 </a:solidFill>
@@ -5779,7 +5810,7 @@
                 <a:ea typeface="微软雅黑"/>
                 <a:cs typeface="微软雅黑"/>
               </a:rPr>
-              <a:t>  52% 随机更好 → 统计打平</a:t>
+              <a:t>· 运动学只解释 &lt;40% 瞬时功率</a:t>
             </a:r>
           </a:p>
           <a:p>
@@ -5789,69 +5820,15 @@
               </a:spcAft>
             </a:pPr>
             <a:r>
-              <a:rPr sz="1700" b="1">
-                <a:solidFill>
-                  <a:srgbClr val="1A2333"/>
-                </a:solidFill>
-                <a:latin typeface="微软雅黑"/>
-                <a:ea typeface="微软雅黑"/>
-                <a:cs typeface="微软雅黑"/>
-              </a:rPr>
-              <a:t>规划器域(有改进空间):</a:t>
-            </a:r>
-          </a:p>
-          <a:p>
-            <a:pPr algn="l">
-              <a:spcAft>
-                <a:spcPts val="1200"/>
-              </a:spcAft>
-            </a:pPr>
-            <a:r>
               <a:rPr sz="1600" b="1">
                 <a:solidFill>
-                  <a:srgbClr val="5B9BD5"/>
-                </a:solidFill>
-                <a:latin typeface="微软雅黑"/>
-                <a:ea typeface="微软雅黑"/>
-                <a:cs typeface="微软雅黑"/>
-              </a:rPr>
-              <a:t>  loop 显著低于随机,z=−2.38</a:t>
-            </a:r>
-          </a:p>
-          <a:p>
-            <a:pPr algn="l">
-              <a:spcAft>
-                <a:spcPts val="1200"/>
-              </a:spcAft>
-            </a:pPr>
-            <a:r>
-              <a:rPr sz="1600" b="0">
-                <a:solidFill>
-                  <a:srgbClr val="1A2333"/>
-                </a:solidFill>
-                <a:latin typeface="微软雅黑"/>
-                <a:ea typeface="微软雅黑"/>
-                <a:cs typeface="微软雅黑"/>
-              </a:rPr>
-              <a:t>  0% 随机更好 → 显著胜</a:t>
-            </a:r>
-          </a:p>
-          <a:p>
-            <a:pPr algn="l">
-              <a:spcAft>
-                <a:spcPts val="1200"/>
-              </a:spcAft>
-            </a:pPr>
-            <a:r>
-              <a:rPr sz="1600" b="1">
-                <a:solidFill>
                   <a:srgbClr val="0563C1"/>
                 </a:solidFill>
                 <a:latin typeface="微软雅黑"/>
                 <a:ea typeface="微软雅黑"/>
                 <a:cs typeface="微软雅黑"/>
               </a:rPr>
-              <a:t>→ 优势取决于搜索空间复杂度:小空间相当,大空间显著胜</a:t>
+              <a:t>“数据封顶”从主张变测量</a:t>
             </a:r>
           </a:p>
         </p:txBody>
@@ -5892,7 +5869,7 @@
                 <a:ea typeface="微软雅黑"/>
                 <a:cs typeface="微软雅黑"/>
               </a:rPr>
-              <a:t>significance_test.py / planner_significance.py(随机分布 + z 检验)</a:t>
+              <a:t>domain_value.py;对标 Tseng 多项式(数据集既定最优)</a:t>
             </a:r>
           </a:p>
         </p:txBody>
@@ -6097,14 +6074,14 @@
                 <a:ea typeface="微软雅黑"/>
                 <a:cs typeface="微软雅黑"/>
               </a:rPr>
-              <a:t>为什么打平?引导搜索的优势随搜索空间复杂度增长(文献规律)</a:t>
+              <a:t>同框架:有改进空间的域显著胜随机,噪声封顶的域统计打平</a:t>
             </a:r>
           </a:p>
         </p:txBody>
       </p:sp>
       <p:pic>
         <p:nvPicPr>
-          <p:cNvPr id="6" name="Picture 5" descr="复杂度规律.png"/>
+          <p:cNvPr id="6" name="Picture 5" descr="两域显著性.png"/>
           <p:cNvPicPr>
             <a:picLocks noChangeAspect="1"/>
           </p:cNvPicPr>
@@ -6118,8 +6095,8 @@
         </p:blipFill>
         <p:spPr>
           <a:xfrm>
-            <a:off x="457200" y="2095384"/>
-            <a:ext cx="6766560" cy="3673072"/>
+            <a:off x="457200" y="2527503"/>
+            <a:ext cx="5760720" cy="2991714"/>
           </a:xfrm>
           <a:prstGeom prst="rect">
             <a:avLst/>
@@ -6134,8 +6111,8 @@
         </p:nvSpPr>
         <p:spPr>
           <a:xfrm>
-            <a:off x="7406640" y="1920240"/>
-            <a:ext cx="4480560" cy="4389120"/>
+            <a:off x="6309360" y="1920240"/>
+            <a:ext cx="5486400" cy="4389120"/>
           </a:xfrm>
           <a:prstGeom prst="rect">
             <a:avLst/>
@@ -6150,119 +6127,119 @@
           <a:p>
             <a:pPr algn="l">
               <a:spcAft>
-                <a:spcPts val="900"/>
+                <a:spcPts val="1200"/>
+              </a:spcAft>
+            </a:pPr>
+            <a:r>
+              <a:rPr sz="1700" b="1">
+                <a:solidFill>
+                  <a:srgbClr val="1A2333"/>
+                </a:solidFill>
+                <a:latin typeface="微软雅黑"/>
+                <a:ea typeface="微软雅黑"/>
+                <a:cs typeface="微软雅黑"/>
+              </a:rPr>
+              <a:t>能耗域(封顶):</a:t>
+            </a:r>
+          </a:p>
+          <a:p>
+            <a:pPr algn="l">
+              <a:spcAft>
+                <a:spcPts val="1200"/>
+              </a:spcAft>
+            </a:pPr>
+            <a:r>
+              <a:rPr sz="1600" b="0">
+                <a:solidFill>
+                  <a:srgbClr val="1A2333"/>
+                </a:solidFill>
+                <a:latin typeface="微软雅黑"/>
+                <a:ea typeface="微软雅黑"/>
+                <a:cs typeface="微软雅黑"/>
+              </a:rPr>
+              <a:t>  loop 1.86% vs 随机 1.87±0.03,z=−0.35</a:t>
+            </a:r>
+          </a:p>
+          <a:p>
+            <a:pPr algn="l">
+              <a:spcAft>
+                <a:spcPts val="1200"/>
+              </a:spcAft>
+            </a:pPr>
+            <a:r>
+              <a:rPr sz="1600" b="0">
+                <a:solidFill>
+                  <a:srgbClr val="1A2333"/>
+                </a:solidFill>
+                <a:latin typeface="微软雅黑"/>
+                <a:ea typeface="微软雅黑"/>
+                <a:cs typeface="微软雅黑"/>
+              </a:rPr>
+              <a:t>  52% 随机更好 → 统计打平</a:t>
+            </a:r>
+          </a:p>
+          <a:p>
+            <a:pPr algn="l">
+              <a:spcAft>
+                <a:spcPts val="1200"/>
+              </a:spcAft>
+            </a:pPr>
+            <a:r>
+              <a:rPr sz="1700" b="1">
+                <a:solidFill>
+                  <a:srgbClr val="1A2333"/>
+                </a:solidFill>
+                <a:latin typeface="微软雅黑"/>
+                <a:ea typeface="微软雅黑"/>
+                <a:cs typeface="微软雅黑"/>
+              </a:rPr>
+              <a:t>规划器域(有改进空间):</a:t>
+            </a:r>
+          </a:p>
+          <a:p>
+            <a:pPr algn="l">
+              <a:spcAft>
+                <a:spcPts val="1200"/>
               </a:spcAft>
             </a:pPr>
             <a:r>
               <a:rPr sz="1600" b="1">
                 <a:solidFill>
+                  <a:srgbClr val="5B9BD5"/>
+                </a:solidFill>
+                <a:latin typeface="微软雅黑"/>
+                <a:ea typeface="微软雅黑"/>
+                <a:cs typeface="微软雅黑"/>
+              </a:rPr>
+              <a:t>  loop 显著低于随机,z=−2.38</a:t>
+            </a:r>
+          </a:p>
+          <a:p>
+            <a:pPr algn="l">
+              <a:spcAft>
+                <a:spcPts val="1200"/>
+              </a:spcAft>
+            </a:pPr>
+            <a:r>
+              <a:rPr sz="1600" b="0">
+                <a:solidFill>
                   <a:srgbClr val="1A2333"/>
                 </a:solidFill>
                 <a:latin typeface="微软雅黑"/>
                 <a:ea typeface="微软雅黑"/>
                 <a:cs typeface="微软雅黑"/>
               </a:rPr>
-              <a:t>引导搜索优势随空间复杂度增长:</a:t>
-            </a:r>
-          </a:p>
-          <a:p>
-            <a:pPr algn="l">
-              <a:spcAft>
-                <a:spcPts val="900"/>
-              </a:spcAft>
-            </a:pPr>
-            <a:r>
-              <a:rPr sz="1400" b="0">
-                <a:solidFill>
-                  <a:srgbClr val="1A2333"/>
-                </a:solidFill>
-                <a:latin typeface="微软雅黑"/>
-                <a:ea typeface="微软雅黑"/>
-                <a:cs typeface="微软雅黑"/>
-              </a:rPr>
-              <a:t>· Bergstra'12:低有效维→随机追平</a:t>
-            </a:r>
-          </a:p>
-          <a:p>
-            <a:pPr algn="l">
-              <a:spcAft>
-                <a:spcPts val="900"/>
-              </a:spcAft>
-            </a:pPr>
-            <a:r>
-              <a:rPr sz="1400" b="0">
-                <a:solidFill>
-                  <a:srgbClr val="1A2333"/>
-                </a:solidFill>
-                <a:latin typeface="微软雅黑"/>
-                <a:ea typeface="微软雅黑"/>
-                <a:cs typeface="微软雅黑"/>
-              </a:rPr>
-              <a:t>· REMBO:~15–20 维临界点</a:t>
-            </a:r>
-          </a:p>
-          <a:p>
-            <a:pPr algn="l">
-              <a:spcAft>
-                <a:spcPts val="900"/>
-              </a:spcAft>
-            </a:pPr>
-            <a:r>
-              <a:rPr sz="1400" b="0">
-                <a:solidFill>
-                  <a:srgbClr val="1A2333"/>
-                </a:solidFill>
-                <a:latin typeface="微软雅黑"/>
-                <a:ea typeface="微软雅黑"/>
-                <a:cs typeface="微软雅黑"/>
-              </a:rPr>
-              <a:t>· FunSearch:巨大程序空间→引导才行</a:t>
-            </a:r>
-          </a:p>
-          <a:p>
-            <a:pPr algn="l">
-              <a:spcAft>
-                <a:spcPts val="900"/>
-              </a:spcAft>
-            </a:pPr>
-            <a:r>
-              <a:rPr sz="1500" b="1">
-                <a:solidFill>
-                  <a:srgbClr val="C0502D"/>
-                </a:solidFill>
-                <a:latin typeface="微软雅黑"/>
-                <a:ea typeface="微软雅黑"/>
-                <a:cs typeface="微软雅黑"/>
-              </a:rPr>
-              <a:t>· 我们能耗域(小)→打平</a:t>
-            </a:r>
-          </a:p>
-          <a:p>
-            <a:pPr algn="l">
-              <a:spcAft>
-                <a:spcPts val="900"/>
-              </a:spcAft>
-            </a:pPr>
-            <a:r>
-              <a:rPr sz="1500" b="1">
-                <a:solidFill>
-                  <a:srgbClr val="5B9BD5"/>
-                </a:solidFill>
-                <a:latin typeface="微软雅黑"/>
-                <a:ea typeface="微软雅黑"/>
-                <a:cs typeface="微软雅黑"/>
-              </a:rPr>
-              <a:t>· 我们规划器域(大)→胜 27%</a:t>
-            </a:r>
-          </a:p>
-          <a:p>
-            <a:pPr algn="l">
-              <a:spcAft>
-                <a:spcPts val="900"/>
-              </a:spcAft>
-            </a:pPr>
-            <a:r>
-              <a:rPr sz="1500" b="1">
+              <a:t>  0% 随机更好 → 显著胜</a:t>
+            </a:r>
+          </a:p>
+          <a:p>
+            <a:pPr algn="l">
+              <a:spcAft>
+                <a:spcPts val="1200"/>
+              </a:spcAft>
+            </a:pPr>
+            <a:r>
+              <a:rPr sz="1600" b="1">
                 <a:solidFill>
                   <a:srgbClr val="0563C1"/>
                 </a:solidFill>
@@ -6270,7 +6247,7 @@
                 <a:ea typeface="微软雅黑"/>
                 <a:cs typeface="微软雅黑"/>
               </a:rPr>
-              <a:t>→ 同框架横跨两端点,亲手印证规律</a:t>
+              <a:t>→ 优势取决于搜索空间复杂度:小空间相当,大空间显著胜</a:t>
             </a:r>
           </a:p>
         </p:txBody>
@@ -6311,7 +6288,7 @@
                 <a:ea typeface="微软雅黑"/>
                 <a:cs typeface="微软雅黑"/>
               </a:rPr>
-              <a:t>规律=文献综合;两端点=我们实测。CMU《Hidden Pitfalls》2509.08713 反证可信性为刚需</a:t>
+              <a:t>significance_test.py / planner_significance.py(随机分布 + z 检验)</a:t>
             </a:r>
           </a:p>
         </p:txBody>
@@ -6516,14 +6493,14 @@
                 <a:ea typeface="微软雅黑"/>
                 <a:cs typeface="微软雅黑"/>
               </a:rPr>
-              <a:t>可信协议的价值:同数据同候选,防住了朴素流程的过度声称</a:t>
+              <a:t>为什么打平?引导搜索的优势随搜索空间复杂度增长(文献规律)</a:t>
             </a:r>
           </a:p>
         </p:txBody>
       </p:sp>
       <p:pic>
         <p:nvPicPr>
-          <p:cNvPr id="6" name="Picture 5" descr="naive_vs_trustworthy.png"/>
+          <p:cNvPr id="6" name="Picture 5" descr="复杂度规律.png"/>
           <p:cNvPicPr>
             <a:picLocks noChangeAspect="1"/>
           </p:cNvPicPr>
@@ -6537,8 +6514,8 @@
         </p:blipFill>
         <p:spPr>
           <a:xfrm>
-            <a:off x="548640" y="2326234"/>
-            <a:ext cx="8412480" cy="3028492"/>
+            <a:off x="457200" y="2095384"/>
+            <a:ext cx="6766560" cy="3673072"/>
           </a:xfrm>
           <a:prstGeom prst="rect">
             <a:avLst/>
@@ -6553,8 +6530,8 @@
         </p:nvSpPr>
         <p:spPr>
           <a:xfrm>
-            <a:off x="9052560" y="2011680"/>
-            <a:ext cx="2743200" cy="4023360"/>
+            <a:off x="7406640" y="1920240"/>
+            <a:ext cx="4480560" cy="4389120"/>
           </a:xfrm>
           <a:prstGeom prst="rect">
             <a:avLst/>
@@ -6569,65 +6546,101 @@
           <a:p>
             <a:pPr algn="l">
               <a:spcAft>
-                <a:spcPts val="1000"/>
+                <a:spcPts val="900"/>
               </a:spcAft>
             </a:pPr>
             <a:r>
               <a:rPr sz="1600" b="1">
                 <a:solidFill>
+                  <a:srgbClr val="1A2333"/>
+                </a:solidFill>
+                <a:latin typeface="微软雅黑"/>
+                <a:ea typeface="微软雅黑"/>
+                <a:cs typeface="微软雅黑"/>
+              </a:rPr>
+              <a:t>引导搜索优势随空间复杂度增长:</a:t>
+            </a:r>
+          </a:p>
+          <a:p>
+            <a:pPr algn="l">
+              <a:spcAft>
+                <a:spcPts val="900"/>
+              </a:spcAft>
+            </a:pPr>
+            <a:r>
+              <a:rPr sz="1400" b="0">
+                <a:solidFill>
+                  <a:srgbClr val="1A2333"/>
+                </a:solidFill>
+                <a:latin typeface="微软雅黑"/>
+                <a:ea typeface="微软雅黑"/>
+                <a:cs typeface="微软雅黑"/>
+              </a:rPr>
+              <a:t>· Bergstra'12:低有效维→随机追平</a:t>
+            </a:r>
+          </a:p>
+          <a:p>
+            <a:pPr algn="l">
+              <a:spcAft>
+                <a:spcPts val="900"/>
+              </a:spcAft>
+            </a:pPr>
+            <a:r>
+              <a:rPr sz="1400" b="0">
+                <a:solidFill>
+                  <a:srgbClr val="1A2333"/>
+                </a:solidFill>
+                <a:latin typeface="微软雅黑"/>
+                <a:ea typeface="微软雅黑"/>
+                <a:cs typeface="微软雅黑"/>
+              </a:rPr>
+              <a:t>· REMBO:~15–20 维临界点</a:t>
+            </a:r>
+          </a:p>
+          <a:p>
+            <a:pPr algn="l">
+              <a:spcAft>
+                <a:spcPts val="900"/>
+              </a:spcAft>
+            </a:pPr>
+            <a:r>
+              <a:rPr sz="1400" b="0">
+                <a:solidFill>
+                  <a:srgbClr val="1A2333"/>
+                </a:solidFill>
+                <a:latin typeface="微软雅黑"/>
+                <a:ea typeface="微软雅黑"/>
+                <a:cs typeface="微软雅黑"/>
+              </a:rPr>
+              <a:t>· FunSearch:巨大程序空间→引导才行</a:t>
+            </a:r>
+          </a:p>
+          <a:p>
+            <a:pPr algn="l">
+              <a:spcAft>
+                <a:spcPts val="900"/>
+              </a:spcAft>
+            </a:pPr>
+            <a:r>
+              <a:rPr sz="1500" b="1">
+                <a:solidFill>
                   <a:srgbClr val="C0502D"/>
                 </a:solidFill>
                 <a:latin typeface="微软雅黑"/>
                 <a:ea typeface="微软雅黑"/>
                 <a:cs typeface="微软雅黑"/>
               </a:rPr>
-              <a:t>朴素 AI4S:</a:t>
-            </a:r>
-          </a:p>
-          <a:p>
-            <a:pPr algn="l">
-              <a:spcAft>
-                <a:spcPts val="1000"/>
-              </a:spcAft>
-            </a:pPr>
-            <a:r>
-              <a:rPr sz="1500" b="0">
-                <a:solidFill>
-                  <a:srgbClr val="1A2333"/>
-                </a:solidFill>
-                <a:latin typeface="微软雅黑"/>
-                <a:ea typeface="微软雅黑"/>
-                <a:cs typeface="微软雅黑"/>
-              </a:rPr>
-              <a:t>声称 4 项发现</a:t>
-            </a:r>
-          </a:p>
-          <a:p>
-            <a:pPr algn="l">
-              <a:spcAft>
-                <a:spcPts val="1000"/>
-              </a:spcAft>
-            </a:pPr>
-            <a:r>
-              <a:rPr sz="1400" b="0">
-                <a:solidFill>
-                  <a:srgbClr val="6B7A8D"/>
-                </a:solidFill>
-                <a:latin typeface="微软雅黑"/>
-                <a:ea typeface="微软雅黑"/>
-                <a:cs typeface="微软雅黑"/>
-              </a:rPr>
-              <a:t>(经查全为已有)、不报局限</a:t>
-            </a:r>
-          </a:p>
-          <a:p>
-            <a:pPr algn="l">
-              <a:spcAft>
-                <a:spcPts val="1000"/>
-              </a:spcAft>
-            </a:pPr>
-            <a:r>
-              <a:rPr sz="1600" b="1">
+              <a:t>· 我们能耗域(小)→打平</a:t>
+            </a:r>
+          </a:p>
+          <a:p>
+            <a:pPr algn="l">
+              <a:spcAft>
+                <a:spcPts val="900"/>
+              </a:spcAft>
+            </a:pPr>
+            <a:r>
+              <a:rPr sz="1500" b="1">
                 <a:solidFill>
                   <a:srgbClr val="5B9BD5"/>
                 </a:solidFill>
@@ -6635,53 +6648,17 @@
                 <a:ea typeface="微软雅黑"/>
                 <a:cs typeface="微软雅黑"/>
               </a:rPr>
-              <a:t>本框架:</a:t>
-            </a:r>
-          </a:p>
-          <a:p>
-            <a:pPr algn="l">
-              <a:spcAft>
-                <a:spcPts val="1000"/>
-              </a:spcAft>
-            </a:pPr>
-            <a:r>
-              <a:rPr sz="1500" b="0">
-                <a:solidFill>
-                  <a:srgbClr val="1A2333"/>
-                </a:solidFill>
-                <a:latin typeface="微软雅黑"/>
-                <a:ea typeface="微软雅黑"/>
-                <a:cs typeface="微软雅黑"/>
-              </a:rPr>
-              <a:t>查新/留出过滤后</a:t>
-            </a:r>
-          </a:p>
-          <a:p>
-            <a:pPr algn="l">
-              <a:spcAft>
-                <a:spcPts val="1000"/>
-              </a:spcAft>
-            </a:pPr>
-            <a:r>
-              <a:rPr sz="1400" b="0">
-                <a:solidFill>
-                  <a:srgbClr val="6B7A8D"/>
-                </a:solidFill>
-                <a:latin typeface="微软雅黑"/>
-                <a:ea typeface="微软雅黑"/>
-                <a:cs typeface="微软雅黑"/>
-              </a:rPr>
-              <a:t>如实报告 + 记 4 项边界</a:t>
-            </a:r>
-          </a:p>
-          <a:p>
-            <a:pPr algn="l">
-              <a:spcAft>
-                <a:spcPts val="1000"/>
-              </a:spcAft>
-            </a:pPr>
-            <a:r>
-              <a:rPr sz="1400" b="1">
+              <a:t>· 我们规划器域(大)→胜 27%</a:t>
+            </a:r>
+          </a:p>
+          <a:p>
+            <a:pPr algn="l">
+              <a:spcAft>
+                <a:spcPts val="900"/>
+              </a:spcAft>
+            </a:pPr>
+            <a:r>
+              <a:rPr sz="1500" b="1">
                 <a:solidFill>
                   <a:srgbClr val="0563C1"/>
                 </a:solidFill>
@@ -6689,7 +6666,7 @@
                 <a:ea typeface="微软雅黑"/>
                 <a:cs typeface="微软雅黑"/>
               </a:rPr>
-              <a:t>→ 安全机制把“看似发现”挡在门外</a:t>
+              <a:t>→ 同框架横跨两端点,亲手印证规律</a:t>
             </a:r>
           </a:p>
         </p:txBody>
@@ -6730,7 +6707,7 @@
                 <a:ea typeface="微软雅黑"/>
                 <a:cs typeface="微软雅黑"/>
               </a:rPr>
-              <a:t>naive_vs_trustworthy.py(同数据同候选,端到端产出对照)</a:t>
+              <a:t>规律=文献综合;两端点=我们实测。CMU《Hidden Pitfalls》2509.08713 反证可信性为刚需</a:t>
             </a:r>
           </a:p>
         </p:txBody>
@@ -6935,14 +6912,14 @@
                 <a:ea typeface="微软雅黑"/>
                 <a:cs typeface="微软雅黑"/>
               </a:rPr>
-              <a:t>适用范围:省能收益集中于“障碍逼出爬升”的几何(可达 4–22%)</a:t>
+              <a:t>可信协议的价值:同数据同候选,防住了朴素流程的过度声称</a:t>
             </a:r>
           </a:p>
         </p:txBody>
       </p:sp>
       <p:pic>
         <p:nvPicPr>
-          <p:cNvPr id="6" name="Picture 5" descr="省能分布_n250.png"/>
+          <p:cNvPr id="6" name="Picture 5" descr="naive_vs_trustworthy.png"/>
           <p:cNvPicPr>
             <a:picLocks noChangeAspect="1"/>
           </p:cNvPicPr>
@@ -6956,8 +6933,8 @@
         </p:blipFill>
         <p:spPr>
           <a:xfrm>
-            <a:off x="562672" y="1828800"/>
-            <a:ext cx="6829936" cy="4114800"/>
+            <a:off x="548640" y="2326234"/>
+            <a:ext cx="8412480" cy="3028492"/>
           </a:xfrm>
           <a:prstGeom prst="rect">
             <a:avLst/>
@@ -6972,8 +6949,8 @@
         </p:nvSpPr>
         <p:spPr>
           <a:xfrm>
-            <a:off x="7680960" y="1920240"/>
-            <a:ext cx="4114800" cy="4206240"/>
+            <a:off x="9052560" y="2011680"/>
+            <a:ext cx="2743200" cy="4023360"/>
           </a:xfrm>
           <a:prstGeom prst="rect">
             <a:avLst/>
@@ -6988,29 +6965,65 @@
           <a:p>
             <a:pPr algn="l">
               <a:spcAft>
-                <a:spcPts val="1100"/>
+                <a:spcPts val="1000"/>
               </a:spcAft>
             </a:pPr>
             <a:r>
               <a:rPr sz="1600" b="1">
                 <a:solidFill>
+                  <a:srgbClr val="C0502D"/>
+                </a:solidFill>
+                <a:latin typeface="微软雅黑"/>
+                <a:ea typeface="微软雅黑"/>
+                <a:cs typeface="微软雅黑"/>
+              </a:rPr>
+              <a:t>朴素 AI4S:</a:t>
+            </a:r>
+          </a:p>
+          <a:p>
+            <a:pPr algn="l">
+              <a:spcAft>
+                <a:spcPts val="1000"/>
+              </a:spcAft>
+            </a:pPr>
+            <a:r>
+              <a:rPr sz="1500" b="0">
+                <a:solidFill>
                   <a:srgbClr val="1A2333"/>
                 </a:solidFill>
                 <a:latin typeface="微软雅黑"/>
                 <a:ea typeface="微软雅黑"/>
                 <a:cs typeface="微软雅黑"/>
               </a:rPr>
-              <a:t>n=250 随机城市场景,划清适用边界:</a:t>
-            </a:r>
-          </a:p>
-          <a:p>
-            <a:pPr algn="l">
-              <a:spcAft>
-                <a:spcPts val="1100"/>
-              </a:spcAft>
-            </a:pPr>
-            <a:r>
-              <a:rPr sz="1500" b="1">
+              <a:t>声称 4 项发现</a:t>
+            </a:r>
+          </a:p>
+          <a:p>
+            <a:pPr algn="l">
+              <a:spcAft>
+                <a:spcPts val="1000"/>
+              </a:spcAft>
+            </a:pPr>
+            <a:r>
+              <a:rPr sz="1400" b="0">
+                <a:solidFill>
+                  <a:srgbClr val="6B7A8D"/>
+                </a:solidFill>
+                <a:latin typeface="微软雅黑"/>
+                <a:ea typeface="微软雅黑"/>
+                <a:cs typeface="微软雅黑"/>
+              </a:rPr>
+              <a:t>(经查全为已有)、不报局限</a:t>
+            </a:r>
+          </a:p>
+          <a:p>
+            <a:pPr algn="l">
+              <a:spcAft>
+                <a:spcPts val="1000"/>
+              </a:spcAft>
+            </a:pPr>
+            <a:r>
+              <a:rPr sz="1600" b="1">
                 <a:solidFill>
                   <a:srgbClr val="5B9BD5"/>
                 </a:solidFill>
@@ -7018,13 +7031,13 @@
                 <a:ea typeface="微软雅黑"/>
                 <a:cs typeface="微软雅黑"/>
               </a:rPr>
-              <a:t>· 障碍逼出爬升的几何:省能 3–22%</a:t>
-            </a:r>
-          </a:p>
-          <a:p>
-            <a:pPr algn="l">
-              <a:spcAft>
-                <a:spcPts val="1100"/>
+              <a:t>本框架:</a:t>
+            </a:r>
+          </a:p>
+          <a:p>
+            <a:pPr algn="l">
+              <a:spcAft>
+                <a:spcPts val="1000"/>
               </a:spcAft>
             </a:pPr>
             <a:r>
@@ -7036,53 +7049,17 @@
                 <a:ea typeface="微软雅黑"/>
                 <a:cs typeface="微软雅黑"/>
               </a:rPr>
-              <a:t>· 有低空走廊时:能量最优≈最短路</a:t>
-            </a:r>
-          </a:p>
-          <a:p>
-            <a:pPr algn="l">
-              <a:spcAft>
-                <a:spcPts val="1100"/>
-              </a:spcAft>
-            </a:pPr>
-            <a:r>
-              <a:rPr sz="1500" b="0">
-                <a:solidFill>
-                  <a:srgbClr val="1A2333"/>
-                </a:solidFill>
-                <a:latin typeface="微软雅黑"/>
-                <a:ea typeface="微软雅黑"/>
-                <a:cs typeface="微软雅黑"/>
-              </a:rPr>
-              <a:t>· 结论用统计陈述,不挑单一场景</a:t>
-            </a:r>
-          </a:p>
-          <a:p>
-            <a:pPr algn="l">
-              <a:spcAft>
-                <a:spcPts val="1100"/>
-              </a:spcAft>
-            </a:pPr>
-            <a:r>
-              <a:rPr sz="1600" b="1">
-                <a:solidFill>
-                  <a:srgbClr val="1A2333"/>
-                </a:solidFill>
-                <a:latin typeface="微软雅黑"/>
-                <a:ea typeface="微软雅黑"/>
-                <a:cs typeface="微软雅黑"/>
-              </a:rPr>
-              <a:t>适用条件(诚实标注):</a:t>
-            </a:r>
-          </a:p>
-          <a:p>
-            <a:pPr algn="l">
-              <a:spcAft>
-                <a:spcPts val="1100"/>
-              </a:spcAft>
-            </a:pPr>
-            <a:r>
-              <a:rPr sz="1500" b="0">
+              <a:t>查新/留出过滤后</a:t>
+            </a:r>
+          </a:p>
+          <a:p>
+            <a:pPr algn="l">
+              <a:spcAft>
+                <a:spcPts val="1000"/>
+              </a:spcAft>
+            </a:pPr>
+            <a:r>
+              <a:rPr sz="1400" b="0">
                 <a:solidFill>
                   <a:srgbClr val="6B7A8D"/>
                 </a:solidFill>
@@ -7090,7 +7067,25 @@
                 <a:ea typeface="微软雅黑"/>
                 <a:cs typeface="微软雅黑"/>
               </a:rPr>
-              <a:t>· 载荷 ≤500g 不改变路径;当前止于仿真</a:t>
+              <a:t>如实报告 + 记 4 项边界</a:t>
+            </a:r>
+          </a:p>
+          <a:p>
+            <a:pPr algn="l">
+              <a:spcAft>
+                <a:spcPts val="1000"/>
+              </a:spcAft>
+            </a:pPr>
+            <a:r>
+              <a:rPr sz="1400" b="1">
+                <a:solidFill>
+                  <a:srgbClr val="0563C1"/>
+                </a:solidFill>
+                <a:latin typeface="微软雅黑"/>
+                <a:ea typeface="微软雅黑"/>
+                <a:cs typeface="微软雅黑"/>
+              </a:rPr>
+              <a:t>→ 安全机制把“看似发现”挡在门外</a:t>
             </a:r>
           </a:p>
         </p:txBody>
@@ -7131,7 +7126,7 @@
                 <a:ea typeface="微软雅黑"/>
                 <a:cs typeface="微软雅黑"/>
               </a:rPr>
-              <a:t>large_scale_savings.py(n=250);相图见附录 B(何时省能)</a:t>
+              <a:t>naive_vs_trustworthy.py(同数据同候选,端到端产出对照)</a:t>
             </a:r>
           </a:p>
         </p:txBody>
@@ -7150,7 +7145,7 @@
     <p:bg>
       <p:bgPr>
         <a:solidFill>
-          <a:srgbClr val="0A2A66"/>
+          <a:srgbClr val="FFFFFF"/>
         </a:solidFill>
         <a:effectLst/>
       </p:bgPr>
@@ -7177,7 +7172,7 @@
             <a:avLst/>
           </a:prstGeom>
           <a:solidFill>
-            <a:srgbClr val="5B9BD5"/>
+            <a:srgbClr val="4472C4"/>
           </a:solidFill>
           <a:ln>
             <a:noFill/>
@@ -7205,9 +7200,145 @@
           </a:p>
         </p:txBody>
       </p:sp>
+      <p:sp>
+        <p:nvSpPr>
+          <p:cNvPr id="3" name="TextBox 2"/>
+          <p:cNvSpPr txBox="1"/>
+          <p:nvPr/>
+        </p:nvSpPr>
+        <p:spPr>
+          <a:xfrm>
+            <a:off x="9052560" y="292608"/>
+            <a:ext cx="2834640" cy="365760"/>
+          </a:xfrm>
+          <a:prstGeom prst="rect">
+            <a:avLst/>
+          </a:prstGeom>
+          <a:noFill/>
+        </p:spPr>
+        <p:txBody>
+          <a:bodyPr wrap="square" anchor="t" lIns="25400" rIns="25400" tIns="25400" bIns="25400">
+            <a:spAutoFit/>
+          </a:bodyPr>
+          <a:lstStyle/>
+          <a:p>
+            <a:pPr algn="r">
+              <a:spcAft>
+                <a:spcPts val="400"/>
+              </a:spcAft>
+            </a:pPr>
+            <a:r>
+              <a:rPr sz="1200" b="0">
+                <a:solidFill>
+                  <a:srgbClr val="9AA8B8"/>
+                </a:solidFill>
+                <a:latin typeface="微软雅黑"/>
+                <a:ea typeface="微软雅黑"/>
+                <a:cs typeface="微软雅黑"/>
+              </a:rPr>
+              <a:t>西安交通大学</a:t>
+            </a:r>
+          </a:p>
+        </p:txBody>
+      </p:sp>
+      <p:sp>
+        <p:nvSpPr>
+          <p:cNvPr id="4" name="Rounded Rectangle 3"/>
+          <p:cNvSpPr/>
+          <p:nvPr/>
+        </p:nvSpPr>
+        <p:spPr>
+          <a:xfrm>
+            <a:off x="502920" y="365760"/>
+            <a:ext cx="566928" cy="457200"/>
+          </a:xfrm>
+          <a:prstGeom prst="roundRect">
+            <a:avLst/>
+          </a:prstGeom>
+          <a:solidFill>
+            <a:srgbClr val="4472C4"/>
+          </a:solidFill>
+          <a:ln>
+            <a:noFill/>
+          </a:ln>
+        </p:spPr>
+        <p:style>
+          <a:lnRef idx="1">
+            <a:schemeClr val="accent1"/>
+          </a:lnRef>
+          <a:fillRef idx="3">
+            <a:schemeClr val="accent1"/>
+          </a:fillRef>
+          <a:effectRef idx="2">
+            <a:schemeClr val="accent1"/>
+          </a:effectRef>
+          <a:fontRef idx="minor">
+            <a:schemeClr val="lt1"/>
+          </a:fontRef>
+        </p:style>
+        <p:txBody>
+          <a:bodyPr rtlCol="0" anchor="ctr" tIns="0" bIns="0" lIns="0" rIns="0" wrap="none"/>
+          <a:lstStyle/>
+          <a:p>
+            <a:pPr algn="ctr"/>
+            <a:r>
+              <a:rPr sz="1600" b="1">
+                <a:solidFill>
+                  <a:srgbClr val="FFFFFF"/>
+                </a:solidFill>
+                <a:latin typeface="微软雅黑"/>
+                <a:ea typeface="微软雅黑"/>
+                <a:cs typeface="微软雅黑"/>
+              </a:rPr>
+              <a:t>16</a:t>
+            </a:r>
+          </a:p>
+        </p:txBody>
+      </p:sp>
+      <p:sp>
+        <p:nvSpPr>
+          <p:cNvPr id="5" name="TextBox 4"/>
+          <p:cNvSpPr txBox="1"/>
+          <p:nvPr/>
+        </p:nvSpPr>
+        <p:spPr>
+          <a:xfrm>
+            <a:off x="1143000" y="347472"/>
+            <a:ext cx="10607040" cy="914400"/>
+          </a:xfrm>
+          <a:prstGeom prst="rect">
+            <a:avLst/>
+          </a:prstGeom>
+          <a:noFill/>
+        </p:spPr>
+        <p:txBody>
+          <a:bodyPr wrap="square" anchor="t" lIns="25400" rIns="25400" tIns="25400" bIns="25400">
+            <a:spAutoFit/>
+          </a:bodyPr>
+          <a:lstStyle/>
+          <a:p>
+            <a:pPr algn="l">
+              <a:spcAft>
+                <a:spcPts val="400"/>
+              </a:spcAft>
+            </a:pPr>
+            <a:r>
+              <a:rPr sz="2600" b="1">
+                <a:solidFill>
+                  <a:srgbClr val="0563C1"/>
+                </a:solidFill>
+                <a:latin typeface="微软雅黑"/>
+                <a:ea typeface="微软雅黑"/>
+                <a:cs typeface="微软雅黑"/>
+              </a:rPr>
+              <a:t>适用范围:省能收益集中于“障碍逼出爬升”的几何(可达 4–22%)</a:t>
+            </a:r>
+          </a:p>
+        </p:txBody>
+      </p:sp>
       <p:pic>
         <p:nvPicPr>
-          <p:cNvPr id="3" name="Picture 2" descr="xjtu_logo_white.png"/>
+          <p:cNvPr id="6" name="Picture 5" descr="省能分布_n250.png"/>
           <p:cNvPicPr>
             <a:picLocks noChangeAspect="1"/>
           </p:cNvPicPr>
@@ -7221,8 +7352,8 @@
         </p:blipFill>
         <p:spPr>
           <a:xfrm>
-            <a:off x="8686800" y="365760"/>
-            <a:ext cx="1707229" cy="457200"/>
+            <a:off x="562672" y="1828800"/>
+            <a:ext cx="6829936" cy="4114800"/>
           </a:xfrm>
           <a:prstGeom prst="rect">
             <a:avLst/>
@@ -7231,68 +7362,14 @@
       </p:pic>
       <p:sp>
         <p:nvSpPr>
-          <p:cNvPr id="4" name="Rounded Rectangle 3"/>
-          <p:cNvSpPr/>
-          <p:nvPr/>
-        </p:nvSpPr>
-        <p:spPr>
-          <a:xfrm>
-            <a:off x="502920" y="365760"/>
-            <a:ext cx="566928" cy="457200"/>
-          </a:xfrm>
-          <a:prstGeom prst="roundRect">
-            <a:avLst/>
-          </a:prstGeom>
-          <a:solidFill>
-            <a:srgbClr val="5B9BD5"/>
-          </a:solidFill>
-          <a:ln>
-            <a:noFill/>
-          </a:ln>
-        </p:spPr>
-        <p:style>
-          <a:lnRef idx="1">
-            <a:schemeClr val="accent1"/>
-          </a:lnRef>
-          <a:fillRef idx="3">
-            <a:schemeClr val="accent1"/>
-          </a:fillRef>
-          <a:effectRef idx="2">
-            <a:schemeClr val="accent1"/>
-          </a:effectRef>
-          <a:fontRef idx="minor">
-            <a:schemeClr val="lt1"/>
-          </a:fontRef>
-        </p:style>
-        <p:txBody>
-          <a:bodyPr rtlCol="0" anchor="ctr" tIns="0" bIns="0" lIns="0" rIns="0" wrap="none"/>
-          <a:lstStyle/>
-          <a:p>
-            <a:pPr algn="ctr"/>
-            <a:r>
-              <a:rPr sz="1600" b="1">
-                <a:solidFill>
-                  <a:srgbClr val="FFFFFF"/>
-                </a:solidFill>
-                <a:latin typeface="微软雅黑"/>
-                <a:ea typeface="微软雅黑"/>
-                <a:cs typeface="微软雅黑"/>
-              </a:rPr>
-              <a:t>16</a:t>
-            </a:r>
-          </a:p>
-        </p:txBody>
-      </p:sp>
-      <p:sp>
-        <p:nvSpPr>
-          <p:cNvPr id="5" name="TextBox 4"/>
+          <p:cNvPr id="7" name="TextBox 6"/>
           <p:cNvSpPr txBox="1"/>
           <p:nvPr/>
         </p:nvSpPr>
         <p:spPr>
           <a:xfrm>
-            <a:off x="822960" y="1188720"/>
-            <a:ext cx="10515600" cy="640080"/>
+            <a:off x="7680960" y="1920240"/>
+            <a:ext cx="4114800" cy="4206240"/>
           </a:xfrm>
           <a:prstGeom prst="rect">
             <a:avLst/>
@@ -7307,11 +7384,29 @@
           <a:p>
             <a:pPr algn="l">
               <a:spcAft>
-                <a:spcPts val="400"/>
-              </a:spcAft>
-            </a:pPr>
-            <a:r>
-              <a:rPr sz="2400" b="1">
+                <a:spcPts val="1100"/>
+              </a:spcAft>
+            </a:pPr>
+            <a:r>
+              <a:rPr sz="1600" b="1">
+                <a:solidFill>
+                  <a:srgbClr val="1A2333"/>
+                </a:solidFill>
+                <a:latin typeface="微软雅黑"/>
+                <a:ea typeface="微软雅黑"/>
+                <a:cs typeface="微软雅黑"/>
+              </a:rPr>
+              <a:t>n=250 随机城市场景,划清适用边界:</a:t>
+            </a:r>
+          </a:p>
+          <a:p>
+            <a:pPr algn="l">
+              <a:spcAft>
+                <a:spcPts val="1100"/>
+              </a:spcAft>
+            </a:pPr>
+            <a:r>
+              <a:rPr sz="1500" b="1">
                 <a:solidFill>
                   <a:srgbClr val="5B9BD5"/>
                 </a:solidFill>
@@ -7319,21 +7414,93 @@
                 <a:ea typeface="微软雅黑"/>
                 <a:cs typeface="微软雅黑"/>
               </a:rPr>
-              <a:t>结论</a:t>
-            </a:r>
-          </a:p>
-        </p:txBody>
-      </p:sp>
-      <p:sp>
-        <p:nvSpPr>
-          <p:cNvPr id="6" name="TextBox 5"/>
+              <a:t>· 障碍逼出爬升的几何:省能 3–22%</a:t>
+            </a:r>
+          </a:p>
+          <a:p>
+            <a:pPr algn="l">
+              <a:spcAft>
+                <a:spcPts val="1100"/>
+              </a:spcAft>
+            </a:pPr>
+            <a:r>
+              <a:rPr sz="1500" b="0">
+                <a:solidFill>
+                  <a:srgbClr val="1A2333"/>
+                </a:solidFill>
+                <a:latin typeface="微软雅黑"/>
+                <a:ea typeface="微软雅黑"/>
+                <a:cs typeface="微软雅黑"/>
+              </a:rPr>
+              <a:t>· 有低空走廊时:能量最优≈最短路</a:t>
+            </a:r>
+          </a:p>
+          <a:p>
+            <a:pPr algn="l">
+              <a:spcAft>
+                <a:spcPts val="1100"/>
+              </a:spcAft>
+            </a:pPr>
+            <a:r>
+              <a:rPr sz="1500" b="0">
+                <a:solidFill>
+                  <a:srgbClr val="1A2333"/>
+                </a:solidFill>
+                <a:latin typeface="微软雅黑"/>
+                <a:ea typeface="微软雅黑"/>
+                <a:cs typeface="微软雅黑"/>
+              </a:rPr>
+              <a:t>· 结论用统计陈述,不挑单一场景</a:t>
+            </a:r>
+          </a:p>
+          <a:p>
+            <a:pPr algn="l">
+              <a:spcAft>
+                <a:spcPts val="1100"/>
+              </a:spcAft>
+            </a:pPr>
+            <a:r>
+              <a:rPr sz="1600" b="1">
+                <a:solidFill>
+                  <a:srgbClr val="1A2333"/>
+                </a:solidFill>
+                <a:latin typeface="微软雅黑"/>
+                <a:ea typeface="微软雅黑"/>
+                <a:cs typeface="微软雅黑"/>
+              </a:rPr>
+              <a:t>适用条件(诚实标注):</a:t>
+            </a:r>
+          </a:p>
+          <a:p>
+            <a:pPr algn="l">
+              <a:spcAft>
+                <a:spcPts val="1100"/>
+              </a:spcAft>
+            </a:pPr>
+            <a:r>
+              <a:rPr sz="1500" b="0">
+                <a:solidFill>
+                  <a:srgbClr val="6B7A8D"/>
+                </a:solidFill>
+                <a:latin typeface="微软雅黑"/>
+                <a:ea typeface="微软雅黑"/>
+                <a:cs typeface="微软雅黑"/>
+              </a:rPr>
+              <a:t>· 载荷 ≤500g 不改变路径;当前止于仿真</a:t>
+            </a:r>
+          </a:p>
+        </p:txBody>
+      </p:sp>
+      <p:sp>
+        <p:nvSpPr>
+          <p:cNvPr id="8" name="TextBox 7"/>
           <p:cNvSpPr txBox="1"/>
           <p:nvPr/>
         </p:nvSpPr>
         <p:spPr>
           <a:xfrm>
-            <a:off x="822960" y="2103120"/>
-            <a:ext cx="10698480" cy="4023360"/>
+            <a:off x="502920" y="6400800"/>
+            <a:ext cx="11155680" cy="320040"/>
           </a:xfrm>
           <a:prstGeom prst="rect">
             <a:avLst/>
@@ -7348,91 +7515,19 @@
           <a:p>
             <a:pPr algn="l">
               <a:spcAft>
-                <a:spcPts val="1600"/>
-              </a:spcAft>
-            </a:pPr>
-            <a:r>
-              <a:rPr sz="2100" b="0">
-                <a:solidFill>
-                  <a:srgbClr val="FFFFFF"/>
-                </a:solidFill>
-                <a:latin typeface="微软雅黑"/>
-                <a:ea typeface="微软雅黑"/>
-                <a:cs typeface="微软雅黑"/>
-              </a:rPr>
-              <a:t>① 不声称新算法/新效应——三次查新确认均为 prior art,主动引用</a:t>
-            </a:r>
-          </a:p>
-          <a:p>
-            <a:pPr algn="l">
-              <a:spcAft>
-                <a:spcPts val="1600"/>
-              </a:spcAft>
-            </a:pPr>
-            <a:r>
-              <a:rPr sz="2100" b="1">
-                <a:solidFill>
-                  <a:srgbClr val="5B9BD5"/>
-                </a:solidFill>
-                <a:latin typeface="微软雅黑"/>
-                <a:ea typeface="微软雅黑"/>
-                <a:cs typeface="微软雅黑"/>
-              </a:rPr>
-              <a:t>② 贡献 = 可信自动科研方法学 + 真机数据锚定 + 诚实能力边界</a:t>
-            </a:r>
-          </a:p>
-          <a:p>
-            <a:pPr algn="l">
-              <a:spcAft>
-                <a:spcPts val="1600"/>
-              </a:spcAft>
-            </a:pPr>
-            <a:r>
-              <a:rPr sz="2100" b="0">
-                <a:solidFill>
-                  <a:srgbClr val="FFFFFF"/>
-                </a:solidFill>
-                <a:latin typeface="微软雅黑"/>
-                <a:ea typeface="微软雅黑"/>
-                <a:cs typeface="微软雅黑"/>
-              </a:rPr>
-              <a:t>③ 逐个消融证明每道节点“承重”:去掉即退化/overclaim</a:t>
-            </a:r>
-          </a:p>
-          <a:p>
-            <a:pPr algn="l">
-              <a:spcAft>
-                <a:spcPts val="1600"/>
-              </a:spcAft>
-            </a:pPr>
-            <a:r>
-              <a:rPr sz="2100" b="0">
-                <a:solidFill>
-                  <a:srgbClr val="FFFFFF"/>
-                </a:solidFill>
-                <a:latin typeface="微软雅黑"/>
-                <a:ea typeface="微软雅黑"/>
-                <a:cs typeface="微软雅黑"/>
-              </a:rPr>
-              <a:t>④ 价值 = 在该 overclaim 处不 overclaim,并量化能力边界</a:t>
-            </a:r>
-          </a:p>
-          <a:p>
-            <a:pPr algn="l">
-              <a:spcAft>
-                <a:spcPts val="1600"/>
-              </a:spcAft>
-            </a:pPr>
-            <a:r>
-              <a:rPr sz="2100" b="0">
-                <a:solidFill>
-                  <a:srgbClr val="FFFFFF"/>
-                </a:solidFill>
-                <a:latin typeface="微软雅黑"/>
-                <a:ea typeface="微软雅黑"/>
-                <a:cs typeface="微软雅黑"/>
-              </a:rPr>
-              <a:t>⑤ 搜索空间大则显著胜随机,空间小(已封顶)则与随机相当</a:t>
+                <a:spcPts val="400"/>
+              </a:spcAft>
+            </a:pPr>
+            <a:r>
+              <a:rPr sz="1100" b="0">
+                <a:solidFill>
+                  <a:srgbClr val="6B7A8D"/>
+                </a:solidFill>
+                <a:latin typeface="微软雅黑"/>
+                <a:ea typeface="微软雅黑"/>
+                <a:cs typeface="微软雅黑"/>
+              </a:rPr>
+              <a:t>large_scale_savings.py(n=250)</a:t>
             </a:r>
           </a:p>
         </p:txBody>
@@ -7834,7 +7929,7 @@
     <p:bg>
       <p:bgPr>
         <a:solidFill>
-          <a:srgbClr val="FFFFFF"/>
+          <a:srgbClr val="0A2A66"/>
         </a:solidFill>
         <a:effectLst/>
       </p:bgPr>
@@ -7861,7 +7956,7 @@
             <a:avLst/>
           </a:prstGeom>
           <a:solidFill>
-            <a:srgbClr val="4472C4"/>
+            <a:srgbClr val="5B9BD5"/>
           </a:solidFill>
           <a:ln>
             <a:noFill/>
@@ -7889,47 +7984,30 @@
           </a:p>
         </p:txBody>
       </p:sp>
-      <p:sp>
-        <p:nvSpPr>
-          <p:cNvPr id="3" name="TextBox 2"/>
-          <p:cNvSpPr txBox="1"/>
-          <p:nvPr/>
-        </p:nvSpPr>
-        <p:spPr>
-          <a:xfrm>
-            <a:off x="9052560" y="292608"/>
-            <a:ext cx="2834640" cy="365760"/>
-          </a:xfrm>
-          <a:prstGeom prst="rect">
-            <a:avLst/>
-          </a:prstGeom>
-          <a:noFill/>
-        </p:spPr>
-        <p:txBody>
-          <a:bodyPr wrap="square" anchor="t" lIns="25400" rIns="25400" tIns="25400" bIns="25400">
-            <a:spAutoFit/>
-          </a:bodyPr>
-          <a:lstStyle/>
-          <a:p>
-            <a:pPr algn="r">
-              <a:spcAft>
-                <a:spcPts val="400"/>
-              </a:spcAft>
-            </a:pPr>
-            <a:r>
-              <a:rPr sz="1200" b="0">
-                <a:solidFill>
-                  <a:srgbClr val="9AA8B8"/>
-                </a:solidFill>
-                <a:latin typeface="微软雅黑"/>
-                <a:ea typeface="微软雅黑"/>
-                <a:cs typeface="微软雅黑"/>
-              </a:rPr>
-              <a:t>西安交通大学</a:t>
-            </a:r>
-          </a:p>
-        </p:txBody>
-      </p:sp>
+      <p:pic>
+        <p:nvPicPr>
+          <p:cNvPr id="3" name="Picture 2" descr="xjtu_logo_white.png"/>
+          <p:cNvPicPr>
+            <a:picLocks noChangeAspect="1"/>
+          </p:cNvPicPr>
+          <p:nvPr/>
+        </p:nvPicPr>
+        <p:blipFill>
+          <a:blip r:embed="rId2"/>
+          <a:stretch>
+            <a:fillRect/>
+          </a:stretch>
+        </p:blipFill>
+        <p:spPr>
+          <a:xfrm>
+            <a:off x="8686800" y="365760"/>
+            <a:ext cx="1707229" cy="457200"/>
+          </a:xfrm>
+          <a:prstGeom prst="rect">
+            <a:avLst/>
+          </a:prstGeom>
+        </p:spPr>
+      </p:pic>
       <p:sp>
         <p:nvSpPr>
           <p:cNvPr id="4" name="Rounded Rectangle 3"/>
@@ -7945,7 +8023,7 @@
             <a:avLst/>
           </a:prstGeom>
           <a:solidFill>
-            <a:srgbClr val="4472C4"/>
+            <a:srgbClr val="5B9BD5"/>
           </a:solidFill>
           <a:ln>
             <a:noFill/>
@@ -7992,8 +8070,8 @@
         </p:nvSpPr>
         <p:spPr>
           <a:xfrm>
-            <a:off x="1143000" y="347472"/>
-            <a:ext cx="10607040" cy="914400"/>
+            <a:off x="822960" y="1188720"/>
+            <a:ext cx="10515600" cy="640080"/>
           </a:xfrm>
           <a:prstGeom prst="rect">
             <a:avLst/>
@@ -8012,15 +8090,15 @@
               </a:spcAft>
             </a:pPr>
             <a:r>
-              <a:rPr sz="2600" b="1">
-                <a:solidFill>
-                  <a:srgbClr val="0563C1"/>
-                </a:solidFill>
-                <a:latin typeface="微软雅黑"/>
-                <a:ea typeface="微软雅黑"/>
-                <a:cs typeface="微软雅黑"/>
-              </a:rPr>
-              <a:t>参考文献</a:t>
+              <a:rPr sz="2400" b="1">
+                <a:solidFill>
+                  <a:srgbClr val="5B9BD5"/>
+                </a:solidFill>
+                <a:latin typeface="微软雅黑"/>
+                <a:ea typeface="微软雅黑"/>
+                <a:cs typeface="微软雅黑"/>
+              </a:rPr>
+              <a:t>结论</a:t>
             </a:r>
           </a:p>
         </p:txBody>
@@ -8033,8 +8111,8 @@
         </p:nvSpPr>
         <p:spPr>
           <a:xfrm>
-            <a:off x="685800" y="1828800"/>
-            <a:ext cx="10972800" cy="4389120"/>
+            <a:off x="822960" y="2103120"/>
+            <a:ext cx="10698480" cy="4023360"/>
           </a:xfrm>
           <a:prstGeom prst="rect">
             <a:avLst/>
@@ -8049,163 +8127,91 @@
           <a:p>
             <a:pPr algn="l">
               <a:spcAft>
-                <a:spcPts val="800"/>
-              </a:spcAft>
-            </a:pPr>
-            <a:r>
-              <a:rPr sz="1500" b="0">
-                <a:solidFill>
-                  <a:srgbClr val="1A2333"/>
-                </a:solidFill>
-                <a:latin typeface="微软雅黑"/>
-                <a:ea typeface="微软雅黑"/>
-                <a:cs typeface="微软雅黑"/>
-              </a:rPr>
-              <a:t>Romera-Paredes et al. FunSearch. Nature 2023.</a:t>
-            </a:r>
-          </a:p>
-          <a:p>
-            <a:pPr algn="l">
-              <a:spcAft>
-                <a:spcPts val="800"/>
-              </a:spcAft>
-            </a:pPr>
-            <a:r>
-              <a:rPr sz="1500" b="0">
-                <a:solidFill>
-                  <a:srgbClr val="1A2333"/>
-                </a:solidFill>
-                <a:latin typeface="微软雅黑"/>
-                <a:ea typeface="微软雅黑"/>
-                <a:cs typeface="微软雅黑"/>
-              </a:rPr>
-              <a:t>Novikov et al. AlphaEvolve. DeepMind 2025.</a:t>
-            </a:r>
-          </a:p>
-          <a:p>
-            <a:pPr algn="l">
-              <a:spcAft>
-                <a:spcPts val="800"/>
-              </a:spcAft>
-            </a:pPr>
-            <a:r>
-              <a:rPr sz="1500" b="0">
-                <a:solidFill>
-                  <a:srgbClr val="1A2333"/>
-                </a:solidFill>
-                <a:latin typeface="微软雅黑"/>
-                <a:ea typeface="微软雅黑"/>
-                <a:cs typeface="微软雅黑"/>
-              </a:rPr>
-              <a:t>Ma et al. Eureka. ICLR 2024. arXiv:2310.12931.</a:t>
-            </a:r>
-          </a:p>
-          <a:p>
-            <a:pPr algn="l">
-              <a:spcAft>
-                <a:spcPts val="800"/>
-              </a:spcAft>
-            </a:pPr>
-            <a:r>
-              <a:rPr sz="1500" b="0">
-                <a:solidFill>
-                  <a:srgbClr val="1A2333"/>
-                </a:solidFill>
-                <a:latin typeface="微软雅黑"/>
-                <a:ea typeface="微软雅黑"/>
-                <a:cs typeface="微软雅黑"/>
-              </a:rPr>
-              <a:t>Beel, Kan &amp; Baumgart. AI Scientist 独立评估. ACM SIGIR Forum 2025. arXiv:2502.14297.</a:t>
-            </a:r>
-          </a:p>
-          <a:p>
-            <a:pPr algn="l">
-              <a:spcAft>
-                <a:spcPts val="800"/>
-              </a:spcAft>
-            </a:pPr>
-            <a:r>
-              <a:rPr sz="1500" b="0">
-                <a:solidFill>
-                  <a:srgbClr val="1A2333"/>
-                </a:solidFill>
-                <a:latin typeface="微软雅黑"/>
-                <a:ea typeface="微软雅黑"/>
-                <a:cs typeface="微软雅黑"/>
-              </a:rPr>
-              <a:t>Michel et al. Energy-Optimal Waypoint UAV Missions. 2024. arXiv:2410.17585.</a:t>
-            </a:r>
-          </a:p>
-          <a:p>
-            <a:pPr algn="l">
-              <a:spcAft>
-                <a:spcPts val="800"/>
-              </a:spcAft>
-            </a:pPr>
-            <a:r>
-              <a:rPr sz="1500" b="0">
-                <a:solidFill>
-                  <a:srgbClr val="1A2333"/>
-                </a:solidFill>
-                <a:latin typeface="微软雅黑"/>
-                <a:ea typeface="微软雅黑"/>
-                <a:cs typeface="微软雅黑"/>
-              </a:rPr>
-              <a:t>Nguyen &amp; Au. Extending drone delivery reachable set. AAMAS 2017.</a:t>
-            </a:r>
-          </a:p>
-          <a:p>
-            <a:pPr algn="l">
-              <a:spcAft>
-                <a:spcPts val="800"/>
-              </a:spcAft>
-            </a:pPr>
-            <a:r>
-              <a:rPr sz="1500" b="0">
-                <a:solidFill>
-                  <a:srgbClr val="1A2333"/>
-                </a:solidFill>
-                <a:latin typeface="微软雅黑"/>
-                <a:ea typeface="微软雅黑"/>
-                <a:cs typeface="微软雅黑"/>
-              </a:rPr>
-              <a:t>Karl et al. Position: Embracing Negative Results in ML. ICML 2024.</a:t>
-            </a:r>
-          </a:p>
-          <a:p>
-            <a:pPr algn="l">
-              <a:spcAft>
-                <a:spcPts val="800"/>
-              </a:spcAft>
-            </a:pPr>
-            <a:r>
-              <a:rPr sz="1500" b="0">
-                <a:solidFill>
-                  <a:srgbClr val="1A2333"/>
-                </a:solidFill>
-                <a:latin typeface="微软雅黑"/>
-                <a:ea typeface="微软雅黑"/>
-                <a:cs typeface="微软雅黑"/>
-              </a:rPr>
-              <a:t>Rodrigues et al. DJI M100 energy dataset. Scientific Data 2021.</a:t>
-            </a:r>
-          </a:p>
-          <a:p>
-            <a:pPr algn="l">
-              <a:spcAft>
-                <a:spcPts val="800"/>
-              </a:spcAft>
-            </a:pPr>
-            <a:r>
-              <a:rPr sz="1500" b="0">
-                <a:solidFill>
-                  <a:srgbClr val="1A2333"/>
-                </a:solidFill>
-                <a:latin typeface="微软雅黑"/>
-                <a:ea typeface="微软雅黑"/>
-                <a:cs typeface="微软雅黑"/>
-              </a:rPr>
-              <a:t>Di Franco &amp; Buttazzo 2015;Liu 2017;EcoFlight 2025.</a:t>
+                <a:spcPts val="1600"/>
+              </a:spcAft>
+            </a:pPr>
+            <a:r>
+              <a:rPr sz="2100" b="0">
+                <a:solidFill>
+                  <a:srgbClr val="FFFFFF"/>
+                </a:solidFill>
+                <a:latin typeface="微软雅黑"/>
+                <a:ea typeface="微软雅黑"/>
+                <a:cs typeface="微软雅黑"/>
+              </a:rPr>
+              <a:t>① 不声称新算法/新效应——三次查新确认均为 prior art,主动引用</a:t>
+            </a:r>
+          </a:p>
+          <a:p>
+            <a:pPr algn="l">
+              <a:spcAft>
+                <a:spcPts val="1600"/>
+              </a:spcAft>
+            </a:pPr>
+            <a:r>
+              <a:rPr sz="2100" b="1">
+                <a:solidFill>
+                  <a:srgbClr val="5B9BD5"/>
+                </a:solidFill>
+                <a:latin typeface="微软雅黑"/>
+                <a:ea typeface="微软雅黑"/>
+                <a:cs typeface="微软雅黑"/>
+              </a:rPr>
+              <a:t>② 贡献 = 可信自动科研方法学 + 真机数据锚定 + 诚实能力边界</a:t>
+            </a:r>
+          </a:p>
+          <a:p>
+            <a:pPr algn="l">
+              <a:spcAft>
+                <a:spcPts val="1600"/>
+              </a:spcAft>
+            </a:pPr>
+            <a:r>
+              <a:rPr sz="2100" b="0">
+                <a:solidFill>
+                  <a:srgbClr val="FFFFFF"/>
+                </a:solidFill>
+                <a:latin typeface="微软雅黑"/>
+                <a:ea typeface="微软雅黑"/>
+                <a:cs typeface="微软雅黑"/>
+              </a:rPr>
+              <a:t>③ 逐个消融证明每道节点“承重”:去掉即退化/overclaim</a:t>
+            </a:r>
+          </a:p>
+          <a:p>
+            <a:pPr algn="l">
+              <a:spcAft>
+                <a:spcPts val="1600"/>
+              </a:spcAft>
+            </a:pPr>
+            <a:r>
+              <a:rPr sz="2100" b="0">
+                <a:solidFill>
+                  <a:srgbClr val="FFFFFF"/>
+                </a:solidFill>
+                <a:latin typeface="微软雅黑"/>
+                <a:ea typeface="微软雅黑"/>
+                <a:cs typeface="微软雅黑"/>
+              </a:rPr>
+              <a:t>④ 价值 = 在该 overclaim 处不 overclaim,并量化能力边界</a:t>
+            </a:r>
+          </a:p>
+          <a:p>
+            <a:pPr algn="l">
+              <a:spcAft>
+                <a:spcPts val="1600"/>
+              </a:spcAft>
+            </a:pPr>
+            <a:r>
+              <a:rPr sz="2100" b="0">
+                <a:solidFill>
+                  <a:srgbClr val="FFFFFF"/>
+                </a:solidFill>
+                <a:latin typeface="微软雅黑"/>
+                <a:ea typeface="微软雅黑"/>
+                <a:cs typeface="微软雅黑"/>
+              </a:rPr>
+              <a:t>⑤ 搜索空间大则显著胜随机,空间小(已封顶)则与随机相当</a:t>
             </a:r>
           </a:p>
         </p:txBody>
@@ -8322,148 +8328,16 @@
       </p:sp>
       <p:sp>
         <p:nvSpPr>
-          <p:cNvPr id="4" name="TextBox 3"/>
-          <p:cNvSpPr txBox="1"/>
-          <p:nvPr/>
-        </p:nvSpPr>
-        <p:spPr>
-          <a:xfrm>
-            <a:off x="1143000" y="347472"/>
-            <a:ext cx="10607040" cy="914400"/>
-          </a:xfrm>
-          <a:prstGeom prst="rect">
-            <a:avLst/>
-          </a:prstGeom>
-          <a:noFill/>
-        </p:spPr>
-        <p:txBody>
-          <a:bodyPr wrap="square" anchor="t" lIns="25400" rIns="25400" tIns="25400" bIns="25400">
-            <a:spAutoFit/>
-          </a:bodyPr>
-          <a:lstStyle/>
-          <a:p>
-            <a:pPr algn="l">
-              <a:spcAft>
-                <a:spcPts val="400"/>
-              </a:spcAft>
-            </a:pPr>
-            <a:r>
-              <a:rPr sz="2600" b="1">
-                <a:solidFill>
-                  <a:srgbClr val="0563C1"/>
-                </a:solidFill>
-                <a:latin typeface="微软雅黑"/>
-                <a:ea typeface="微软雅黑"/>
-                <a:cs typeface="微软雅黑"/>
-              </a:rPr>
-              <a:t>附录 A:累加消融阶梯(框架每步都承重)</a:t>
-            </a:r>
-          </a:p>
-        </p:txBody>
-      </p:sp>
-      <p:pic>
-        <p:nvPicPr>
-          <p:cNvPr id="5" name="Picture 4" descr="消融阶梯.png"/>
-          <p:cNvPicPr>
-            <a:picLocks noChangeAspect="1"/>
-          </p:cNvPicPr>
-          <p:nvPr/>
-        </p:nvPicPr>
-        <p:blipFill>
-          <a:blip r:embed="rId2"/>
-          <a:stretch>
-            <a:fillRect/>
-          </a:stretch>
-        </p:blipFill>
-        <p:spPr>
-          <a:xfrm>
-            <a:off x="1914202" y="1737360"/>
-            <a:ext cx="8333116" cy="4480560"/>
-          </a:xfrm>
-          <a:prstGeom prst="rect">
-            <a:avLst/>
-          </a:prstGeom>
-        </p:spPr>
-      </p:pic>
-      <p:sp>
-        <p:nvSpPr>
-          <p:cNvPr id="6" name="TextBox 5"/>
-          <p:cNvSpPr txBox="1"/>
-          <p:nvPr/>
-        </p:nvSpPr>
-        <p:spPr>
-          <a:xfrm>
-            <a:off x="502920" y="6400800"/>
-            <a:ext cx="11155680" cy="320040"/>
-          </a:xfrm>
-          <a:prstGeom prst="rect">
-            <a:avLst/>
-          </a:prstGeom>
-          <a:noFill/>
-        </p:spPr>
-        <p:txBody>
-          <a:bodyPr wrap="square" anchor="t" lIns="25400" rIns="25400" tIns="25400" bIns="25400">
-            <a:spAutoFit/>
-          </a:bodyPr>
-          <a:lstStyle/>
-          <a:p>
-            <a:pPr algn="l">
-              <a:spcAft>
-                <a:spcPts val="400"/>
-              </a:spcAft>
-            </a:pPr>
-            <a:r>
-              <a:rPr sz="1100" b="0">
-                <a:solidFill>
-                  <a:srgbClr val="6B7A8D"/>
-                </a:solidFill>
-                <a:latin typeface="微软雅黑"/>
-                <a:ea typeface="微软雅黑"/>
-                <a:cs typeface="微软雅黑"/>
-              </a:rPr>
-              <a:t>逐步加回安全机制:假发现 3→0(左),报告数字保持诚实不虚低(右)</a:t>
-            </a:r>
-          </a:p>
-        </p:txBody>
-      </p:sp>
-    </p:spTree>
-  </p:cSld>
-  <p:clrMapOvr>
-    <a:masterClrMapping/>
-  </p:clrMapOvr>
-</p:sld>
-</file>
-
-<file path=ppt/slides/slide22.xml><?xml version="1.0" encoding="utf-8"?>
-<p:sld xmlns:a="http://schemas.openxmlformats.org/drawingml/2006/main" xmlns:p="http://schemas.openxmlformats.org/presentationml/2006/main" xmlns:r="http://schemas.openxmlformats.org/officeDocument/2006/relationships">
-  <p:cSld>
-    <p:bg>
-      <p:bgPr>
-        <a:solidFill>
-          <a:srgbClr val="FFFFFF"/>
-        </a:solidFill>
-        <a:effectLst/>
-      </p:bgPr>
-    </p:bg>
-    <p:spTree>
-      <p:nvGrpSpPr>
-        <p:cNvPr id="1" name=""/>
-        <p:cNvGrpSpPr/>
-        <p:nvPr/>
-      </p:nvGrpSpPr>
-      <p:grpSpPr/>
-      <p:sp>
-        <p:nvSpPr>
-          <p:cNvPr id="2" name="Rectangle 1"/>
+          <p:cNvPr id="4" name="Rounded Rectangle 3"/>
           <p:cNvSpPr/>
           <p:nvPr/>
         </p:nvSpPr>
         <p:spPr>
           <a:xfrm>
-            <a:off x="0" y="0"/>
-            <a:ext cx="109728" cy="6858000"/>
-          </a:xfrm>
-          <a:prstGeom prst="rect">
+            <a:off x="502920" y="365760"/>
+            <a:ext cx="566928" cy="457200"/>
+          </a:xfrm>
+          <a:prstGeom prst="roundRect">
             <a:avLst/>
           </a:prstGeom>
           <a:solidFill>
@@ -8488,23 +8362,34 @@
           </a:fontRef>
         </p:style>
         <p:txBody>
-          <a:bodyPr rtlCol="0" anchor="ctr"/>
+          <a:bodyPr rtlCol="0" anchor="ctr" tIns="0" bIns="0" lIns="0" rIns="0" wrap="none"/>
           <a:lstStyle/>
           <a:p>
             <a:pPr algn="ctr"/>
-          </a:p>
-        </p:txBody>
-      </p:sp>
-      <p:sp>
-        <p:nvSpPr>
-          <p:cNvPr id="3" name="TextBox 2"/>
+            <a:r>
+              <a:rPr sz="1600" b="1">
+                <a:solidFill>
+                  <a:srgbClr val="FFFFFF"/>
+                </a:solidFill>
+                <a:latin typeface="微软雅黑"/>
+                <a:ea typeface="微软雅黑"/>
+                <a:cs typeface="微软雅黑"/>
+              </a:rPr>
+              <a:t>18</a:t>
+            </a:r>
+          </a:p>
+        </p:txBody>
+      </p:sp>
+      <p:sp>
+        <p:nvSpPr>
+          <p:cNvPr id="5" name="TextBox 4"/>
           <p:cNvSpPr txBox="1"/>
           <p:nvPr/>
         </p:nvSpPr>
         <p:spPr>
           <a:xfrm>
-            <a:off x="9052560" y="292608"/>
-            <a:ext cx="2834640" cy="365760"/>
+            <a:off x="1143000" y="347472"/>
+            <a:ext cx="10607040" cy="914400"/>
           </a:xfrm>
           <a:prstGeom prst="rect">
             <a:avLst/>
@@ -8517,35 +8402,35 @@
           </a:bodyPr>
           <a:lstStyle/>
           <a:p>
-            <a:pPr algn="r">
+            <a:pPr algn="l">
               <a:spcAft>
                 <a:spcPts val="400"/>
               </a:spcAft>
             </a:pPr>
             <a:r>
-              <a:rPr sz="1200" b="0">
-                <a:solidFill>
-                  <a:srgbClr val="9AA8B8"/>
-                </a:solidFill>
-                <a:latin typeface="微软雅黑"/>
-                <a:ea typeface="微软雅黑"/>
-                <a:cs typeface="微软雅黑"/>
-              </a:rPr>
-              <a:t>西安交通大学</a:t>
-            </a:r>
-          </a:p>
-        </p:txBody>
-      </p:sp>
-      <p:sp>
-        <p:nvSpPr>
-          <p:cNvPr id="4" name="TextBox 3"/>
+              <a:rPr sz="2600" b="1">
+                <a:solidFill>
+                  <a:srgbClr val="0563C1"/>
+                </a:solidFill>
+                <a:latin typeface="微软雅黑"/>
+                <a:ea typeface="微软雅黑"/>
+                <a:cs typeface="微软雅黑"/>
+              </a:rPr>
+              <a:t>参考文献</a:t>
+            </a:r>
+          </a:p>
+        </p:txBody>
+      </p:sp>
+      <p:sp>
+        <p:nvSpPr>
+          <p:cNvPr id="6" name="TextBox 5"/>
           <p:cNvSpPr txBox="1"/>
           <p:nvPr/>
         </p:nvSpPr>
         <p:spPr>
           <a:xfrm>
-            <a:off x="1143000" y="347472"/>
-            <a:ext cx="10607040" cy="914400"/>
+            <a:off x="685800" y="1828800"/>
+            <a:ext cx="10972800" cy="4389120"/>
           </a:xfrm>
           <a:prstGeom prst="rect">
             <a:avLst/>
@@ -8560,948 +8445,163 @@
           <a:p>
             <a:pPr algn="l">
               <a:spcAft>
-                <a:spcPts val="400"/>
-              </a:spcAft>
-            </a:pPr>
-            <a:r>
-              <a:rPr sz="2600" b="1">
-                <a:solidFill>
-                  <a:srgbClr val="0563C1"/>
-                </a:solidFill>
-                <a:latin typeface="微软雅黑"/>
-                <a:ea typeface="微软雅黑"/>
-                <a:cs typeface="微软雅黑"/>
-              </a:rPr>
-              <a:t>附录 A2:翻越/绕行能量权衡分解</a:t>
-            </a:r>
-          </a:p>
-        </p:txBody>
-      </p:sp>
-      <p:pic>
-        <p:nvPicPr>
-          <p:cNvPr id="5" name="Picture 4" descr="翻越绕行权衡.png"/>
-          <p:cNvPicPr>
-            <a:picLocks noChangeAspect="1"/>
-          </p:cNvPicPr>
-          <p:nvPr/>
-        </p:nvPicPr>
-        <p:blipFill>
-          <a:blip r:embed="rId2"/>
-          <a:stretch>
-            <a:fillRect/>
-          </a:stretch>
-        </p:blipFill>
-        <p:spPr>
-          <a:xfrm>
-            <a:off x="2576732" y="1737360"/>
-            <a:ext cx="7008055" cy="4480560"/>
-          </a:xfrm>
-          <a:prstGeom prst="rect">
-            <a:avLst/>
-          </a:prstGeom>
-        </p:spPr>
-      </p:pic>
-      <p:sp>
-        <p:nvSpPr>
-          <p:cNvPr id="6" name="TextBox 5"/>
-          <p:cNvSpPr txBox="1"/>
-          <p:nvPr/>
-        </p:nvSpPr>
-        <p:spPr>
-          <a:xfrm>
-            <a:off x="502920" y="6400800"/>
-            <a:ext cx="11155680" cy="320040"/>
-          </a:xfrm>
-          <a:prstGeom prst="rect">
-            <a:avLst/>
-          </a:prstGeom>
-          <a:noFill/>
-        </p:spPr>
-        <p:txBody>
-          <a:bodyPr wrap="square" anchor="t" lIns="25400" rIns="25400" tIns="25400" bIns="25400">
-            <a:spAutoFit/>
-          </a:bodyPr>
-          <a:lstStyle/>
-          <a:p>
-            <a:pPr algn="l">
-              <a:spcAft>
-                <a:spcPts val="400"/>
-              </a:spcAft>
-            </a:pPr>
-            <a:r>
-              <a:rPr sz="1100" b="0">
-                <a:solidFill>
-                  <a:srgbClr val="6B7A8D"/>
-                </a:solidFill>
-                <a:latin typeface="微软雅黑"/>
-                <a:ea typeface="微软雅黑"/>
-                <a:cs typeface="微软雅黑"/>
-              </a:rPr>
-              <a:t>翻越=固定爬升罚+少走距离,绕行=无爬升+多走距离,交叉≈半宽24m=相图边界物理解释</a:t>
-            </a:r>
-          </a:p>
-        </p:txBody>
-      </p:sp>
-    </p:spTree>
-  </p:cSld>
-  <p:clrMapOvr>
-    <a:masterClrMapping/>
-  </p:clrMapOvr>
-</p:sld>
-</file>
-
-<file path=ppt/slides/slide23.xml><?xml version="1.0" encoding="utf-8"?>
-<p:sld xmlns:a="http://schemas.openxmlformats.org/drawingml/2006/main" xmlns:p="http://schemas.openxmlformats.org/presentationml/2006/main" xmlns:r="http://schemas.openxmlformats.org/officeDocument/2006/relationships">
-  <p:cSld>
-    <p:bg>
-      <p:bgPr>
-        <a:solidFill>
-          <a:srgbClr val="FFFFFF"/>
-        </a:solidFill>
-        <a:effectLst/>
-      </p:bgPr>
-    </p:bg>
-    <p:spTree>
-      <p:nvGrpSpPr>
-        <p:cNvPr id="1" name=""/>
-        <p:cNvGrpSpPr/>
-        <p:nvPr/>
-      </p:nvGrpSpPr>
-      <p:grpSpPr/>
-      <p:sp>
-        <p:nvSpPr>
-          <p:cNvPr id="2" name="Rectangle 1"/>
-          <p:cNvSpPr/>
-          <p:nvPr/>
-        </p:nvSpPr>
-        <p:spPr>
-          <a:xfrm>
-            <a:off x="0" y="0"/>
-            <a:ext cx="109728" cy="6858000"/>
-          </a:xfrm>
-          <a:prstGeom prst="rect">
-            <a:avLst/>
-          </a:prstGeom>
-          <a:solidFill>
-            <a:srgbClr val="4472C4"/>
-          </a:solidFill>
-          <a:ln>
-            <a:noFill/>
-          </a:ln>
-        </p:spPr>
-        <p:style>
-          <a:lnRef idx="1">
-            <a:schemeClr val="accent1"/>
-          </a:lnRef>
-          <a:fillRef idx="3">
-            <a:schemeClr val="accent1"/>
-          </a:fillRef>
-          <a:effectRef idx="2">
-            <a:schemeClr val="accent1"/>
-          </a:effectRef>
-          <a:fontRef idx="minor">
-            <a:schemeClr val="lt1"/>
-          </a:fontRef>
-        </p:style>
-        <p:txBody>
-          <a:bodyPr rtlCol="0" anchor="ctr"/>
-          <a:lstStyle/>
-          <a:p>
-            <a:pPr algn="ctr"/>
-          </a:p>
-        </p:txBody>
-      </p:sp>
-      <p:sp>
-        <p:nvSpPr>
-          <p:cNvPr id="3" name="TextBox 2"/>
-          <p:cNvSpPr txBox="1"/>
-          <p:nvPr/>
-        </p:nvSpPr>
-        <p:spPr>
-          <a:xfrm>
-            <a:off x="9052560" y="292608"/>
-            <a:ext cx="2834640" cy="365760"/>
-          </a:xfrm>
-          <a:prstGeom prst="rect">
-            <a:avLst/>
-          </a:prstGeom>
-          <a:noFill/>
-        </p:spPr>
-        <p:txBody>
-          <a:bodyPr wrap="square" anchor="t" lIns="25400" rIns="25400" tIns="25400" bIns="25400">
-            <a:spAutoFit/>
-          </a:bodyPr>
-          <a:lstStyle/>
-          <a:p>
-            <a:pPr algn="r">
-              <a:spcAft>
-                <a:spcPts val="400"/>
-              </a:spcAft>
-            </a:pPr>
-            <a:r>
-              <a:rPr sz="1200" b="0">
-                <a:solidFill>
-                  <a:srgbClr val="9AA8B8"/>
-                </a:solidFill>
-                <a:latin typeface="微软雅黑"/>
-                <a:ea typeface="微软雅黑"/>
-                <a:cs typeface="微软雅黑"/>
-              </a:rPr>
-              <a:t>西安交通大学</a:t>
-            </a:r>
-          </a:p>
-        </p:txBody>
-      </p:sp>
-      <p:sp>
-        <p:nvSpPr>
-          <p:cNvPr id="4" name="TextBox 3"/>
-          <p:cNvSpPr txBox="1"/>
-          <p:nvPr/>
-        </p:nvSpPr>
-        <p:spPr>
-          <a:xfrm>
-            <a:off x="1143000" y="347472"/>
-            <a:ext cx="10607040" cy="914400"/>
-          </a:xfrm>
-          <a:prstGeom prst="rect">
-            <a:avLst/>
-          </a:prstGeom>
-          <a:noFill/>
-        </p:spPr>
-        <p:txBody>
-          <a:bodyPr wrap="square" anchor="t" lIns="25400" rIns="25400" tIns="25400" bIns="25400">
-            <a:spAutoFit/>
-          </a:bodyPr>
-          <a:lstStyle/>
-          <a:p>
-            <a:pPr algn="l">
-              <a:spcAft>
-                <a:spcPts val="400"/>
-              </a:spcAft>
-            </a:pPr>
-            <a:r>
-              <a:rPr sz="2600" b="1">
-                <a:solidFill>
-                  <a:srgbClr val="0563C1"/>
-                </a:solidFill>
-                <a:latin typeface="微软雅黑"/>
-                <a:ea typeface="微软雅黑"/>
-                <a:cs typeface="微软雅黑"/>
-              </a:rPr>
-              <a:t>附录 B:操作包络相图</a:t>
-            </a:r>
-          </a:p>
-        </p:txBody>
-      </p:sp>
-      <p:pic>
-        <p:nvPicPr>
-          <p:cNvPr id="5" name="Picture 4" descr="操作包络相图.png"/>
-          <p:cNvPicPr>
-            <a:picLocks noChangeAspect="1"/>
-          </p:cNvPicPr>
-          <p:nvPr/>
-        </p:nvPicPr>
-        <p:blipFill>
-          <a:blip r:embed="rId2"/>
-          <a:stretch>
-            <a:fillRect/>
-          </a:stretch>
-        </p:blipFill>
-        <p:spPr>
-          <a:xfrm>
-            <a:off x="2589562" y="1737360"/>
-            <a:ext cx="6982395" cy="4480560"/>
-          </a:xfrm>
-          <a:prstGeom prst="rect">
-            <a:avLst/>
-          </a:prstGeom>
-        </p:spPr>
-      </p:pic>
-      <p:sp>
-        <p:nvSpPr>
-          <p:cNvPr id="6" name="TextBox 5"/>
-          <p:cNvSpPr txBox="1"/>
-          <p:nvPr/>
-        </p:nvSpPr>
-        <p:spPr>
-          <a:xfrm>
-            <a:off x="502920" y="6400800"/>
-            <a:ext cx="11155680" cy="320040"/>
-          </a:xfrm>
-          <a:prstGeom prst="rect">
-            <a:avLst/>
-          </a:prstGeom>
-          <a:noFill/>
-        </p:spPr>
-        <p:txBody>
-          <a:bodyPr wrap="square" anchor="t" lIns="25400" rIns="25400" tIns="25400" bIns="25400">
-            <a:spAutoFit/>
-          </a:bodyPr>
-          <a:lstStyle/>
-          <a:p>
-            <a:pPr algn="l">
-              <a:spcAft>
-                <a:spcPts val="400"/>
-              </a:spcAft>
-            </a:pPr>
-            <a:r>
-              <a:rPr sz="1100" b="0">
-                <a:solidFill>
-                  <a:srgbClr val="6B7A8D"/>
-                </a:solidFill>
-                <a:latin typeface="微软雅黑"/>
-                <a:ea typeface="微软雅黑"/>
-                <a:cs typeface="微软雅黑"/>
-              </a:rPr>
-              <a:t>高速+窄障省 22%,低速/宽障归零</a:t>
-            </a:r>
-          </a:p>
-        </p:txBody>
-      </p:sp>
-    </p:spTree>
-  </p:cSld>
-  <p:clrMapOvr>
-    <a:masterClrMapping/>
-  </p:clrMapOvr>
-</p:sld>
-</file>
-
-<file path=ppt/slides/slide24.xml><?xml version="1.0" encoding="utf-8"?>
-<p:sld xmlns:a="http://schemas.openxmlformats.org/drawingml/2006/main" xmlns:p="http://schemas.openxmlformats.org/presentationml/2006/main" xmlns:r="http://schemas.openxmlformats.org/officeDocument/2006/relationships">
-  <p:cSld>
-    <p:bg>
-      <p:bgPr>
-        <a:solidFill>
-          <a:srgbClr val="FFFFFF"/>
-        </a:solidFill>
-        <a:effectLst/>
-      </p:bgPr>
-    </p:bg>
-    <p:spTree>
-      <p:nvGrpSpPr>
-        <p:cNvPr id="1" name=""/>
-        <p:cNvGrpSpPr/>
-        <p:nvPr/>
-      </p:nvGrpSpPr>
-      <p:grpSpPr/>
-      <p:sp>
-        <p:nvSpPr>
-          <p:cNvPr id="2" name="Rectangle 1"/>
-          <p:cNvSpPr/>
-          <p:nvPr/>
-        </p:nvSpPr>
-        <p:spPr>
-          <a:xfrm>
-            <a:off x="0" y="0"/>
-            <a:ext cx="109728" cy="6858000"/>
-          </a:xfrm>
-          <a:prstGeom prst="rect">
-            <a:avLst/>
-          </a:prstGeom>
-          <a:solidFill>
-            <a:srgbClr val="4472C4"/>
-          </a:solidFill>
-          <a:ln>
-            <a:noFill/>
-          </a:ln>
-        </p:spPr>
-        <p:style>
-          <a:lnRef idx="1">
-            <a:schemeClr val="accent1"/>
-          </a:lnRef>
-          <a:fillRef idx="3">
-            <a:schemeClr val="accent1"/>
-          </a:fillRef>
-          <a:effectRef idx="2">
-            <a:schemeClr val="accent1"/>
-          </a:effectRef>
-          <a:fontRef idx="minor">
-            <a:schemeClr val="lt1"/>
-          </a:fontRef>
-        </p:style>
-        <p:txBody>
-          <a:bodyPr rtlCol="0" anchor="ctr"/>
-          <a:lstStyle/>
-          <a:p>
-            <a:pPr algn="ctr"/>
-          </a:p>
-        </p:txBody>
-      </p:sp>
-      <p:sp>
-        <p:nvSpPr>
-          <p:cNvPr id="3" name="TextBox 2"/>
-          <p:cNvSpPr txBox="1"/>
-          <p:nvPr/>
-        </p:nvSpPr>
-        <p:spPr>
-          <a:xfrm>
-            <a:off x="9052560" y="292608"/>
-            <a:ext cx="2834640" cy="365760"/>
-          </a:xfrm>
-          <a:prstGeom prst="rect">
-            <a:avLst/>
-          </a:prstGeom>
-          <a:noFill/>
-        </p:spPr>
-        <p:txBody>
-          <a:bodyPr wrap="square" anchor="t" lIns="25400" rIns="25400" tIns="25400" bIns="25400">
-            <a:spAutoFit/>
-          </a:bodyPr>
-          <a:lstStyle/>
-          <a:p>
-            <a:pPr algn="r">
-              <a:spcAft>
-                <a:spcPts val="400"/>
-              </a:spcAft>
-            </a:pPr>
-            <a:r>
-              <a:rPr sz="1200" b="0">
-                <a:solidFill>
-                  <a:srgbClr val="9AA8B8"/>
-                </a:solidFill>
-                <a:latin typeface="微软雅黑"/>
-                <a:ea typeface="微软雅黑"/>
-                <a:cs typeface="微软雅黑"/>
-              </a:rPr>
-              <a:t>西安交通大学</a:t>
-            </a:r>
-          </a:p>
-        </p:txBody>
-      </p:sp>
-      <p:sp>
-        <p:nvSpPr>
-          <p:cNvPr id="4" name="TextBox 3"/>
-          <p:cNvSpPr txBox="1"/>
-          <p:nvPr/>
-        </p:nvSpPr>
-        <p:spPr>
-          <a:xfrm>
-            <a:off x="1143000" y="347472"/>
-            <a:ext cx="10607040" cy="914400"/>
-          </a:xfrm>
-          <a:prstGeom prst="rect">
-            <a:avLst/>
-          </a:prstGeom>
-          <a:noFill/>
-        </p:spPr>
-        <p:txBody>
-          <a:bodyPr wrap="square" anchor="t" lIns="25400" rIns="25400" tIns="25400" bIns="25400">
-            <a:spAutoFit/>
-          </a:bodyPr>
-          <a:lstStyle/>
-          <a:p>
-            <a:pPr algn="l">
-              <a:spcAft>
-                <a:spcPts val="400"/>
-              </a:spcAft>
-            </a:pPr>
-            <a:r>
-              <a:rPr sz="2600" b="1">
-                <a:solidFill>
-                  <a:srgbClr val="0563C1"/>
-                </a:solidFill>
-                <a:latin typeface="微软雅黑"/>
-                <a:ea typeface="微软雅黑"/>
-                <a:cs typeface="微软雅黑"/>
-              </a:rPr>
-              <a:t>附录 C:安全机制消融(评测器抗 gaming)</a:t>
-            </a:r>
-          </a:p>
-        </p:txBody>
-      </p:sp>
-      <p:pic>
-        <p:nvPicPr>
-          <p:cNvPr id="5" name="Picture 4" descr="safeguard_ablation.png"/>
-          <p:cNvPicPr>
-            <a:picLocks noChangeAspect="1"/>
-          </p:cNvPicPr>
-          <p:nvPr/>
-        </p:nvPicPr>
-        <p:blipFill>
-          <a:blip r:embed="rId2"/>
-          <a:stretch>
-            <a:fillRect/>
-          </a:stretch>
-        </p:blipFill>
-        <p:spPr>
-          <a:xfrm>
-            <a:off x="731520" y="2506599"/>
-            <a:ext cx="10698480" cy="2942082"/>
-          </a:xfrm>
-          <a:prstGeom prst="rect">
-            <a:avLst/>
-          </a:prstGeom>
-        </p:spPr>
-      </p:pic>
-      <p:sp>
-        <p:nvSpPr>
-          <p:cNvPr id="6" name="TextBox 5"/>
-          <p:cNvSpPr txBox="1"/>
-          <p:nvPr/>
-        </p:nvSpPr>
-        <p:spPr>
-          <a:xfrm>
-            <a:off x="502920" y="6400800"/>
-            <a:ext cx="11155680" cy="320040"/>
-          </a:xfrm>
-          <a:prstGeom prst="rect">
-            <a:avLst/>
-          </a:prstGeom>
-          <a:noFill/>
-        </p:spPr>
-        <p:txBody>
-          <a:bodyPr wrap="square" anchor="t" lIns="25400" rIns="25400" tIns="25400" bIns="25400">
-            <a:spAutoFit/>
-          </a:bodyPr>
-          <a:lstStyle/>
-          <a:p>
-            <a:pPr algn="l">
-              <a:spcAft>
-                <a:spcPts val="400"/>
-              </a:spcAft>
-            </a:pPr>
-            <a:r>
-              <a:rPr sz="1100" b="0">
-                <a:solidFill>
-                  <a:srgbClr val="6B7A8D"/>
-                </a:solidFill>
-                <a:latin typeface="微软雅黑"/>
-                <a:ea typeface="微软雅黑"/>
-                <a:cs typeface="微软雅黑"/>
-              </a:rPr>
-              <a:t>过拟合探针刷不动;查新门降级 2/3</a:t>
-            </a:r>
-          </a:p>
-        </p:txBody>
-      </p:sp>
-    </p:spTree>
-  </p:cSld>
-  <p:clrMapOvr>
-    <a:masterClrMapping/>
-  </p:clrMapOvr>
-</p:sld>
-</file>
-
-<file path=ppt/slides/slide25.xml><?xml version="1.0" encoding="utf-8"?>
-<p:sld xmlns:a="http://schemas.openxmlformats.org/drawingml/2006/main" xmlns:p="http://schemas.openxmlformats.org/presentationml/2006/main" xmlns:r="http://schemas.openxmlformats.org/officeDocument/2006/relationships">
-  <p:cSld>
-    <p:bg>
-      <p:bgPr>
-        <a:solidFill>
-          <a:srgbClr val="FFFFFF"/>
-        </a:solidFill>
-        <a:effectLst/>
-      </p:bgPr>
-    </p:bg>
-    <p:spTree>
-      <p:nvGrpSpPr>
-        <p:cNvPr id="1" name=""/>
-        <p:cNvGrpSpPr/>
-        <p:nvPr/>
-      </p:nvGrpSpPr>
-      <p:grpSpPr/>
-      <p:sp>
-        <p:nvSpPr>
-          <p:cNvPr id="2" name="Rectangle 1"/>
-          <p:cNvSpPr/>
-          <p:nvPr/>
-        </p:nvSpPr>
-        <p:spPr>
-          <a:xfrm>
-            <a:off x="0" y="0"/>
-            <a:ext cx="109728" cy="6858000"/>
-          </a:xfrm>
-          <a:prstGeom prst="rect">
-            <a:avLst/>
-          </a:prstGeom>
-          <a:solidFill>
-            <a:srgbClr val="4472C4"/>
-          </a:solidFill>
-          <a:ln>
-            <a:noFill/>
-          </a:ln>
-        </p:spPr>
-        <p:style>
-          <a:lnRef idx="1">
-            <a:schemeClr val="accent1"/>
-          </a:lnRef>
-          <a:fillRef idx="3">
-            <a:schemeClr val="accent1"/>
-          </a:fillRef>
-          <a:effectRef idx="2">
-            <a:schemeClr val="accent1"/>
-          </a:effectRef>
-          <a:fontRef idx="minor">
-            <a:schemeClr val="lt1"/>
-          </a:fontRef>
-        </p:style>
-        <p:txBody>
-          <a:bodyPr rtlCol="0" anchor="ctr"/>
-          <a:lstStyle/>
-          <a:p>
-            <a:pPr algn="ctr"/>
-          </a:p>
-        </p:txBody>
-      </p:sp>
-      <p:sp>
-        <p:nvSpPr>
-          <p:cNvPr id="3" name="TextBox 2"/>
-          <p:cNvSpPr txBox="1"/>
-          <p:nvPr/>
-        </p:nvSpPr>
-        <p:spPr>
-          <a:xfrm>
-            <a:off x="9052560" y="292608"/>
-            <a:ext cx="2834640" cy="365760"/>
-          </a:xfrm>
-          <a:prstGeom prst="rect">
-            <a:avLst/>
-          </a:prstGeom>
-          <a:noFill/>
-        </p:spPr>
-        <p:txBody>
-          <a:bodyPr wrap="square" anchor="t" lIns="25400" rIns="25400" tIns="25400" bIns="25400">
-            <a:spAutoFit/>
-          </a:bodyPr>
-          <a:lstStyle/>
-          <a:p>
-            <a:pPr algn="r">
-              <a:spcAft>
-                <a:spcPts val="400"/>
-              </a:spcAft>
-            </a:pPr>
-            <a:r>
-              <a:rPr sz="1200" b="0">
-                <a:solidFill>
-                  <a:srgbClr val="9AA8B8"/>
-                </a:solidFill>
-                <a:latin typeface="微软雅黑"/>
-                <a:ea typeface="微软雅黑"/>
-                <a:cs typeface="微软雅黑"/>
-              </a:rPr>
-              <a:t>西安交通大学</a:t>
-            </a:r>
-          </a:p>
-        </p:txBody>
-      </p:sp>
-      <p:sp>
-        <p:nvSpPr>
-          <p:cNvPr id="4" name="TextBox 3"/>
-          <p:cNvSpPr txBox="1"/>
-          <p:nvPr/>
-        </p:nvSpPr>
-        <p:spPr>
-          <a:xfrm>
-            <a:off x="1143000" y="347472"/>
-            <a:ext cx="10607040" cy="914400"/>
-          </a:xfrm>
-          <a:prstGeom prst="rect">
-            <a:avLst/>
-          </a:prstGeom>
-          <a:noFill/>
-        </p:spPr>
-        <p:txBody>
-          <a:bodyPr wrap="square" anchor="t" lIns="25400" rIns="25400" tIns="25400" bIns="25400">
-            <a:spAutoFit/>
-          </a:bodyPr>
-          <a:lstStyle/>
-          <a:p>
-            <a:pPr algn="l">
-              <a:spcAft>
-                <a:spcPts val="400"/>
-              </a:spcAft>
-            </a:pPr>
-            <a:r>
-              <a:rPr sz="2600" b="1">
-                <a:solidFill>
-                  <a:srgbClr val="0563C1"/>
-                </a:solidFill>
-                <a:latin typeface="微软雅黑"/>
-                <a:ea typeface="微软雅黑"/>
-                <a:cs typeface="微软雅黑"/>
-              </a:rPr>
-              <a:t>附录 D:动力学实飞功率剖面</a:t>
-            </a:r>
-          </a:p>
-        </p:txBody>
-      </p:sp>
-      <p:pic>
-        <p:nvPicPr>
-          <p:cNvPr id="5" name="Picture 4" descr="sim_flight.png"/>
-          <p:cNvPicPr>
-            <a:picLocks noChangeAspect="1"/>
-          </p:cNvPicPr>
-          <p:nvPr/>
-        </p:nvPicPr>
-        <p:blipFill>
-          <a:blip r:embed="rId2"/>
-          <a:stretch>
-            <a:fillRect/>
-          </a:stretch>
-        </p:blipFill>
-        <p:spPr>
-          <a:xfrm>
-            <a:off x="731520" y="2573464"/>
-            <a:ext cx="10698480" cy="2808351"/>
-          </a:xfrm>
-          <a:prstGeom prst="rect">
-            <a:avLst/>
-          </a:prstGeom>
-        </p:spPr>
-      </p:pic>
-      <p:sp>
-        <p:nvSpPr>
-          <p:cNvPr id="6" name="TextBox 5"/>
-          <p:cNvSpPr txBox="1"/>
-          <p:nvPr/>
-        </p:nvSpPr>
-        <p:spPr>
-          <a:xfrm>
-            <a:off x="502920" y="6400800"/>
-            <a:ext cx="11155680" cy="320040"/>
-          </a:xfrm>
-          <a:prstGeom prst="rect">
-            <a:avLst/>
-          </a:prstGeom>
-          <a:noFill/>
-        </p:spPr>
-        <p:txBody>
-          <a:bodyPr wrap="square" anchor="t" lIns="25400" rIns="25400" tIns="25400" bIns="25400">
-            <a:spAutoFit/>
-          </a:bodyPr>
-          <a:lstStyle/>
-          <a:p>
-            <a:pPr algn="l">
-              <a:spcAft>
-                <a:spcPts val="400"/>
-              </a:spcAft>
-            </a:pPr>
-            <a:r>
-              <a:rPr sz="1100" b="0">
-                <a:solidFill>
-                  <a:srgbClr val="6B7A8D"/>
-                </a:solidFill>
-                <a:latin typeface="微软雅黑"/>
-                <a:ea typeface="微软雅黑"/>
-                <a:cs typeface="微软雅黑"/>
-              </a:rPr>
-              <a:t>翻墙爬升段飙 870W,绕行平稳</a:t>
-            </a:r>
-          </a:p>
-        </p:txBody>
-      </p:sp>
-    </p:spTree>
-  </p:cSld>
-  <p:clrMapOvr>
-    <a:masterClrMapping/>
-  </p:clrMapOvr>
-</p:sld>
-</file>
-
-<file path=ppt/slides/slide26.xml><?xml version="1.0" encoding="utf-8"?>
-<p:sld xmlns:a="http://schemas.openxmlformats.org/drawingml/2006/main" xmlns:p="http://schemas.openxmlformats.org/presentationml/2006/main" xmlns:r="http://schemas.openxmlformats.org/officeDocument/2006/relationships">
-  <p:cSld>
-    <p:bg>
-      <p:bgPr>
-        <a:solidFill>
-          <a:srgbClr val="FFFFFF"/>
-        </a:solidFill>
-        <a:effectLst/>
-      </p:bgPr>
-    </p:bg>
-    <p:spTree>
-      <p:nvGrpSpPr>
-        <p:cNvPr id="1" name=""/>
-        <p:cNvGrpSpPr/>
-        <p:nvPr/>
-      </p:nvGrpSpPr>
-      <p:grpSpPr/>
-      <p:sp>
-        <p:nvSpPr>
-          <p:cNvPr id="2" name="Rectangle 1"/>
-          <p:cNvSpPr/>
-          <p:nvPr/>
-        </p:nvSpPr>
-        <p:spPr>
-          <a:xfrm>
-            <a:off x="0" y="0"/>
-            <a:ext cx="109728" cy="6858000"/>
-          </a:xfrm>
-          <a:prstGeom prst="rect">
-            <a:avLst/>
-          </a:prstGeom>
-          <a:solidFill>
-            <a:srgbClr val="4472C4"/>
-          </a:solidFill>
-          <a:ln>
-            <a:noFill/>
-          </a:ln>
-        </p:spPr>
-        <p:style>
-          <a:lnRef idx="1">
-            <a:schemeClr val="accent1"/>
-          </a:lnRef>
-          <a:fillRef idx="3">
-            <a:schemeClr val="accent1"/>
-          </a:fillRef>
-          <a:effectRef idx="2">
-            <a:schemeClr val="accent1"/>
-          </a:effectRef>
-          <a:fontRef idx="minor">
-            <a:schemeClr val="lt1"/>
-          </a:fontRef>
-        </p:style>
-        <p:txBody>
-          <a:bodyPr rtlCol="0" anchor="ctr"/>
-          <a:lstStyle/>
-          <a:p>
-            <a:pPr algn="ctr"/>
-          </a:p>
-        </p:txBody>
-      </p:sp>
-      <p:sp>
-        <p:nvSpPr>
-          <p:cNvPr id="3" name="TextBox 2"/>
-          <p:cNvSpPr txBox="1"/>
-          <p:nvPr/>
-        </p:nvSpPr>
-        <p:spPr>
-          <a:xfrm>
-            <a:off x="9052560" y="292608"/>
-            <a:ext cx="2834640" cy="365760"/>
-          </a:xfrm>
-          <a:prstGeom prst="rect">
-            <a:avLst/>
-          </a:prstGeom>
-          <a:noFill/>
-        </p:spPr>
-        <p:txBody>
-          <a:bodyPr wrap="square" anchor="t" lIns="25400" rIns="25400" tIns="25400" bIns="25400">
-            <a:spAutoFit/>
-          </a:bodyPr>
-          <a:lstStyle/>
-          <a:p>
-            <a:pPr algn="r">
-              <a:spcAft>
-                <a:spcPts val="400"/>
-              </a:spcAft>
-            </a:pPr>
-            <a:r>
-              <a:rPr sz="1200" b="0">
-                <a:solidFill>
-                  <a:srgbClr val="9AA8B8"/>
-                </a:solidFill>
-                <a:latin typeface="微软雅黑"/>
-                <a:ea typeface="微软雅黑"/>
-                <a:cs typeface="微软雅黑"/>
-              </a:rPr>
-              <a:t>西安交通大学</a:t>
-            </a:r>
-          </a:p>
-        </p:txBody>
-      </p:sp>
-      <p:sp>
-        <p:nvSpPr>
-          <p:cNvPr id="4" name="TextBox 3"/>
-          <p:cNvSpPr txBox="1"/>
-          <p:nvPr/>
-        </p:nvSpPr>
-        <p:spPr>
-          <a:xfrm>
-            <a:off x="1143000" y="347472"/>
-            <a:ext cx="10607040" cy="914400"/>
-          </a:xfrm>
-          <a:prstGeom prst="rect">
-            <a:avLst/>
-          </a:prstGeom>
-          <a:noFill/>
-        </p:spPr>
-        <p:txBody>
-          <a:bodyPr wrap="square" anchor="t" lIns="25400" rIns="25400" tIns="25400" bIns="25400">
-            <a:spAutoFit/>
-          </a:bodyPr>
-          <a:lstStyle/>
-          <a:p>
-            <a:pPr algn="l">
-              <a:spcAft>
-                <a:spcPts val="400"/>
-              </a:spcAft>
-            </a:pPr>
-            <a:r>
-              <a:rPr sz="2600" b="1">
-                <a:solidFill>
-                  <a:srgbClr val="0563C1"/>
-                </a:solidFill>
-                <a:latin typeface="微软雅黑"/>
-                <a:ea typeface="微软雅黑"/>
-                <a:cs typeface="微软雅黑"/>
-              </a:rPr>
-              <a:t>附录 E:PX4 真飞控轨迹(俯视/侧视)</a:t>
-            </a:r>
-          </a:p>
-        </p:txBody>
-      </p:sp>
-      <p:pic>
-        <p:nvPicPr>
-          <p:cNvPr id="5" name="Picture 4" descr="px4_traj.png"/>
-          <p:cNvPicPr>
-            <a:picLocks noChangeAspect="1"/>
-          </p:cNvPicPr>
-          <p:nvPr/>
-        </p:nvPicPr>
-        <p:blipFill>
-          <a:blip r:embed="rId2"/>
-          <a:stretch>
-            <a:fillRect/>
-          </a:stretch>
-        </p:blipFill>
-        <p:spPr>
-          <a:xfrm>
-            <a:off x="731520" y="2127626"/>
-            <a:ext cx="10698480" cy="3700028"/>
-          </a:xfrm>
-          <a:prstGeom prst="rect">
-            <a:avLst/>
-          </a:prstGeom>
-        </p:spPr>
-      </p:pic>
-      <p:sp>
-        <p:nvSpPr>
-          <p:cNvPr id="6" name="TextBox 5"/>
-          <p:cNvSpPr txBox="1"/>
-          <p:nvPr/>
-        </p:nvSpPr>
-        <p:spPr>
-          <a:xfrm>
-            <a:off x="502920" y="6400800"/>
-            <a:ext cx="11155680" cy="320040"/>
-          </a:xfrm>
-          <a:prstGeom prst="rect">
-            <a:avLst/>
-          </a:prstGeom>
-          <a:noFill/>
-        </p:spPr>
-        <p:txBody>
-          <a:bodyPr wrap="square" anchor="t" lIns="25400" rIns="25400" tIns="25400" bIns="25400">
-            <a:spAutoFit/>
-          </a:bodyPr>
-          <a:lstStyle/>
-          <a:p>
-            <a:pPr algn="l">
-              <a:spcAft>
-                <a:spcPts val="400"/>
-              </a:spcAft>
-            </a:pPr>
-            <a:r>
-              <a:rPr sz="1100" b="0">
-                <a:solidFill>
-                  <a:srgbClr val="6B7A8D"/>
-                </a:solidFill>
-                <a:latin typeface="微软雅黑"/>
-                <a:ea typeface="微软雅黑"/>
-                <a:cs typeface="微软雅黑"/>
-              </a:rPr>
-              <a:t>翻矮楼 A + 绕高楼 B</a:t>
+                <a:spcPts val="800"/>
+              </a:spcAft>
+            </a:pPr>
+            <a:r>
+              <a:rPr sz="1500" b="0">
+                <a:solidFill>
+                  <a:srgbClr val="1A2333"/>
+                </a:solidFill>
+                <a:latin typeface="微软雅黑"/>
+                <a:ea typeface="微软雅黑"/>
+                <a:cs typeface="微软雅黑"/>
+              </a:rPr>
+              <a:t>Romera-Paredes et al. FunSearch. Nature 2023.</a:t>
+            </a:r>
+          </a:p>
+          <a:p>
+            <a:pPr algn="l">
+              <a:spcAft>
+                <a:spcPts val="800"/>
+              </a:spcAft>
+            </a:pPr>
+            <a:r>
+              <a:rPr sz="1500" b="0">
+                <a:solidFill>
+                  <a:srgbClr val="1A2333"/>
+                </a:solidFill>
+                <a:latin typeface="微软雅黑"/>
+                <a:ea typeface="微软雅黑"/>
+                <a:cs typeface="微软雅黑"/>
+              </a:rPr>
+              <a:t>Novikov et al. AlphaEvolve. DeepMind 2025.</a:t>
+            </a:r>
+          </a:p>
+          <a:p>
+            <a:pPr algn="l">
+              <a:spcAft>
+                <a:spcPts val="800"/>
+              </a:spcAft>
+            </a:pPr>
+            <a:r>
+              <a:rPr sz="1500" b="0">
+                <a:solidFill>
+                  <a:srgbClr val="1A2333"/>
+                </a:solidFill>
+                <a:latin typeface="微软雅黑"/>
+                <a:ea typeface="微软雅黑"/>
+                <a:cs typeface="微软雅黑"/>
+              </a:rPr>
+              <a:t>Ma et al. Eureka. ICLR 2024. arXiv:2310.12931.</a:t>
+            </a:r>
+          </a:p>
+          <a:p>
+            <a:pPr algn="l">
+              <a:spcAft>
+                <a:spcPts val="800"/>
+              </a:spcAft>
+            </a:pPr>
+            <a:r>
+              <a:rPr sz="1500" b="0">
+                <a:solidFill>
+                  <a:srgbClr val="1A2333"/>
+                </a:solidFill>
+                <a:latin typeface="微软雅黑"/>
+                <a:ea typeface="微软雅黑"/>
+                <a:cs typeface="微软雅黑"/>
+              </a:rPr>
+              <a:t>Beel, Kan &amp; Baumgart. AI Scientist 独立评估. ACM SIGIR Forum 2025. arXiv:2502.14297.</a:t>
+            </a:r>
+          </a:p>
+          <a:p>
+            <a:pPr algn="l">
+              <a:spcAft>
+                <a:spcPts val="800"/>
+              </a:spcAft>
+            </a:pPr>
+            <a:r>
+              <a:rPr sz="1500" b="0">
+                <a:solidFill>
+                  <a:srgbClr val="1A2333"/>
+                </a:solidFill>
+                <a:latin typeface="微软雅黑"/>
+                <a:ea typeface="微软雅黑"/>
+                <a:cs typeface="微软雅黑"/>
+              </a:rPr>
+              <a:t>Michel et al. Energy-Optimal Waypoint UAV Missions. 2024. arXiv:2410.17585.</a:t>
+            </a:r>
+          </a:p>
+          <a:p>
+            <a:pPr algn="l">
+              <a:spcAft>
+                <a:spcPts val="800"/>
+              </a:spcAft>
+            </a:pPr>
+            <a:r>
+              <a:rPr sz="1500" b="0">
+                <a:solidFill>
+                  <a:srgbClr val="1A2333"/>
+                </a:solidFill>
+                <a:latin typeface="微软雅黑"/>
+                <a:ea typeface="微软雅黑"/>
+                <a:cs typeface="微软雅黑"/>
+              </a:rPr>
+              <a:t>Nguyen &amp; Au. Extending drone delivery reachable set. AAMAS 2017.</a:t>
+            </a:r>
+          </a:p>
+          <a:p>
+            <a:pPr algn="l">
+              <a:spcAft>
+                <a:spcPts val="800"/>
+              </a:spcAft>
+            </a:pPr>
+            <a:r>
+              <a:rPr sz="1500" b="0">
+                <a:solidFill>
+                  <a:srgbClr val="1A2333"/>
+                </a:solidFill>
+                <a:latin typeface="微软雅黑"/>
+                <a:ea typeface="微软雅黑"/>
+                <a:cs typeface="微软雅黑"/>
+              </a:rPr>
+              <a:t>Karl et al. Position: Embracing Negative Results in ML. ICML 2024.</a:t>
+            </a:r>
+          </a:p>
+          <a:p>
+            <a:pPr algn="l">
+              <a:spcAft>
+                <a:spcPts val="800"/>
+              </a:spcAft>
+            </a:pPr>
+            <a:r>
+              <a:rPr sz="1500" b="0">
+                <a:solidFill>
+                  <a:srgbClr val="1A2333"/>
+                </a:solidFill>
+                <a:latin typeface="微软雅黑"/>
+                <a:ea typeface="微软雅黑"/>
+                <a:cs typeface="微软雅黑"/>
+              </a:rPr>
+              <a:t>Rodrigues et al. DJI M100 energy dataset. Scientific Data 2021.</a:t>
+            </a:r>
+          </a:p>
+          <a:p>
+            <a:pPr algn="l">
+              <a:spcAft>
+                <a:spcPts val="800"/>
+              </a:spcAft>
+            </a:pPr>
+            <a:r>
+              <a:rPr sz="1500" b="0">
+                <a:solidFill>
+                  <a:srgbClr val="1A2333"/>
+                </a:solidFill>
+                <a:latin typeface="微软雅黑"/>
+                <a:ea typeface="微软雅黑"/>
+                <a:cs typeface="微软雅黑"/>
+              </a:rPr>
+              <a:t>Di Franco &amp; Buttazzo 2015;Liu 2017;EcoFlight 2025.</a:t>
             </a:r>
           </a:p>
         </p:txBody>

</xml_diff>

<commit_message>
Final slide polish: swap refs<->conclusion (conclusion last, stays up during Q&A), add '恳请各位老师批评指正', lead conclusion with contribution (not self-negation), remove 'overclaim' jargon
Co-Authored-By: Claude Opus 4.8 (1M context) <noreply@anthropic.com>
</commit_message>
<xml_diff>
--- a/autoresearch/energy_m100/experiments/midterm_defense.pptx
+++ b/autoresearch/energy_m100/experiments/midterm_defense.pptx
@@ -7929,7 +7929,7 @@
     <p:bg>
       <p:bgPr>
         <a:solidFill>
-          <a:srgbClr val="0A2A66"/>
+          <a:srgbClr val="FFFFFF"/>
         </a:solidFill>
         <a:effectLst/>
       </p:bgPr>
@@ -7956,7 +7956,7 @@
             <a:avLst/>
           </a:prstGeom>
           <a:solidFill>
-            <a:srgbClr val="5B9BD5"/>
+            <a:srgbClr val="4472C4"/>
           </a:solidFill>
           <a:ln>
             <a:noFill/>
@@ -7984,30 +7984,47 @@
           </a:p>
         </p:txBody>
       </p:sp>
-      <p:pic>
-        <p:nvPicPr>
-          <p:cNvPr id="3" name="Picture 2" descr="xjtu_logo_white.png"/>
-          <p:cNvPicPr>
-            <a:picLocks noChangeAspect="1"/>
-          </p:cNvPicPr>
-          <p:nvPr/>
-        </p:nvPicPr>
-        <p:blipFill>
-          <a:blip r:embed="rId2"/>
-          <a:stretch>
-            <a:fillRect/>
-          </a:stretch>
-        </p:blipFill>
-        <p:spPr>
-          <a:xfrm>
-            <a:off x="8686800" y="365760"/>
-            <a:ext cx="1707229" cy="457200"/>
-          </a:xfrm>
-          <a:prstGeom prst="rect">
-            <a:avLst/>
-          </a:prstGeom>
-        </p:spPr>
-      </p:pic>
+      <p:sp>
+        <p:nvSpPr>
+          <p:cNvPr id="3" name="TextBox 2"/>
+          <p:cNvSpPr txBox="1"/>
+          <p:nvPr/>
+        </p:nvSpPr>
+        <p:spPr>
+          <a:xfrm>
+            <a:off x="9052560" y="292608"/>
+            <a:ext cx="2834640" cy="365760"/>
+          </a:xfrm>
+          <a:prstGeom prst="rect">
+            <a:avLst/>
+          </a:prstGeom>
+          <a:noFill/>
+        </p:spPr>
+        <p:txBody>
+          <a:bodyPr wrap="square" anchor="t" lIns="25400" rIns="25400" tIns="25400" bIns="25400">
+            <a:spAutoFit/>
+          </a:bodyPr>
+          <a:lstStyle/>
+          <a:p>
+            <a:pPr algn="r">
+              <a:spcAft>
+                <a:spcPts val="400"/>
+              </a:spcAft>
+            </a:pPr>
+            <a:r>
+              <a:rPr sz="1200" b="0">
+                <a:solidFill>
+                  <a:srgbClr val="9AA8B8"/>
+                </a:solidFill>
+                <a:latin typeface="微软雅黑"/>
+                <a:ea typeface="微软雅黑"/>
+                <a:cs typeface="微软雅黑"/>
+              </a:rPr>
+              <a:t>西安交通大学</a:t>
+            </a:r>
+          </a:p>
+        </p:txBody>
+      </p:sp>
       <p:sp>
         <p:nvSpPr>
           <p:cNvPr id="4" name="Rounded Rectangle 3"/>
@@ -8023,7 +8040,7 @@
             <a:avLst/>
           </a:prstGeom>
           <a:solidFill>
-            <a:srgbClr val="5B9BD5"/>
+            <a:srgbClr val="4472C4"/>
           </a:solidFill>
           <a:ln>
             <a:noFill/>
@@ -8070,8 +8087,8 @@
         </p:nvSpPr>
         <p:spPr>
           <a:xfrm>
-            <a:off x="822960" y="1188720"/>
-            <a:ext cx="10515600" cy="640080"/>
+            <a:off x="1143000" y="347472"/>
+            <a:ext cx="10607040" cy="914400"/>
           </a:xfrm>
           <a:prstGeom prst="rect">
             <a:avLst/>
@@ -8090,15 +8107,15 @@
               </a:spcAft>
             </a:pPr>
             <a:r>
-              <a:rPr sz="2400" b="1">
-                <a:solidFill>
-                  <a:srgbClr val="5B9BD5"/>
-                </a:solidFill>
-                <a:latin typeface="微软雅黑"/>
-                <a:ea typeface="微软雅黑"/>
-                <a:cs typeface="微软雅黑"/>
-              </a:rPr>
-              <a:t>结论</a:t>
+              <a:rPr sz="2600" b="1">
+                <a:solidFill>
+                  <a:srgbClr val="0563C1"/>
+                </a:solidFill>
+                <a:latin typeface="微软雅黑"/>
+                <a:ea typeface="微软雅黑"/>
+                <a:cs typeface="微软雅黑"/>
+              </a:rPr>
+              <a:t>参考文献</a:t>
             </a:r>
           </a:p>
         </p:txBody>
@@ -8111,8 +8128,8 @@
         </p:nvSpPr>
         <p:spPr>
           <a:xfrm>
-            <a:off x="822960" y="2103120"/>
-            <a:ext cx="10698480" cy="4023360"/>
+            <a:off x="685800" y="1828800"/>
+            <a:ext cx="10972800" cy="4389120"/>
           </a:xfrm>
           <a:prstGeom prst="rect">
             <a:avLst/>
@@ -8127,91 +8144,163 @@
           <a:p>
             <a:pPr algn="l">
               <a:spcAft>
-                <a:spcPts val="1600"/>
-              </a:spcAft>
-            </a:pPr>
-            <a:r>
-              <a:rPr sz="2100" b="0">
-                <a:solidFill>
-                  <a:srgbClr val="FFFFFF"/>
-                </a:solidFill>
-                <a:latin typeface="微软雅黑"/>
-                <a:ea typeface="微软雅黑"/>
-                <a:cs typeface="微软雅黑"/>
-              </a:rPr>
-              <a:t>① 不声称新算法/新效应——三次查新确认均为 prior art,主动引用</a:t>
-            </a:r>
-          </a:p>
-          <a:p>
-            <a:pPr algn="l">
-              <a:spcAft>
-                <a:spcPts val="1600"/>
-              </a:spcAft>
-            </a:pPr>
-            <a:r>
-              <a:rPr sz="2100" b="1">
-                <a:solidFill>
-                  <a:srgbClr val="5B9BD5"/>
-                </a:solidFill>
-                <a:latin typeface="微软雅黑"/>
-                <a:ea typeface="微软雅黑"/>
-                <a:cs typeface="微软雅黑"/>
-              </a:rPr>
-              <a:t>② 贡献 = 可信自动科研方法学 + 真机数据锚定 + 诚实能力边界</a:t>
-            </a:r>
-          </a:p>
-          <a:p>
-            <a:pPr algn="l">
-              <a:spcAft>
-                <a:spcPts val="1600"/>
-              </a:spcAft>
-            </a:pPr>
-            <a:r>
-              <a:rPr sz="2100" b="0">
-                <a:solidFill>
-                  <a:srgbClr val="FFFFFF"/>
-                </a:solidFill>
-                <a:latin typeface="微软雅黑"/>
-                <a:ea typeface="微软雅黑"/>
-                <a:cs typeface="微软雅黑"/>
-              </a:rPr>
-              <a:t>③ 逐个消融证明每道节点“承重”:去掉即退化/overclaim</a:t>
-            </a:r>
-          </a:p>
-          <a:p>
-            <a:pPr algn="l">
-              <a:spcAft>
-                <a:spcPts val="1600"/>
-              </a:spcAft>
-            </a:pPr>
-            <a:r>
-              <a:rPr sz="2100" b="0">
-                <a:solidFill>
-                  <a:srgbClr val="FFFFFF"/>
-                </a:solidFill>
-                <a:latin typeface="微软雅黑"/>
-                <a:ea typeface="微软雅黑"/>
-                <a:cs typeface="微软雅黑"/>
-              </a:rPr>
-              <a:t>④ 价值 = 在该 overclaim 处不 overclaim,并量化能力边界</a:t>
-            </a:r>
-          </a:p>
-          <a:p>
-            <a:pPr algn="l">
-              <a:spcAft>
-                <a:spcPts val="1600"/>
-              </a:spcAft>
-            </a:pPr>
-            <a:r>
-              <a:rPr sz="2100" b="0">
-                <a:solidFill>
-                  <a:srgbClr val="FFFFFF"/>
-                </a:solidFill>
-                <a:latin typeface="微软雅黑"/>
-                <a:ea typeface="微软雅黑"/>
-                <a:cs typeface="微软雅黑"/>
-              </a:rPr>
-              <a:t>⑤ 搜索空间大则显著胜随机,空间小(已封顶)则与随机相当</a:t>
+                <a:spcPts val="800"/>
+              </a:spcAft>
+            </a:pPr>
+            <a:r>
+              <a:rPr sz="1500" b="0">
+                <a:solidFill>
+                  <a:srgbClr val="1A2333"/>
+                </a:solidFill>
+                <a:latin typeface="微软雅黑"/>
+                <a:ea typeface="微软雅黑"/>
+                <a:cs typeface="微软雅黑"/>
+              </a:rPr>
+              <a:t>Romera-Paredes et al. FunSearch. Nature 2023.</a:t>
+            </a:r>
+          </a:p>
+          <a:p>
+            <a:pPr algn="l">
+              <a:spcAft>
+                <a:spcPts val="800"/>
+              </a:spcAft>
+            </a:pPr>
+            <a:r>
+              <a:rPr sz="1500" b="0">
+                <a:solidFill>
+                  <a:srgbClr val="1A2333"/>
+                </a:solidFill>
+                <a:latin typeface="微软雅黑"/>
+                <a:ea typeface="微软雅黑"/>
+                <a:cs typeface="微软雅黑"/>
+              </a:rPr>
+              <a:t>Novikov et al. AlphaEvolve. DeepMind 2025.</a:t>
+            </a:r>
+          </a:p>
+          <a:p>
+            <a:pPr algn="l">
+              <a:spcAft>
+                <a:spcPts val="800"/>
+              </a:spcAft>
+            </a:pPr>
+            <a:r>
+              <a:rPr sz="1500" b="0">
+                <a:solidFill>
+                  <a:srgbClr val="1A2333"/>
+                </a:solidFill>
+                <a:latin typeface="微软雅黑"/>
+                <a:ea typeface="微软雅黑"/>
+                <a:cs typeface="微软雅黑"/>
+              </a:rPr>
+              <a:t>Ma et al. Eureka. ICLR 2024. arXiv:2310.12931.</a:t>
+            </a:r>
+          </a:p>
+          <a:p>
+            <a:pPr algn="l">
+              <a:spcAft>
+                <a:spcPts val="800"/>
+              </a:spcAft>
+            </a:pPr>
+            <a:r>
+              <a:rPr sz="1500" b="0">
+                <a:solidFill>
+                  <a:srgbClr val="1A2333"/>
+                </a:solidFill>
+                <a:latin typeface="微软雅黑"/>
+                <a:ea typeface="微软雅黑"/>
+                <a:cs typeface="微软雅黑"/>
+              </a:rPr>
+              <a:t>Beel, Kan &amp; Baumgart. AI Scientist 独立评估. ACM SIGIR Forum 2025. arXiv:2502.14297.</a:t>
+            </a:r>
+          </a:p>
+          <a:p>
+            <a:pPr algn="l">
+              <a:spcAft>
+                <a:spcPts val="800"/>
+              </a:spcAft>
+            </a:pPr>
+            <a:r>
+              <a:rPr sz="1500" b="0">
+                <a:solidFill>
+                  <a:srgbClr val="1A2333"/>
+                </a:solidFill>
+                <a:latin typeface="微软雅黑"/>
+                <a:ea typeface="微软雅黑"/>
+                <a:cs typeface="微软雅黑"/>
+              </a:rPr>
+              <a:t>Michel et al. Energy-Optimal Waypoint UAV Missions. 2024. arXiv:2410.17585.</a:t>
+            </a:r>
+          </a:p>
+          <a:p>
+            <a:pPr algn="l">
+              <a:spcAft>
+                <a:spcPts val="800"/>
+              </a:spcAft>
+            </a:pPr>
+            <a:r>
+              <a:rPr sz="1500" b="0">
+                <a:solidFill>
+                  <a:srgbClr val="1A2333"/>
+                </a:solidFill>
+                <a:latin typeface="微软雅黑"/>
+                <a:ea typeface="微软雅黑"/>
+                <a:cs typeface="微软雅黑"/>
+              </a:rPr>
+              <a:t>Nguyen &amp; Au. Extending drone delivery reachable set. AAMAS 2017.</a:t>
+            </a:r>
+          </a:p>
+          <a:p>
+            <a:pPr algn="l">
+              <a:spcAft>
+                <a:spcPts val="800"/>
+              </a:spcAft>
+            </a:pPr>
+            <a:r>
+              <a:rPr sz="1500" b="0">
+                <a:solidFill>
+                  <a:srgbClr val="1A2333"/>
+                </a:solidFill>
+                <a:latin typeface="微软雅黑"/>
+                <a:ea typeface="微软雅黑"/>
+                <a:cs typeface="微软雅黑"/>
+              </a:rPr>
+              <a:t>Karl et al. Position: Embracing Negative Results in ML. ICML 2024.</a:t>
+            </a:r>
+          </a:p>
+          <a:p>
+            <a:pPr algn="l">
+              <a:spcAft>
+                <a:spcPts val="800"/>
+              </a:spcAft>
+            </a:pPr>
+            <a:r>
+              <a:rPr sz="1500" b="0">
+                <a:solidFill>
+                  <a:srgbClr val="1A2333"/>
+                </a:solidFill>
+                <a:latin typeface="微软雅黑"/>
+                <a:ea typeface="微软雅黑"/>
+                <a:cs typeface="微软雅黑"/>
+              </a:rPr>
+              <a:t>Rodrigues et al. DJI M100 energy dataset. Scientific Data 2021.</a:t>
+            </a:r>
+          </a:p>
+          <a:p>
+            <a:pPr algn="l">
+              <a:spcAft>
+                <a:spcPts val="800"/>
+              </a:spcAft>
+            </a:pPr>
+            <a:r>
+              <a:rPr sz="1500" b="0">
+                <a:solidFill>
+                  <a:srgbClr val="1A2333"/>
+                </a:solidFill>
+                <a:latin typeface="微软雅黑"/>
+                <a:ea typeface="微软雅黑"/>
+                <a:cs typeface="微软雅黑"/>
+              </a:rPr>
+              <a:t>Di Franco &amp; Buttazzo 2015;Liu 2017;EcoFlight 2025.</a:t>
             </a:r>
           </a:p>
         </p:txBody>
@@ -8230,7 +8319,7 @@
     <p:bg>
       <p:bgPr>
         <a:solidFill>
-          <a:srgbClr val="FFFFFF"/>
+          <a:srgbClr val="0A2A66"/>
         </a:solidFill>
         <a:effectLst/>
       </p:bgPr>
@@ -8257,7 +8346,7 @@
             <a:avLst/>
           </a:prstGeom>
           <a:solidFill>
-            <a:srgbClr val="4472C4"/>
+            <a:srgbClr val="5B9BD5"/>
           </a:solidFill>
           <a:ln>
             <a:noFill/>
@@ -8285,47 +8374,30 @@
           </a:p>
         </p:txBody>
       </p:sp>
-      <p:sp>
-        <p:nvSpPr>
-          <p:cNvPr id="3" name="TextBox 2"/>
-          <p:cNvSpPr txBox="1"/>
-          <p:nvPr/>
-        </p:nvSpPr>
-        <p:spPr>
-          <a:xfrm>
-            <a:off x="9052560" y="292608"/>
-            <a:ext cx="2834640" cy="365760"/>
-          </a:xfrm>
-          <a:prstGeom prst="rect">
-            <a:avLst/>
-          </a:prstGeom>
-          <a:noFill/>
-        </p:spPr>
-        <p:txBody>
-          <a:bodyPr wrap="square" anchor="t" lIns="25400" rIns="25400" tIns="25400" bIns="25400">
-            <a:spAutoFit/>
-          </a:bodyPr>
-          <a:lstStyle/>
-          <a:p>
-            <a:pPr algn="r">
-              <a:spcAft>
-                <a:spcPts val="400"/>
-              </a:spcAft>
-            </a:pPr>
-            <a:r>
-              <a:rPr sz="1200" b="0">
-                <a:solidFill>
-                  <a:srgbClr val="9AA8B8"/>
-                </a:solidFill>
-                <a:latin typeface="微软雅黑"/>
-                <a:ea typeface="微软雅黑"/>
-                <a:cs typeface="微软雅黑"/>
-              </a:rPr>
-              <a:t>西安交通大学</a:t>
-            </a:r>
-          </a:p>
-        </p:txBody>
-      </p:sp>
+      <p:pic>
+        <p:nvPicPr>
+          <p:cNvPr id="3" name="Picture 2" descr="xjtu_logo_white.png"/>
+          <p:cNvPicPr>
+            <a:picLocks noChangeAspect="1"/>
+          </p:cNvPicPr>
+          <p:nvPr/>
+        </p:nvPicPr>
+        <p:blipFill>
+          <a:blip r:embed="rId2"/>
+          <a:stretch>
+            <a:fillRect/>
+          </a:stretch>
+        </p:blipFill>
+        <p:spPr>
+          <a:xfrm>
+            <a:off x="8686800" y="365760"/>
+            <a:ext cx="1707229" cy="457200"/>
+          </a:xfrm>
+          <a:prstGeom prst="rect">
+            <a:avLst/>
+          </a:prstGeom>
+        </p:spPr>
+      </p:pic>
       <p:sp>
         <p:nvSpPr>
           <p:cNvPr id="4" name="Rounded Rectangle 3"/>
@@ -8341,7 +8413,7 @@
             <a:avLst/>
           </a:prstGeom>
           <a:solidFill>
-            <a:srgbClr val="4472C4"/>
+            <a:srgbClr val="5B9BD5"/>
           </a:solidFill>
           <a:ln>
             <a:noFill/>
@@ -8388,8 +8460,8 @@
         </p:nvSpPr>
         <p:spPr>
           <a:xfrm>
-            <a:off x="1143000" y="347472"/>
-            <a:ext cx="10607040" cy="914400"/>
+            <a:off x="822960" y="1097280"/>
+            <a:ext cx="10515600" cy="640080"/>
           </a:xfrm>
           <a:prstGeom prst="rect">
             <a:avLst/>
@@ -8408,15 +8480,15 @@
               </a:spcAft>
             </a:pPr>
             <a:r>
-              <a:rPr sz="2600" b="1">
-                <a:solidFill>
-                  <a:srgbClr val="0563C1"/>
-                </a:solidFill>
-                <a:latin typeface="微软雅黑"/>
-                <a:ea typeface="微软雅黑"/>
-                <a:cs typeface="微软雅黑"/>
-              </a:rPr>
-              <a:t>参考文献</a:t>
+              <a:rPr sz="2400" b="1">
+                <a:solidFill>
+                  <a:srgbClr val="5B9BD5"/>
+                </a:solidFill>
+                <a:latin typeface="微软雅黑"/>
+                <a:ea typeface="微软雅黑"/>
+                <a:cs typeface="微软雅黑"/>
+              </a:rPr>
+              <a:t>结论</a:t>
             </a:r>
           </a:p>
         </p:txBody>
@@ -8429,8 +8501,8 @@
         </p:nvSpPr>
         <p:spPr>
           <a:xfrm>
-            <a:off x="685800" y="1828800"/>
-            <a:ext cx="10972800" cy="4389120"/>
+            <a:off x="822960" y="1920240"/>
+            <a:ext cx="10698480" cy="3383280"/>
           </a:xfrm>
           <a:prstGeom prst="rect">
             <a:avLst/>
@@ -8445,163 +8517,114 @@
           <a:p>
             <a:pPr algn="l">
               <a:spcAft>
-                <a:spcPts val="800"/>
-              </a:spcAft>
-            </a:pPr>
-            <a:r>
-              <a:rPr sz="1500" b="0">
-                <a:solidFill>
-                  <a:srgbClr val="1A2333"/>
-                </a:solidFill>
-                <a:latin typeface="微软雅黑"/>
-                <a:ea typeface="微软雅黑"/>
-                <a:cs typeface="微软雅黑"/>
-              </a:rPr>
-              <a:t>Romera-Paredes et al. FunSearch. Nature 2023.</a:t>
-            </a:r>
-          </a:p>
-          <a:p>
-            <a:pPr algn="l">
-              <a:spcAft>
-                <a:spcPts val="800"/>
-              </a:spcAft>
-            </a:pPr>
-            <a:r>
-              <a:rPr sz="1500" b="0">
-                <a:solidFill>
-                  <a:srgbClr val="1A2333"/>
-                </a:solidFill>
-                <a:latin typeface="微软雅黑"/>
-                <a:ea typeface="微软雅黑"/>
-                <a:cs typeface="微软雅黑"/>
-              </a:rPr>
-              <a:t>Novikov et al. AlphaEvolve. DeepMind 2025.</a:t>
-            </a:r>
-          </a:p>
-          <a:p>
-            <a:pPr algn="l">
-              <a:spcAft>
-                <a:spcPts val="800"/>
-              </a:spcAft>
-            </a:pPr>
-            <a:r>
-              <a:rPr sz="1500" b="0">
-                <a:solidFill>
-                  <a:srgbClr val="1A2333"/>
-                </a:solidFill>
-                <a:latin typeface="微软雅黑"/>
-                <a:ea typeface="微软雅黑"/>
-                <a:cs typeface="微软雅黑"/>
-              </a:rPr>
-              <a:t>Ma et al. Eureka. ICLR 2024. arXiv:2310.12931.</a:t>
-            </a:r>
-          </a:p>
-          <a:p>
-            <a:pPr algn="l">
-              <a:spcAft>
-                <a:spcPts val="800"/>
-              </a:spcAft>
-            </a:pPr>
-            <a:r>
-              <a:rPr sz="1500" b="0">
-                <a:solidFill>
-                  <a:srgbClr val="1A2333"/>
-                </a:solidFill>
-                <a:latin typeface="微软雅黑"/>
-                <a:ea typeface="微软雅黑"/>
-                <a:cs typeface="微软雅黑"/>
-              </a:rPr>
-              <a:t>Beel, Kan &amp; Baumgart. AI Scientist 独立评估. ACM SIGIR Forum 2025. arXiv:2502.14297.</a:t>
-            </a:r>
-          </a:p>
-          <a:p>
-            <a:pPr algn="l">
-              <a:spcAft>
-                <a:spcPts val="800"/>
-              </a:spcAft>
-            </a:pPr>
-            <a:r>
-              <a:rPr sz="1500" b="0">
-                <a:solidFill>
-                  <a:srgbClr val="1A2333"/>
-                </a:solidFill>
-                <a:latin typeface="微软雅黑"/>
-                <a:ea typeface="微软雅黑"/>
-                <a:cs typeface="微软雅黑"/>
-              </a:rPr>
-              <a:t>Michel et al. Energy-Optimal Waypoint UAV Missions. 2024. arXiv:2410.17585.</a:t>
-            </a:r>
-          </a:p>
-          <a:p>
-            <a:pPr algn="l">
-              <a:spcAft>
-                <a:spcPts val="800"/>
-              </a:spcAft>
-            </a:pPr>
-            <a:r>
-              <a:rPr sz="1500" b="0">
-                <a:solidFill>
-                  <a:srgbClr val="1A2333"/>
-                </a:solidFill>
-                <a:latin typeface="微软雅黑"/>
-                <a:ea typeface="微软雅黑"/>
-                <a:cs typeface="微软雅黑"/>
-              </a:rPr>
-              <a:t>Nguyen &amp; Au. Extending drone delivery reachable set. AAMAS 2017.</a:t>
-            </a:r>
-          </a:p>
-          <a:p>
-            <a:pPr algn="l">
-              <a:spcAft>
-                <a:spcPts val="800"/>
-              </a:spcAft>
-            </a:pPr>
-            <a:r>
-              <a:rPr sz="1500" b="0">
-                <a:solidFill>
-                  <a:srgbClr val="1A2333"/>
-                </a:solidFill>
-                <a:latin typeface="微软雅黑"/>
-                <a:ea typeface="微软雅黑"/>
-                <a:cs typeface="微软雅黑"/>
-              </a:rPr>
-              <a:t>Karl et al. Position: Embracing Negative Results in ML. ICML 2024.</a:t>
-            </a:r>
-          </a:p>
-          <a:p>
-            <a:pPr algn="l">
-              <a:spcAft>
-                <a:spcPts val="800"/>
-              </a:spcAft>
-            </a:pPr>
-            <a:r>
-              <a:rPr sz="1500" b="0">
-                <a:solidFill>
-                  <a:srgbClr val="1A2333"/>
-                </a:solidFill>
-                <a:latin typeface="微软雅黑"/>
-                <a:ea typeface="微软雅黑"/>
-                <a:cs typeface="微软雅黑"/>
-              </a:rPr>
-              <a:t>Rodrigues et al. DJI M100 energy dataset. Scientific Data 2021.</a:t>
-            </a:r>
-          </a:p>
-          <a:p>
-            <a:pPr algn="l">
-              <a:spcAft>
-                <a:spcPts val="800"/>
-              </a:spcAft>
-            </a:pPr>
-            <a:r>
-              <a:rPr sz="1500" b="0">
-                <a:solidFill>
-                  <a:srgbClr val="1A2333"/>
-                </a:solidFill>
-                <a:latin typeface="微软雅黑"/>
-                <a:ea typeface="微软雅黑"/>
-                <a:cs typeface="微软雅黑"/>
-              </a:rPr>
-              <a:t>Di Franco &amp; Buttazzo 2015;Liu 2017;EcoFlight 2025.</a:t>
+                <a:spcPts val="1600"/>
+              </a:spcAft>
+            </a:pPr>
+            <a:r>
+              <a:rPr sz="2000" b="1">
+                <a:solidFill>
+                  <a:srgbClr val="5B9BD5"/>
+                </a:solidFill>
+                <a:latin typeface="微软雅黑"/>
+                <a:ea typeface="微软雅黑"/>
+                <a:cs typeface="微软雅黑"/>
+              </a:rPr>
+              <a:t>① 贡献 = 可信自动科研方法学 + 真机数据锚定 + 诚实能力边界</a:t>
+            </a:r>
+          </a:p>
+          <a:p>
+            <a:pPr algn="l">
+              <a:spcAft>
+                <a:spcPts val="1600"/>
+              </a:spcAft>
+            </a:pPr>
+            <a:r>
+              <a:rPr sz="2000" b="0">
+                <a:solidFill>
+                  <a:srgbClr val="FFFFFF"/>
+                </a:solidFill>
+                <a:latin typeface="微软雅黑"/>
+                <a:ea typeface="微软雅黑"/>
+                <a:cs typeface="微软雅黑"/>
+              </a:rPr>
+              <a:t>② 真机 M100 能耗建模(误差 6.88%→1.86%)接入规划,全栈验证省 14.3%</a:t>
+            </a:r>
+          </a:p>
+          <a:p>
+            <a:pPr algn="l">
+              <a:spcAft>
+                <a:spcPts val="1600"/>
+              </a:spcAft>
+            </a:pPr>
+            <a:r>
+              <a:rPr sz="2000" b="0">
+                <a:solidFill>
+                  <a:srgbClr val="FFFFFF"/>
+                </a:solidFill>
+                <a:latin typeface="微软雅黑"/>
+                <a:ea typeface="微软雅黑"/>
+                <a:cs typeface="微软雅黑"/>
+              </a:rPr>
+              <a:t>③ 逐个消融证明框架每道安全机制都“承重”</a:t>
+            </a:r>
+          </a:p>
+          <a:p>
+            <a:pPr algn="l">
+              <a:spcAft>
+                <a:spcPts val="1600"/>
+              </a:spcAft>
+            </a:pPr>
+            <a:r>
+              <a:rPr sz="2000" b="0">
+                <a:solidFill>
+                  <a:srgbClr val="FFFFFF"/>
+                </a:solidFill>
+                <a:latin typeface="微软雅黑"/>
+                <a:ea typeface="微软雅黑"/>
+                <a:cs typeface="微软雅黑"/>
+              </a:rPr>
+              <a:t>④ 诚实划出适用边界:空间大则显著胜随机,空间小则与随机相当</a:t>
+            </a:r>
+          </a:p>
+        </p:txBody>
+      </p:sp>
+      <p:sp>
+        <p:nvSpPr>
+          <p:cNvPr id="7" name="TextBox 6"/>
+          <p:cNvSpPr txBox="1"/>
+          <p:nvPr/>
+        </p:nvSpPr>
+        <p:spPr>
+          <a:xfrm>
+            <a:off x="822960" y="5760720"/>
+            <a:ext cx="10515600" cy="731520"/>
+          </a:xfrm>
+          <a:prstGeom prst="rect">
+            <a:avLst/>
+          </a:prstGeom>
+          <a:noFill/>
+        </p:spPr>
+        <p:txBody>
+          <a:bodyPr wrap="square" anchor="t" lIns="25400" rIns="25400" tIns="25400" bIns="25400">
+            <a:spAutoFit/>
+          </a:bodyPr>
+          <a:lstStyle/>
+          <a:p>
+            <a:pPr algn="ctr">
+              <a:spcAft>
+                <a:spcPts val="400"/>
+              </a:spcAft>
+            </a:pPr>
+            <a:r>
+              <a:rPr sz="2400" b="1">
+                <a:solidFill>
+                  <a:srgbClr val="FFFFFF"/>
+                </a:solidFill>
+                <a:latin typeface="微软雅黑"/>
+                <a:ea typeface="微软雅黑"/>
+                <a:cs typeface="微软雅黑"/>
+              </a:rPr>
+              <a:t>恳请各位老师批评指正</a:t>
             </a:r>
           </a:p>
         </p:txBody>

</xml_diff>